<commit_message>
Mise à jour suivi et présentation
</commit_message>
<xml_diff>
--- a/presentation/dsfs_ft_36_Projet_REnergies_efficiency_prediction.pptx
+++ b/presentation/dsfs_ft_36_Projet_REnergies_efficiency_prediction.pptx
@@ -291,7 +291,7 @@
 <file path=ppt/revisionInfo.xml><?xml version="1.0" encoding="utf-8"?>
 <p1510:revInfo xmlns:a="http://schemas.openxmlformats.org/drawingml/2006/main" xmlns:r="http://schemas.openxmlformats.org/officeDocument/2006/relationships" xmlns:p1510="http://schemas.microsoft.com/office/powerpoint/2015/10/main">
   <p1510:revLst>
-    <p1510:client id="{2EB72A00-7F79-4813-B4C2-C6564860F3F6}" v="1411" dt="2025-11-20T20:39:03.634"/>
+    <p1510:client id="{2EB72A00-7F79-4813-B4C2-C6564860F3F6}" v="1576" dt="2025-11-21T02:14:12.346"/>
   </p1510:revLst>
 </p1510:revInfo>
 </file>
@@ -301,7 +301,7 @@
   <pc:docChgLst>
     <pc:chgData name="Jean-Yves Vuillequez" userId="e7fac481abea6bd0" providerId="LiveId" clId="{79E365E8-22BC-4EC2-9606-9A9AC6CD1D22}"/>
     <pc:docChg chg="undo custSel addSld delSld modSld sldOrd">
-      <pc:chgData name="Jean-Yves Vuillequez" userId="e7fac481abea6bd0" providerId="LiveId" clId="{79E365E8-22BC-4EC2-9606-9A9AC6CD1D22}" dt="2025-11-20T20:45:26.230" v="5250" actId="20577"/>
+      <pc:chgData name="Jean-Yves Vuillequez" userId="e7fac481abea6bd0" providerId="LiveId" clId="{79E365E8-22BC-4EC2-9606-9A9AC6CD1D22}" dt="2025-11-21T02:29:34.535" v="5608" actId="6549"/>
       <pc:docMkLst>
         <pc:docMk/>
       </pc:docMkLst>
@@ -329,13 +329,13 @@
         </pc:spChg>
       </pc:sldChg>
       <pc:sldChg chg="addSp delSp modSp add del mod">
-        <pc:chgData name="Jean-Yves Vuillequez" userId="e7fac481abea6bd0" providerId="LiveId" clId="{79E365E8-22BC-4EC2-9606-9A9AC6CD1D22}" dt="2025-11-20T14:44:47.056" v="3910" actId="1076"/>
+        <pc:chgData name="Jean-Yves Vuillequez" userId="e7fac481abea6bd0" providerId="LiveId" clId="{79E365E8-22BC-4EC2-9606-9A9AC6CD1D22}" dt="2025-11-21T02:25:39.724" v="5607" actId="20577"/>
         <pc:sldMkLst>
           <pc:docMk/>
           <pc:sldMk cId="0" sldId="263"/>
         </pc:sldMkLst>
         <pc:spChg chg="add mod">
-          <ac:chgData name="Jean-Yves Vuillequez" userId="e7fac481abea6bd0" providerId="LiveId" clId="{79E365E8-22BC-4EC2-9606-9A9AC6CD1D22}" dt="2025-11-20T14:44:47.056" v="3910" actId="1076"/>
+          <ac:chgData name="Jean-Yves Vuillequez" userId="e7fac481abea6bd0" providerId="LiveId" clId="{79E365E8-22BC-4EC2-9606-9A9AC6CD1D22}" dt="2025-11-21T02:25:39.724" v="5607" actId="20577"/>
           <ac:spMkLst>
             <pc:docMk/>
             <pc:sldMk cId="0" sldId="263"/>
@@ -343,49 +343,13 @@
           </ac:spMkLst>
         </pc:spChg>
         <pc:spChg chg="mod">
-          <ac:chgData name="Jean-Yves Vuillequez" userId="e7fac481abea6bd0" providerId="LiveId" clId="{79E365E8-22BC-4EC2-9606-9A9AC6CD1D22}" dt="2025-11-19T10:57:53.045" v="42" actId="20577"/>
+          <ac:chgData name="Jean-Yves Vuillequez" userId="e7fac481abea6bd0" providerId="LiveId" clId="{79E365E8-22BC-4EC2-9606-9A9AC6CD1D22}" dt="2025-11-21T02:25:31.718" v="5591" actId="20577"/>
           <ac:spMkLst>
             <pc:docMk/>
             <pc:sldMk cId="0" sldId="263"/>
             <ac:spMk id="61" creationId="{00000000-0000-0000-0000-000000000000}"/>
           </ac:spMkLst>
         </pc:spChg>
-        <pc:picChg chg="del mod">
-          <ac:chgData name="Jean-Yves Vuillequez" userId="e7fac481abea6bd0" providerId="LiveId" clId="{79E365E8-22BC-4EC2-9606-9A9AC6CD1D22}" dt="2025-11-19T10:57:28.093" v="13" actId="478"/>
-          <ac:picMkLst>
-            <pc:docMk/>
-            <pc:sldMk cId="0" sldId="263"/>
-            <ac:picMk id="5" creationId="{BF507C43-8C8F-F14C-A2E6-D966FC03A531}"/>
-          </ac:picMkLst>
-        </pc:picChg>
-      </pc:sldChg>
-      <pc:sldChg chg="del">
-        <pc:chgData name="Jean-Yves Vuillequez" userId="e7fac481abea6bd0" providerId="LiveId" clId="{79E365E8-22BC-4EC2-9606-9A9AC6CD1D22}" dt="2025-11-19T10:57:21.256" v="9" actId="47"/>
-        <pc:sldMkLst>
-          <pc:docMk/>
-          <pc:sldMk cId="0" sldId="264"/>
-        </pc:sldMkLst>
-      </pc:sldChg>
-      <pc:sldChg chg="del">
-        <pc:chgData name="Jean-Yves Vuillequez" userId="e7fac481abea6bd0" providerId="LiveId" clId="{79E365E8-22BC-4EC2-9606-9A9AC6CD1D22}" dt="2025-11-19T11:00:58.858" v="84" actId="47"/>
-        <pc:sldMkLst>
-          <pc:docMk/>
-          <pc:sldMk cId="0" sldId="265"/>
-        </pc:sldMkLst>
-      </pc:sldChg>
-      <pc:sldChg chg="del">
-        <pc:chgData name="Jean-Yves Vuillequez" userId="e7fac481abea6bd0" providerId="LiveId" clId="{79E365E8-22BC-4EC2-9606-9A9AC6CD1D22}" dt="2025-11-19T11:00:58.858" v="84" actId="47"/>
-        <pc:sldMkLst>
-          <pc:docMk/>
-          <pc:sldMk cId="1868318443" sldId="266"/>
-        </pc:sldMkLst>
-      </pc:sldChg>
-      <pc:sldChg chg="del">
-        <pc:chgData name="Jean-Yves Vuillequez" userId="e7fac481abea6bd0" providerId="LiveId" clId="{79E365E8-22BC-4EC2-9606-9A9AC6CD1D22}" dt="2025-11-19T11:00:58.858" v="84" actId="47"/>
-        <pc:sldMkLst>
-          <pc:docMk/>
-          <pc:sldMk cId="2644984178" sldId="267"/>
-        </pc:sldMkLst>
       </pc:sldChg>
       <pc:sldChg chg="addSp delSp modSp mod modAnim">
         <pc:chgData name="Jean-Yves Vuillequez" userId="e7fac481abea6bd0" providerId="LiveId" clId="{79E365E8-22BC-4EC2-9606-9A9AC6CD1D22}" dt="2025-11-20T20:36:02.952" v="5213"/>
@@ -415,14 +379,6 @@
             <pc:docMk/>
             <pc:sldMk cId="0" sldId="270"/>
             <ac:spMk id="5" creationId="{6E9B9A86-9FEE-4DF9-2C6B-AA0F6754EFCC}"/>
-          </ac:spMkLst>
-        </pc:spChg>
-        <pc:spChg chg="add del">
-          <ac:chgData name="Jean-Yves Vuillequez" userId="e7fac481abea6bd0" providerId="LiveId" clId="{79E365E8-22BC-4EC2-9606-9A9AC6CD1D22}" dt="2025-11-19T15:27:31.625" v="178" actId="22"/>
-          <ac:spMkLst>
-            <pc:docMk/>
-            <pc:sldMk cId="0" sldId="270"/>
-            <ac:spMk id="5" creationId="{CFDEE9DF-9D18-D97C-5C14-CA1236A83E99}"/>
           </ac:spMkLst>
         </pc:spChg>
         <pc:spChg chg="add mod">
@@ -545,22 +501,6 @@
             <ac:spMk id="181" creationId="{00000000-0000-0000-0000-000000000000}"/>
           </ac:spMkLst>
         </pc:spChg>
-        <pc:spChg chg="del">
-          <ac:chgData name="Jean-Yves Vuillequez" userId="e7fac481abea6bd0" providerId="LiveId" clId="{79E365E8-22BC-4EC2-9606-9A9AC6CD1D22}" dt="2025-11-19T11:00:46.457" v="81" actId="478"/>
-          <ac:spMkLst>
-            <pc:docMk/>
-            <pc:sldMk cId="0" sldId="270"/>
-            <ac:spMk id="182" creationId="{00000000-0000-0000-0000-000000000000}"/>
-          </ac:spMkLst>
-        </pc:spChg>
-        <pc:picChg chg="add del">
-          <ac:chgData name="Jean-Yves Vuillequez" userId="e7fac481abea6bd0" providerId="LiveId" clId="{79E365E8-22BC-4EC2-9606-9A9AC6CD1D22}" dt="2025-11-19T11:04:20.428" v="92" actId="22"/>
-          <ac:picMkLst>
-            <pc:docMk/>
-            <pc:sldMk cId="0" sldId="270"/>
-            <ac:picMk id="3" creationId="{385EAD59-F5EF-433F-E72D-66416F21249B}"/>
-          </ac:picMkLst>
-        </pc:picChg>
         <pc:picChg chg="add del mod">
           <ac:chgData name="Jean-Yves Vuillequez" userId="e7fac481abea6bd0" providerId="LiveId" clId="{79E365E8-22BC-4EC2-9606-9A9AC6CD1D22}" dt="2025-11-20T12:53:29.722" v="2837" actId="478"/>
           <ac:picMkLst>
@@ -626,20 +566,6 @@
           </ac:cxnSpMkLst>
         </pc:cxnChg>
       </pc:sldChg>
-      <pc:sldChg chg="del">
-        <pc:chgData name="Jean-Yves Vuillequez" userId="e7fac481abea6bd0" providerId="LiveId" clId="{79E365E8-22BC-4EC2-9606-9A9AC6CD1D22}" dt="2025-11-19T14:02:01.719" v="119" actId="47"/>
-        <pc:sldMkLst>
-          <pc:docMk/>
-          <pc:sldMk cId="2182015625" sldId="272"/>
-        </pc:sldMkLst>
-      </pc:sldChg>
-      <pc:sldChg chg="add del">
-        <pc:chgData name="Jean-Yves Vuillequez" userId="e7fac481abea6bd0" providerId="LiveId" clId="{79E365E8-22BC-4EC2-9606-9A9AC6CD1D22}" dt="2025-11-19T14:02:17.709" v="121" actId="47"/>
-        <pc:sldMkLst>
-          <pc:docMk/>
-          <pc:sldMk cId="1023234914" sldId="273"/>
-        </pc:sldMkLst>
-      </pc:sldChg>
       <pc:sldChg chg="modSp add del mod">
         <pc:chgData name="Jean-Yves Vuillequez" userId="e7fac481abea6bd0" providerId="LiveId" clId="{79E365E8-22BC-4EC2-9606-9A9AC6CD1D22}" dt="2025-11-19T14:03:57.617" v="139" actId="20577"/>
         <pc:sldMkLst>
@@ -652,125 +578,6 @@
             <pc:docMk/>
             <pc:sldMk cId="1558646683" sldId="273"/>
             <ac:spMk id="62" creationId="{1465D56F-7913-AD4E-8248-AEC9AC3FBC16}"/>
-          </ac:spMkLst>
-        </pc:spChg>
-      </pc:sldChg>
-      <pc:sldChg chg="delSp modSp del mod delAnim">
-        <pc:chgData name="Jean-Yves Vuillequez" userId="e7fac481abea6bd0" providerId="LiveId" clId="{79E365E8-22BC-4EC2-9606-9A9AC6CD1D22}" dt="2025-11-19T11:00:27.703" v="73" actId="2696"/>
-        <pc:sldMkLst>
-          <pc:docMk/>
-          <pc:sldMk cId="76015710" sldId="274"/>
-        </pc:sldMkLst>
-        <pc:spChg chg="del">
-          <ac:chgData name="Jean-Yves Vuillequez" userId="e7fac481abea6bd0" providerId="LiveId" clId="{79E365E8-22BC-4EC2-9606-9A9AC6CD1D22}" dt="2025-11-19T10:58:31.404" v="47" actId="478"/>
-          <ac:spMkLst>
-            <pc:docMk/>
-            <pc:sldMk cId="76015710" sldId="274"/>
-            <ac:spMk id="5" creationId="{88A106DF-7A83-DB85-D675-3B89338AAC0D}"/>
-          </ac:spMkLst>
-        </pc:spChg>
-        <pc:spChg chg="del">
-          <ac:chgData name="Jean-Yves Vuillequez" userId="e7fac481abea6bd0" providerId="LiveId" clId="{79E365E8-22BC-4EC2-9606-9A9AC6CD1D22}" dt="2025-11-19T10:58:36.593" v="49" actId="478"/>
-          <ac:spMkLst>
-            <pc:docMk/>
-            <pc:sldMk cId="76015710" sldId="274"/>
-            <ac:spMk id="9" creationId="{0EA1EBA7-5A55-2DB4-2AAA-7181ADF95728}"/>
-          </ac:spMkLst>
-        </pc:spChg>
-        <pc:spChg chg="del">
-          <ac:chgData name="Jean-Yves Vuillequez" userId="e7fac481abea6bd0" providerId="LiveId" clId="{79E365E8-22BC-4EC2-9606-9A9AC6CD1D22}" dt="2025-11-19T10:58:36.593" v="49" actId="478"/>
-          <ac:spMkLst>
-            <pc:docMk/>
-            <pc:sldMk cId="76015710" sldId="274"/>
-            <ac:spMk id="10" creationId="{A409361B-330D-D2A5-D967-903166D5DAE4}"/>
-          </ac:spMkLst>
-        </pc:spChg>
-        <pc:spChg chg="del">
-          <ac:chgData name="Jean-Yves Vuillequez" userId="e7fac481abea6bd0" providerId="LiveId" clId="{79E365E8-22BC-4EC2-9606-9A9AC6CD1D22}" dt="2025-11-19T10:58:36.593" v="49" actId="478"/>
-          <ac:spMkLst>
-            <pc:docMk/>
-            <pc:sldMk cId="76015710" sldId="274"/>
-            <ac:spMk id="11" creationId="{F0A9E65F-DDDA-6923-AE09-42C784AB054A}"/>
-          </ac:spMkLst>
-        </pc:spChg>
-        <pc:spChg chg="del">
-          <ac:chgData name="Jean-Yves Vuillequez" userId="e7fac481abea6bd0" providerId="LiveId" clId="{79E365E8-22BC-4EC2-9606-9A9AC6CD1D22}" dt="2025-11-19T10:58:31.404" v="47" actId="478"/>
-          <ac:spMkLst>
-            <pc:docMk/>
-            <pc:sldMk cId="76015710" sldId="274"/>
-            <ac:spMk id="15" creationId="{60EA83CE-862E-0716-7D4B-D10594298AFC}"/>
-          </ac:spMkLst>
-        </pc:spChg>
-        <pc:spChg chg="del">
-          <ac:chgData name="Jean-Yves Vuillequez" userId="e7fac481abea6bd0" providerId="LiveId" clId="{79E365E8-22BC-4EC2-9606-9A9AC6CD1D22}" dt="2025-11-19T10:58:31.404" v="47" actId="478"/>
-          <ac:spMkLst>
-            <pc:docMk/>
-            <pc:sldMk cId="76015710" sldId="274"/>
-            <ac:spMk id="17" creationId="{8304CF66-5C77-FB70-A0AB-14108326AAF8}"/>
-          </ac:spMkLst>
-        </pc:spChg>
-        <pc:spChg chg="del">
-          <ac:chgData name="Jean-Yves Vuillequez" userId="e7fac481abea6bd0" providerId="LiveId" clId="{79E365E8-22BC-4EC2-9606-9A9AC6CD1D22}" dt="2025-11-19T10:58:31.404" v="47" actId="478"/>
-          <ac:spMkLst>
-            <pc:docMk/>
-            <pc:sldMk cId="76015710" sldId="274"/>
-            <ac:spMk id="30" creationId="{4E85C3F7-9A4B-4403-40BA-E16E7B8AA378}"/>
-          </ac:spMkLst>
-        </pc:spChg>
-        <pc:spChg chg="del">
-          <ac:chgData name="Jean-Yves Vuillequez" userId="e7fac481abea6bd0" providerId="LiveId" clId="{79E365E8-22BC-4EC2-9606-9A9AC6CD1D22}" dt="2025-11-19T10:58:31.404" v="47" actId="478"/>
-          <ac:spMkLst>
-            <pc:docMk/>
-            <pc:sldMk cId="76015710" sldId="274"/>
-            <ac:spMk id="31" creationId="{D4DF20D5-B823-CD4C-6253-AA52E542825B}"/>
-          </ac:spMkLst>
-        </pc:spChg>
-        <pc:spChg chg="del">
-          <ac:chgData name="Jean-Yves Vuillequez" userId="e7fac481abea6bd0" providerId="LiveId" clId="{79E365E8-22BC-4EC2-9606-9A9AC6CD1D22}" dt="2025-11-19T10:58:31.404" v="47" actId="478"/>
-          <ac:spMkLst>
-            <pc:docMk/>
-            <pc:sldMk cId="76015710" sldId="274"/>
-            <ac:spMk id="38" creationId="{BB03DB3F-AABC-78B6-177C-8257943D252C}"/>
-          </ac:spMkLst>
-        </pc:spChg>
-        <pc:spChg chg="del">
-          <ac:chgData name="Jean-Yves Vuillequez" userId="e7fac481abea6bd0" providerId="LiveId" clId="{79E365E8-22BC-4EC2-9606-9A9AC6CD1D22}" dt="2025-11-19T10:58:31.404" v="47" actId="478"/>
-          <ac:spMkLst>
-            <pc:docMk/>
-            <pc:sldMk cId="76015710" sldId="274"/>
-            <ac:spMk id="46" creationId="{322DB39E-A9B2-B285-9879-968293AD4F66}"/>
-          </ac:spMkLst>
-        </pc:spChg>
-        <pc:spChg chg="del">
-          <ac:chgData name="Jean-Yves Vuillequez" userId="e7fac481abea6bd0" providerId="LiveId" clId="{79E365E8-22BC-4EC2-9606-9A9AC6CD1D22}" dt="2025-11-19T10:58:31.404" v="47" actId="478"/>
-          <ac:spMkLst>
-            <pc:docMk/>
-            <pc:sldMk cId="76015710" sldId="274"/>
-            <ac:spMk id="51" creationId="{0CF2B953-3A17-D1D1-0C1F-3CC46B1E9440}"/>
-          </ac:spMkLst>
-        </pc:spChg>
-        <pc:spChg chg="del">
-          <ac:chgData name="Jean-Yves Vuillequez" userId="e7fac481abea6bd0" providerId="LiveId" clId="{79E365E8-22BC-4EC2-9606-9A9AC6CD1D22}" dt="2025-11-19T10:58:31.404" v="47" actId="478"/>
-          <ac:spMkLst>
-            <pc:docMk/>
-            <pc:sldMk cId="76015710" sldId="274"/>
-            <ac:spMk id="54" creationId="{B4290750-3B48-DB32-F34D-A5ED50FB2781}"/>
-          </ac:spMkLst>
-        </pc:spChg>
-        <pc:spChg chg="del">
-          <ac:chgData name="Jean-Yves Vuillequez" userId="e7fac481abea6bd0" providerId="LiveId" clId="{79E365E8-22BC-4EC2-9606-9A9AC6CD1D22}" dt="2025-11-19T10:58:33.360" v="48" actId="478"/>
-          <ac:spMkLst>
-            <pc:docMk/>
-            <pc:sldMk cId="76015710" sldId="274"/>
-            <ac:spMk id="55" creationId="{0E6AC91E-885F-D28E-5599-E7B82E562698}"/>
-          </ac:spMkLst>
-        </pc:spChg>
-        <pc:spChg chg="del">
-          <ac:chgData name="Jean-Yves Vuillequez" userId="e7fac481abea6bd0" providerId="LiveId" clId="{79E365E8-22BC-4EC2-9606-9A9AC6CD1D22}" dt="2025-11-19T10:58:31.404" v="47" actId="478"/>
-          <ac:spMkLst>
-            <pc:docMk/>
-            <pc:sldMk cId="76015710" sldId="274"/>
-            <ac:spMk id="64" creationId="{AB510ECB-2555-D6DB-1542-96D0D3B9EEC4}"/>
           </ac:spMkLst>
         </pc:spChg>
       </pc:sldChg>
@@ -794,14 +601,6 @@
             <pc:docMk/>
             <pc:sldMk cId="1821755839" sldId="274"/>
             <ac:spMk id="4" creationId="{CBCFB9A3-164B-59E0-23FF-58CBDB2217D5}"/>
-          </ac:spMkLst>
-        </pc:spChg>
-        <pc:spChg chg="add del">
-          <ac:chgData name="Jean-Yves Vuillequez" userId="e7fac481abea6bd0" providerId="LiveId" clId="{79E365E8-22BC-4EC2-9606-9A9AC6CD1D22}" dt="2025-11-19T15:21:25.434" v="149" actId="22"/>
-          <ac:spMkLst>
-            <pc:docMk/>
-            <pc:sldMk cId="1821755839" sldId="274"/>
-            <ac:spMk id="5" creationId="{42ECEDB8-E4FE-DAD1-959E-CE1C852FF3B7}"/>
           </ac:spMkLst>
         </pc:spChg>
         <pc:spChg chg="add del mod">
@@ -828,28 +627,12 @@
             <ac:spMk id="7" creationId="{67A62F17-EB69-4DE3-2CF4-7B669263DC3D}"/>
           </ac:spMkLst>
         </pc:spChg>
-        <pc:spChg chg="add del">
-          <ac:chgData name="Jean-Yves Vuillequez" userId="e7fac481abea6bd0" providerId="LiveId" clId="{79E365E8-22BC-4EC2-9606-9A9AC6CD1D22}" dt="2025-11-19T15:25:59.512" v="172" actId="22"/>
-          <ac:spMkLst>
-            <pc:docMk/>
-            <pc:sldMk cId="1821755839" sldId="274"/>
-            <ac:spMk id="7" creationId="{A1088045-42F5-FD97-ED83-6AEF73316F36}"/>
-          </ac:spMkLst>
-        </pc:spChg>
         <pc:spChg chg="mod">
           <ac:chgData name="Jean-Yves Vuillequez" userId="e7fac481abea6bd0" providerId="LiveId" clId="{79E365E8-22BC-4EC2-9606-9A9AC6CD1D22}" dt="2025-11-20T08:33:18.924" v="343"/>
           <ac:spMkLst>
             <pc:docMk/>
             <pc:sldMk cId="1821755839" sldId="274"/>
             <ac:spMk id="9" creationId="{7CF89CA7-8084-322B-0AD8-B63AD2B345E1}"/>
-          </ac:spMkLst>
-        </pc:spChg>
-        <pc:spChg chg="add del">
-          <ac:chgData name="Jean-Yves Vuillequez" userId="e7fac481abea6bd0" providerId="LiveId" clId="{79E365E8-22BC-4EC2-9606-9A9AC6CD1D22}" dt="2025-11-19T15:31:05.378" v="184" actId="22"/>
-          <ac:spMkLst>
-            <pc:docMk/>
-            <pc:sldMk cId="1821755839" sldId="274"/>
-            <ac:spMk id="9" creationId="{C85936DC-7A36-C7FD-89BC-2AF218A582C2}"/>
           </ac:spMkLst>
         </pc:spChg>
         <pc:spChg chg="mod">
@@ -1893,29 +1676,6 @@
           </ac:cxnSpMkLst>
         </pc:cxnChg>
       </pc:sldChg>
-      <pc:sldChg chg="modSp del mod">
-        <pc:chgData name="Jean-Yves Vuillequez" userId="e7fac481abea6bd0" providerId="LiveId" clId="{79E365E8-22BC-4EC2-9606-9A9AC6CD1D22}" dt="2025-11-19T11:00:27.703" v="73" actId="2696"/>
-        <pc:sldMkLst>
-          <pc:docMk/>
-          <pc:sldMk cId="4075992510" sldId="275"/>
-        </pc:sldMkLst>
-        <pc:spChg chg="mod">
-          <ac:chgData name="Jean-Yves Vuillequez" userId="e7fac481abea6bd0" providerId="LiveId" clId="{79E365E8-22BC-4EC2-9606-9A9AC6CD1D22}" dt="2025-11-19T10:58:13.405" v="45" actId="20577"/>
-          <ac:spMkLst>
-            <pc:docMk/>
-            <pc:sldMk cId="4075992510" sldId="275"/>
-            <ac:spMk id="13" creationId="{A4E917A3-F694-3B96-CCCF-E8B993CF7914}"/>
-          </ac:spMkLst>
-        </pc:spChg>
-        <pc:graphicFrameChg chg="modGraphic">
-          <ac:chgData name="Jean-Yves Vuillequez" userId="e7fac481abea6bd0" providerId="LiveId" clId="{79E365E8-22BC-4EC2-9606-9A9AC6CD1D22}" dt="2025-11-19T10:58:19.644" v="46" actId="6549"/>
-          <ac:graphicFrameMkLst>
-            <pc:docMk/>
-            <pc:sldMk cId="4075992510" sldId="275"/>
-            <ac:graphicFrameMk id="2" creationId="{B369D15F-B77E-9E89-4E59-4FB8C96A6FDE}"/>
-          </ac:graphicFrameMkLst>
-        </pc:graphicFrameChg>
-      </pc:sldChg>
       <pc:sldChg chg="addSp delSp modSp add mod ord">
         <pc:chgData name="Jean-Yves Vuillequez" userId="e7fac481abea6bd0" providerId="LiveId" clId="{79E365E8-22BC-4EC2-9606-9A9AC6CD1D22}" dt="2025-11-20T16:41:43.422" v="4740" actId="113"/>
         <pc:sldMkLst>
@@ -1979,55 +1739,6 @@
           </ac:graphicFrameMkLst>
         </pc:graphicFrameChg>
       </pc:sldChg>
-      <pc:sldChg chg="del">
-        <pc:chgData name="Jean-Yves Vuillequez" userId="e7fac481abea6bd0" providerId="LiveId" clId="{79E365E8-22BC-4EC2-9606-9A9AC6CD1D22}" dt="2025-11-19T10:58:46.543" v="50" actId="47"/>
-        <pc:sldMkLst>
-          <pc:docMk/>
-          <pc:sldMk cId="4260295178" sldId="276"/>
-        </pc:sldMkLst>
-      </pc:sldChg>
-      <pc:sldChg chg="del">
-        <pc:chgData name="Jean-Yves Vuillequez" userId="e7fac481abea6bd0" providerId="LiveId" clId="{79E365E8-22BC-4EC2-9606-9A9AC6CD1D22}" dt="2025-11-19T11:00:58.858" v="84" actId="47"/>
-        <pc:sldMkLst>
-          <pc:docMk/>
-          <pc:sldMk cId="2782134582" sldId="280"/>
-        </pc:sldMkLst>
-      </pc:sldChg>
-      <pc:sldChg chg="del">
-        <pc:chgData name="Jean-Yves Vuillequez" userId="e7fac481abea6bd0" providerId="LiveId" clId="{79E365E8-22BC-4EC2-9606-9A9AC6CD1D22}" dt="2025-11-19T11:00:58.858" v="84" actId="47"/>
-        <pc:sldMkLst>
-          <pc:docMk/>
-          <pc:sldMk cId="3379059680" sldId="281"/>
-        </pc:sldMkLst>
-      </pc:sldChg>
-      <pc:sldChg chg="del">
-        <pc:chgData name="Jean-Yves Vuillequez" userId="e7fac481abea6bd0" providerId="LiveId" clId="{79E365E8-22BC-4EC2-9606-9A9AC6CD1D22}" dt="2025-11-19T11:00:58.858" v="84" actId="47"/>
-        <pc:sldMkLst>
-          <pc:docMk/>
-          <pc:sldMk cId="1308464095" sldId="282"/>
-        </pc:sldMkLst>
-      </pc:sldChg>
-      <pc:sldChg chg="del">
-        <pc:chgData name="Jean-Yves Vuillequez" userId="e7fac481abea6bd0" providerId="LiveId" clId="{79E365E8-22BC-4EC2-9606-9A9AC6CD1D22}" dt="2025-11-19T11:00:58.858" v="84" actId="47"/>
-        <pc:sldMkLst>
-          <pc:docMk/>
-          <pc:sldMk cId="3541112122" sldId="283"/>
-        </pc:sldMkLst>
-      </pc:sldChg>
-      <pc:sldChg chg="del">
-        <pc:chgData name="Jean-Yves Vuillequez" userId="e7fac481abea6bd0" providerId="LiveId" clId="{79E365E8-22BC-4EC2-9606-9A9AC6CD1D22}" dt="2025-11-19T11:00:58.858" v="84" actId="47"/>
-        <pc:sldMkLst>
-          <pc:docMk/>
-          <pc:sldMk cId="3746995239" sldId="284"/>
-        </pc:sldMkLst>
-      </pc:sldChg>
-      <pc:sldChg chg="del">
-        <pc:chgData name="Jean-Yves Vuillequez" userId="e7fac481abea6bd0" providerId="LiveId" clId="{79E365E8-22BC-4EC2-9606-9A9AC6CD1D22}" dt="2025-11-19T11:00:58.858" v="84" actId="47"/>
-        <pc:sldMkLst>
-          <pc:docMk/>
-          <pc:sldMk cId="2602082869" sldId="285"/>
-        </pc:sldMkLst>
-      </pc:sldChg>
       <pc:sldChg chg="addSp delSp modSp mod addAnim delAnim modAnim modNotesTx">
         <pc:chgData name="Jean-Yves Vuillequez" userId="e7fac481abea6bd0" providerId="LiveId" clId="{79E365E8-22BC-4EC2-9606-9A9AC6CD1D22}" dt="2025-11-20T20:03:48.943" v="4847"/>
         <pc:sldMkLst>
@@ -2040,14 +1751,6 @@
             <pc:docMk/>
             <pc:sldMk cId="406580661" sldId="286"/>
             <ac:spMk id="2" creationId="{42BBF137-A4F8-10C8-E76C-714A4AC08CD8}"/>
-          </ac:spMkLst>
-        </pc:spChg>
-        <pc:spChg chg="add del mod">
-          <ac:chgData name="Jean-Yves Vuillequez" userId="e7fac481abea6bd0" providerId="LiveId" clId="{79E365E8-22BC-4EC2-9606-9A9AC6CD1D22}" dt="2025-11-19T15:04:10.897" v="143" actId="478"/>
-          <ac:spMkLst>
-            <pc:docMk/>
-            <pc:sldMk cId="406580661" sldId="286"/>
-            <ac:spMk id="3" creationId="{C43968D4-0691-98E3-02E7-DB654E7392F3}"/>
           </ac:spMkLst>
         </pc:spChg>
         <pc:spChg chg="add mod">
@@ -2266,76 +1969,12 @@
             <ac:spMk id="44" creationId="{52DAE273-297D-B78E-8D7A-2AA631E57226}"/>
           </ac:spMkLst>
         </pc:spChg>
-        <pc:spChg chg="del">
-          <ac:chgData name="Jean-Yves Vuillequez" userId="e7fac481abea6bd0" providerId="LiveId" clId="{79E365E8-22BC-4EC2-9606-9A9AC6CD1D22}" dt="2025-11-19T15:03:54.191" v="140" actId="478"/>
-          <ac:spMkLst>
-            <pc:docMk/>
-            <pc:sldMk cId="406580661" sldId="286"/>
-            <ac:spMk id="69" creationId="{2DFE67F9-5520-F4B8-B6C5-40C9605525B6}"/>
-          </ac:spMkLst>
-        </pc:spChg>
         <pc:spChg chg="mod">
           <ac:chgData name="Jean-Yves Vuillequez" userId="e7fac481abea6bd0" providerId="LiveId" clId="{79E365E8-22BC-4EC2-9606-9A9AC6CD1D22}" dt="2025-11-20T08:33:31.466" v="346" actId="113"/>
           <ac:spMkLst>
             <pc:docMk/>
             <pc:sldMk cId="406580661" sldId="286"/>
             <ac:spMk id="70" creationId="{6C332C7A-0C1B-7002-DD8F-E4EB26F3199D}"/>
-          </ac:spMkLst>
-        </pc:spChg>
-        <pc:spChg chg="del mod">
-          <ac:chgData name="Jean-Yves Vuillequez" userId="e7fac481abea6bd0" providerId="LiveId" clId="{79E365E8-22BC-4EC2-9606-9A9AC6CD1D22}" dt="2025-11-19T15:04:08.497" v="142" actId="478"/>
-          <ac:spMkLst>
-            <pc:docMk/>
-            <pc:sldMk cId="406580661" sldId="286"/>
-            <ac:spMk id="73" creationId="{1362DE8B-B008-E6AB-C9CD-6095A12B8D39}"/>
-          </ac:spMkLst>
-        </pc:spChg>
-        <pc:spChg chg="del mod">
-          <ac:chgData name="Jean-Yves Vuillequez" userId="e7fac481abea6bd0" providerId="LiveId" clId="{79E365E8-22BC-4EC2-9606-9A9AC6CD1D22}" dt="2025-11-19T15:03:54.191" v="140" actId="478"/>
-          <ac:spMkLst>
-            <pc:docMk/>
-            <pc:sldMk cId="406580661" sldId="286"/>
-            <ac:spMk id="74" creationId="{594EF5A4-95A8-DB9E-307C-92C5044EEF3F}"/>
-          </ac:spMkLst>
-        </pc:spChg>
-        <pc:spChg chg="del mod">
-          <ac:chgData name="Jean-Yves Vuillequez" userId="e7fac481abea6bd0" providerId="LiveId" clId="{79E365E8-22BC-4EC2-9606-9A9AC6CD1D22}" dt="2025-11-19T15:03:57.484" v="141" actId="478"/>
-          <ac:spMkLst>
-            <pc:docMk/>
-            <pc:sldMk cId="406580661" sldId="286"/>
-            <ac:spMk id="75" creationId="{2DA76B5D-5507-C433-3A50-BA24AFDD5759}"/>
-          </ac:spMkLst>
-        </pc:spChg>
-        <pc:spChg chg="del mod">
-          <ac:chgData name="Jean-Yves Vuillequez" userId="e7fac481abea6bd0" providerId="LiveId" clId="{79E365E8-22BC-4EC2-9606-9A9AC6CD1D22}" dt="2025-11-19T15:03:57.484" v="141" actId="478"/>
-          <ac:spMkLst>
-            <pc:docMk/>
-            <pc:sldMk cId="406580661" sldId="286"/>
-            <ac:spMk id="76" creationId="{0D0BEA13-407D-BB40-EDD4-89543044A7D8}"/>
-          </ac:spMkLst>
-        </pc:spChg>
-        <pc:spChg chg="del mod">
-          <ac:chgData name="Jean-Yves Vuillequez" userId="e7fac481abea6bd0" providerId="LiveId" clId="{79E365E8-22BC-4EC2-9606-9A9AC6CD1D22}" dt="2025-11-19T15:03:57.484" v="141" actId="478"/>
-          <ac:spMkLst>
-            <pc:docMk/>
-            <pc:sldMk cId="406580661" sldId="286"/>
-            <ac:spMk id="77" creationId="{4B2D55FD-E6CB-F70B-1A6D-C59E9EAB43E2}"/>
-          </ac:spMkLst>
-        </pc:spChg>
-        <pc:spChg chg="del">
-          <ac:chgData name="Jean-Yves Vuillequez" userId="e7fac481abea6bd0" providerId="LiveId" clId="{79E365E8-22BC-4EC2-9606-9A9AC6CD1D22}" dt="2025-11-19T10:59:15.865" v="69" actId="478"/>
-          <ac:spMkLst>
-            <pc:docMk/>
-            <pc:sldMk cId="406580661" sldId="286"/>
-            <ac:spMk id="78" creationId="{EE57DF56-19D6-5F9D-623C-FD197620AB38}"/>
-          </ac:spMkLst>
-        </pc:spChg>
-        <pc:spChg chg="del">
-          <ac:chgData name="Jean-Yves Vuillequez" userId="e7fac481abea6bd0" providerId="LiveId" clId="{79E365E8-22BC-4EC2-9606-9A9AC6CD1D22}" dt="2025-11-19T10:59:15.865" v="69" actId="478"/>
-          <ac:spMkLst>
-            <pc:docMk/>
-            <pc:sldMk cId="406580661" sldId="286"/>
-            <ac:spMk id="79" creationId="{9872CB08-4753-4C4E-189F-43C9459E961D}"/>
           </ac:spMkLst>
         </pc:spChg>
         <pc:grpChg chg="add mod">
@@ -2547,13 +2186,6 @@
         </pc:picChg>
       </pc:sldChg>
       <pc:sldChg chg="add del">
-        <pc:chgData name="Jean-Yves Vuillequez" userId="e7fac481abea6bd0" providerId="LiveId" clId="{79E365E8-22BC-4EC2-9606-9A9AC6CD1D22}" dt="2025-11-19T18:14:09.212" v="197"/>
-        <pc:sldMkLst>
-          <pc:docMk/>
-          <pc:sldMk cId="919858653" sldId="288"/>
-        </pc:sldMkLst>
-      </pc:sldChg>
-      <pc:sldChg chg="add del">
         <pc:chgData name="Jean-Yves Vuillequez" userId="e7fac481abea6bd0" providerId="LiveId" clId="{79E365E8-22BC-4EC2-9606-9A9AC6CD1D22}" dt="2025-11-20T16:28:21.698" v="4730"/>
         <pc:sldMkLst>
           <pc:docMk/>
@@ -2670,21 +2302,6 @@
           </ac:spMkLst>
         </pc:spChg>
       </pc:sldChg>
-      <pc:sldChg chg="modSp add del">
-        <pc:chgData name="Jean-Yves Vuillequez" userId="e7fac481abea6bd0" providerId="LiveId" clId="{79E365E8-22BC-4EC2-9606-9A9AC6CD1D22}" dt="2025-11-19T18:59:08.937" v="303" actId="47"/>
-        <pc:sldMkLst>
-          <pc:docMk/>
-          <pc:sldMk cId="3738511160" sldId="290"/>
-        </pc:sldMkLst>
-        <pc:spChg chg="mod">
-          <ac:chgData name="Jean-Yves Vuillequez" userId="e7fac481abea6bd0" providerId="LiveId" clId="{79E365E8-22BC-4EC2-9606-9A9AC6CD1D22}" dt="2025-11-19T18:59:02.352" v="301"/>
-          <ac:spMkLst>
-            <pc:docMk/>
-            <pc:sldMk cId="3738511160" sldId="290"/>
-            <ac:spMk id="70" creationId="{4B63368A-49D0-EF4C-D66D-6EEF2743BE0B}"/>
-          </ac:spMkLst>
-        </pc:spChg>
-      </pc:sldChg>
       <pc:sldChg chg="addSp delSp modSp add mod">
         <pc:chgData name="Jean-Yves Vuillequez" userId="e7fac481abea6bd0" providerId="LiveId" clId="{79E365E8-22BC-4EC2-9606-9A9AC6CD1D22}" dt="2025-11-20T14:45:38.621" v="3933"/>
         <pc:sldMkLst>
@@ -2733,13 +2350,13 @@
         </pc:spChg>
       </pc:sldChg>
       <pc:sldChg chg="addSp delSp modSp add mod ord delAnim modAnim modNotesTx">
-        <pc:chgData name="Jean-Yves Vuillequez" userId="e7fac481abea6bd0" providerId="LiveId" clId="{79E365E8-22BC-4EC2-9606-9A9AC6CD1D22}" dt="2025-11-20T20:38:01.208" v="5232"/>
+        <pc:chgData name="Jean-Yves Vuillequez" userId="e7fac481abea6bd0" providerId="LiveId" clId="{79E365E8-22BC-4EC2-9606-9A9AC6CD1D22}" dt="2025-11-21T02:14:36.257" v="5432" actId="1076"/>
         <pc:sldMkLst>
           <pc:docMk/>
           <pc:sldMk cId="3315518580" sldId="292"/>
         </pc:sldMkLst>
         <pc:spChg chg="add mod">
-          <ac:chgData name="Jean-Yves Vuillequez" userId="e7fac481abea6bd0" providerId="LiveId" clId="{79E365E8-22BC-4EC2-9606-9A9AC6CD1D22}" dt="2025-11-20T15:04:30.018" v="3955" actId="403"/>
+          <ac:chgData name="Jean-Yves Vuillequez" userId="e7fac481abea6bd0" providerId="LiveId" clId="{79E365E8-22BC-4EC2-9606-9A9AC6CD1D22}" dt="2025-11-21T02:11:56.158" v="5290" actId="6549"/>
           <ac:spMkLst>
             <pc:docMk/>
             <pc:sldMk cId="3315518580" sldId="292"/>
@@ -2778,6 +2395,14 @@
             <ac:spMk id="4" creationId="{CDF36CC3-8438-C6F0-3E01-EC79EEB762E1}"/>
           </ac:spMkLst>
         </pc:spChg>
+        <pc:spChg chg="add mod">
+          <ac:chgData name="Jean-Yves Vuillequez" userId="e7fac481abea6bd0" providerId="LiveId" clId="{79E365E8-22BC-4EC2-9606-9A9AC6CD1D22}" dt="2025-11-21T02:14:36.257" v="5432" actId="1076"/>
+          <ac:spMkLst>
+            <pc:docMk/>
+            <pc:sldMk cId="3315518580" sldId="292"/>
+            <ac:spMk id="4" creationId="{DC681EF8-A850-D11F-7ECC-97847033BF06}"/>
+          </ac:spMkLst>
+        </pc:spChg>
         <pc:spChg chg="add">
           <ac:chgData name="Jean-Yves Vuillequez" userId="e7fac481abea6bd0" providerId="LiveId" clId="{79E365E8-22BC-4EC2-9606-9A9AC6CD1D22}" dt="2025-11-20T15:03:44.399" v="3944"/>
           <ac:spMkLst>
@@ -2787,7 +2412,7 @@
           </ac:spMkLst>
         </pc:spChg>
         <pc:spChg chg="add mod">
-          <ac:chgData name="Jean-Yves Vuillequez" userId="e7fac481abea6bd0" providerId="LiveId" clId="{79E365E8-22BC-4EC2-9606-9A9AC6CD1D22}" dt="2025-11-20T15:15:34.139" v="4044" actId="1076"/>
+          <ac:chgData name="Jean-Yves Vuillequez" userId="e7fac481abea6bd0" providerId="LiveId" clId="{79E365E8-22BC-4EC2-9606-9A9AC6CD1D22}" dt="2025-11-21T02:14:00.132" v="5414" actId="20577"/>
           <ac:spMkLst>
             <pc:docMk/>
             <pc:sldMk cId="3315518580" sldId="292"/>
@@ -3010,7 +2635,7 @@
         </pc:spChg>
       </pc:sldChg>
       <pc:sldChg chg="modSp add mod">
-        <pc:chgData name="Jean-Yves Vuillequez" userId="e7fac481abea6bd0" providerId="LiveId" clId="{79E365E8-22BC-4EC2-9606-9A9AC6CD1D22}" dt="2025-11-20T16:41:47.501" v="4741" actId="113"/>
+        <pc:chgData name="Jean-Yves Vuillequez" userId="e7fac481abea6bd0" providerId="LiveId" clId="{79E365E8-22BC-4EC2-9606-9A9AC6CD1D22}" dt="2025-11-21T02:29:34.535" v="5608" actId="6549"/>
         <pc:sldMkLst>
           <pc:docMk/>
           <pc:sldMk cId="4010613788" sldId="294"/>
@@ -3023,6 +2648,14 @@
             <ac:spMk id="96" creationId="{A01AE6FF-5294-F6EC-FB0D-D63D7D63D71C}"/>
           </ac:spMkLst>
         </pc:spChg>
+        <pc:graphicFrameChg chg="modGraphic">
+          <ac:chgData name="Jean-Yves Vuillequez" userId="e7fac481abea6bd0" providerId="LiveId" clId="{79E365E8-22BC-4EC2-9606-9A9AC6CD1D22}" dt="2025-11-21T02:29:34.535" v="5608" actId="6549"/>
+          <ac:graphicFrameMkLst>
+            <pc:docMk/>
+            <pc:sldMk cId="4010613788" sldId="294"/>
+            <ac:graphicFrameMk id="2" creationId="{1F110593-1E38-6872-65AA-F9F3DBB52889}"/>
+          </ac:graphicFrameMkLst>
+        </pc:graphicFrameChg>
       </pc:sldChg>
       <pc:sldChg chg="modSp add mod">
         <pc:chgData name="Jean-Yves Vuillequez" userId="e7fac481abea6bd0" providerId="LiveId" clId="{79E365E8-22BC-4EC2-9606-9A9AC6CD1D22}" dt="2025-11-20T20:45:26.230" v="5250" actId="20577"/>
@@ -3048,7 +2681,7 @@
         </pc:graphicFrameChg>
       </pc:sldChg>
       <pc:sldChg chg="modSp add mod">
-        <pc:chgData name="Jean-Yves Vuillequez" userId="e7fac481abea6bd0" providerId="LiveId" clId="{79E365E8-22BC-4EC2-9606-9A9AC6CD1D22}" dt="2025-11-20T16:41:57.627" v="4743" actId="113"/>
+        <pc:chgData name="Jean-Yves Vuillequez" userId="e7fac481abea6bd0" providerId="LiveId" clId="{79E365E8-22BC-4EC2-9606-9A9AC6CD1D22}" dt="2025-11-21T02:15:47.871" v="5462" actId="20577"/>
         <pc:sldMkLst>
           <pc:docMk/>
           <pc:sldMk cId="2552402859" sldId="296"/>
@@ -3062,7 +2695,7 @@
           </ac:spMkLst>
         </pc:spChg>
         <pc:graphicFrameChg chg="mod modGraphic">
-          <ac:chgData name="Jean-Yves Vuillequez" userId="e7fac481abea6bd0" providerId="LiveId" clId="{79E365E8-22BC-4EC2-9606-9A9AC6CD1D22}" dt="2025-11-20T16:29:44.257" v="4737" actId="14100"/>
+          <ac:chgData name="Jean-Yves Vuillequez" userId="e7fac481abea6bd0" providerId="LiveId" clId="{79E365E8-22BC-4EC2-9606-9A9AC6CD1D22}" dt="2025-11-21T02:15:47.871" v="5462" actId="20577"/>
           <ac:graphicFrameMkLst>
             <pc:docMk/>
             <pc:sldMk cId="2552402859" sldId="296"/>
@@ -19312,11 +18945,11 @@
             </a:pPr>
             <a:r>
               <a:rPr lang="fr-FR" b="1" dirty="0"/>
-              <a:t>Visibilité sur 3 jours</a:t>
+              <a:t>Visibilité sur 3 jours : </a:t>
             </a:r>
             <a:r>
               <a:rPr lang="fr-FR" dirty="0"/>
-              <a:t>, permettant une planification énergétique plus fiable</a:t>
+              <a:t>Planification énergétique plus fiable</a:t>
             </a:r>
           </a:p>
           <a:p>
@@ -19333,7 +18966,7 @@
             </a:r>
             <a:r>
               <a:rPr lang="fr-FR" dirty="0"/>
-              <a:t>, contribuant à un réseau plus stable</a:t>
+              <a:t> : Réseau plus stable</a:t>
             </a:r>
           </a:p>
           <a:p>
@@ -19346,11 +18979,11 @@
             </a:pPr>
             <a:r>
               <a:rPr lang="fr-FR" b="1" dirty="0"/>
-              <a:t>Analyse régionale précise</a:t>
+              <a:t>Analyse régionale précise : </a:t>
             </a:r>
             <a:r>
               <a:rPr lang="fr-FR" dirty="0"/>
-              <a:t>, facilitant la priorisation des zones à fort potentiel solaire</a:t>
+              <a:t>Priorisation des zones à fort potentiel solaire</a:t>
             </a:r>
           </a:p>
           <a:p>
@@ -19363,7 +18996,7 @@
             </a:pPr>
             <a:r>
               <a:rPr lang="fr-FR" b="1" dirty="0"/>
-              <a:t>Outil d’aide à la décision simple, clair et directement exploitable</a:t>
+              <a:t>Outil d’aide à la décision</a:t>
             </a:r>
             <a:endParaRPr lang="fr-FR" dirty="0"/>
           </a:p>
@@ -19453,7 +19086,7 @@
             </a:r>
             <a:r>
               <a:rPr lang="fr-FR" dirty="0"/>
-              <a:t> des données et des prévisions</a:t>
+              <a:t> des données et des prévisions (prédictions lancées en synchrone depuis le Dashboard)</a:t>
             </a:r>
           </a:p>
           <a:p>
@@ -19474,7 +19107,7 @@
             </a:r>
             <a:r>
               <a:rPr lang="fr-FR" dirty="0"/>
-              <a:t>, appuyée sur les données RTE mises à jour toutes les 30 minutes</a:t>
+              <a:t> : données RTE mises à jour toutes les 30 minutes (intérêt métier à vérifier)</a:t>
             </a:r>
           </a:p>
           <a:p>
@@ -19491,8 +19124,18 @@
             </a:r>
             <a:r>
               <a:rPr lang="fr-FR" dirty="0"/>
-              <a:t> (nuages, albédo, couverture atmosphérique)</a:t>
+              <a:t> (nuages, couverture atmosphérique)</a:t>
             </a:r>
+          </a:p>
+          <a:p>
+            <a:pPr marL="285750" indent="-285750">
+              <a:spcBef>
+                <a:spcPts val="1200"/>
+              </a:spcBef>
+              <a:buFont typeface="Arial" panose="020B0604020202020204" pitchFamily="34" charset="0"/>
+              <a:buChar char="•"/>
+            </a:pPr>
+            <a:endParaRPr lang="fr-FR" dirty="0"/>
           </a:p>
         </p:txBody>
       </p:sp>
@@ -19752,6 +19395,51 @@
           <a:p>
             <a:pPr algn="ctr"/>
             <a:endParaRPr lang="fr-FR" dirty="0"/>
+          </a:p>
+        </p:txBody>
+      </p:sp>
+      <p:sp>
+        <p:nvSpPr>
+          <p:cNvPr id="4" name="ZoneTexte 3">
+            <a:extLst>
+              <a:ext uri="{FF2B5EF4-FFF2-40B4-BE49-F238E27FC236}">
+                <a16:creationId xmlns:a16="http://schemas.microsoft.com/office/drawing/2014/main" id="{DC681EF8-A850-D11F-7ECC-97847033BF06}"/>
+              </a:ext>
+            </a:extLst>
+          </p:cNvPr>
+          <p:cNvSpPr txBox="1"/>
+          <p:nvPr/>
+        </p:nvSpPr>
+        <p:spPr>
+          <a:xfrm rot="443839">
+            <a:off x="5562932" y="1075208"/>
+            <a:ext cx="3244850" cy="584775"/>
+          </a:xfrm>
+          <a:prstGeom prst="rect">
+            <a:avLst/>
+          </a:prstGeom>
+          <a:noFill/>
+          <a:ln>
+            <a:solidFill>
+              <a:srgbClr val="FF0000"/>
+            </a:solidFill>
+          </a:ln>
+        </p:spPr>
+        <p:txBody>
+          <a:bodyPr wrap="square" rtlCol="0">
+            <a:spAutoFit/>
+          </a:bodyPr>
+          <a:lstStyle/>
+          <a:p>
+            <a:pPr algn="ctr"/>
+            <a:r>
+              <a:rPr lang="fr-FR" sz="3200" dirty="0">
+                <a:solidFill>
+                  <a:srgbClr val="FF0000"/>
+                </a:solidFill>
+              </a:rPr>
+              <a:t>A discuter</a:t>
+            </a:r>
           </a:p>
         </p:txBody>
       </p:sp>
@@ -20700,7 +20388,13 @@
           <p:cNvGraphicFramePr>
             <a:graphicFrameLocks noGrp="1"/>
           </p:cNvGraphicFramePr>
-          <p:nvPr/>
+          <p:nvPr>
+            <p:extLst>
+              <p:ext uri="{D42A27DB-BD31-4B8C-83A1-F6EECF244321}">
+                <p14:modId xmlns:p14="http://schemas.microsoft.com/office/powerpoint/2010/main" val="2643252541"/>
+              </p:ext>
+            </p:extLst>
+          </p:nvPr>
         </p:nvGraphicFramePr>
         <p:xfrm>
           <a:off x="463375" y="1160010"/>
@@ -21042,9 +20736,6 @@
                   <a:txBody>
                     <a:bodyPr/>
                     <a:lstStyle/>
-                    <a:p>
-                      <a:endParaRPr lang="fr-FR" sz="700" dirty="0"/>
-                    </a:p>
                     <a:p>
                       <a:r>
                         <a:rPr lang="fr-FR" sz="700" dirty="0">
@@ -22957,7 +22648,7 @@
           <p:nvPr>
             <p:extLst>
               <p:ext uri="{D42A27DB-BD31-4B8C-83A1-F6EECF244321}">
-                <p14:modId xmlns:p14="http://schemas.microsoft.com/office/powerpoint/2010/main" val="286112335"/>
+                <p14:modId xmlns:p14="http://schemas.microsoft.com/office/powerpoint/2010/main" val="687343311"/>
               </p:ext>
             </p:extLst>
           </p:nvPr>
@@ -23147,9 +22838,14 @@
                     <a:lstStyle/>
                     <a:p>
                       <a:r>
-                        <a:rPr sz="900"/>
-                        <a:t>Feature eng.</a:t>
+                        <a:rPr sz="900" dirty="0"/>
+                        <a:t>Feature </a:t>
                       </a:r>
+                      <a:r>
+                        <a:rPr lang="fr-FR" sz="900" dirty="0"/>
+                        <a:t>engineering</a:t>
+                      </a:r>
+                      <a:endParaRPr sz="900" dirty="0"/>
                     </a:p>
                   </a:txBody>
                   <a:tcPr/>
@@ -23242,9 +22938,10 @@
                     <a:lstStyle/>
                     <a:p>
                       <a:r>
-                        <a:rPr sz="900"/>
+                        <a:rPr sz="900" dirty="0" err="1"/>
                         <a:t>Modélisation</a:t>
                       </a:r>
+                      <a:endParaRPr sz="900" dirty="0"/>
                     </a:p>
                   </a:txBody>
                   <a:tcPr/>
@@ -23433,7 +23130,7 @@
                     <a:lstStyle/>
                     <a:p>
                       <a:r>
-                        <a:rPr sz="900"/>
+                        <a:rPr sz="900" dirty="0"/>
                         <a:t>API</a:t>
                       </a:r>
                     </a:p>
@@ -23528,7 +23225,7 @@
                     <a:lstStyle/>
                     <a:p>
                       <a:r>
-                        <a:rPr sz="900"/>
+                        <a:rPr sz="900" dirty="0"/>
                         <a:t>Dashboard</a:t>
                       </a:r>
                     </a:p>
@@ -24211,6 +23908,34 @@
               <a:buFont typeface="Arial"/>
               <a:buNone/>
             </a:pPr>
+            <a:endParaRPr lang="fr-FR" sz="1400" b="0" i="0" u="none" strike="noStrike" cap="none" dirty="0">
+              <a:solidFill>
+                <a:srgbClr val="000000"/>
+              </a:solidFill>
+              <a:latin typeface="Arial"/>
+              <a:ea typeface="Arial"/>
+              <a:cs typeface="Arial"/>
+              <a:sym typeface="Arial"/>
+            </a:endParaRPr>
+          </a:p>
+          <a:p>
+            <a:pPr marL="0" marR="0" lvl="0" indent="0" algn="l" rtl="0">
+              <a:lnSpc>
+                <a:spcPct val="200000"/>
+              </a:lnSpc>
+              <a:spcBef>
+                <a:spcPts val="0"/>
+              </a:spcBef>
+              <a:spcAft>
+                <a:spcPts val="0"/>
+              </a:spcAft>
+              <a:buClr>
+                <a:srgbClr val="000000"/>
+              </a:buClr>
+              <a:buSzPts val="1400"/>
+              <a:buFont typeface="Arial"/>
+              <a:buNone/>
+            </a:pPr>
             <a:r>
               <a:rPr lang="fr-FR" sz="1400" b="0" i="0" u="none" strike="noStrike" cap="none" dirty="0" err="1">
                 <a:solidFill>
@@ -24221,7 +23946,7 @@
                 <a:cs typeface="Arial"/>
                 <a:sym typeface="Arial"/>
               </a:rPr>
-              <a:t>Xxxxxxx</a:t>
+              <a:t>Jhon</a:t>
             </a:r>
             <a:r>
               <a:rPr lang="fr-FR" sz="1400" b="0" i="0" u="none" strike="noStrike" cap="none" dirty="0">
@@ -24233,7 +23958,7 @@
                 <a:cs typeface="Arial"/>
                 <a:sym typeface="Arial"/>
               </a:rPr>
-              <a:t>  XXXXXXXX</a:t>
+              <a:t> DUBOS</a:t>
             </a:r>
             <a:endParaRPr sz="1400" b="0" i="0" u="none" strike="noStrike" cap="none" dirty="0">
               <a:solidFill>
@@ -24253,12 +23978,8 @@
               <a:buSzPts val="1400"/>
             </a:pPr>
             <a:r>
-              <a:rPr lang="fr-FR" dirty="0" err="1"/>
-              <a:t>Xxxxxxx</a:t>
-            </a:r>
-            <a:r>
               <a:rPr lang="fr-FR" dirty="0"/>
-              <a:t>  XXXXXXXX</a:t>
+              <a:t>Sandrine HARDY</a:t>
             </a:r>
           </a:p>
           <a:p>
@@ -24269,12 +23990,8 @@
               <a:buSzPts val="1400"/>
             </a:pPr>
             <a:r>
-              <a:rPr lang="fr-FR" dirty="0" err="1"/>
-              <a:t>Xxxxxxx</a:t>
-            </a:r>
-            <a:r>
               <a:rPr lang="fr-FR" dirty="0"/>
-              <a:t>  XXXXXXXX</a:t>
+              <a:t>Jean-Yves VUILLEQUEZ</a:t>
             </a:r>
           </a:p>
           <a:p>
@@ -24285,12 +24002,20 @@
               <a:buSzPts val="1400"/>
             </a:pPr>
             <a:r>
-              <a:rPr lang="fr-FR" dirty="0" err="1"/>
-              <a:t>Xxxxxxx</a:t>
+              <a:rPr lang="fr-FR" dirty="0"/>
+              <a:t>Victor NOUANE</a:t>
             </a:r>
+          </a:p>
+          <a:p>
+            <a:pPr>
+              <a:lnSpc>
+                <a:spcPct val="200000"/>
+              </a:lnSpc>
+              <a:buSzPts val="1400"/>
+            </a:pPr>
             <a:r>
               <a:rPr lang="fr-FR" dirty="0"/>
-              <a:t>  XXXXXXXX</a:t>
+              <a:t>Eduardo NAVARRETE</a:t>
             </a:r>
           </a:p>
           <a:p>
@@ -24437,7 +24162,7 @@
                   <a:srgbClr val="FF0000"/>
                 </a:solidFill>
               </a:rPr>
-              <a:t>A mettre à jour</a:t>
+              <a:t>MAJ illustration</a:t>
             </a:r>
           </a:p>
         </p:txBody>

</xml_diff>

<commit_message>
Mise à jour dashboard, suivi projet, présentation
</commit_message>
<xml_diff>
--- a/presentation/dsfs_ft_36_Projet_REnergies_efficiency_prediction.pptx
+++ b/presentation/dsfs_ft_36_Projet_REnergies_efficiency_prediction.pptx
@@ -291,7 +291,7 @@
 <file path=ppt/revisionInfo.xml><?xml version="1.0" encoding="utf-8"?>
 <p1510:revInfo xmlns:a="http://schemas.openxmlformats.org/drawingml/2006/main" xmlns:r="http://schemas.openxmlformats.org/officeDocument/2006/relationships" xmlns:p1510="http://schemas.microsoft.com/office/powerpoint/2015/10/main">
   <p1510:revLst>
-    <p1510:client id="{2EB72A00-7F79-4813-B4C2-C6564860F3F6}" v="1576" dt="2025-11-21T02:14:12.346"/>
+    <p1510:client id="{2EB72A00-7F79-4813-B4C2-C6564860F3F6}" v="1578" dt="2025-11-21T09:08:53.483"/>
   </p1510:revLst>
 </p1510:revInfo>
 </file>
@@ -301,7 +301,7 @@
   <pc:docChgLst>
     <pc:chgData name="Jean-Yves Vuillequez" userId="e7fac481abea6bd0" providerId="LiveId" clId="{79E365E8-22BC-4EC2-9606-9A9AC6CD1D22}"/>
     <pc:docChg chg="undo custSel addSld delSld modSld sldOrd">
-      <pc:chgData name="Jean-Yves Vuillequez" userId="e7fac481abea6bd0" providerId="LiveId" clId="{79E365E8-22BC-4EC2-9606-9A9AC6CD1D22}" dt="2025-11-21T02:29:34.535" v="5608" actId="6549"/>
+      <pc:chgData name="Jean-Yves Vuillequez" userId="e7fac481abea6bd0" providerId="LiveId" clId="{79E365E8-22BC-4EC2-9606-9A9AC6CD1D22}" dt="2025-11-21T09:08:53.483" v="5611"/>
       <pc:docMkLst>
         <pc:docMk/>
       </pc:docMkLst>
@@ -2350,7 +2350,7 @@
         </pc:spChg>
       </pc:sldChg>
       <pc:sldChg chg="addSp delSp modSp add mod ord delAnim modAnim modNotesTx">
-        <pc:chgData name="Jean-Yves Vuillequez" userId="e7fac481abea6bd0" providerId="LiveId" clId="{79E365E8-22BC-4EC2-9606-9A9AC6CD1D22}" dt="2025-11-21T02:14:36.257" v="5432" actId="1076"/>
+        <pc:chgData name="Jean-Yves Vuillequez" userId="e7fac481abea6bd0" providerId="LiveId" clId="{79E365E8-22BC-4EC2-9606-9A9AC6CD1D22}" dt="2025-11-21T09:08:53.483" v="5611"/>
         <pc:sldMkLst>
           <pc:docMk/>
           <pc:sldMk cId="3315518580" sldId="292"/>
@@ -2412,7 +2412,7 @@
           </ac:spMkLst>
         </pc:spChg>
         <pc:spChg chg="add mod">
-          <ac:chgData name="Jean-Yves Vuillequez" userId="e7fac481abea6bd0" providerId="LiveId" clId="{79E365E8-22BC-4EC2-9606-9A9AC6CD1D22}" dt="2025-11-21T02:14:00.132" v="5414" actId="20577"/>
+          <ac:chgData name="Jean-Yves Vuillequez" userId="e7fac481abea6bd0" providerId="LiveId" clId="{79E365E8-22BC-4EC2-9606-9A9AC6CD1D22}" dt="2025-11-21T09:08:53.483" v="5611"/>
           <ac:spMkLst>
             <pc:docMk/>
             <pc:sldMk cId="3315518580" sldId="292"/>
@@ -18929,7 +18929,7 @@
               <a:buChar char="•"/>
               <a:defRPr/>
             </a:pPr>
-            <a:endParaRPr lang="fr-FR" kern="1200" dirty="0">
+            <a:endParaRPr lang="fr-FR" sz="1200" kern="1200" dirty="0">
               <a:latin typeface="Calibri"/>
               <a:ea typeface="Calibri"/>
               <a:cs typeface="Calibri"/>
@@ -18944,11 +18944,11 @@
               <a:buChar char="•"/>
             </a:pPr>
             <a:r>
-              <a:rPr lang="fr-FR" b="1" dirty="0"/>
+              <a:rPr lang="fr-FR" sz="1200" b="1" dirty="0"/>
               <a:t>Visibilité sur 3 jours : </a:t>
             </a:r>
             <a:r>
-              <a:rPr lang="fr-FR" dirty="0"/>
+              <a:rPr lang="fr-FR" sz="1200" dirty="0"/>
               <a:t>Planification énergétique plus fiable</a:t>
             </a:r>
           </a:p>
@@ -18961,11 +18961,11 @@
               <a:buChar char="•"/>
             </a:pPr>
             <a:r>
-              <a:rPr lang="fr-FR" b="1" dirty="0"/>
+              <a:rPr lang="fr-FR" sz="1200" b="1" dirty="0"/>
               <a:t>Détection proactive des pics et creux</a:t>
             </a:r>
             <a:r>
-              <a:rPr lang="fr-FR" dirty="0"/>
+              <a:rPr lang="fr-FR" sz="1200" dirty="0"/>
               <a:t> : Réseau plus stable</a:t>
             </a:r>
           </a:p>
@@ -18978,11 +18978,11 @@
               <a:buChar char="•"/>
             </a:pPr>
             <a:r>
-              <a:rPr lang="fr-FR" b="1" dirty="0"/>
+              <a:rPr lang="fr-FR" sz="1200" b="1" dirty="0"/>
               <a:t>Analyse régionale précise : </a:t>
             </a:r>
             <a:r>
-              <a:rPr lang="fr-FR" dirty="0"/>
+              <a:rPr lang="fr-FR" sz="1200" dirty="0"/>
               <a:t>Priorisation des zones à fort potentiel solaire</a:t>
             </a:r>
           </a:p>
@@ -18995,20 +18995,22 @@
               <a:buChar char="•"/>
             </a:pPr>
             <a:r>
-              <a:rPr lang="fr-FR" b="1" dirty="0"/>
+              <a:rPr lang="fr-FR" sz="1200" b="1" dirty="0"/>
               <a:t>Outil d’aide à la décision</a:t>
             </a:r>
-            <a:endParaRPr lang="fr-FR" dirty="0"/>
+            <a:endParaRPr lang="fr-FR" sz="1200" dirty="0"/>
           </a:p>
           <a:p>
-            <a:pPr>
+            <a:pPr marL="285750" indent="-285750">
               <a:spcBef>
                 <a:spcPts val="300"/>
               </a:spcBef>
               <a:buClrTx/>
+              <a:buFont typeface="Arial" panose="020B0604020202020204" pitchFamily="34" charset="0"/>
+              <a:buChar char="•"/>
               <a:defRPr/>
             </a:pPr>
-            <a:endParaRPr lang="fr-FR" kern="1200" dirty="0">
+            <a:endParaRPr lang="fr-FR" sz="1200" kern="1200" dirty="0">
               <a:latin typeface="Calibri"/>
               <a:ea typeface="Calibri"/>
               <a:cs typeface="Calibri"/>
@@ -19066,7 +19068,7 @@
               <a:buChar char="•"/>
               <a:defRPr/>
             </a:pPr>
-            <a:endParaRPr lang="fr-FR" kern="1200" dirty="0">
+            <a:endParaRPr lang="fr-FR" sz="1200" kern="1200" dirty="0">
               <a:latin typeface="Calibri"/>
               <a:ea typeface="Calibri"/>
               <a:cs typeface="Calibri"/>
@@ -19081,12 +19083,12 @@
               <a:buChar char="•"/>
             </a:pPr>
             <a:r>
-              <a:rPr lang="fr-FR" b="1" dirty="0"/>
+              <a:rPr lang="fr-FR" sz="1200" b="1" dirty="0"/>
               <a:t>Passage en temps réel</a:t>
             </a:r>
             <a:r>
-              <a:rPr lang="fr-FR" dirty="0"/>
-              <a:t> des données et des prévisions (prédictions lancées en synchrone depuis le Dashboard)</a:t>
+              <a:rPr lang="fr-FR" sz="1200" dirty="0"/>
+              <a:t> des données et des prévisions</a:t>
             </a:r>
           </a:p>
           <a:p>
@@ -19098,15 +19100,32 @@
               <a:buChar char="•"/>
             </a:pPr>
             <a:r>
-              <a:rPr lang="fr-FR" b="1" dirty="0"/>
+              <a:rPr lang="fr-FR" sz="1200" b="1" dirty="0"/>
+              <a:t>Lancement des prédictions </a:t>
+            </a:r>
+            <a:r>
+              <a:rPr lang="fr-FR" sz="1200" dirty="0"/>
+              <a:t>depuis le Dashboard (prédictions lancées en synchrone depuis le Dashboard)</a:t>
+            </a:r>
+          </a:p>
+          <a:p>
+            <a:pPr marL="285750" indent="-285750">
+              <a:spcBef>
+                <a:spcPts val="1200"/>
+              </a:spcBef>
+              <a:buFont typeface="Arial" panose="020B0604020202020204" pitchFamily="34" charset="0"/>
+              <a:buChar char="•"/>
+            </a:pPr>
+            <a:r>
+              <a:rPr lang="fr-FR" sz="1200" b="1" dirty="0"/>
               <a:t>Ajout d’une prévision </a:t>
             </a:r>
             <a:r>
-              <a:rPr lang="fr-FR" b="1" dirty="0" err="1"/>
+              <a:rPr lang="fr-FR" sz="1200" b="1" dirty="0" err="1"/>
               <a:t>intraday</a:t>
             </a:r>
             <a:r>
-              <a:rPr lang="fr-FR" dirty="0"/>
+              <a:rPr lang="fr-FR" sz="1200" dirty="0"/>
               <a:t> : données RTE mises à jour toutes les 30 minutes (intérêt métier à vérifier)</a:t>
             </a:r>
           </a:p>
@@ -19119,11 +19138,11 @@
               <a:buChar char="•"/>
             </a:pPr>
             <a:r>
-              <a:rPr lang="fr-FR" b="1" dirty="0"/>
+              <a:rPr lang="fr-FR" sz="1200" b="1" dirty="0"/>
               <a:t>Enrichissement par données satellitaires avancées</a:t>
             </a:r>
             <a:r>
-              <a:rPr lang="fr-FR" dirty="0"/>
+              <a:rPr lang="fr-FR" sz="1200" dirty="0"/>
               <a:t> (nuages, couverture atmosphérique)</a:t>
             </a:r>
           </a:p>
@@ -19135,7 +19154,7 @@
               <a:buFont typeface="Arial" panose="020B0604020202020204" pitchFamily="34" charset="0"/>
               <a:buChar char="•"/>
             </a:pPr>
-            <a:endParaRPr lang="fr-FR" dirty="0"/>
+            <a:endParaRPr lang="fr-FR" sz="1200" dirty="0"/>
           </a:p>
         </p:txBody>
       </p:sp>
@@ -19411,8 +19430,8 @@
           <p:nvPr/>
         </p:nvSpPr>
         <p:spPr>
-          <a:xfrm rot="443839">
-            <a:off x="5562932" y="1075208"/>
+          <a:xfrm rot="1199074">
+            <a:off x="5584842" y="806544"/>
             <a:ext cx="3244850" cy="584775"/>
           </a:xfrm>
           <a:prstGeom prst="rect">

</xml_diff>

<commit_message>
Maj schéma fonctionnel et suivi projet
</commit_message>
<xml_diff>
--- a/presentation/dsfs_ft_36_Projet_REnergies_efficiency_prediction.pptx
+++ b/presentation/dsfs_ft_36_Projet_REnergies_efficiency_prediction.pptx
@@ -292,7 +292,7 @@
 <file path=ppt/revisionInfo.xml><?xml version="1.0" encoding="utf-8"?>
 <p1510:revInfo xmlns:a="http://schemas.openxmlformats.org/drawingml/2006/main" xmlns:r="http://schemas.openxmlformats.org/officeDocument/2006/relationships" xmlns:p1510="http://schemas.microsoft.com/office/powerpoint/2015/10/main">
   <p1510:revLst>
-    <p1510:client id="{2EB72A00-7F79-4813-B4C2-C6564860F3F6}" v="2111" dt="2025-11-22T18:31:07.116"/>
+    <p1510:client id="{2EB72A00-7F79-4813-B4C2-C6564860F3F6}" v="2136" dt="2025-11-24T09:25:37.185"/>
   </p1510:revLst>
 </p1510:revInfo>
 </file>
@@ -302,7 +302,7 @@
   <pc:docChgLst>
     <pc:chgData name="Jean-Yves Vuillequez" userId="e7fac481abea6bd0" providerId="LiveId" clId="{79E365E8-22BC-4EC2-9606-9A9AC6CD1D22}"/>
     <pc:docChg chg="undo custSel addSld delSld modSld sldOrd">
-      <pc:chgData name="Jean-Yves Vuillequez" userId="e7fac481abea6bd0" providerId="LiveId" clId="{79E365E8-22BC-4EC2-9606-9A9AC6CD1D22}" dt="2025-11-23T09:52:32.533" v="7718" actId="1037"/>
+      <pc:chgData name="Jean-Yves Vuillequez" userId="e7fac481abea6bd0" providerId="LiveId" clId="{79E365E8-22BC-4EC2-9606-9A9AC6CD1D22}" dt="2025-11-24T09:28:51.221" v="7814" actId="1076"/>
       <pc:docMkLst>
         <pc:docMk/>
       </pc:docMkLst>
@@ -605,7 +605,7 @@
         </pc:spChg>
       </pc:sldChg>
       <pc:sldChg chg="addSp delSp modSp add mod ord delAnim modAnim modNotesTx">
-        <pc:chgData name="Jean-Yves Vuillequez" userId="e7fac481abea6bd0" providerId="LiveId" clId="{79E365E8-22BC-4EC2-9606-9A9AC6CD1D22}" dt="2025-11-23T09:52:32.533" v="7718" actId="1037"/>
+        <pc:chgData name="Jean-Yves Vuillequez" userId="e7fac481abea6bd0" providerId="LiveId" clId="{79E365E8-22BC-4EC2-9606-9A9AC6CD1D22}" dt="2025-11-24T08:29:20.359" v="7736"/>
         <pc:sldMkLst>
           <pc:docMk/>
           <pc:sldMk cId="1821755839" sldId="274"/>
@@ -616,14 +616,6 @@
             <pc:docMk/>
             <pc:sldMk cId="1821755839" sldId="274"/>
             <ac:spMk id="2" creationId="{F584810C-5501-210A-FC09-7E76BEE6CF2D}"/>
-          </ac:spMkLst>
-        </pc:spChg>
-        <pc:spChg chg="add del mod">
-          <ac:chgData name="Jean-Yves Vuillequez" userId="e7fac481abea6bd0" providerId="LiveId" clId="{79E365E8-22BC-4EC2-9606-9A9AC6CD1D22}" dt="2025-11-22T09:16:01.202" v="7226" actId="478"/>
-          <ac:spMkLst>
-            <pc:docMk/>
-            <pc:sldMk cId="1821755839" sldId="274"/>
-            <ac:spMk id="3" creationId="{162FFC6F-D9F3-0E9D-8995-E9C5F33E53C6}"/>
           </ac:spMkLst>
         </pc:spChg>
         <pc:spChg chg="add mod">
@@ -802,14 +794,6 @@
             <ac:spMk id="58" creationId="{42C67AD7-C645-5367-3E47-6D6A996C5FE8}"/>
           </ac:spMkLst>
         </pc:spChg>
-        <pc:spChg chg="add del">
-          <ac:chgData name="Jean-Yves Vuillequez" userId="e7fac481abea6bd0" providerId="LiveId" clId="{79E365E8-22BC-4EC2-9606-9A9AC6CD1D22}" dt="2025-11-22T09:30:14.960" v="7330" actId="22"/>
-          <ac:spMkLst>
-            <pc:docMk/>
-            <pc:sldMk cId="1821755839" sldId="274"/>
-            <ac:spMk id="61" creationId="{9604BE13-7DDD-AB2A-8533-AFDCA94F78A3}"/>
-          </ac:spMkLst>
-        </pc:spChg>
         <pc:spChg chg="add mod topLvl">
           <ac:chgData name="Jean-Yves Vuillequez" userId="e7fac481abea6bd0" providerId="LiveId" clId="{79E365E8-22BC-4EC2-9606-9A9AC6CD1D22}" dt="2025-11-22T09:50:17.468" v="7485" actId="165"/>
           <ac:spMkLst>
@@ -851,7 +835,7 @@
           </ac:spMkLst>
         </pc:spChg>
         <pc:spChg chg="mod">
-          <ac:chgData name="Jean-Yves Vuillequez" userId="e7fac481abea6bd0" providerId="LiveId" clId="{79E365E8-22BC-4EC2-9606-9A9AC6CD1D22}" dt="2025-11-20T08:33:39.048" v="348" actId="108"/>
+          <ac:chgData name="Jean-Yves Vuillequez" userId="e7fac481abea6bd0" providerId="LiveId" clId="{79E365E8-22BC-4EC2-9606-9A9AC6CD1D22}" dt="2025-11-24T08:27:20.212" v="7732" actId="1076"/>
           <ac:spMkLst>
             <pc:docMk/>
             <pc:sldMk cId="1821755839" sldId="274"/>
@@ -864,14 +848,6 @@
             <pc:docMk/>
             <pc:sldMk cId="1821755839" sldId="274"/>
             <ac:spMk id="106" creationId="{70820C9A-B957-87A8-109D-6C661627DA4C}"/>
-          </ac:spMkLst>
-        </pc:spChg>
-        <pc:spChg chg="add del">
-          <ac:chgData name="Jean-Yves Vuillequez" userId="e7fac481abea6bd0" providerId="LiveId" clId="{79E365E8-22BC-4EC2-9606-9A9AC6CD1D22}" dt="2025-11-22T10:36:23.904" v="7493" actId="22"/>
-          <ac:spMkLst>
-            <pc:docMk/>
-            <pc:sldMk cId="1821755839" sldId="274"/>
-            <ac:spMk id="1031" creationId="{09D91F1B-81AB-FA01-B260-5DCC085FC57A}"/>
           </ac:spMkLst>
         </pc:spChg>
         <pc:spChg chg="add mod topLvl">
@@ -898,38 +874,6 @@
             <ac:spMk id="2097" creationId="{ADF20F1D-E32A-83D7-1C9F-ED56E1ADF5A6}"/>
           </ac:spMkLst>
         </pc:spChg>
-        <pc:grpChg chg="add del mod">
-          <ac:chgData name="Jean-Yves Vuillequez" userId="e7fac481abea6bd0" providerId="LiveId" clId="{79E365E8-22BC-4EC2-9606-9A9AC6CD1D22}" dt="2025-11-22T09:50:17.468" v="7485" actId="165"/>
-          <ac:grpSpMkLst>
-            <pc:docMk/>
-            <pc:sldMk cId="1821755839" sldId="274"/>
-            <ac:grpSpMk id="9" creationId="{1942901F-9902-04A0-3544-E014B88B92FF}"/>
-          </ac:grpSpMkLst>
-        </pc:grpChg>
-        <pc:grpChg chg="add del mod topLvl">
-          <ac:chgData name="Jean-Yves Vuillequez" userId="e7fac481abea6bd0" providerId="LiveId" clId="{79E365E8-22BC-4EC2-9606-9A9AC6CD1D22}" dt="2025-11-22T18:03:46.416" v="7531" actId="165"/>
-          <ac:grpSpMkLst>
-            <pc:docMk/>
-            <pc:sldMk cId="1821755839" sldId="274"/>
-            <ac:grpSpMk id="12" creationId="{A4F3950E-A273-3885-0546-EA789FEF3AD4}"/>
-          </ac:grpSpMkLst>
-        </pc:grpChg>
-        <pc:grpChg chg="add del mod">
-          <ac:chgData name="Jean-Yves Vuillequez" userId="e7fac481abea6bd0" providerId="LiveId" clId="{79E365E8-22BC-4EC2-9606-9A9AC6CD1D22}" dt="2025-11-22T18:03:28.800" v="7530" actId="165"/>
-          <ac:grpSpMkLst>
-            <pc:docMk/>
-            <pc:sldMk cId="1821755839" sldId="274"/>
-            <ac:grpSpMk id="13" creationId="{17A2B2F0-AB99-333B-30C9-EC04234D17C0}"/>
-          </ac:grpSpMkLst>
-        </pc:grpChg>
-        <pc:grpChg chg="add del mod">
-          <ac:chgData name="Jean-Yves Vuillequez" userId="e7fac481abea6bd0" providerId="LiveId" clId="{79E365E8-22BC-4EC2-9606-9A9AC6CD1D22}" dt="2025-11-22T09:26:21.189" v="7280" actId="165"/>
-          <ac:grpSpMkLst>
-            <pc:docMk/>
-            <pc:sldMk cId="1821755839" sldId="274"/>
-            <ac:grpSpMk id="17" creationId="{618688FD-4D2F-7A63-8807-ABB66A2C4089}"/>
-          </ac:grpSpMkLst>
-        </pc:grpChg>
         <pc:grpChg chg="add mod">
           <ac:chgData name="Jean-Yves Vuillequez" userId="e7fac481abea6bd0" providerId="LiveId" clId="{79E365E8-22BC-4EC2-9606-9A9AC6CD1D22}" dt="2025-11-22T09:49:04.487" v="7454" actId="1076"/>
           <ac:grpSpMkLst>
@@ -938,30 +882,6 @@
             <ac:grpSpMk id="78" creationId="{48BB1303-220D-775F-BC97-35D0BC10D7AC}"/>
           </ac:grpSpMkLst>
         </pc:grpChg>
-        <pc:grpChg chg="add del mod">
-          <ac:chgData name="Jean-Yves Vuillequez" userId="e7fac481abea6bd0" providerId="LiveId" clId="{79E365E8-22BC-4EC2-9606-9A9AC6CD1D22}" dt="2025-11-22T09:50:28.945" v="7488" actId="478"/>
-          <ac:grpSpMkLst>
-            <pc:docMk/>
-            <pc:sldMk cId="1821755839" sldId="274"/>
-            <ac:grpSpMk id="1024" creationId="{DA7793AF-7555-0276-9AAD-DD92E5CEBF43}"/>
-          </ac:grpSpMkLst>
-        </pc:grpChg>
-        <pc:picChg chg="add del mod">
-          <ac:chgData name="Jean-Yves Vuillequez" userId="e7fac481abea6bd0" providerId="LiveId" clId="{79E365E8-22BC-4EC2-9606-9A9AC6CD1D22}" dt="2025-11-22T09:26:15.227" v="7279" actId="478"/>
-          <ac:picMkLst>
-            <pc:docMk/>
-            <pc:sldMk cId="1821755839" sldId="274"/>
-            <ac:picMk id="19" creationId="{B06A4583-878B-26D3-2EE9-8D9E4A4CD1F3}"/>
-          </ac:picMkLst>
-        </pc:picChg>
-        <pc:picChg chg="add del mod">
-          <ac:chgData name="Jean-Yves Vuillequez" userId="e7fac481abea6bd0" providerId="LiveId" clId="{79E365E8-22BC-4EC2-9606-9A9AC6CD1D22}" dt="2025-11-22T09:26:25.741" v="7282" actId="478"/>
-          <ac:picMkLst>
-            <pc:docMk/>
-            <pc:sldMk cId="1821755839" sldId="274"/>
-            <ac:picMk id="20" creationId="{90F037CF-090B-C902-E6E2-089C3D502131}"/>
-          </ac:picMkLst>
-        </pc:picChg>
         <pc:picChg chg="add mod">
           <ac:chgData name="Jean-Yves Vuillequez" userId="e7fac481abea6bd0" providerId="LiveId" clId="{79E365E8-22BC-4EC2-9606-9A9AC6CD1D22}" dt="2025-11-22T18:15:44.176" v="7605" actId="1076"/>
           <ac:picMkLst>
@@ -976,14 +896,6 @@
             <pc:docMk/>
             <pc:sldMk cId="1821755839" sldId="274"/>
             <ac:picMk id="21" creationId="{174134F5-72A3-DA25-E671-C7DDD8DFA83A}"/>
-          </ac:picMkLst>
-        </pc:picChg>
-        <pc:picChg chg="add del mod">
-          <ac:chgData name="Jean-Yves Vuillequez" userId="e7fac481abea6bd0" providerId="LiveId" clId="{79E365E8-22BC-4EC2-9606-9A9AC6CD1D22}" dt="2025-11-22T18:15:33.516" v="7603" actId="478"/>
-          <ac:picMkLst>
-            <pc:docMk/>
-            <pc:sldMk cId="1821755839" sldId="274"/>
-            <ac:picMk id="25" creationId="{9A368348-C30E-D050-C4DB-B32BDBE3589F}"/>
           </ac:picMkLst>
         </pc:picChg>
         <pc:picChg chg="add mod topLvl">
@@ -1026,30 +938,6 @@
             <ac:picMk id="68" creationId="{6A1FE08D-DF15-8940-EAA5-98ED76914736}"/>
           </ac:picMkLst>
         </pc:picChg>
-        <pc:picChg chg="add del mod topLvl">
-          <ac:chgData name="Jean-Yves Vuillequez" userId="e7fac481abea6bd0" providerId="LiveId" clId="{79E365E8-22BC-4EC2-9606-9A9AC6CD1D22}" dt="2025-11-22T09:49:27.118" v="7467" actId="478"/>
-          <ac:picMkLst>
-            <pc:docMk/>
-            <pc:sldMk cId="1821755839" sldId="274"/>
-            <ac:picMk id="102" creationId="{26F3760A-01F7-627E-27AC-B1F00D3B52C6}"/>
-          </ac:picMkLst>
-        </pc:picChg>
-        <pc:picChg chg="add del mod topLvl">
-          <ac:chgData name="Jean-Yves Vuillequez" userId="e7fac481abea6bd0" providerId="LiveId" clId="{79E365E8-22BC-4EC2-9606-9A9AC6CD1D22}" dt="2025-11-22T09:49:26.577" v="7466" actId="478"/>
-          <ac:picMkLst>
-            <pc:docMk/>
-            <pc:sldMk cId="1821755839" sldId="274"/>
-            <ac:picMk id="103" creationId="{B33DCAA7-8CDF-83ED-2AFC-66875EDF434A}"/>
-          </ac:picMkLst>
-        </pc:picChg>
-        <pc:picChg chg="add del mod topLvl">
-          <ac:chgData name="Jean-Yves Vuillequez" userId="e7fac481abea6bd0" providerId="LiveId" clId="{79E365E8-22BC-4EC2-9606-9A9AC6CD1D22}" dt="2025-11-22T09:49:26.577" v="7466" actId="478"/>
-          <ac:picMkLst>
-            <pc:docMk/>
-            <pc:sldMk cId="1821755839" sldId="274"/>
-            <ac:picMk id="104" creationId="{30EDEF50-F042-0782-1F82-E1015B7ED2D4}"/>
-          </ac:picMkLst>
-        </pc:picChg>
         <pc:picChg chg="add mod topLvl">
           <ac:chgData name="Jean-Yves Vuillequez" userId="e7fac481abea6bd0" providerId="LiveId" clId="{79E365E8-22BC-4EC2-9606-9A9AC6CD1D22}" dt="2025-11-22T18:30:48.419" v="7706" actId="1076"/>
           <ac:picMkLst>
@@ -1072,38 +960,6 @@
             <pc:docMk/>
             <pc:sldMk cId="1821755839" sldId="274"/>
             <ac:picMk id="117" creationId="{B3747ED9-0378-A202-7151-54782D96CF66}"/>
-          </ac:picMkLst>
-        </pc:picChg>
-        <pc:picChg chg="add del mod topLvl">
-          <ac:chgData name="Jean-Yves Vuillequez" userId="e7fac481abea6bd0" providerId="LiveId" clId="{79E365E8-22BC-4EC2-9606-9A9AC6CD1D22}" dt="2025-11-22T09:49:27.564" v="7468" actId="478"/>
-          <ac:picMkLst>
-            <pc:docMk/>
-            <pc:sldMk cId="1821755839" sldId="274"/>
-            <ac:picMk id="123" creationId="{D715FB7A-A546-1D86-6C47-6E592D4CF67D}"/>
-          </ac:picMkLst>
-        </pc:picChg>
-        <pc:picChg chg="add del mod">
-          <ac:chgData name="Jean-Yves Vuillequez" userId="e7fac481abea6bd0" providerId="LiveId" clId="{79E365E8-22BC-4EC2-9606-9A9AC6CD1D22}" dt="2025-11-22T09:49:28.527" v="7469" actId="478"/>
-          <ac:picMkLst>
-            <pc:docMk/>
-            <pc:sldMk cId="1821755839" sldId="274"/>
-            <ac:picMk id="124" creationId="{C5293EF4-20E0-DF10-D159-DD1506BA9014}"/>
-          </ac:picMkLst>
-        </pc:picChg>
-        <pc:picChg chg="add del mod topLvl">
-          <ac:chgData name="Jean-Yves Vuillequez" userId="e7fac481abea6bd0" providerId="LiveId" clId="{79E365E8-22BC-4EC2-9606-9A9AC6CD1D22}" dt="2025-11-22T09:49:29.121" v="7470" actId="478"/>
-          <ac:picMkLst>
-            <pc:docMk/>
-            <pc:sldMk cId="1821755839" sldId="274"/>
-            <ac:picMk id="125" creationId="{33AAD6E8-755C-ADC6-DD82-513A7A7A0F5B}"/>
-          </ac:picMkLst>
-        </pc:picChg>
-        <pc:picChg chg="add del mod topLvl">
-          <ac:chgData name="Jean-Yves Vuillequez" userId="e7fac481abea6bd0" providerId="LiveId" clId="{79E365E8-22BC-4EC2-9606-9A9AC6CD1D22}" dt="2025-11-22T09:49:26.577" v="7466" actId="478"/>
-          <ac:picMkLst>
-            <pc:docMk/>
-            <pc:sldMk cId="1821755839" sldId="274"/>
-            <ac:picMk id="126" creationId="{CDFE02BC-1F91-5E6A-387E-5166BAEB4B47}"/>
           </ac:picMkLst>
         </pc:picChg>
         <pc:picChg chg="add mod">
@@ -1138,14 +994,6 @@
             <ac:picMk id="1030" creationId="{2941D76B-6840-C572-907F-F3680B66EBF7}"/>
           </ac:picMkLst>
         </pc:picChg>
-        <pc:picChg chg="add del mod topLvl">
-          <ac:chgData name="Jean-Yves Vuillequez" userId="e7fac481abea6bd0" providerId="LiveId" clId="{79E365E8-22BC-4EC2-9606-9A9AC6CD1D22}" dt="2025-11-22T09:50:28.945" v="7488" actId="478"/>
-          <ac:picMkLst>
-            <pc:docMk/>
-            <pc:sldMk cId="1821755839" sldId="274"/>
-            <ac:picMk id="1032" creationId="{0AA62D0C-7533-F64F-5205-AC2C6EB164FE}"/>
-          </ac:picMkLst>
-        </pc:picChg>
         <pc:picChg chg="add mod">
           <ac:chgData name="Jean-Yves Vuillequez" userId="e7fac481abea6bd0" providerId="LiveId" clId="{79E365E8-22BC-4EC2-9606-9A9AC6CD1D22}" dt="2025-11-22T18:03:10.913" v="7529" actId="1076"/>
           <ac:picMkLst>
@@ -1176,14 +1024,6 @@
             <pc:docMk/>
             <pc:sldMk cId="1821755839" sldId="274"/>
             <ac:picMk id="1038" creationId="{1B3822DD-A0E9-A37F-0DE9-40781F1C3DF4}"/>
-          </ac:picMkLst>
-        </pc:picChg>
-        <pc:picChg chg="add del mod">
-          <ac:chgData name="Jean-Yves Vuillequez" userId="e7fac481abea6bd0" providerId="LiveId" clId="{79E365E8-22BC-4EC2-9606-9A9AC6CD1D22}" dt="2025-11-22T09:49:26.577" v="7466" actId="478"/>
-          <ac:picMkLst>
-            <pc:docMk/>
-            <pc:sldMk cId="1821755839" sldId="274"/>
-            <ac:picMk id="2050" creationId="{66BE5478-2C49-E651-22DF-909C00CA75C0}"/>
           </ac:picMkLst>
         </pc:picChg>
         <pc:picChg chg="add mod topLvl">
@@ -1282,52 +1122,12 @@
             <ac:cxnSpMk id="30" creationId="{DD9C7B50-C6F5-7260-C61A-2CAE5E4C0BF7}"/>
           </ac:cxnSpMkLst>
         </pc:cxnChg>
-        <pc:cxnChg chg="add del mod">
-          <ac:chgData name="Jean-Yves Vuillequez" userId="e7fac481abea6bd0" providerId="LiveId" clId="{79E365E8-22BC-4EC2-9606-9A9AC6CD1D22}" dt="2025-11-22T09:50:09.002" v="7484" actId="478"/>
-          <ac:cxnSpMkLst>
-            <pc:docMk/>
-            <pc:sldMk cId="1821755839" sldId="274"/>
-            <ac:cxnSpMk id="75" creationId="{EA2D8E70-0E38-6F85-C46D-473AA9425B34}"/>
-          </ac:cxnSpMkLst>
-        </pc:cxnChg>
-        <pc:cxnChg chg="add del mod">
-          <ac:chgData name="Jean-Yves Vuillequez" userId="e7fac481abea6bd0" providerId="LiveId" clId="{79E365E8-22BC-4EC2-9606-9A9AC6CD1D22}" dt="2025-11-22T09:49:37" v="7474" actId="478"/>
-          <ac:cxnSpMkLst>
-            <pc:docMk/>
-            <pc:sldMk cId="1821755839" sldId="274"/>
-            <ac:cxnSpMk id="99" creationId="{1740FD3C-BB82-E8E4-4341-9F9B0A291611}"/>
-          </ac:cxnSpMkLst>
-        </pc:cxnChg>
         <pc:cxnChg chg="add mod ord topLvl">
           <ac:chgData name="Jean-Yves Vuillequez" userId="e7fac481abea6bd0" providerId="LiveId" clId="{79E365E8-22BC-4EC2-9606-9A9AC6CD1D22}" dt="2025-11-22T18:30:29.969" v="7704" actId="208"/>
           <ac:cxnSpMkLst>
             <pc:docMk/>
             <pc:sldMk cId="1821755839" sldId="274"/>
             <ac:cxnSpMk id="108" creationId="{8FC538F3-E888-6C1B-940B-D6B968D8FCEE}"/>
-          </ac:cxnSpMkLst>
-        </pc:cxnChg>
-        <pc:cxnChg chg="add del mod">
-          <ac:chgData name="Jean-Yves Vuillequez" userId="e7fac481abea6bd0" providerId="LiveId" clId="{79E365E8-22BC-4EC2-9606-9A9AC6CD1D22}" dt="2025-11-22T09:49:30.751" v="7472" actId="478"/>
-          <ac:cxnSpMkLst>
-            <pc:docMk/>
-            <pc:sldMk cId="1821755839" sldId="274"/>
-            <ac:cxnSpMk id="111" creationId="{67D61FBD-E531-1326-0C48-8BF9669015EF}"/>
-          </ac:cxnSpMkLst>
-        </pc:cxnChg>
-        <pc:cxnChg chg="add del mod">
-          <ac:chgData name="Jean-Yves Vuillequez" userId="e7fac481abea6bd0" providerId="LiveId" clId="{79E365E8-22BC-4EC2-9606-9A9AC6CD1D22}" dt="2025-11-22T09:49:30.107" v="7471" actId="478"/>
-          <ac:cxnSpMkLst>
-            <pc:docMk/>
-            <pc:sldMk cId="1821755839" sldId="274"/>
-            <ac:cxnSpMk id="114" creationId="{D838041E-F078-6C94-A2B0-03079C59425A}"/>
-          </ac:cxnSpMkLst>
-        </pc:cxnChg>
-        <pc:cxnChg chg="add del mod">
-          <ac:chgData name="Jean-Yves Vuillequez" userId="e7fac481abea6bd0" providerId="LiveId" clId="{79E365E8-22BC-4EC2-9606-9A9AC6CD1D22}" dt="2025-11-22T09:49:26.577" v="7466" actId="478"/>
-          <ac:cxnSpMkLst>
-            <pc:docMk/>
-            <pc:sldMk cId="1821755839" sldId="274"/>
-            <ac:cxnSpMk id="119" creationId="{71456FE5-64C3-8B7D-7CCF-34EA9321C3CA}"/>
           </ac:cxnSpMkLst>
         </pc:cxnChg>
         <pc:cxnChg chg="add mod">
@@ -1368,14 +1168,6 @@
             <pc:docMk/>
             <pc:sldMk cId="1821755839" sldId="274"/>
             <ac:cxnSpMk id="1075" creationId="{EB70B985-2508-613E-3824-FAD3BB6966AC}"/>
-          </ac:cxnSpMkLst>
-        </pc:cxnChg>
-        <pc:cxnChg chg="add del mod">
-          <ac:chgData name="Jean-Yves Vuillequez" userId="e7fac481abea6bd0" providerId="LiveId" clId="{79E365E8-22BC-4EC2-9606-9A9AC6CD1D22}" dt="2025-11-22T09:49:31.711" v="7473" actId="478"/>
-          <ac:cxnSpMkLst>
-            <pc:docMk/>
-            <pc:sldMk cId="1821755839" sldId="274"/>
-            <ac:cxnSpMk id="2055" creationId="{87E620DB-CBC1-5464-4E1E-A4B454C8BE5D}"/>
           </ac:cxnSpMkLst>
         </pc:cxnChg>
         <pc:cxnChg chg="add mod">
@@ -1656,8 +1448,8 @@
           </ac:picMkLst>
         </pc:picChg>
       </pc:sldChg>
-      <pc:sldChg chg="addSp delSp modSp add mod modNotesTx">
-        <pc:chgData name="Jean-Yves Vuillequez" userId="e7fac481abea6bd0" providerId="LiveId" clId="{79E365E8-22BC-4EC2-9606-9A9AC6CD1D22}" dt="2025-11-21T15:51:02.429" v="7194" actId="14100"/>
+      <pc:sldChg chg="addSp delSp modSp add mod modAnim modNotesTx">
+        <pc:chgData name="Jean-Yves Vuillequez" userId="e7fac481abea6bd0" providerId="LiveId" clId="{79E365E8-22BC-4EC2-9606-9A9AC6CD1D22}" dt="2025-11-24T09:28:44.476" v="7813" actId="1076"/>
         <pc:sldMkLst>
           <pc:docMk/>
           <pc:sldMk cId="2290935718" sldId="289"/>
@@ -1671,7 +1463,23 @@
           </ac:spMkLst>
         </pc:spChg>
         <pc:spChg chg="add mod">
-          <ac:chgData name="Jean-Yves Vuillequez" userId="e7fac481abea6bd0" providerId="LiveId" clId="{79E365E8-22BC-4EC2-9606-9A9AC6CD1D22}" dt="2025-11-21T15:51:02.429" v="7194" actId="14100"/>
+          <ac:chgData name="Jean-Yves Vuillequez" userId="e7fac481abea6bd0" providerId="LiveId" clId="{79E365E8-22BC-4EC2-9606-9A9AC6CD1D22}" dt="2025-11-24T08:55:57.791" v="7744" actId="1076"/>
+          <ac:spMkLst>
+            <pc:docMk/>
+            <pc:sldMk cId="2290935718" sldId="289"/>
+            <ac:spMk id="3" creationId="{E869AAB6-05E5-7ABD-6265-0FBFDCCB98A9}"/>
+          </ac:spMkLst>
+        </pc:spChg>
+        <pc:spChg chg="add mod">
+          <ac:chgData name="Jean-Yves Vuillequez" userId="e7fac481abea6bd0" providerId="LiveId" clId="{79E365E8-22BC-4EC2-9606-9A9AC6CD1D22}" dt="2025-11-24T09:28:44.476" v="7813" actId="1076"/>
+          <ac:spMkLst>
+            <pc:docMk/>
+            <pc:sldMk cId="2290935718" sldId="289"/>
+            <ac:spMk id="4" creationId="{786453DB-D6FB-CB5F-9376-5629883FAC60}"/>
+          </ac:spMkLst>
+        </pc:spChg>
+        <pc:spChg chg="add mod">
+          <ac:chgData name="Jean-Yves Vuillequez" userId="e7fac481abea6bd0" providerId="LiveId" clId="{79E365E8-22BC-4EC2-9606-9A9AC6CD1D22}" dt="2025-11-24T08:56:09.895" v="7746" actId="207"/>
           <ac:spMkLst>
             <pc:docMk/>
             <pc:sldMk cId="2290935718" sldId="289"/>
@@ -1710,8 +1518,8 @@
             <ac:spMk id="178" creationId="{834EF362-0DAC-26BA-DE49-3126B33E851C}"/>
           </ac:spMkLst>
         </pc:spChg>
-        <pc:picChg chg="add mod">
-          <ac:chgData name="Jean-Yves Vuillequez" userId="e7fac481abea6bd0" providerId="LiveId" clId="{79E365E8-22BC-4EC2-9606-9A9AC6CD1D22}" dt="2025-11-21T14:51:53.241" v="7078" actId="1076"/>
+        <pc:picChg chg="add del mod">
+          <ac:chgData name="Jean-Yves Vuillequez" userId="e7fac481abea6bd0" providerId="LiveId" clId="{79E365E8-22BC-4EC2-9606-9A9AC6CD1D22}" dt="2025-11-24T09:17:46.771" v="7796" actId="478"/>
           <ac:picMkLst>
             <pc:docMk/>
             <pc:sldMk cId="2290935718" sldId="289"/>
@@ -1726,9 +1534,25 @@
             <ac:picMk id="7" creationId="{5FE561E2-56B0-D6A0-F0B7-7F202EE51386}"/>
           </ac:picMkLst>
         </pc:picChg>
+        <pc:picChg chg="add del mod">
+          <ac:chgData name="Jean-Yves Vuillequez" userId="e7fac481abea6bd0" providerId="LiveId" clId="{79E365E8-22BC-4EC2-9606-9A9AC6CD1D22}" dt="2025-11-24T09:17:44.883" v="7795" actId="21"/>
+          <ac:picMkLst>
+            <pc:docMk/>
+            <pc:sldMk cId="2290935718" sldId="289"/>
+            <ac:picMk id="12" creationId="{7D6B0B43-8628-A21E-C82B-D058DBA5452A}"/>
+          </ac:picMkLst>
+        </pc:picChg>
+        <pc:picChg chg="add mod">
+          <ac:chgData name="Jean-Yves Vuillequez" userId="e7fac481abea6bd0" providerId="LiveId" clId="{79E365E8-22BC-4EC2-9606-9A9AC6CD1D22}" dt="2025-11-24T09:17:55.495" v="7798" actId="14100"/>
+          <ac:picMkLst>
+            <pc:docMk/>
+            <pc:sldMk cId="2290935718" sldId="289"/>
+            <ac:picMk id="13" creationId="{7D6B0B43-8628-A21E-C82B-D058DBA5452A}"/>
+          </ac:picMkLst>
+        </pc:picChg>
       </pc:sldChg>
       <pc:sldChg chg="addSp delSp modSp add mod modNotesTx">
-        <pc:chgData name="Jean-Yves Vuillequez" userId="e7fac481abea6bd0" providerId="LiveId" clId="{79E365E8-22BC-4EC2-9606-9A9AC6CD1D22}" dt="2025-11-21T15:51:10.968" v="7196" actId="478"/>
+        <pc:chgData name="Jean-Yves Vuillequez" userId="e7fac481abea6bd0" providerId="LiveId" clId="{79E365E8-22BC-4EC2-9606-9A9AC6CD1D22}" dt="2025-11-24T09:28:51.221" v="7814" actId="1076"/>
         <pc:sldMkLst>
           <pc:docMk/>
           <pc:sldMk cId="3332770" sldId="291"/>
@@ -1739,6 +1563,14 @@
             <pc:docMk/>
             <pc:sldMk cId="3332770" sldId="291"/>
             <ac:spMk id="2" creationId="{010F41C2-7624-67DE-B008-1F392C11A870}"/>
+          </ac:spMkLst>
+        </pc:spChg>
+        <pc:spChg chg="add mod">
+          <ac:chgData name="Jean-Yves Vuillequez" userId="e7fac481abea6bd0" providerId="LiveId" clId="{79E365E8-22BC-4EC2-9606-9A9AC6CD1D22}" dt="2025-11-24T09:28:51.221" v="7814" actId="1076"/>
+          <ac:spMkLst>
+            <pc:docMk/>
+            <pc:sldMk cId="3332770" sldId="291"/>
+            <ac:spMk id="3" creationId="{6C8C8F79-17EE-7C7E-88F5-83418E095E94}"/>
           </ac:spMkLst>
         </pc:spChg>
         <pc:spChg chg="add mod">
@@ -1789,8 +1621,24 @@
             <ac:spMk id="178" creationId="{1DE246AA-5B17-33A5-5EF2-125E8EA81EFC}"/>
           </ac:spMkLst>
         </pc:spChg>
-        <pc:picChg chg="add mod">
-          <ac:chgData name="Jean-Yves Vuillequez" userId="e7fac481abea6bd0" providerId="LiveId" clId="{79E365E8-22BC-4EC2-9606-9A9AC6CD1D22}" dt="2025-11-21T14:41:50.316" v="6978" actId="1076"/>
+        <pc:picChg chg="add del mod">
+          <ac:chgData name="Jean-Yves Vuillequez" userId="e7fac481abea6bd0" providerId="LiveId" clId="{79E365E8-22BC-4EC2-9606-9A9AC6CD1D22}" dt="2025-11-24T09:25:34.626" v="7809" actId="21"/>
+          <ac:picMkLst>
+            <pc:docMk/>
+            <pc:sldMk cId="3332770" sldId="291"/>
+            <ac:picMk id="8" creationId="{1C4C223B-DBE1-9C23-F6A9-F0D53C7554EA}"/>
+          </ac:picMkLst>
+        </pc:picChg>
+        <pc:picChg chg="add mod ord">
+          <ac:chgData name="Jean-Yves Vuillequez" userId="e7fac481abea6bd0" providerId="LiveId" clId="{79E365E8-22BC-4EC2-9606-9A9AC6CD1D22}" dt="2025-11-24T09:25:47.374" v="7812" actId="167"/>
+          <ac:picMkLst>
+            <pc:docMk/>
+            <pc:sldMk cId="3332770" sldId="291"/>
+            <ac:picMk id="9" creationId="{1C4C223B-DBE1-9C23-F6A9-F0D53C7554EA}"/>
+          </ac:picMkLst>
+        </pc:picChg>
+        <pc:picChg chg="add del mod">
+          <ac:chgData name="Jean-Yves Vuillequez" userId="e7fac481abea6bd0" providerId="LiveId" clId="{79E365E8-22BC-4EC2-9606-9A9AC6CD1D22}" dt="2025-11-24T09:25:36.785" v="7810" actId="478"/>
           <ac:picMkLst>
             <pc:docMk/>
             <pc:sldMk cId="3332770" sldId="291"/>
@@ -1995,12 +1843,20 @@
           </ac:graphicFrameMkLst>
         </pc:graphicFrameChg>
       </pc:sldChg>
-      <pc:sldChg chg="modSp add mod">
-        <pc:chgData name="Jean-Yves Vuillequez" userId="e7fac481abea6bd0" providerId="LiveId" clId="{79E365E8-22BC-4EC2-9606-9A9AC6CD1D22}" dt="2025-11-20T20:45:26.230" v="5250" actId="20577"/>
+      <pc:sldChg chg="addSp modSp add mod">
+        <pc:chgData name="Jean-Yves Vuillequez" userId="e7fac481abea6bd0" providerId="LiveId" clId="{79E365E8-22BC-4EC2-9606-9A9AC6CD1D22}" dt="2025-11-24T08:57:28.398" v="7786" actId="207"/>
         <pc:sldMkLst>
           <pc:docMk/>
           <pc:sldMk cId="2817282669" sldId="295"/>
         </pc:sldMkLst>
+        <pc:spChg chg="add mod">
+          <ac:chgData name="Jean-Yves Vuillequez" userId="e7fac481abea6bd0" providerId="LiveId" clId="{79E365E8-22BC-4EC2-9606-9A9AC6CD1D22}" dt="2025-11-24T08:57:28.398" v="7786" actId="207"/>
+          <ac:spMkLst>
+            <pc:docMk/>
+            <pc:sldMk cId="2817282669" sldId="295"/>
+            <ac:spMk id="3" creationId="{89EE8D39-D478-0817-1A92-C3865BB10A61}"/>
+          </ac:spMkLst>
+        </pc:spChg>
         <pc:spChg chg="mod">
           <ac:chgData name="Jean-Yves Vuillequez" userId="e7fac481abea6bd0" providerId="LiveId" clId="{79E365E8-22BC-4EC2-9606-9A9AC6CD1D22}" dt="2025-11-20T16:41:51.642" v="4742" actId="113"/>
           <ac:spMkLst>
@@ -2018,12 +1874,20 @@
           </ac:graphicFrameMkLst>
         </pc:graphicFrameChg>
       </pc:sldChg>
-      <pc:sldChg chg="modSp add mod">
-        <pc:chgData name="Jean-Yves Vuillequez" userId="e7fac481abea6bd0" providerId="LiveId" clId="{79E365E8-22BC-4EC2-9606-9A9AC6CD1D22}" dt="2025-11-21T02:15:47.871" v="5462" actId="20577"/>
+      <pc:sldChg chg="addSp modSp add mod">
+        <pc:chgData name="Jean-Yves Vuillequez" userId="e7fac481abea6bd0" providerId="LiveId" clId="{79E365E8-22BC-4EC2-9606-9A9AC6CD1D22}" dt="2025-11-24T08:57:30.272" v="7787"/>
         <pc:sldMkLst>
           <pc:docMk/>
           <pc:sldMk cId="2552402859" sldId="296"/>
         </pc:sldMkLst>
+        <pc:spChg chg="add mod">
+          <ac:chgData name="Jean-Yves Vuillequez" userId="e7fac481abea6bd0" providerId="LiveId" clId="{79E365E8-22BC-4EC2-9606-9A9AC6CD1D22}" dt="2025-11-24T08:57:30.272" v="7787"/>
+          <ac:spMkLst>
+            <pc:docMk/>
+            <pc:sldMk cId="2552402859" sldId="296"/>
+            <ac:spMk id="3" creationId="{5B05B1FD-33BF-DA06-1EDF-2A61D6895874}"/>
+          </ac:spMkLst>
+        </pc:spChg>
         <pc:spChg chg="mod">
           <ac:chgData name="Jean-Yves Vuillequez" userId="e7fac481abea6bd0" providerId="LiveId" clId="{79E365E8-22BC-4EC2-9606-9A9AC6CD1D22}" dt="2025-11-20T16:41:57.627" v="4743" actId="113"/>
           <ac:spMkLst>
@@ -18286,6 +18150,43 @@
           <a:chExt cx="0" cy="0"/>
         </a:xfrm>
       </p:grpSpPr>
+      <p:pic>
+        <p:nvPicPr>
+          <p:cNvPr id="9" name="Image 8">
+            <a:extLst>
+              <a:ext uri="{FF2B5EF4-FFF2-40B4-BE49-F238E27FC236}">
+                <a16:creationId xmlns:a16="http://schemas.microsoft.com/office/drawing/2014/main" id="{1C4C223B-DBE1-9C23-F6A9-F0D53C7554EA}"/>
+              </a:ext>
+            </a:extLst>
+          </p:cNvPr>
+          <p:cNvPicPr>
+            <a:picLocks noChangeAspect="1"/>
+          </p:cNvPicPr>
+          <p:nvPr/>
+        </p:nvPicPr>
+        <p:blipFill>
+          <a:blip r:embed="rId3"/>
+          <a:stretch>
+            <a:fillRect/>
+          </a:stretch>
+        </p:blipFill>
+        <p:spPr>
+          <a:xfrm>
+            <a:off x="4528035" y="1337691"/>
+            <a:ext cx="4414918" cy="2603869"/>
+          </a:xfrm>
+          <a:prstGeom prst="rect">
+            <a:avLst/>
+          </a:prstGeom>
+          <a:ln>
+            <a:solidFill>
+              <a:schemeClr val="bg1">
+                <a:lumMod val="75000"/>
+              </a:schemeClr>
+            </a:solidFill>
+          </a:ln>
+        </p:spPr>
+      </p:pic>
       <p:sp>
         <p:nvSpPr>
           <p:cNvPr id="178" name="Google Shape;178;p8">
@@ -18355,7 +18256,7 @@
           <p:nvPr/>
         </p:nvPicPr>
         <p:blipFill rotWithShape="1">
-          <a:blip r:embed="rId3">
+          <a:blip r:embed="rId4">
             <a:alphaModFix/>
           </a:blip>
           <a:srcRect/>
@@ -18822,7 +18723,7 @@
             <a:pPr algn="ctr"/>
             <a:r>
               <a:rPr lang="fr-FR" sz="1000" dirty="0">
-                <a:hlinkClick r:id="rId4"/>
+                <a:hlinkClick r:id="rId5"/>
               </a:rPr>
               <a:t>Lien Dashboard</a:t>
             </a:r>
@@ -18874,43 +18775,6 @@
           </a:fontRef>
         </p:style>
       </p:cxnSp>
-      <p:pic>
-        <p:nvPicPr>
-          <p:cNvPr id="11" name="Image 10">
-            <a:extLst>
-              <a:ext uri="{FF2B5EF4-FFF2-40B4-BE49-F238E27FC236}">
-                <a16:creationId xmlns:a16="http://schemas.microsoft.com/office/drawing/2014/main" id="{6B0F1A83-2432-176C-4AA5-8DD51C43E45F}"/>
-              </a:ext>
-            </a:extLst>
-          </p:cNvPr>
-          <p:cNvPicPr>
-            <a:picLocks noChangeAspect="1"/>
-          </p:cNvPicPr>
-          <p:nvPr/>
-        </p:nvPicPr>
-        <p:blipFill>
-          <a:blip r:embed="rId5"/>
-          <a:stretch>
-            <a:fillRect/>
-          </a:stretch>
-        </p:blipFill>
-        <p:spPr>
-          <a:xfrm>
-            <a:off x="4597225" y="1335349"/>
-            <a:ext cx="4290207" cy="2609350"/>
-          </a:xfrm>
-          <a:prstGeom prst="rect">
-            <a:avLst/>
-          </a:prstGeom>
-          <a:ln>
-            <a:solidFill>
-              <a:schemeClr val="bg1">
-                <a:lumMod val="75000"/>
-              </a:schemeClr>
-            </a:solidFill>
-          </a:ln>
-        </p:spPr>
-      </p:pic>
       <p:pic>
         <p:nvPicPr>
           <p:cNvPr id="13" name="Image 12">
@@ -19379,6 +19243,51 @@
                 </a:solidFill>
               </a:rPr>
               <a:t>!</a:t>
+            </a:r>
+          </a:p>
+        </p:txBody>
+      </p:sp>
+      <p:sp>
+        <p:nvSpPr>
+          <p:cNvPr id="3" name="ZoneTexte 2">
+            <a:extLst>
+              <a:ext uri="{FF2B5EF4-FFF2-40B4-BE49-F238E27FC236}">
+                <a16:creationId xmlns:a16="http://schemas.microsoft.com/office/drawing/2014/main" id="{6C8C8F79-17EE-7C7E-88F5-83418E095E94}"/>
+              </a:ext>
+            </a:extLst>
+          </p:cNvPr>
+          <p:cNvSpPr txBox="1"/>
+          <p:nvPr/>
+        </p:nvSpPr>
+        <p:spPr>
+          <a:xfrm rot="1276305">
+            <a:off x="3235574" y="1414184"/>
+            <a:ext cx="1220771" cy="307777"/>
+          </a:xfrm>
+          <a:prstGeom prst="rect">
+            <a:avLst/>
+          </a:prstGeom>
+          <a:noFill/>
+          <a:ln>
+            <a:solidFill>
+              <a:srgbClr val="FF0000"/>
+            </a:solidFill>
+          </a:ln>
+        </p:spPr>
+        <p:txBody>
+          <a:bodyPr wrap="square" rtlCol="0">
+            <a:spAutoFit/>
+          </a:bodyPr>
+          <a:lstStyle/>
+          <a:p>
+            <a:pPr algn="ctr"/>
+            <a:r>
+              <a:rPr lang="fr-FR" dirty="0">
+                <a:solidFill>
+                  <a:srgbClr val="FF0000"/>
+                </a:solidFill>
+              </a:rPr>
+              <a:t>Mettre à jour</a:t>
             </a:r>
           </a:p>
         </p:txBody>
@@ -23298,6 +23207,53 @@
           </a:graphicData>
         </a:graphic>
       </p:graphicFrame>
+      <p:sp>
+        <p:nvSpPr>
+          <p:cNvPr id="3" name="ZoneTexte 2">
+            <a:extLst>
+              <a:ext uri="{FF2B5EF4-FFF2-40B4-BE49-F238E27FC236}">
+                <a16:creationId xmlns:a16="http://schemas.microsoft.com/office/drawing/2014/main" id="{89EE8D39-D478-0817-1A92-C3865BB10A61}"/>
+              </a:ext>
+            </a:extLst>
+          </p:cNvPr>
+          <p:cNvSpPr txBox="1"/>
+          <p:nvPr/>
+        </p:nvSpPr>
+        <p:spPr>
+          <a:xfrm rot="1276305">
+            <a:off x="6809476" y="1363286"/>
+            <a:ext cx="1220771" cy="307777"/>
+          </a:xfrm>
+          <a:prstGeom prst="rect">
+            <a:avLst/>
+          </a:prstGeom>
+          <a:solidFill>
+            <a:schemeClr val="bg1"/>
+          </a:solidFill>
+          <a:ln>
+            <a:solidFill>
+              <a:srgbClr val="FF0000"/>
+            </a:solidFill>
+          </a:ln>
+        </p:spPr>
+        <p:txBody>
+          <a:bodyPr wrap="square" rtlCol="0">
+            <a:spAutoFit/>
+          </a:bodyPr>
+          <a:lstStyle/>
+          <a:p>
+            <a:pPr algn="ctr"/>
+            <a:r>
+              <a:rPr lang="fr-FR" dirty="0">
+                <a:solidFill>
+                  <a:srgbClr val="FF0000"/>
+                </a:solidFill>
+              </a:rPr>
+              <a:t>Mettre à jour</a:t>
+            </a:r>
+          </a:p>
+        </p:txBody>
+      </p:sp>
     </p:spTree>
     <p:extLst>
       <p:ext uri="{BB962C8B-B14F-4D97-AF65-F5344CB8AC3E}">
@@ -24473,6 +24429,53 @@
           </a:graphicData>
         </a:graphic>
       </p:graphicFrame>
+      <p:sp>
+        <p:nvSpPr>
+          <p:cNvPr id="3" name="ZoneTexte 2">
+            <a:extLst>
+              <a:ext uri="{FF2B5EF4-FFF2-40B4-BE49-F238E27FC236}">
+                <a16:creationId xmlns:a16="http://schemas.microsoft.com/office/drawing/2014/main" id="{5B05B1FD-33BF-DA06-1EDF-2A61D6895874}"/>
+              </a:ext>
+            </a:extLst>
+          </p:cNvPr>
+          <p:cNvSpPr txBox="1"/>
+          <p:nvPr/>
+        </p:nvSpPr>
+        <p:spPr>
+          <a:xfrm rot="1276305">
+            <a:off x="6809476" y="1363286"/>
+            <a:ext cx="1220771" cy="307777"/>
+          </a:xfrm>
+          <a:prstGeom prst="rect">
+            <a:avLst/>
+          </a:prstGeom>
+          <a:solidFill>
+            <a:schemeClr val="bg1"/>
+          </a:solidFill>
+          <a:ln>
+            <a:solidFill>
+              <a:srgbClr val="FF0000"/>
+            </a:solidFill>
+          </a:ln>
+        </p:spPr>
+        <p:txBody>
+          <a:bodyPr wrap="square" rtlCol="0">
+            <a:spAutoFit/>
+          </a:bodyPr>
+          <a:lstStyle/>
+          <a:p>
+            <a:pPr algn="ctr"/>
+            <a:r>
+              <a:rPr lang="fr-FR" dirty="0">
+                <a:solidFill>
+                  <a:srgbClr val="FF0000"/>
+                </a:solidFill>
+              </a:rPr>
+              <a:t>Mettre à jour</a:t>
+            </a:r>
+          </a:p>
+        </p:txBody>
+      </p:sp>
     </p:spTree>
     <p:extLst>
       <p:ext uri="{BB962C8B-B14F-4D97-AF65-F5344CB8AC3E}">
@@ -34125,6 +34128,1990 @@
   <p:clrMapOvr>
     <a:masterClrMapping/>
   </p:clrMapOvr>
+  <p:timing>
+    <p:tnLst>
+      <p:par>
+        <p:cTn id="1" dur="indefinite" restart="never" nodeType="tmRoot">
+          <p:childTnLst>
+            <p:seq concurrent="1" nextAc="seek">
+              <p:cTn id="2" dur="indefinite" nodeType="mainSeq">
+                <p:childTnLst>
+                  <p:par>
+                    <p:cTn id="3" fill="hold">
+                      <p:stCondLst>
+                        <p:cond delay="indefinite"/>
+                      </p:stCondLst>
+                      <p:childTnLst>
+                        <p:par>
+                          <p:cTn id="4" fill="hold">
+                            <p:stCondLst>
+                              <p:cond delay="0"/>
+                            </p:stCondLst>
+                            <p:childTnLst>
+                              <p:par>
+                                <p:cTn id="5" presetID="1" presetClass="entr" presetSubtype="0" fill="hold" nodeType="clickEffect">
+                                  <p:stCondLst>
+                                    <p:cond delay="0"/>
+                                  </p:stCondLst>
+                                  <p:childTnLst>
+                                    <p:set>
+                                      <p:cBhvr>
+                                        <p:cTn id="6" dur="1" fill="hold">
+                                          <p:stCondLst>
+                                            <p:cond delay="0"/>
+                                          </p:stCondLst>
+                                        </p:cTn>
+                                        <p:tgtEl>
+                                          <p:spTgt spid="1028"/>
+                                        </p:tgtEl>
+                                        <p:attrNameLst>
+                                          <p:attrName>style.visibility</p:attrName>
+                                        </p:attrNameLst>
+                                      </p:cBhvr>
+                                      <p:to>
+                                        <p:strVal val="visible"/>
+                                      </p:to>
+                                    </p:set>
+                                  </p:childTnLst>
+                                </p:cTn>
+                              </p:par>
+                              <p:par>
+                                <p:cTn id="7" presetID="1" presetClass="entr" presetSubtype="0" fill="hold" nodeType="withEffect">
+                                  <p:stCondLst>
+                                    <p:cond delay="0"/>
+                                  </p:stCondLst>
+                                  <p:childTnLst>
+                                    <p:set>
+                                      <p:cBhvr>
+                                        <p:cTn id="8" dur="1" fill="hold">
+                                          <p:stCondLst>
+                                            <p:cond delay="0"/>
+                                          </p:stCondLst>
+                                        </p:cTn>
+                                        <p:tgtEl>
+                                          <p:spTgt spid="1030"/>
+                                        </p:tgtEl>
+                                        <p:attrNameLst>
+                                          <p:attrName>style.visibility</p:attrName>
+                                        </p:attrNameLst>
+                                      </p:cBhvr>
+                                      <p:to>
+                                        <p:strVal val="visible"/>
+                                      </p:to>
+                                    </p:set>
+                                  </p:childTnLst>
+                                </p:cTn>
+                              </p:par>
+                              <p:par>
+                                <p:cTn id="9" presetID="1" presetClass="entr" presetSubtype="0" fill="hold" grpId="0" nodeType="withEffect">
+                                  <p:stCondLst>
+                                    <p:cond delay="0"/>
+                                  </p:stCondLst>
+                                  <p:childTnLst>
+                                    <p:set>
+                                      <p:cBhvr>
+                                        <p:cTn id="10" dur="1" fill="hold">
+                                          <p:stCondLst>
+                                            <p:cond delay="0"/>
+                                          </p:stCondLst>
+                                        </p:cTn>
+                                        <p:tgtEl>
+                                          <p:spTgt spid="58"/>
+                                        </p:tgtEl>
+                                        <p:attrNameLst>
+                                          <p:attrName>style.visibility</p:attrName>
+                                        </p:attrNameLst>
+                                      </p:cBhvr>
+                                      <p:to>
+                                        <p:strVal val="visible"/>
+                                      </p:to>
+                                    </p:set>
+                                  </p:childTnLst>
+                                </p:cTn>
+                              </p:par>
+                              <p:par>
+                                <p:cTn id="11" presetID="1" presetClass="entr" presetSubtype="0" fill="hold" nodeType="withEffect">
+                                  <p:stCondLst>
+                                    <p:cond delay="0"/>
+                                  </p:stCondLst>
+                                  <p:childTnLst>
+                                    <p:set>
+                                      <p:cBhvr>
+                                        <p:cTn id="12" dur="1" fill="hold">
+                                          <p:stCondLst>
+                                            <p:cond delay="0"/>
+                                          </p:stCondLst>
+                                        </p:cTn>
+                                        <p:tgtEl>
+                                          <p:spTgt spid="65"/>
+                                        </p:tgtEl>
+                                        <p:attrNameLst>
+                                          <p:attrName>style.visibility</p:attrName>
+                                        </p:attrNameLst>
+                                      </p:cBhvr>
+                                      <p:to>
+                                        <p:strVal val="visible"/>
+                                      </p:to>
+                                    </p:set>
+                                  </p:childTnLst>
+                                </p:cTn>
+                              </p:par>
+                              <p:par>
+                                <p:cTn id="13" presetID="1" presetClass="entr" presetSubtype="0" fill="hold" grpId="0" nodeType="withEffect">
+                                  <p:stCondLst>
+                                    <p:cond delay="0"/>
+                                  </p:stCondLst>
+                                  <p:childTnLst>
+                                    <p:set>
+                                      <p:cBhvr>
+                                        <p:cTn id="14" dur="1" fill="hold">
+                                          <p:stCondLst>
+                                            <p:cond delay="0"/>
+                                          </p:stCondLst>
+                                        </p:cTn>
+                                        <p:tgtEl>
+                                          <p:spTgt spid="67"/>
+                                        </p:tgtEl>
+                                        <p:attrNameLst>
+                                          <p:attrName>style.visibility</p:attrName>
+                                        </p:attrNameLst>
+                                      </p:cBhvr>
+                                      <p:to>
+                                        <p:strVal val="visible"/>
+                                      </p:to>
+                                    </p:set>
+                                  </p:childTnLst>
+                                </p:cTn>
+                              </p:par>
+                              <p:par>
+                                <p:cTn id="15" presetID="1" presetClass="entr" presetSubtype="0" fill="hold" nodeType="withEffect">
+                                  <p:stCondLst>
+                                    <p:cond delay="0"/>
+                                  </p:stCondLst>
+                                  <p:childTnLst>
+                                    <p:set>
+                                      <p:cBhvr>
+                                        <p:cTn id="16" dur="1" fill="hold">
+                                          <p:stCondLst>
+                                            <p:cond delay="0"/>
+                                          </p:stCondLst>
+                                        </p:cTn>
+                                        <p:tgtEl>
+                                          <p:spTgt spid="68"/>
+                                        </p:tgtEl>
+                                        <p:attrNameLst>
+                                          <p:attrName>style.visibility</p:attrName>
+                                        </p:attrNameLst>
+                                      </p:cBhvr>
+                                      <p:to>
+                                        <p:strVal val="visible"/>
+                                      </p:to>
+                                    </p:set>
+                                  </p:childTnLst>
+                                </p:cTn>
+                              </p:par>
+                              <p:par>
+                                <p:cTn id="17" presetID="1" presetClass="entr" presetSubtype="0" fill="hold" grpId="0" nodeType="withEffect">
+                                  <p:stCondLst>
+                                    <p:cond delay="0"/>
+                                  </p:stCondLst>
+                                  <p:childTnLst>
+                                    <p:set>
+                                      <p:cBhvr>
+                                        <p:cTn id="18" dur="1" fill="hold">
+                                          <p:stCondLst>
+                                            <p:cond delay="0"/>
+                                          </p:stCondLst>
+                                        </p:cTn>
+                                        <p:tgtEl>
+                                          <p:spTgt spid="70"/>
+                                        </p:tgtEl>
+                                        <p:attrNameLst>
+                                          <p:attrName>style.visibility</p:attrName>
+                                        </p:attrNameLst>
+                                      </p:cBhvr>
+                                      <p:to>
+                                        <p:strVal val="visible"/>
+                                      </p:to>
+                                    </p:set>
+                                  </p:childTnLst>
+                                </p:cTn>
+                              </p:par>
+                              <p:par>
+                                <p:cTn id="19" presetID="1" presetClass="entr" presetSubtype="0" fill="hold" grpId="0" nodeType="withEffect">
+                                  <p:stCondLst>
+                                    <p:cond delay="0"/>
+                                  </p:stCondLst>
+                                  <p:childTnLst>
+                                    <p:set>
+                                      <p:cBhvr>
+                                        <p:cTn id="20" dur="1" fill="hold">
+                                          <p:stCondLst>
+                                            <p:cond delay="0"/>
+                                          </p:stCondLst>
+                                        </p:cTn>
+                                        <p:tgtEl>
+                                          <p:spTgt spid="73"/>
+                                        </p:tgtEl>
+                                        <p:attrNameLst>
+                                          <p:attrName>style.visibility</p:attrName>
+                                        </p:attrNameLst>
+                                      </p:cBhvr>
+                                      <p:to>
+                                        <p:strVal val="visible"/>
+                                      </p:to>
+                                    </p:set>
+                                  </p:childTnLst>
+                                </p:cTn>
+                              </p:par>
+                              <p:par>
+                                <p:cTn id="21" presetID="1" presetClass="entr" presetSubtype="0" fill="hold" nodeType="withEffect">
+                                  <p:stCondLst>
+                                    <p:cond delay="0"/>
+                                  </p:stCondLst>
+                                  <p:childTnLst>
+                                    <p:set>
+                                      <p:cBhvr>
+                                        <p:cTn id="22" dur="1" fill="hold">
+                                          <p:stCondLst>
+                                            <p:cond delay="0"/>
+                                          </p:stCondLst>
+                                        </p:cTn>
+                                        <p:tgtEl>
+                                          <p:spTgt spid="1026"/>
+                                        </p:tgtEl>
+                                        <p:attrNameLst>
+                                          <p:attrName>style.visibility</p:attrName>
+                                        </p:attrNameLst>
+                                      </p:cBhvr>
+                                      <p:to>
+                                        <p:strVal val="visible"/>
+                                      </p:to>
+                                    </p:set>
+                                  </p:childTnLst>
+                                </p:cTn>
+                              </p:par>
+                              <p:par>
+                                <p:cTn id="23" presetID="1" presetClass="entr" presetSubtype="0" fill="hold" nodeType="withEffect">
+                                  <p:stCondLst>
+                                    <p:cond delay="0"/>
+                                  </p:stCondLst>
+                                  <p:childTnLst>
+                                    <p:set>
+                                      <p:cBhvr>
+                                        <p:cTn id="24" dur="1" fill="hold">
+                                          <p:stCondLst>
+                                            <p:cond delay="0"/>
+                                          </p:stCondLst>
+                                        </p:cTn>
+                                        <p:tgtEl>
+                                          <p:spTgt spid="127"/>
+                                        </p:tgtEl>
+                                        <p:attrNameLst>
+                                          <p:attrName>style.visibility</p:attrName>
+                                        </p:attrNameLst>
+                                      </p:cBhvr>
+                                      <p:to>
+                                        <p:strVal val="visible"/>
+                                      </p:to>
+                                    </p:set>
+                                  </p:childTnLst>
+                                </p:cTn>
+                              </p:par>
+                              <p:par>
+                                <p:cTn id="25" presetID="1" presetClass="entr" presetSubtype="0" fill="hold" nodeType="withEffect">
+                                  <p:stCondLst>
+                                    <p:cond delay="0"/>
+                                  </p:stCondLst>
+                                  <p:childTnLst>
+                                    <p:set>
+                                      <p:cBhvr>
+                                        <p:cTn id="26" dur="1" fill="hold">
+                                          <p:stCondLst>
+                                            <p:cond delay="0"/>
+                                          </p:stCondLst>
+                                        </p:cTn>
+                                        <p:tgtEl>
+                                          <p:spTgt spid="1033"/>
+                                        </p:tgtEl>
+                                        <p:attrNameLst>
+                                          <p:attrName>style.visibility</p:attrName>
+                                        </p:attrNameLst>
+                                      </p:cBhvr>
+                                      <p:to>
+                                        <p:strVal val="visible"/>
+                                      </p:to>
+                                    </p:set>
+                                  </p:childTnLst>
+                                </p:cTn>
+                              </p:par>
+                              <p:par>
+                                <p:cTn id="27" presetID="1" presetClass="entr" presetSubtype="0" fill="hold" grpId="0" nodeType="withEffect">
+                                  <p:stCondLst>
+                                    <p:cond delay="0"/>
+                                  </p:stCondLst>
+                                  <p:childTnLst>
+                                    <p:set>
+                                      <p:cBhvr>
+                                        <p:cTn id="28" dur="1" fill="hold">
+                                          <p:stCondLst>
+                                            <p:cond delay="0"/>
+                                          </p:stCondLst>
+                                        </p:cTn>
+                                        <p:tgtEl>
+                                          <p:spTgt spid="3"/>
+                                        </p:tgtEl>
+                                        <p:attrNameLst>
+                                          <p:attrName>style.visibility</p:attrName>
+                                        </p:attrNameLst>
+                                      </p:cBhvr>
+                                      <p:to>
+                                        <p:strVal val="visible"/>
+                                      </p:to>
+                                    </p:set>
+                                  </p:childTnLst>
+                                </p:cTn>
+                              </p:par>
+                              <p:par>
+                                <p:cTn id="29" presetID="1" presetClass="entr" presetSubtype="0" fill="hold" nodeType="withEffect">
+                                  <p:stCondLst>
+                                    <p:cond delay="0"/>
+                                  </p:stCondLst>
+                                  <p:childTnLst>
+                                    <p:set>
+                                      <p:cBhvr>
+                                        <p:cTn id="30" dur="1" fill="hold">
+                                          <p:stCondLst>
+                                            <p:cond delay="0"/>
+                                          </p:stCondLst>
+                                        </p:cTn>
+                                        <p:tgtEl>
+                                          <p:spTgt spid="6"/>
+                                        </p:tgtEl>
+                                        <p:attrNameLst>
+                                          <p:attrName>style.visibility</p:attrName>
+                                        </p:attrNameLst>
+                                      </p:cBhvr>
+                                      <p:to>
+                                        <p:strVal val="visible"/>
+                                      </p:to>
+                                    </p:set>
+                                  </p:childTnLst>
+                                </p:cTn>
+                              </p:par>
+                              <p:par>
+                                <p:cTn id="31" presetID="1" presetClass="entr" presetSubtype="0" fill="hold" nodeType="withEffect">
+                                  <p:stCondLst>
+                                    <p:cond delay="0"/>
+                                  </p:stCondLst>
+                                  <p:childTnLst>
+                                    <p:set>
+                                      <p:cBhvr>
+                                        <p:cTn id="32" dur="1" fill="hold">
+                                          <p:stCondLst>
+                                            <p:cond delay="0"/>
+                                          </p:stCondLst>
+                                        </p:cTn>
+                                        <p:tgtEl>
+                                          <p:spTgt spid="10"/>
+                                        </p:tgtEl>
+                                        <p:attrNameLst>
+                                          <p:attrName>style.visibility</p:attrName>
+                                        </p:attrNameLst>
+                                      </p:cBhvr>
+                                      <p:to>
+                                        <p:strVal val="visible"/>
+                                      </p:to>
+                                    </p:set>
+                                  </p:childTnLst>
+                                </p:cTn>
+                              </p:par>
+                              <p:par>
+                                <p:cTn id="33" presetID="1" presetClass="entr" presetSubtype="0" fill="hold" grpId="0" nodeType="withEffect">
+                                  <p:stCondLst>
+                                    <p:cond delay="0"/>
+                                  </p:stCondLst>
+                                  <p:childTnLst>
+                                    <p:set>
+                                      <p:cBhvr>
+                                        <p:cTn id="34" dur="1" fill="hold">
+                                          <p:stCondLst>
+                                            <p:cond delay="0"/>
+                                          </p:stCondLst>
+                                        </p:cTn>
+                                        <p:tgtEl>
+                                          <p:spTgt spid="2"/>
+                                        </p:tgtEl>
+                                        <p:attrNameLst>
+                                          <p:attrName>style.visibility</p:attrName>
+                                        </p:attrNameLst>
+                                      </p:cBhvr>
+                                      <p:to>
+                                        <p:strVal val="visible"/>
+                                      </p:to>
+                                    </p:set>
+                                  </p:childTnLst>
+                                </p:cTn>
+                              </p:par>
+                            </p:childTnLst>
+                          </p:cTn>
+                        </p:par>
+                      </p:childTnLst>
+                    </p:cTn>
+                  </p:par>
+                  <p:par>
+                    <p:cTn id="35" fill="hold">
+                      <p:stCondLst>
+                        <p:cond delay="indefinite"/>
+                      </p:stCondLst>
+                      <p:childTnLst>
+                        <p:par>
+                          <p:cTn id="36" fill="hold">
+                            <p:stCondLst>
+                              <p:cond delay="0"/>
+                            </p:stCondLst>
+                            <p:childTnLst>
+                              <p:par>
+                                <p:cTn id="37" presetID="1" presetClass="entr" presetSubtype="0" fill="hold" nodeType="clickEffect">
+                                  <p:stCondLst>
+                                    <p:cond delay="0"/>
+                                  </p:stCondLst>
+                                  <p:childTnLst>
+                                    <p:set>
+                                      <p:cBhvr>
+                                        <p:cTn id="38" dur="1" fill="hold">
+                                          <p:stCondLst>
+                                            <p:cond delay="0"/>
+                                          </p:stCondLst>
+                                        </p:cTn>
+                                        <p:tgtEl>
+                                          <p:spTgt spid="28"/>
+                                        </p:tgtEl>
+                                        <p:attrNameLst>
+                                          <p:attrName>style.visibility</p:attrName>
+                                        </p:attrNameLst>
+                                      </p:cBhvr>
+                                      <p:to>
+                                        <p:strVal val="visible"/>
+                                      </p:to>
+                                    </p:set>
+                                  </p:childTnLst>
+                                </p:cTn>
+                              </p:par>
+                              <p:par>
+                                <p:cTn id="39" presetID="1" presetClass="entr" presetSubtype="0" fill="hold" nodeType="withEffect">
+                                  <p:stCondLst>
+                                    <p:cond delay="0"/>
+                                  </p:stCondLst>
+                                  <p:childTnLst>
+                                    <p:set>
+                                      <p:cBhvr>
+                                        <p:cTn id="40" dur="1" fill="hold">
+                                          <p:stCondLst>
+                                            <p:cond delay="0"/>
+                                          </p:stCondLst>
+                                        </p:cTn>
+                                        <p:tgtEl>
+                                          <p:spTgt spid="29"/>
+                                        </p:tgtEl>
+                                        <p:attrNameLst>
+                                          <p:attrName>style.visibility</p:attrName>
+                                        </p:attrNameLst>
+                                      </p:cBhvr>
+                                      <p:to>
+                                        <p:strVal val="visible"/>
+                                      </p:to>
+                                    </p:set>
+                                  </p:childTnLst>
+                                </p:cTn>
+                              </p:par>
+                              <p:par>
+                                <p:cTn id="41" presetID="1" presetClass="entr" presetSubtype="0" fill="hold" grpId="0" nodeType="withEffect">
+                                  <p:stCondLst>
+                                    <p:cond delay="0"/>
+                                  </p:stCondLst>
+                                  <p:childTnLst>
+                                    <p:set>
+                                      <p:cBhvr>
+                                        <p:cTn id="42" dur="1" fill="hold">
+                                          <p:stCondLst>
+                                            <p:cond delay="0"/>
+                                          </p:stCondLst>
+                                        </p:cTn>
+                                        <p:tgtEl>
+                                          <p:spTgt spid="71"/>
+                                        </p:tgtEl>
+                                        <p:attrNameLst>
+                                          <p:attrName>style.visibility</p:attrName>
+                                        </p:attrNameLst>
+                                      </p:cBhvr>
+                                      <p:to>
+                                        <p:strVal val="visible"/>
+                                      </p:to>
+                                    </p:set>
+                                  </p:childTnLst>
+                                </p:cTn>
+                              </p:par>
+                              <p:par>
+                                <p:cTn id="43" presetID="1" presetClass="entr" presetSubtype="0" fill="hold" grpId="0" nodeType="withEffect">
+                                  <p:stCondLst>
+                                    <p:cond delay="0"/>
+                                  </p:stCondLst>
+                                  <p:childTnLst>
+                                    <p:set>
+                                      <p:cBhvr>
+                                        <p:cTn id="44" dur="1" fill="hold">
+                                          <p:stCondLst>
+                                            <p:cond delay="0"/>
+                                          </p:stCondLst>
+                                        </p:cTn>
+                                        <p:tgtEl>
+                                          <p:spTgt spid="106"/>
+                                        </p:tgtEl>
+                                        <p:attrNameLst>
+                                          <p:attrName>style.visibility</p:attrName>
+                                        </p:attrNameLst>
+                                      </p:cBhvr>
+                                      <p:to>
+                                        <p:strVal val="visible"/>
+                                      </p:to>
+                                    </p:set>
+                                  </p:childTnLst>
+                                </p:cTn>
+                              </p:par>
+                              <p:par>
+                                <p:cTn id="45" presetID="1" presetClass="entr" presetSubtype="0" fill="hold" nodeType="withEffect">
+                                  <p:stCondLst>
+                                    <p:cond delay="0"/>
+                                  </p:stCondLst>
+                                  <p:childTnLst>
+                                    <p:set>
+                                      <p:cBhvr>
+                                        <p:cTn id="46" dur="1" fill="hold">
+                                          <p:stCondLst>
+                                            <p:cond delay="0"/>
+                                          </p:stCondLst>
+                                        </p:cTn>
+                                        <p:tgtEl>
+                                          <p:spTgt spid="107"/>
+                                        </p:tgtEl>
+                                        <p:attrNameLst>
+                                          <p:attrName>style.visibility</p:attrName>
+                                        </p:attrNameLst>
+                                      </p:cBhvr>
+                                      <p:to>
+                                        <p:strVal val="visible"/>
+                                      </p:to>
+                                    </p:set>
+                                  </p:childTnLst>
+                                </p:cTn>
+                              </p:par>
+                              <p:par>
+                                <p:cTn id="47" presetID="1" presetClass="entr" presetSubtype="0" fill="hold" nodeType="withEffect">
+                                  <p:stCondLst>
+                                    <p:cond delay="0"/>
+                                  </p:stCondLst>
+                                  <p:childTnLst>
+                                    <p:set>
+                                      <p:cBhvr>
+                                        <p:cTn id="48" dur="1" fill="hold">
+                                          <p:stCondLst>
+                                            <p:cond delay="0"/>
+                                          </p:stCondLst>
+                                        </p:cTn>
+                                        <p:tgtEl>
+                                          <p:spTgt spid="116"/>
+                                        </p:tgtEl>
+                                        <p:attrNameLst>
+                                          <p:attrName>style.visibility</p:attrName>
+                                        </p:attrNameLst>
+                                      </p:cBhvr>
+                                      <p:to>
+                                        <p:strVal val="visible"/>
+                                      </p:to>
+                                    </p:set>
+                                  </p:childTnLst>
+                                </p:cTn>
+                              </p:par>
+                              <p:par>
+                                <p:cTn id="49" presetID="1" presetClass="entr" presetSubtype="0" fill="hold" nodeType="withEffect">
+                                  <p:stCondLst>
+                                    <p:cond delay="0"/>
+                                  </p:stCondLst>
+                                  <p:childTnLst>
+                                    <p:set>
+                                      <p:cBhvr>
+                                        <p:cTn id="50" dur="1" fill="hold">
+                                          <p:stCondLst>
+                                            <p:cond delay="0"/>
+                                          </p:stCondLst>
+                                        </p:cTn>
+                                        <p:tgtEl>
+                                          <p:spTgt spid="117"/>
+                                        </p:tgtEl>
+                                        <p:attrNameLst>
+                                          <p:attrName>style.visibility</p:attrName>
+                                        </p:attrNameLst>
+                                      </p:cBhvr>
+                                      <p:to>
+                                        <p:strVal val="visible"/>
+                                      </p:to>
+                                    </p:set>
+                                  </p:childTnLst>
+                                </p:cTn>
+                              </p:par>
+                              <p:par>
+                                <p:cTn id="51" presetID="1" presetClass="entr" presetSubtype="0" fill="hold" nodeType="withEffect">
+                                  <p:stCondLst>
+                                    <p:cond delay="0"/>
+                                  </p:stCondLst>
+                                  <p:childTnLst>
+                                    <p:set>
+                                      <p:cBhvr>
+                                        <p:cTn id="52" dur="1" fill="hold">
+                                          <p:stCondLst>
+                                            <p:cond delay="0"/>
+                                          </p:stCondLst>
+                                        </p:cTn>
+                                        <p:tgtEl>
+                                          <p:spTgt spid="11"/>
+                                        </p:tgtEl>
+                                        <p:attrNameLst>
+                                          <p:attrName>style.visibility</p:attrName>
+                                        </p:attrNameLst>
+                                      </p:cBhvr>
+                                      <p:to>
+                                        <p:strVal val="visible"/>
+                                      </p:to>
+                                    </p:set>
+                                  </p:childTnLst>
+                                </p:cTn>
+                              </p:par>
+                              <p:par>
+                                <p:cTn id="53" presetID="1" presetClass="entr" presetSubtype="0" fill="hold" nodeType="withEffect">
+                                  <p:stCondLst>
+                                    <p:cond delay="0"/>
+                                  </p:stCondLst>
+                                  <p:childTnLst>
+                                    <p:set>
+                                      <p:cBhvr>
+                                        <p:cTn id="54" dur="1" fill="hold">
+                                          <p:stCondLst>
+                                            <p:cond delay="0"/>
+                                          </p:stCondLst>
+                                        </p:cTn>
+                                        <p:tgtEl>
+                                          <p:spTgt spid="19"/>
+                                        </p:tgtEl>
+                                        <p:attrNameLst>
+                                          <p:attrName>style.visibility</p:attrName>
+                                        </p:attrNameLst>
+                                      </p:cBhvr>
+                                      <p:to>
+                                        <p:strVal val="visible"/>
+                                      </p:to>
+                                    </p:set>
+                                  </p:childTnLst>
+                                </p:cTn>
+                              </p:par>
+                              <p:par>
+                                <p:cTn id="55" presetID="1" presetClass="entr" presetSubtype="0" fill="hold" nodeType="withEffect">
+                                  <p:stCondLst>
+                                    <p:cond delay="0"/>
+                                  </p:stCondLst>
+                                  <p:childTnLst>
+                                    <p:set>
+                                      <p:cBhvr>
+                                        <p:cTn id="56" dur="1" fill="hold">
+                                          <p:stCondLst>
+                                            <p:cond delay="0"/>
+                                          </p:stCondLst>
+                                        </p:cTn>
+                                        <p:tgtEl>
+                                          <p:spTgt spid="20"/>
+                                        </p:tgtEl>
+                                        <p:attrNameLst>
+                                          <p:attrName>style.visibility</p:attrName>
+                                        </p:attrNameLst>
+                                      </p:cBhvr>
+                                      <p:to>
+                                        <p:strVal val="visible"/>
+                                      </p:to>
+                                    </p:set>
+                                  </p:childTnLst>
+                                </p:cTn>
+                              </p:par>
+                              <p:par>
+                                <p:cTn id="57" presetID="1" presetClass="entr" presetSubtype="0" fill="hold" nodeType="withEffect">
+                                  <p:stCondLst>
+                                    <p:cond delay="0"/>
+                                  </p:stCondLst>
+                                  <p:childTnLst>
+                                    <p:set>
+                                      <p:cBhvr>
+                                        <p:cTn id="58" dur="1" fill="hold">
+                                          <p:stCondLst>
+                                            <p:cond delay="0"/>
+                                          </p:stCondLst>
+                                        </p:cTn>
+                                        <p:tgtEl>
+                                          <p:spTgt spid="24"/>
+                                        </p:tgtEl>
+                                        <p:attrNameLst>
+                                          <p:attrName>style.visibility</p:attrName>
+                                        </p:attrNameLst>
+                                      </p:cBhvr>
+                                      <p:to>
+                                        <p:strVal val="visible"/>
+                                      </p:to>
+                                    </p:set>
+                                  </p:childTnLst>
+                                </p:cTn>
+                              </p:par>
+                              <p:par>
+                                <p:cTn id="59" presetID="1" presetClass="entr" presetSubtype="0" fill="hold" grpId="0" nodeType="withEffect">
+                                  <p:stCondLst>
+                                    <p:cond delay="0"/>
+                                  </p:stCondLst>
+                                  <p:childTnLst>
+                                    <p:set>
+                                      <p:cBhvr>
+                                        <p:cTn id="60" dur="1" fill="hold">
+                                          <p:stCondLst>
+                                            <p:cond delay="0"/>
+                                          </p:stCondLst>
+                                        </p:cTn>
+                                        <p:tgtEl>
+                                          <p:spTgt spid="31"/>
+                                        </p:tgtEl>
+                                        <p:attrNameLst>
+                                          <p:attrName>style.visibility</p:attrName>
+                                        </p:attrNameLst>
+                                      </p:cBhvr>
+                                      <p:to>
+                                        <p:strVal val="visible"/>
+                                      </p:to>
+                                    </p:set>
+                                  </p:childTnLst>
+                                </p:cTn>
+                              </p:par>
+                              <p:par>
+                                <p:cTn id="61" presetID="1" presetClass="entr" presetSubtype="0" fill="hold" grpId="0" nodeType="withEffect">
+                                  <p:stCondLst>
+                                    <p:cond delay="0"/>
+                                  </p:stCondLst>
+                                  <p:childTnLst>
+                                    <p:set>
+                                      <p:cBhvr>
+                                        <p:cTn id="62" dur="1" fill="hold">
+                                          <p:stCondLst>
+                                            <p:cond delay="0"/>
+                                          </p:stCondLst>
+                                        </p:cTn>
+                                        <p:tgtEl>
+                                          <p:spTgt spid="32"/>
+                                        </p:tgtEl>
+                                        <p:attrNameLst>
+                                          <p:attrName>style.visibility</p:attrName>
+                                        </p:attrNameLst>
+                                      </p:cBhvr>
+                                      <p:to>
+                                        <p:strVal val="visible"/>
+                                      </p:to>
+                                    </p:set>
+                                  </p:childTnLst>
+                                </p:cTn>
+                              </p:par>
+                              <p:par>
+                                <p:cTn id="63" presetID="1" presetClass="entr" presetSubtype="0" fill="hold" grpId="0" nodeType="withEffect">
+                                  <p:stCondLst>
+                                    <p:cond delay="0"/>
+                                  </p:stCondLst>
+                                  <p:childTnLst>
+                                    <p:set>
+                                      <p:cBhvr>
+                                        <p:cTn id="64" dur="1" fill="hold">
+                                          <p:stCondLst>
+                                            <p:cond delay="0"/>
+                                          </p:stCondLst>
+                                        </p:cTn>
+                                        <p:tgtEl>
+                                          <p:spTgt spid="18"/>
+                                        </p:tgtEl>
+                                        <p:attrNameLst>
+                                          <p:attrName>style.visibility</p:attrName>
+                                        </p:attrNameLst>
+                                      </p:cBhvr>
+                                      <p:to>
+                                        <p:strVal val="visible"/>
+                                      </p:to>
+                                    </p:set>
+                                  </p:childTnLst>
+                                </p:cTn>
+                              </p:par>
+                            </p:childTnLst>
+                          </p:cTn>
+                        </p:par>
+                      </p:childTnLst>
+                    </p:cTn>
+                  </p:par>
+                  <p:par>
+                    <p:cTn id="65" fill="hold">
+                      <p:stCondLst>
+                        <p:cond delay="indefinite"/>
+                      </p:stCondLst>
+                      <p:childTnLst>
+                        <p:par>
+                          <p:cTn id="66" fill="hold">
+                            <p:stCondLst>
+                              <p:cond delay="0"/>
+                            </p:stCondLst>
+                            <p:childTnLst>
+                              <p:par>
+                                <p:cTn id="67" presetID="1" presetClass="entr" presetSubtype="0" fill="hold" grpId="0" nodeType="clickEffect">
+                                  <p:stCondLst>
+                                    <p:cond delay="0"/>
+                                  </p:stCondLst>
+                                  <p:childTnLst>
+                                    <p:set>
+                                      <p:cBhvr>
+                                        <p:cTn id="68" dur="1" fill="hold">
+                                          <p:stCondLst>
+                                            <p:cond delay="0"/>
+                                          </p:stCondLst>
+                                        </p:cTn>
+                                        <p:tgtEl>
+                                          <p:spTgt spid="22"/>
+                                        </p:tgtEl>
+                                        <p:attrNameLst>
+                                          <p:attrName>style.visibility</p:attrName>
+                                        </p:attrNameLst>
+                                      </p:cBhvr>
+                                      <p:to>
+                                        <p:strVal val="visible"/>
+                                      </p:to>
+                                    </p:set>
+                                  </p:childTnLst>
+                                </p:cTn>
+                              </p:par>
+                              <p:par>
+                                <p:cTn id="69" presetID="1" presetClass="entr" presetSubtype="0" fill="hold" nodeType="withEffect">
+                                  <p:stCondLst>
+                                    <p:cond delay="0"/>
+                                  </p:stCondLst>
+                                  <p:childTnLst>
+                                    <p:set>
+                                      <p:cBhvr>
+                                        <p:cTn id="70" dur="1" fill="hold">
+                                          <p:stCondLst>
+                                            <p:cond delay="0"/>
+                                          </p:stCondLst>
+                                        </p:cTn>
+                                        <p:tgtEl>
+                                          <p:spTgt spid="1036"/>
+                                        </p:tgtEl>
+                                        <p:attrNameLst>
+                                          <p:attrName>style.visibility</p:attrName>
+                                        </p:attrNameLst>
+                                      </p:cBhvr>
+                                      <p:to>
+                                        <p:strVal val="visible"/>
+                                      </p:to>
+                                    </p:set>
+                                  </p:childTnLst>
+                                </p:cTn>
+                              </p:par>
+                              <p:par>
+                                <p:cTn id="71" presetID="1" presetClass="entr" presetSubtype="0" fill="hold" nodeType="withEffect">
+                                  <p:stCondLst>
+                                    <p:cond delay="0"/>
+                                  </p:stCondLst>
+                                  <p:childTnLst>
+                                    <p:set>
+                                      <p:cBhvr>
+                                        <p:cTn id="72" dur="1" fill="hold">
+                                          <p:stCondLst>
+                                            <p:cond delay="0"/>
+                                          </p:stCondLst>
+                                        </p:cTn>
+                                        <p:tgtEl>
+                                          <p:spTgt spid="1038"/>
+                                        </p:tgtEl>
+                                        <p:attrNameLst>
+                                          <p:attrName>style.visibility</p:attrName>
+                                        </p:attrNameLst>
+                                      </p:cBhvr>
+                                      <p:to>
+                                        <p:strVal val="visible"/>
+                                      </p:to>
+                                    </p:set>
+                                  </p:childTnLst>
+                                </p:cTn>
+                              </p:par>
+                              <p:par>
+                                <p:cTn id="73" presetID="1" presetClass="entr" presetSubtype="0" fill="hold" grpId="0" nodeType="withEffect">
+                                  <p:stCondLst>
+                                    <p:cond delay="0"/>
+                                  </p:stCondLst>
+                                  <p:childTnLst>
+                                    <p:set>
+                                      <p:cBhvr>
+                                        <p:cTn id="74" dur="1" fill="hold">
+                                          <p:stCondLst>
+                                            <p:cond delay="0"/>
+                                          </p:stCondLst>
+                                        </p:cTn>
+                                        <p:tgtEl>
+                                          <p:spTgt spid="47"/>
+                                        </p:tgtEl>
+                                        <p:attrNameLst>
+                                          <p:attrName>style.visibility</p:attrName>
+                                        </p:attrNameLst>
+                                      </p:cBhvr>
+                                      <p:to>
+                                        <p:strVal val="visible"/>
+                                      </p:to>
+                                    </p:set>
+                                  </p:childTnLst>
+                                </p:cTn>
+                              </p:par>
+                              <p:par>
+                                <p:cTn id="75" presetID="1" presetClass="entr" presetSubtype="0" fill="hold" grpId="0" nodeType="withEffect">
+                                  <p:stCondLst>
+                                    <p:cond delay="0"/>
+                                  </p:stCondLst>
+                                  <p:childTnLst>
+                                    <p:set>
+                                      <p:cBhvr>
+                                        <p:cTn id="76" dur="1" fill="hold">
+                                          <p:stCondLst>
+                                            <p:cond delay="0"/>
+                                          </p:stCondLst>
+                                        </p:cTn>
+                                        <p:tgtEl>
+                                          <p:spTgt spid="48"/>
+                                        </p:tgtEl>
+                                        <p:attrNameLst>
+                                          <p:attrName>style.visibility</p:attrName>
+                                        </p:attrNameLst>
+                                      </p:cBhvr>
+                                      <p:to>
+                                        <p:strVal val="visible"/>
+                                      </p:to>
+                                    </p:set>
+                                  </p:childTnLst>
+                                </p:cTn>
+                              </p:par>
+                              <p:par>
+                                <p:cTn id="77" presetID="1" presetClass="entr" presetSubtype="0" fill="hold" grpId="0" nodeType="withEffect">
+                                  <p:stCondLst>
+                                    <p:cond delay="0"/>
+                                  </p:stCondLst>
+                                  <p:childTnLst>
+                                    <p:set>
+                                      <p:cBhvr>
+                                        <p:cTn id="78" dur="1" fill="hold">
+                                          <p:stCondLst>
+                                            <p:cond delay="0"/>
+                                          </p:stCondLst>
+                                        </p:cTn>
+                                        <p:tgtEl>
+                                          <p:spTgt spid="49"/>
+                                        </p:tgtEl>
+                                        <p:attrNameLst>
+                                          <p:attrName>style.visibility</p:attrName>
+                                        </p:attrNameLst>
+                                      </p:cBhvr>
+                                      <p:to>
+                                        <p:strVal val="visible"/>
+                                      </p:to>
+                                    </p:set>
+                                  </p:childTnLst>
+                                </p:cTn>
+                              </p:par>
+                              <p:par>
+                                <p:cTn id="79" presetID="1" presetClass="entr" presetSubtype="0" fill="hold" grpId="0" nodeType="withEffect">
+                                  <p:stCondLst>
+                                    <p:cond delay="0"/>
+                                  </p:stCondLst>
+                                  <p:childTnLst>
+                                    <p:set>
+                                      <p:cBhvr>
+                                        <p:cTn id="80" dur="1" fill="hold">
+                                          <p:stCondLst>
+                                            <p:cond delay="0"/>
+                                          </p:stCondLst>
+                                        </p:cTn>
+                                        <p:tgtEl>
+                                          <p:spTgt spid="50"/>
+                                        </p:tgtEl>
+                                        <p:attrNameLst>
+                                          <p:attrName>style.visibility</p:attrName>
+                                        </p:attrNameLst>
+                                      </p:cBhvr>
+                                      <p:to>
+                                        <p:strVal val="visible"/>
+                                      </p:to>
+                                    </p:set>
+                                  </p:childTnLst>
+                                </p:cTn>
+                              </p:par>
+                              <p:par>
+                                <p:cTn id="81" presetID="1" presetClass="entr" presetSubtype="0" fill="hold" nodeType="withEffect">
+                                  <p:stCondLst>
+                                    <p:cond delay="0"/>
+                                  </p:stCondLst>
+                                  <p:childTnLst>
+                                    <p:set>
+                                      <p:cBhvr>
+                                        <p:cTn id="82" dur="1" fill="hold">
+                                          <p:stCondLst>
+                                            <p:cond delay="0"/>
+                                          </p:stCondLst>
+                                        </p:cTn>
+                                        <p:tgtEl>
+                                          <p:spTgt spid="2054"/>
+                                        </p:tgtEl>
+                                        <p:attrNameLst>
+                                          <p:attrName>style.visibility</p:attrName>
+                                        </p:attrNameLst>
+                                      </p:cBhvr>
+                                      <p:to>
+                                        <p:strVal val="visible"/>
+                                      </p:to>
+                                    </p:set>
+                                  </p:childTnLst>
+                                </p:cTn>
+                              </p:par>
+                              <p:par>
+                                <p:cTn id="83" presetID="1" presetClass="entr" presetSubtype="0" fill="hold" nodeType="withEffect">
+                                  <p:stCondLst>
+                                    <p:cond delay="0"/>
+                                  </p:stCondLst>
+                                  <p:childTnLst>
+                                    <p:set>
+                                      <p:cBhvr>
+                                        <p:cTn id="84" dur="1" fill="hold">
+                                          <p:stCondLst>
+                                            <p:cond delay="0"/>
+                                          </p:stCondLst>
+                                        </p:cTn>
+                                        <p:tgtEl>
+                                          <p:spTgt spid="51"/>
+                                        </p:tgtEl>
+                                        <p:attrNameLst>
+                                          <p:attrName>style.visibility</p:attrName>
+                                        </p:attrNameLst>
+                                      </p:cBhvr>
+                                      <p:to>
+                                        <p:strVal val="visible"/>
+                                      </p:to>
+                                    </p:set>
+                                  </p:childTnLst>
+                                </p:cTn>
+                              </p:par>
+                              <p:par>
+                                <p:cTn id="85" presetID="1" presetClass="entr" presetSubtype="0" fill="hold" grpId="0" nodeType="withEffect">
+                                  <p:stCondLst>
+                                    <p:cond delay="0"/>
+                                  </p:stCondLst>
+                                  <p:childTnLst>
+                                    <p:set>
+                                      <p:cBhvr>
+                                        <p:cTn id="86" dur="1" fill="hold">
+                                          <p:stCondLst>
+                                            <p:cond delay="0"/>
+                                          </p:stCondLst>
+                                        </p:cTn>
+                                        <p:tgtEl>
+                                          <p:spTgt spid="52"/>
+                                        </p:tgtEl>
+                                        <p:attrNameLst>
+                                          <p:attrName>style.visibility</p:attrName>
+                                        </p:attrNameLst>
+                                      </p:cBhvr>
+                                      <p:to>
+                                        <p:strVal val="visible"/>
+                                      </p:to>
+                                    </p:set>
+                                  </p:childTnLst>
+                                </p:cTn>
+                              </p:par>
+                              <p:par>
+                                <p:cTn id="87" presetID="1" presetClass="entr" presetSubtype="0" fill="hold" grpId="0" nodeType="withEffect">
+                                  <p:stCondLst>
+                                    <p:cond delay="0"/>
+                                  </p:stCondLst>
+                                  <p:childTnLst>
+                                    <p:set>
+                                      <p:cBhvr>
+                                        <p:cTn id="88" dur="1" fill="hold">
+                                          <p:stCondLst>
+                                            <p:cond delay="0"/>
+                                          </p:stCondLst>
+                                        </p:cTn>
+                                        <p:tgtEl>
+                                          <p:spTgt spid="53"/>
+                                        </p:tgtEl>
+                                        <p:attrNameLst>
+                                          <p:attrName>style.visibility</p:attrName>
+                                        </p:attrNameLst>
+                                      </p:cBhvr>
+                                      <p:to>
+                                        <p:strVal val="visible"/>
+                                      </p:to>
+                                    </p:set>
+                                  </p:childTnLst>
+                                </p:cTn>
+                              </p:par>
+                              <p:par>
+                                <p:cTn id="89" presetID="1" presetClass="entr" presetSubtype="0" fill="hold" nodeType="withEffect">
+                                  <p:stCondLst>
+                                    <p:cond delay="0"/>
+                                  </p:stCondLst>
+                                  <p:childTnLst>
+                                    <p:set>
+                                      <p:cBhvr>
+                                        <p:cTn id="90" dur="1" fill="hold">
+                                          <p:stCondLst>
+                                            <p:cond delay="0"/>
+                                          </p:stCondLst>
+                                        </p:cTn>
+                                        <p:tgtEl>
+                                          <p:spTgt spid="1046"/>
+                                        </p:tgtEl>
+                                        <p:attrNameLst>
+                                          <p:attrName>style.visibility</p:attrName>
+                                        </p:attrNameLst>
+                                      </p:cBhvr>
+                                      <p:to>
+                                        <p:strVal val="visible"/>
+                                      </p:to>
+                                    </p:set>
+                                  </p:childTnLst>
+                                </p:cTn>
+                              </p:par>
+                              <p:par>
+                                <p:cTn id="91" presetID="1" presetClass="entr" presetSubtype="0" fill="hold" nodeType="withEffect">
+                                  <p:stCondLst>
+                                    <p:cond delay="0"/>
+                                  </p:stCondLst>
+                                  <p:childTnLst>
+                                    <p:set>
+                                      <p:cBhvr>
+                                        <p:cTn id="92" dur="1" fill="hold">
+                                          <p:stCondLst>
+                                            <p:cond delay="0"/>
+                                          </p:stCondLst>
+                                        </p:cTn>
+                                        <p:tgtEl>
+                                          <p:spTgt spid="1068"/>
+                                        </p:tgtEl>
+                                        <p:attrNameLst>
+                                          <p:attrName>style.visibility</p:attrName>
+                                        </p:attrNameLst>
+                                      </p:cBhvr>
+                                      <p:to>
+                                        <p:strVal val="visible"/>
+                                      </p:to>
+                                    </p:set>
+                                  </p:childTnLst>
+                                </p:cTn>
+                              </p:par>
+                              <p:par>
+                                <p:cTn id="93" presetID="1" presetClass="entr" presetSubtype="0" fill="hold" nodeType="withEffect">
+                                  <p:stCondLst>
+                                    <p:cond delay="0"/>
+                                  </p:stCondLst>
+                                  <p:childTnLst>
+                                    <p:set>
+                                      <p:cBhvr>
+                                        <p:cTn id="94" dur="1" fill="hold">
+                                          <p:stCondLst>
+                                            <p:cond delay="0"/>
+                                          </p:stCondLst>
+                                        </p:cTn>
+                                        <p:tgtEl>
+                                          <p:spTgt spid="30"/>
+                                        </p:tgtEl>
+                                        <p:attrNameLst>
+                                          <p:attrName>style.visibility</p:attrName>
+                                        </p:attrNameLst>
+                                      </p:cBhvr>
+                                      <p:to>
+                                        <p:strVal val="visible"/>
+                                      </p:to>
+                                    </p:set>
+                                  </p:childTnLst>
+                                </p:cTn>
+                              </p:par>
+                              <p:par>
+                                <p:cTn id="95" presetID="1" presetClass="entr" presetSubtype="0" fill="hold" grpId="0" nodeType="withEffect">
+                                  <p:stCondLst>
+                                    <p:cond delay="0"/>
+                                  </p:stCondLst>
+                                  <p:childTnLst>
+                                    <p:set>
+                                      <p:cBhvr>
+                                        <p:cTn id="96" dur="1" fill="hold">
+                                          <p:stCondLst>
+                                            <p:cond delay="0"/>
+                                          </p:stCondLst>
+                                        </p:cTn>
+                                        <p:tgtEl>
+                                          <p:spTgt spid="46"/>
+                                        </p:tgtEl>
+                                        <p:attrNameLst>
+                                          <p:attrName>style.visibility</p:attrName>
+                                        </p:attrNameLst>
+                                      </p:cBhvr>
+                                      <p:to>
+                                        <p:strVal val="visible"/>
+                                      </p:to>
+                                    </p:set>
+                                  </p:childTnLst>
+                                </p:cTn>
+                              </p:par>
+                              <p:par>
+                                <p:cTn id="97" presetID="1" presetClass="entr" presetSubtype="0" fill="hold" nodeType="withEffect">
+                                  <p:stCondLst>
+                                    <p:cond delay="0"/>
+                                  </p:stCondLst>
+                                  <p:childTnLst>
+                                    <p:set>
+                                      <p:cBhvr>
+                                        <p:cTn id="98" dur="1" fill="hold">
+                                          <p:stCondLst>
+                                            <p:cond delay="0"/>
+                                          </p:stCondLst>
+                                        </p:cTn>
+                                        <p:tgtEl>
+                                          <p:spTgt spid="1034"/>
+                                        </p:tgtEl>
+                                        <p:attrNameLst>
+                                          <p:attrName>style.visibility</p:attrName>
+                                        </p:attrNameLst>
+                                      </p:cBhvr>
+                                      <p:to>
+                                        <p:strVal val="visible"/>
+                                      </p:to>
+                                    </p:set>
+                                  </p:childTnLst>
+                                </p:cTn>
+                              </p:par>
+                              <p:par>
+                                <p:cTn id="99" presetID="1" presetClass="entr" presetSubtype="0" fill="hold" grpId="0" nodeType="withEffect">
+                                  <p:stCondLst>
+                                    <p:cond delay="0"/>
+                                  </p:stCondLst>
+                                  <p:childTnLst>
+                                    <p:set>
+                                      <p:cBhvr>
+                                        <p:cTn id="100" dur="1" fill="hold">
+                                          <p:stCondLst>
+                                            <p:cond delay="0"/>
+                                          </p:stCondLst>
+                                        </p:cTn>
+                                        <p:tgtEl>
+                                          <p:spTgt spid="44"/>
+                                        </p:tgtEl>
+                                        <p:attrNameLst>
+                                          <p:attrName>style.visibility</p:attrName>
+                                        </p:attrNameLst>
+                                      </p:cBhvr>
+                                      <p:to>
+                                        <p:strVal val="visible"/>
+                                      </p:to>
+                                    </p:set>
+                                  </p:childTnLst>
+                                </p:cTn>
+                              </p:par>
+                              <p:par>
+                                <p:cTn id="101" presetID="1" presetClass="entr" presetSubtype="0" fill="hold" nodeType="withEffect">
+                                  <p:stCondLst>
+                                    <p:cond delay="0"/>
+                                  </p:stCondLst>
+                                  <p:childTnLst>
+                                    <p:set>
+                                      <p:cBhvr>
+                                        <p:cTn id="102" dur="1" fill="hold">
+                                          <p:stCondLst>
+                                            <p:cond delay="0"/>
+                                          </p:stCondLst>
+                                        </p:cTn>
+                                        <p:tgtEl>
+                                          <p:spTgt spid="108"/>
+                                        </p:tgtEl>
+                                        <p:attrNameLst>
+                                          <p:attrName>style.visibility</p:attrName>
+                                        </p:attrNameLst>
+                                      </p:cBhvr>
+                                      <p:to>
+                                        <p:strVal val="visible"/>
+                                      </p:to>
+                                    </p:set>
+                                  </p:childTnLst>
+                                </p:cTn>
+                              </p:par>
+                              <p:par>
+                                <p:cTn id="103" presetID="1" presetClass="entr" presetSubtype="0" fill="hold" nodeType="withEffect">
+                                  <p:stCondLst>
+                                    <p:cond delay="0"/>
+                                  </p:stCondLst>
+                                  <p:childTnLst>
+                                    <p:set>
+                                      <p:cBhvr>
+                                        <p:cTn id="104" dur="1" fill="hold">
+                                          <p:stCondLst>
+                                            <p:cond delay="0"/>
+                                          </p:stCondLst>
+                                        </p:cTn>
+                                        <p:tgtEl>
+                                          <p:spTgt spid="27"/>
+                                        </p:tgtEl>
+                                        <p:attrNameLst>
+                                          <p:attrName>style.visibility</p:attrName>
+                                        </p:attrNameLst>
+                                      </p:cBhvr>
+                                      <p:to>
+                                        <p:strVal val="visible"/>
+                                      </p:to>
+                                    </p:set>
+                                  </p:childTnLst>
+                                </p:cTn>
+                              </p:par>
+                              <p:par>
+                                <p:cTn id="105" presetID="1" presetClass="entr" presetSubtype="0" fill="hold" grpId="0" nodeType="withEffect">
+                                  <p:stCondLst>
+                                    <p:cond delay="0"/>
+                                  </p:stCondLst>
+                                  <p:childTnLst>
+                                    <p:set>
+                                      <p:cBhvr>
+                                        <p:cTn id="106" dur="1" fill="hold">
+                                          <p:stCondLst>
+                                            <p:cond delay="0"/>
+                                          </p:stCondLst>
+                                        </p:cTn>
+                                        <p:tgtEl>
+                                          <p:spTgt spid="5"/>
+                                        </p:tgtEl>
+                                        <p:attrNameLst>
+                                          <p:attrName>style.visibility</p:attrName>
+                                        </p:attrNameLst>
+                                      </p:cBhvr>
+                                      <p:to>
+                                        <p:strVal val="visible"/>
+                                      </p:to>
+                                    </p:set>
+                                  </p:childTnLst>
+                                </p:cTn>
+                              </p:par>
+                            </p:childTnLst>
+                          </p:cTn>
+                        </p:par>
+                      </p:childTnLst>
+                    </p:cTn>
+                  </p:par>
+                  <p:par>
+                    <p:cTn id="107" fill="hold">
+                      <p:stCondLst>
+                        <p:cond delay="indefinite"/>
+                      </p:stCondLst>
+                      <p:childTnLst>
+                        <p:par>
+                          <p:cTn id="108" fill="hold">
+                            <p:stCondLst>
+                              <p:cond delay="0"/>
+                            </p:stCondLst>
+                            <p:childTnLst>
+                              <p:par>
+                                <p:cTn id="109" presetID="1" presetClass="entr" presetSubtype="0" fill="hold" nodeType="clickEffect">
+                                  <p:stCondLst>
+                                    <p:cond delay="0"/>
+                                  </p:stCondLst>
+                                  <p:childTnLst>
+                                    <p:set>
+                                      <p:cBhvr>
+                                        <p:cTn id="110" dur="1" fill="hold">
+                                          <p:stCondLst>
+                                            <p:cond delay="0"/>
+                                          </p:stCondLst>
+                                        </p:cTn>
+                                        <p:tgtEl>
+                                          <p:spTgt spid="2052"/>
+                                        </p:tgtEl>
+                                        <p:attrNameLst>
+                                          <p:attrName>style.visibility</p:attrName>
+                                        </p:attrNameLst>
+                                      </p:cBhvr>
+                                      <p:to>
+                                        <p:strVal val="visible"/>
+                                      </p:to>
+                                    </p:set>
+                                  </p:childTnLst>
+                                </p:cTn>
+                              </p:par>
+                              <p:par>
+                                <p:cTn id="111" presetID="1" presetClass="entr" presetSubtype="0" fill="hold" nodeType="withEffect">
+                                  <p:stCondLst>
+                                    <p:cond delay="0"/>
+                                  </p:stCondLst>
+                                  <p:childTnLst>
+                                    <p:set>
+                                      <p:cBhvr>
+                                        <p:cTn id="112" dur="1" fill="hold">
+                                          <p:stCondLst>
+                                            <p:cond delay="0"/>
+                                          </p:stCondLst>
+                                        </p:cTn>
+                                        <p:tgtEl>
+                                          <p:spTgt spid="43"/>
+                                        </p:tgtEl>
+                                        <p:attrNameLst>
+                                          <p:attrName>style.visibility</p:attrName>
+                                        </p:attrNameLst>
+                                      </p:cBhvr>
+                                      <p:to>
+                                        <p:strVal val="visible"/>
+                                      </p:to>
+                                    </p:set>
+                                  </p:childTnLst>
+                                </p:cTn>
+                              </p:par>
+                              <p:par>
+                                <p:cTn id="113" presetID="1" presetClass="entr" presetSubtype="0" fill="hold" grpId="0" nodeType="withEffect">
+                                  <p:stCondLst>
+                                    <p:cond delay="0"/>
+                                  </p:stCondLst>
+                                  <p:childTnLst>
+                                    <p:set>
+                                      <p:cBhvr>
+                                        <p:cTn id="114" dur="1" fill="hold">
+                                          <p:stCondLst>
+                                            <p:cond delay="0"/>
+                                          </p:stCondLst>
+                                        </p:cTn>
+                                        <p:tgtEl>
+                                          <p:spTgt spid="54"/>
+                                        </p:tgtEl>
+                                        <p:attrNameLst>
+                                          <p:attrName>style.visibility</p:attrName>
+                                        </p:attrNameLst>
+                                      </p:cBhvr>
+                                      <p:to>
+                                        <p:strVal val="visible"/>
+                                      </p:to>
+                                    </p:set>
+                                  </p:childTnLst>
+                                </p:cTn>
+                              </p:par>
+                              <p:par>
+                                <p:cTn id="115" presetID="1" presetClass="entr" presetSubtype="0" fill="hold" grpId="0" nodeType="withEffect">
+                                  <p:stCondLst>
+                                    <p:cond delay="0"/>
+                                  </p:stCondLst>
+                                  <p:childTnLst>
+                                    <p:set>
+                                      <p:cBhvr>
+                                        <p:cTn id="116" dur="1" fill="hold">
+                                          <p:stCondLst>
+                                            <p:cond delay="0"/>
+                                          </p:stCondLst>
+                                        </p:cTn>
+                                        <p:tgtEl>
+                                          <p:spTgt spid="55"/>
+                                        </p:tgtEl>
+                                        <p:attrNameLst>
+                                          <p:attrName>style.visibility</p:attrName>
+                                        </p:attrNameLst>
+                                      </p:cBhvr>
+                                      <p:to>
+                                        <p:strVal val="visible"/>
+                                      </p:to>
+                                    </p:set>
+                                  </p:childTnLst>
+                                </p:cTn>
+                              </p:par>
+                              <p:par>
+                                <p:cTn id="117" presetID="1" presetClass="entr" presetSubtype="0" fill="hold" grpId="0" nodeType="withEffect">
+                                  <p:stCondLst>
+                                    <p:cond delay="0"/>
+                                  </p:stCondLst>
+                                  <p:childTnLst>
+                                    <p:set>
+                                      <p:cBhvr>
+                                        <p:cTn id="118" dur="1" fill="hold">
+                                          <p:stCondLst>
+                                            <p:cond delay="0"/>
+                                          </p:stCondLst>
+                                        </p:cTn>
+                                        <p:tgtEl>
+                                          <p:spTgt spid="56"/>
+                                        </p:tgtEl>
+                                        <p:attrNameLst>
+                                          <p:attrName>style.visibility</p:attrName>
+                                        </p:attrNameLst>
+                                      </p:cBhvr>
+                                      <p:to>
+                                        <p:strVal val="visible"/>
+                                      </p:to>
+                                    </p:set>
+                                  </p:childTnLst>
+                                </p:cTn>
+                              </p:par>
+                              <p:par>
+                                <p:cTn id="119" presetID="1" presetClass="entr" presetSubtype="0" fill="hold" grpId="0" nodeType="withEffect">
+                                  <p:stCondLst>
+                                    <p:cond delay="0"/>
+                                  </p:stCondLst>
+                                  <p:childTnLst>
+                                    <p:set>
+                                      <p:cBhvr>
+                                        <p:cTn id="120" dur="1" fill="hold">
+                                          <p:stCondLst>
+                                            <p:cond delay="0"/>
+                                          </p:stCondLst>
+                                        </p:cTn>
+                                        <p:tgtEl>
+                                          <p:spTgt spid="57"/>
+                                        </p:tgtEl>
+                                        <p:attrNameLst>
+                                          <p:attrName>style.visibility</p:attrName>
+                                        </p:attrNameLst>
+                                      </p:cBhvr>
+                                      <p:to>
+                                        <p:strVal val="visible"/>
+                                      </p:to>
+                                    </p:set>
+                                  </p:childTnLst>
+                                </p:cTn>
+                              </p:par>
+                              <p:par>
+                                <p:cTn id="121" presetID="1" presetClass="entr" presetSubtype="0" fill="hold" grpId="0" nodeType="withEffect">
+                                  <p:stCondLst>
+                                    <p:cond delay="0"/>
+                                  </p:stCondLst>
+                                  <p:childTnLst>
+                                    <p:set>
+                                      <p:cBhvr>
+                                        <p:cTn id="122" dur="1" fill="hold">
+                                          <p:stCondLst>
+                                            <p:cond delay="0"/>
+                                          </p:stCondLst>
+                                        </p:cTn>
+                                        <p:tgtEl>
+                                          <p:spTgt spid="1074"/>
+                                        </p:tgtEl>
+                                        <p:attrNameLst>
+                                          <p:attrName>style.visibility</p:attrName>
+                                        </p:attrNameLst>
+                                      </p:cBhvr>
+                                      <p:to>
+                                        <p:strVal val="visible"/>
+                                      </p:to>
+                                    </p:set>
+                                  </p:childTnLst>
+                                </p:cTn>
+                              </p:par>
+                              <p:par>
+                                <p:cTn id="123" presetID="1" presetClass="entr" presetSubtype="0" fill="hold" grpId="0" nodeType="withEffect" nodePh="1">
+                                  <p:stCondLst>
+                                    <p:cond delay="0"/>
+                                  </p:stCondLst>
+                                  <p:endCondLst>
+                                    <p:cond evt="begin" delay="0">
+                                      <p:tn val="123"/>
+                                    </p:cond>
+                                  </p:endCondLst>
+                                  <p:childTnLst>
+                                    <p:set>
+                                      <p:cBhvr>
+                                        <p:cTn id="124" dur="1" fill="hold">
+                                          <p:stCondLst>
+                                            <p:cond delay="0"/>
+                                          </p:stCondLst>
+                                        </p:cTn>
+                                        <p:tgtEl>
+                                          <p:spTgt spid="2097"/>
+                                        </p:tgtEl>
+                                        <p:attrNameLst>
+                                          <p:attrName>style.visibility</p:attrName>
+                                        </p:attrNameLst>
+                                      </p:cBhvr>
+                                      <p:to>
+                                        <p:strVal val="visible"/>
+                                      </p:to>
+                                    </p:set>
+                                  </p:childTnLst>
+                                </p:cTn>
+                              </p:par>
+                              <p:par>
+                                <p:cTn id="125" presetID="1" presetClass="entr" presetSubtype="0" fill="hold" grpId="0" nodeType="withEffect">
+                                  <p:stCondLst>
+                                    <p:cond delay="0"/>
+                                  </p:stCondLst>
+                                  <p:childTnLst>
+                                    <p:set>
+                                      <p:cBhvr>
+                                        <p:cTn id="126" dur="1" fill="hold">
+                                          <p:stCondLst>
+                                            <p:cond delay="0"/>
+                                          </p:stCondLst>
+                                        </p:cTn>
+                                        <p:tgtEl>
+                                          <p:spTgt spid="4"/>
+                                        </p:tgtEl>
+                                        <p:attrNameLst>
+                                          <p:attrName>style.visibility</p:attrName>
+                                        </p:attrNameLst>
+                                      </p:cBhvr>
+                                      <p:to>
+                                        <p:strVal val="visible"/>
+                                      </p:to>
+                                    </p:set>
+                                  </p:childTnLst>
+                                </p:cTn>
+                              </p:par>
+                              <p:par>
+                                <p:cTn id="127" presetID="1" presetClass="entr" presetSubtype="0" fill="hold" nodeType="withEffect">
+                                  <p:stCondLst>
+                                    <p:cond delay="0"/>
+                                  </p:stCondLst>
+                                  <p:childTnLst>
+                                    <p:set>
+                                      <p:cBhvr>
+                                        <p:cTn id="128" dur="1" fill="hold">
+                                          <p:stCondLst>
+                                            <p:cond delay="0"/>
+                                          </p:stCondLst>
+                                        </p:cTn>
+                                        <p:tgtEl>
+                                          <p:spTgt spid="21"/>
+                                        </p:tgtEl>
+                                        <p:attrNameLst>
+                                          <p:attrName>style.visibility</p:attrName>
+                                        </p:attrNameLst>
+                                      </p:cBhvr>
+                                      <p:to>
+                                        <p:strVal val="visible"/>
+                                      </p:to>
+                                    </p:set>
+                                  </p:childTnLst>
+                                </p:cTn>
+                              </p:par>
+                              <p:par>
+                                <p:cTn id="129" presetID="1" presetClass="entr" presetSubtype="0" fill="hold" grpId="0" nodeType="withEffect">
+                                  <p:stCondLst>
+                                    <p:cond delay="0"/>
+                                  </p:stCondLst>
+                                  <p:childTnLst>
+                                    <p:set>
+                                      <p:cBhvr>
+                                        <p:cTn id="130" dur="1" fill="hold">
+                                          <p:stCondLst>
+                                            <p:cond delay="0"/>
+                                          </p:stCondLst>
+                                        </p:cTn>
+                                        <p:tgtEl>
+                                          <p:spTgt spid="23"/>
+                                        </p:tgtEl>
+                                        <p:attrNameLst>
+                                          <p:attrName>style.visibility</p:attrName>
+                                        </p:attrNameLst>
+                                      </p:cBhvr>
+                                      <p:to>
+                                        <p:strVal val="visible"/>
+                                      </p:to>
+                                    </p:set>
+                                  </p:childTnLst>
+                                </p:cTn>
+                              </p:par>
+                              <p:par>
+                                <p:cTn id="131" presetID="1" presetClass="entr" presetSubtype="0" fill="hold" nodeType="withEffect">
+                                  <p:stCondLst>
+                                    <p:cond delay="0"/>
+                                  </p:stCondLst>
+                                  <p:childTnLst>
+                                    <p:set>
+                                      <p:cBhvr>
+                                        <p:cTn id="132" dur="1" fill="hold">
+                                          <p:stCondLst>
+                                            <p:cond delay="0"/>
+                                          </p:stCondLst>
+                                        </p:cTn>
+                                        <p:tgtEl>
+                                          <p:spTgt spid="78"/>
+                                        </p:tgtEl>
+                                        <p:attrNameLst>
+                                          <p:attrName>style.visibility</p:attrName>
+                                        </p:attrNameLst>
+                                      </p:cBhvr>
+                                      <p:to>
+                                        <p:strVal val="visible"/>
+                                      </p:to>
+                                    </p:set>
+                                  </p:childTnLst>
+                                </p:cTn>
+                              </p:par>
+                              <p:par>
+                                <p:cTn id="133" presetID="1" presetClass="entr" presetSubtype="0" fill="hold" grpId="0" nodeType="withEffect">
+                                  <p:stCondLst>
+                                    <p:cond delay="0"/>
+                                  </p:stCondLst>
+                                  <p:childTnLst>
+                                    <p:set>
+                                      <p:cBhvr>
+                                        <p:cTn id="134" dur="1" fill="hold">
+                                          <p:stCondLst>
+                                            <p:cond delay="0"/>
+                                          </p:stCondLst>
+                                        </p:cTn>
+                                        <p:tgtEl>
+                                          <p:spTgt spid="26"/>
+                                        </p:tgtEl>
+                                        <p:attrNameLst>
+                                          <p:attrName>style.visibility</p:attrName>
+                                        </p:attrNameLst>
+                                      </p:cBhvr>
+                                      <p:to>
+                                        <p:strVal val="visible"/>
+                                      </p:to>
+                                    </p:set>
+                                  </p:childTnLst>
+                                </p:cTn>
+                              </p:par>
+                              <p:par>
+                                <p:cTn id="135" presetID="1" presetClass="entr" presetSubtype="0" fill="hold" nodeType="withEffect">
+                                  <p:stCondLst>
+                                    <p:cond delay="0"/>
+                                  </p:stCondLst>
+                                  <p:childTnLst>
+                                    <p:set>
+                                      <p:cBhvr>
+                                        <p:cTn id="136" dur="1" fill="hold">
+                                          <p:stCondLst>
+                                            <p:cond delay="0"/>
+                                          </p:stCondLst>
+                                        </p:cTn>
+                                        <p:tgtEl>
+                                          <p:spTgt spid="1029"/>
+                                        </p:tgtEl>
+                                        <p:attrNameLst>
+                                          <p:attrName>style.visibility</p:attrName>
+                                        </p:attrNameLst>
+                                      </p:cBhvr>
+                                      <p:to>
+                                        <p:strVal val="visible"/>
+                                      </p:to>
+                                    </p:set>
+                                  </p:childTnLst>
+                                </p:cTn>
+                              </p:par>
+                              <p:par>
+                                <p:cTn id="137" presetID="1" presetClass="entr" presetSubtype="0" fill="hold" nodeType="withEffect">
+                                  <p:stCondLst>
+                                    <p:cond delay="0"/>
+                                  </p:stCondLst>
+                                  <p:childTnLst>
+                                    <p:set>
+                                      <p:cBhvr>
+                                        <p:cTn id="138" dur="1" fill="hold">
+                                          <p:stCondLst>
+                                            <p:cond delay="0"/>
+                                          </p:stCondLst>
+                                        </p:cTn>
+                                        <p:tgtEl>
+                                          <p:spTgt spid="1062"/>
+                                        </p:tgtEl>
+                                        <p:attrNameLst>
+                                          <p:attrName>style.visibility</p:attrName>
+                                        </p:attrNameLst>
+                                      </p:cBhvr>
+                                      <p:to>
+                                        <p:strVal val="visible"/>
+                                      </p:to>
+                                    </p:set>
+                                  </p:childTnLst>
+                                </p:cTn>
+                              </p:par>
+                            </p:childTnLst>
+                          </p:cTn>
+                        </p:par>
+                      </p:childTnLst>
+                    </p:cTn>
+                  </p:par>
+                  <p:par>
+                    <p:cTn id="139" fill="hold">
+                      <p:stCondLst>
+                        <p:cond delay="indefinite"/>
+                      </p:stCondLst>
+                      <p:childTnLst>
+                        <p:par>
+                          <p:cTn id="140" fill="hold">
+                            <p:stCondLst>
+                              <p:cond delay="0"/>
+                            </p:stCondLst>
+                            <p:childTnLst>
+                              <p:par>
+                                <p:cTn id="141" presetID="1" presetClass="entr" presetSubtype="0" fill="hold" nodeType="clickEffect">
+                                  <p:stCondLst>
+                                    <p:cond delay="0"/>
+                                  </p:stCondLst>
+                                  <p:childTnLst>
+                                    <p:set>
+                                      <p:cBhvr>
+                                        <p:cTn id="142" dur="1" fill="hold">
+                                          <p:stCondLst>
+                                            <p:cond delay="0"/>
+                                          </p:stCondLst>
+                                        </p:cTn>
+                                        <p:tgtEl>
+                                          <p:spTgt spid="1075"/>
+                                        </p:tgtEl>
+                                        <p:attrNameLst>
+                                          <p:attrName>style.visibility</p:attrName>
+                                        </p:attrNameLst>
+                                      </p:cBhvr>
+                                      <p:to>
+                                        <p:strVal val="visible"/>
+                                      </p:to>
+                                    </p:set>
+                                  </p:childTnLst>
+                                </p:cTn>
+                              </p:par>
+                            </p:childTnLst>
+                          </p:cTn>
+                        </p:par>
+                      </p:childTnLst>
+                    </p:cTn>
+                  </p:par>
+                  <p:par>
+                    <p:cTn id="143" fill="hold">
+                      <p:stCondLst>
+                        <p:cond delay="indefinite"/>
+                      </p:stCondLst>
+                      <p:childTnLst>
+                        <p:par>
+                          <p:cTn id="144" fill="hold">
+                            <p:stCondLst>
+                              <p:cond delay="0"/>
+                            </p:stCondLst>
+                            <p:childTnLst>
+                              <p:par>
+                                <p:cTn id="145" presetID="1" presetClass="entr" presetSubtype="0" fill="hold" nodeType="clickEffect">
+                                  <p:stCondLst>
+                                    <p:cond delay="0"/>
+                                  </p:stCondLst>
+                                  <p:childTnLst>
+                                    <p:set>
+                                      <p:cBhvr>
+                                        <p:cTn id="146" dur="1" fill="hold">
+                                          <p:stCondLst>
+                                            <p:cond delay="0"/>
+                                          </p:stCondLst>
+                                        </p:cTn>
+                                        <p:tgtEl>
+                                          <p:spTgt spid="2068"/>
+                                        </p:tgtEl>
+                                        <p:attrNameLst>
+                                          <p:attrName>style.visibility</p:attrName>
+                                        </p:attrNameLst>
+                                      </p:cBhvr>
+                                      <p:to>
+                                        <p:strVal val="visible"/>
+                                      </p:to>
+                                    </p:set>
+                                  </p:childTnLst>
+                                </p:cTn>
+                              </p:par>
+                              <p:par>
+                                <p:cTn id="147" presetID="1" presetClass="entr" presetSubtype="0" fill="hold" nodeType="withEffect">
+                                  <p:stCondLst>
+                                    <p:cond delay="0"/>
+                                  </p:stCondLst>
+                                  <p:childTnLst>
+                                    <p:set>
+                                      <p:cBhvr>
+                                        <p:cTn id="148" dur="1" fill="hold">
+                                          <p:stCondLst>
+                                            <p:cond delay="0"/>
+                                          </p:stCondLst>
+                                        </p:cTn>
+                                        <p:tgtEl>
+                                          <p:spTgt spid="2101"/>
+                                        </p:tgtEl>
+                                        <p:attrNameLst>
+                                          <p:attrName>style.visibility</p:attrName>
+                                        </p:attrNameLst>
+                                      </p:cBhvr>
+                                      <p:to>
+                                        <p:strVal val="visible"/>
+                                      </p:to>
+                                    </p:set>
+                                  </p:childTnLst>
+                                </p:cTn>
+                              </p:par>
+                            </p:childTnLst>
+                          </p:cTn>
+                        </p:par>
+                      </p:childTnLst>
+                    </p:cTn>
+                  </p:par>
+                </p:childTnLst>
+              </p:cTn>
+              <p:prevCondLst>
+                <p:cond evt="onPrev" delay="0">
+                  <p:tgtEl>
+                    <p:sldTgt/>
+                  </p:tgtEl>
+                </p:cond>
+              </p:prevCondLst>
+              <p:nextCondLst>
+                <p:cond evt="onNext" delay="0">
+                  <p:tgtEl>
+                    <p:sldTgt/>
+                  </p:tgtEl>
+                </p:cond>
+              </p:nextCondLst>
+            </p:seq>
+          </p:childTnLst>
+        </p:cTn>
+      </p:par>
+    </p:tnLst>
+    <p:bldLst>
+      <p:bldP spid="26" grpId="0" animBg="1"/>
+      <p:bldP spid="22" grpId="0" animBg="1"/>
+      <p:bldP spid="18" grpId="0" animBg="1"/>
+      <p:bldP spid="2" grpId="0" animBg="1"/>
+      <p:bldP spid="47" grpId="0" animBg="1"/>
+      <p:bldP spid="48" grpId="0"/>
+      <p:bldP spid="49" grpId="0" animBg="1"/>
+      <p:bldP spid="50" grpId="0"/>
+      <p:bldP spid="52" grpId="0" animBg="1"/>
+      <p:bldP spid="53" grpId="0" animBg="1"/>
+      <p:bldP spid="58" grpId="0"/>
+      <p:bldP spid="67" grpId="0"/>
+      <p:bldP spid="70" grpId="0"/>
+      <p:bldP spid="73" grpId="0"/>
+      <p:bldP spid="71" grpId="0" animBg="1"/>
+      <p:bldP spid="106" grpId="0" animBg="1"/>
+      <p:bldP spid="54" grpId="0" animBg="1"/>
+      <p:bldP spid="55" grpId="0"/>
+      <p:bldP spid="56" grpId="0" animBg="1"/>
+      <p:bldP spid="57" grpId="0"/>
+      <p:bldP spid="1074" grpId="0" animBg="1"/>
+      <p:bldP spid="2097" grpId="0"/>
+      <p:bldP spid="46" grpId="0" animBg="1"/>
+      <p:bldP spid="44" grpId="0"/>
+      <p:bldP spid="4" grpId="0" animBg="1"/>
+      <p:bldP spid="5" grpId="0" animBg="1"/>
+      <p:bldP spid="23" grpId="0" animBg="1"/>
+      <p:bldP spid="3" grpId="0" animBg="1"/>
+      <p:bldP spid="31" grpId="0"/>
+      <p:bldP spid="32" grpId="0"/>
+    </p:bldLst>
+  </p:timing>
 </p:sld>
 </file>
 
@@ -38763,43 +40750,6 @@
       </p:sp>
       <p:pic>
         <p:nvPicPr>
-          <p:cNvPr id="5" name="Image 4">
-            <a:extLst>
-              <a:ext uri="{FF2B5EF4-FFF2-40B4-BE49-F238E27FC236}">
-                <a16:creationId xmlns:a16="http://schemas.microsoft.com/office/drawing/2014/main" id="{937780E3-EE64-E9EA-5E8A-0FA88242AC93}"/>
-              </a:ext>
-            </a:extLst>
-          </p:cNvPr>
-          <p:cNvPicPr>
-            <a:picLocks noChangeAspect="1"/>
-          </p:cNvPicPr>
-          <p:nvPr/>
-        </p:nvPicPr>
-        <p:blipFill>
-          <a:blip r:embed="rId4"/>
-          <a:stretch>
-            <a:fillRect/>
-          </a:stretch>
-        </p:blipFill>
-        <p:spPr>
-          <a:xfrm>
-            <a:off x="376856" y="1116074"/>
-            <a:ext cx="4246784" cy="2926040"/>
-          </a:xfrm>
-          <a:prstGeom prst="rect">
-            <a:avLst/>
-          </a:prstGeom>
-          <a:ln>
-            <a:solidFill>
-              <a:schemeClr val="bg1">
-                <a:lumMod val="75000"/>
-              </a:schemeClr>
-            </a:solidFill>
-          </a:ln>
-        </p:spPr>
-      </p:pic>
-      <p:pic>
-        <p:nvPicPr>
           <p:cNvPr id="7" name="Image 6">
             <a:extLst>
               <a:ext uri="{FF2B5EF4-FFF2-40B4-BE49-F238E27FC236}">
@@ -38813,7 +40763,7 @@
           <p:nvPr/>
         </p:nvPicPr>
         <p:blipFill>
-          <a:blip r:embed="rId5"/>
+          <a:blip r:embed="rId4"/>
           <a:stretch>
             <a:fillRect/>
           </a:stretch>
@@ -38849,16 +40799,18 @@
         </p:nvSpPr>
         <p:spPr>
           <a:xfrm>
-            <a:off x="6754305" y="726955"/>
-            <a:ext cx="2020760" cy="307777"/>
+            <a:off x="6754305" y="698496"/>
+            <a:ext cx="2020760" cy="340519"/>
           </a:xfrm>
-          <a:prstGeom prst="rect">
+          <a:prstGeom prst="roundRect">
             <a:avLst/>
           </a:prstGeom>
-          <a:noFill/>
+          <a:solidFill>
+            <a:schemeClr val="bg1"/>
+          </a:solidFill>
           <a:ln>
             <a:solidFill>
-              <a:srgbClr val="FF0000"/>
+              <a:srgbClr val="C00000"/>
             </a:solidFill>
           </a:ln>
         </p:spPr>
@@ -38872,7 +40824,7 @@
             <a:r>
               <a:rPr lang="fr-FR" dirty="0">
                 <a:solidFill>
-                  <a:srgbClr val="FF0000"/>
+                  <a:srgbClr val="C00000"/>
                 </a:solidFill>
               </a:rPr>
               <a:t>MAE du modèle : 6,57</a:t>
@@ -39316,6 +41268,151 @@
           </a:p>
         </p:txBody>
       </p:sp>
+      <p:sp>
+        <p:nvSpPr>
+          <p:cNvPr id="3" name="Ellipse 2">
+            <a:extLst>
+              <a:ext uri="{FF2B5EF4-FFF2-40B4-BE49-F238E27FC236}">
+                <a16:creationId xmlns:a16="http://schemas.microsoft.com/office/drawing/2014/main" id="{E869AAB6-05E5-7ABD-6265-0FBFDCCB98A9}"/>
+              </a:ext>
+            </a:extLst>
+          </p:cNvPr>
+          <p:cNvSpPr/>
+          <p:nvPr/>
+        </p:nvSpPr>
+        <p:spPr>
+          <a:xfrm>
+            <a:off x="6608002" y="486574"/>
+            <a:ext cx="292605" cy="292605"/>
+          </a:xfrm>
+          <a:prstGeom prst="ellipse">
+            <a:avLst/>
+          </a:prstGeom>
+          <a:solidFill>
+            <a:schemeClr val="bg1"/>
+          </a:solidFill>
+          <a:ln>
+            <a:solidFill>
+              <a:srgbClr val="C00000"/>
+            </a:solidFill>
+          </a:ln>
+        </p:spPr>
+        <p:style>
+          <a:lnRef idx="2">
+            <a:schemeClr val="accent1">
+              <a:shade val="15000"/>
+            </a:schemeClr>
+          </a:lnRef>
+          <a:fillRef idx="1">
+            <a:schemeClr val="accent1"/>
+          </a:fillRef>
+          <a:effectRef idx="0">
+            <a:schemeClr val="accent1"/>
+          </a:effectRef>
+          <a:fontRef idx="minor">
+            <a:schemeClr val="lt1"/>
+          </a:fontRef>
+        </p:style>
+        <p:txBody>
+          <a:bodyPr rtlCol="0" anchor="ctr"/>
+          <a:lstStyle/>
+          <a:p>
+            <a:pPr algn="ctr"/>
+            <a:r>
+              <a:rPr lang="fr-FR" sz="1600" b="1" dirty="0">
+                <a:solidFill>
+                  <a:srgbClr val="C00000"/>
+                </a:solidFill>
+              </a:rPr>
+              <a:t>!</a:t>
+            </a:r>
+          </a:p>
+        </p:txBody>
+      </p:sp>
+      <p:sp>
+        <p:nvSpPr>
+          <p:cNvPr id="4" name="ZoneTexte 3">
+            <a:extLst>
+              <a:ext uri="{FF2B5EF4-FFF2-40B4-BE49-F238E27FC236}">
+                <a16:creationId xmlns:a16="http://schemas.microsoft.com/office/drawing/2014/main" id="{786453DB-D6FB-CB5F-9376-5629883FAC60}"/>
+              </a:ext>
+            </a:extLst>
+          </p:cNvPr>
+          <p:cNvSpPr txBox="1"/>
+          <p:nvPr/>
+        </p:nvSpPr>
+        <p:spPr>
+          <a:xfrm rot="1276305">
+            <a:off x="7445610" y="243080"/>
+            <a:ext cx="1220771" cy="307777"/>
+          </a:xfrm>
+          <a:prstGeom prst="rect">
+            <a:avLst/>
+          </a:prstGeom>
+          <a:solidFill>
+            <a:schemeClr val="bg1"/>
+          </a:solidFill>
+          <a:ln>
+            <a:solidFill>
+              <a:srgbClr val="FF0000"/>
+            </a:solidFill>
+          </a:ln>
+        </p:spPr>
+        <p:txBody>
+          <a:bodyPr wrap="square" rtlCol="0">
+            <a:spAutoFit/>
+          </a:bodyPr>
+          <a:lstStyle/>
+          <a:p>
+            <a:pPr algn="ctr"/>
+            <a:r>
+              <a:rPr lang="fr-FR" dirty="0">
+                <a:solidFill>
+                  <a:srgbClr val="FF0000"/>
+                </a:solidFill>
+              </a:rPr>
+              <a:t>Mettre à jour</a:t>
+            </a:r>
+          </a:p>
+        </p:txBody>
+      </p:sp>
+      <p:pic>
+        <p:nvPicPr>
+          <p:cNvPr id="13" name="Image 12" descr="Une image contenant texte, capture d’écran, affichage, nombre&#10;&#10;Le contenu généré par l’IA peut être incorrect.">
+            <a:extLst>
+              <a:ext uri="{FF2B5EF4-FFF2-40B4-BE49-F238E27FC236}">
+                <a16:creationId xmlns:a16="http://schemas.microsoft.com/office/drawing/2014/main" id="{7D6B0B43-8628-A21E-C82B-D058DBA5452A}"/>
+              </a:ext>
+            </a:extLst>
+          </p:cNvPr>
+          <p:cNvPicPr>
+            <a:picLocks noChangeAspect="1"/>
+          </p:cNvPicPr>
+          <p:nvPr/>
+        </p:nvPicPr>
+        <p:blipFill>
+          <a:blip r:embed="rId5"/>
+          <a:stretch>
+            <a:fillRect/>
+          </a:stretch>
+        </p:blipFill>
+        <p:spPr>
+          <a:xfrm>
+            <a:off x="365409" y="1109296"/>
+            <a:ext cx="4267865" cy="2932817"/>
+          </a:xfrm>
+          <a:prstGeom prst="rect">
+            <a:avLst/>
+          </a:prstGeom>
+          <a:ln>
+            <a:solidFill>
+              <a:schemeClr val="bg1">
+                <a:lumMod val="75000"/>
+              </a:schemeClr>
+            </a:solidFill>
+          </a:ln>
+        </p:spPr>
+      </p:pic>
     </p:spTree>
     <p:extLst>
       <p:ext uri="{BB962C8B-B14F-4D97-AF65-F5344CB8AC3E}">
@@ -39326,6 +41423,87 @@
   <p:clrMapOvr>
     <a:masterClrMapping/>
   </p:clrMapOvr>
+  <p:timing>
+    <p:tnLst>
+      <p:par>
+        <p:cTn id="1" dur="indefinite" restart="never" nodeType="tmRoot">
+          <p:childTnLst>
+            <p:seq concurrent="1" nextAc="seek">
+              <p:cTn id="2" dur="indefinite" nodeType="mainSeq">
+                <p:childTnLst>
+                  <p:par>
+                    <p:cTn id="3" fill="hold">
+                      <p:stCondLst>
+                        <p:cond delay="indefinite"/>
+                        <p:cond evt="onBegin" delay="0">
+                          <p:tn val="2"/>
+                        </p:cond>
+                      </p:stCondLst>
+                      <p:childTnLst>
+                        <p:par>
+                          <p:cTn id="4" fill="hold">
+                            <p:stCondLst>
+                              <p:cond delay="0"/>
+                            </p:stCondLst>
+                            <p:childTnLst>
+                              <p:par>
+                                <p:cTn id="5" presetID="1" presetClass="entr" presetSubtype="0" fill="hold" grpId="0" nodeType="withEffect">
+                                  <p:stCondLst>
+                                    <p:cond delay="0"/>
+                                  </p:stCondLst>
+                                  <p:childTnLst>
+                                    <p:set>
+                                      <p:cBhvr>
+                                        <p:cTn id="6" dur="1" fill="hold">
+                                          <p:stCondLst>
+                                            <p:cond delay="0"/>
+                                          </p:stCondLst>
+                                        </p:cTn>
+                                        <p:tgtEl>
+                                          <p:spTgt spid="3"/>
+                                        </p:tgtEl>
+                                        <p:attrNameLst>
+                                          <p:attrName>style.visibility</p:attrName>
+                                        </p:attrNameLst>
+                                      </p:cBhvr>
+                                      <p:to>
+                                        <p:strVal val="visible"/>
+                                      </p:to>
+                                    </p:set>
+                                  </p:childTnLst>
+                                </p:cTn>
+                              </p:par>
+                            </p:childTnLst>
+                          </p:cTn>
+                        </p:par>
+                      </p:childTnLst>
+                    </p:cTn>
+                  </p:par>
+                </p:childTnLst>
+              </p:cTn>
+              <p:prevCondLst>
+                <p:cond evt="onPrev" delay="0">
+                  <p:tgtEl>
+                    <p:sldTgt/>
+                  </p:tgtEl>
+                </p:cond>
+              </p:prevCondLst>
+              <p:nextCondLst>
+                <p:cond evt="onNext" delay="0">
+                  <p:tgtEl>
+                    <p:sldTgt/>
+                  </p:tgtEl>
+                </p:cond>
+              </p:nextCondLst>
+            </p:seq>
+          </p:childTnLst>
+        </p:cTn>
+      </p:par>
+    </p:tnLst>
+    <p:bldLst>
+      <p:bldP spid="3" grpId="0" animBg="1"/>
+    </p:bldLst>
+  </p:timing>
 </p:sld>
 </file>
 

</xml_diff>

<commit_message>
new graphs for presentation
</commit_message>
<xml_diff>
--- a/presentation/dsfs_ft_36_Projet_REnergies_efficiency_prediction.pptx
+++ b/presentation/dsfs_ft_36_Projet_REnergies_efficiency_prediction.pptx
@@ -18944,43 +18944,6 @@
           </a:p>
         </p:txBody>
       </p:sp>
-      <p:pic>
-        <p:nvPicPr>
-          <p:cNvPr id="13" name="Image 12">
-            <a:extLst>
-              <a:ext uri="{FF2B5EF4-FFF2-40B4-BE49-F238E27FC236}">
-                <a16:creationId xmlns:a16="http://schemas.microsoft.com/office/drawing/2014/main" id="{42BBF9A1-C47F-62DF-F307-88D7E8C42892}"/>
-              </a:ext>
-            </a:extLst>
-          </p:cNvPr>
-          <p:cNvPicPr>
-            <a:picLocks noChangeAspect="1"/>
-          </p:cNvPicPr>
-          <p:nvPr/>
-        </p:nvPicPr>
-        <p:blipFill>
-          <a:blip r:embed="rId4"/>
-          <a:stretch>
-            <a:fillRect/>
-          </a:stretch>
-        </p:blipFill>
-        <p:spPr>
-          <a:xfrm>
-            <a:off x="463375" y="1335349"/>
-            <a:ext cx="4139602" cy="2563231"/>
-          </a:xfrm>
-          <a:prstGeom prst="rect">
-            <a:avLst/>
-          </a:prstGeom>
-          <a:ln>
-            <a:solidFill>
-              <a:schemeClr val="bg1">
-                <a:lumMod val="75000"/>
-              </a:schemeClr>
-            </a:solidFill>
-          </a:ln>
-        </p:spPr>
-      </p:pic>
       <p:sp>
         <p:nvSpPr>
           <p:cNvPr id="15" name="Google Shape;69;p3">
@@ -19560,7 +19523,7 @@
           <p:nvPr/>
         </p:nvPicPr>
         <p:blipFill>
-          <a:blip r:embed="rId5"/>
+          <a:blip r:embed="rId4"/>
           <a:srcRect t="5437" b="3975"/>
           <a:stretch>
             <a:fillRect/>
@@ -19568,8 +19531,45 @@
         </p:blipFill>
         <p:spPr>
           <a:xfrm>
-            <a:off x="5016923" y="1335350"/>
-            <a:ext cx="3770637" cy="2561800"/>
+            <a:off x="5131783" y="1335349"/>
+            <a:ext cx="3709114" cy="2520000"/>
+          </a:xfrm>
+          <a:prstGeom prst="rect">
+            <a:avLst/>
+          </a:prstGeom>
+          <a:ln>
+            <a:solidFill>
+              <a:schemeClr val="bg1">
+                <a:lumMod val="75000"/>
+              </a:schemeClr>
+            </a:solidFill>
+          </a:ln>
+        </p:spPr>
+      </p:pic>
+      <p:pic>
+        <p:nvPicPr>
+          <p:cNvPr id="26" name="Image 25">
+            <a:extLst>
+              <a:ext uri="{FF2B5EF4-FFF2-40B4-BE49-F238E27FC236}">
+                <a16:creationId xmlns:a16="http://schemas.microsoft.com/office/drawing/2014/main" id="{3B7D5584-7363-72AF-3C4F-E64B8D6461F7}"/>
+              </a:ext>
+            </a:extLst>
+          </p:cNvPr>
+          <p:cNvPicPr>
+            <a:picLocks noChangeAspect="1"/>
+          </p:cNvPicPr>
+          <p:nvPr/>
+        </p:nvPicPr>
+        <p:blipFill>
+          <a:blip r:embed="rId5"/>
+          <a:stretch>
+            <a:fillRect/>
+          </a:stretch>
+        </p:blipFill>
+        <p:spPr>
+          <a:xfrm>
+            <a:off x="690620" y="1335349"/>
+            <a:ext cx="4199999" cy="2520000"/>
           </a:xfrm>
           <a:prstGeom prst="rect">
             <a:avLst/>
@@ -42036,19 +42036,11 @@
             </a:r>
             <a:r>
               <a:rPr lang="fr-FR" sz="900" b="1" dirty="0"/>
-              <a:t>10.7 cm </a:t>
+              <a:t>10.7 cm</a:t>
             </a:r>
             <a:r>
               <a:rPr lang="fr-FR" sz="900" dirty="0"/>
-              <a:t>(cf. 10cm dans le </a:t>
-            </a:r>
-            <a:r>
-              <a:rPr lang="fr-FR" sz="900" dirty="0" err="1"/>
-              <a:t>Dataset</a:t>
-            </a:r>
-            <a:r>
-              <a:rPr lang="fr-FR" sz="900" dirty="0"/>
-              <a:t>) est </a:t>
+              <a:t> est </a:t>
             </a:r>
             <a:r>
               <a:rPr lang="fr-FR" sz="900" b="1" dirty="0"/>
@@ -42140,10 +42132,10 @@
       </p:sp>
       <p:pic>
         <p:nvPicPr>
-          <p:cNvPr id="13" name="Image 12" descr="Une image contenant texte, capture d’écran, affichage, nombre&#10;&#10;Le contenu généré par l’IA peut être incorrect.">
+          <p:cNvPr id="7" name="Image 6" descr="Une image contenant texte, diagramme, Tracé, capture d’écran">
             <a:extLst>
               <a:ext uri="{FF2B5EF4-FFF2-40B4-BE49-F238E27FC236}">
-                <a16:creationId xmlns:a16="http://schemas.microsoft.com/office/drawing/2014/main" id="{7D6B0B43-8628-A21E-C82B-D058DBA5452A}"/>
+                <a16:creationId xmlns:a16="http://schemas.microsoft.com/office/drawing/2014/main" id="{D843FCAE-84D8-B3E1-4B7A-0383F76C878B}"/>
               </a:ext>
             </a:extLst>
           </p:cNvPr>
@@ -42160,8 +42152,8 @@
         </p:blipFill>
         <p:spPr>
           <a:xfrm>
-            <a:off x="256566" y="1149395"/>
-            <a:ext cx="4174031" cy="2868336"/>
+            <a:off x="4922672" y="1155049"/>
+            <a:ext cx="3595361" cy="2862681"/>
           </a:xfrm>
           <a:prstGeom prst="rect">
             <a:avLst/>
@@ -42177,10 +42169,10 @@
       </p:pic>
       <p:pic>
         <p:nvPicPr>
-          <p:cNvPr id="7" name="Image 6" descr="Une image contenant texte, diagramme, Tracé, capture d’écran">
+          <p:cNvPr id="4" name="Image 3">
             <a:extLst>
               <a:ext uri="{FF2B5EF4-FFF2-40B4-BE49-F238E27FC236}">
-                <a16:creationId xmlns:a16="http://schemas.microsoft.com/office/drawing/2014/main" id="{D843FCAE-84D8-B3E1-4B7A-0383F76C878B}"/>
+                <a16:creationId xmlns:a16="http://schemas.microsoft.com/office/drawing/2014/main" id="{0057AF76-0C79-E1FE-94F2-038DE6A4D033}"/>
               </a:ext>
             </a:extLst>
           </p:cNvPr>
@@ -42197,8 +42189,8 @@
         </p:blipFill>
         <p:spPr>
           <a:xfrm>
-            <a:off x="4922672" y="1155049"/>
-            <a:ext cx="3595361" cy="2862681"/>
+            <a:off x="268239" y="1134334"/>
+            <a:ext cx="4193746" cy="2881883"/>
           </a:xfrm>
           <a:prstGeom prst="rect">
             <a:avLst/>

</xml_diff>

<commit_message>
maj suivi et modifications présentation
</commit_message>
<xml_diff>
--- a/presentation/dsfs_ft_36_Projet_REnergies_efficiency_prediction.pptx
+++ b/presentation/dsfs_ft_36_Projet_REnergies_efficiency_prediction.pptx
@@ -293,7 +293,7 @@
 <file path=ppt/revisionInfo.xml><?xml version="1.0" encoding="utf-8"?>
 <p1510:revInfo xmlns:a="http://schemas.openxmlformats.org/drawingml/2006/main" xmlns:r="http://schemas.openxmlformats.org/officeDocument/2006/relationships" xmlns:p1510="http://schemas.microsoft.com/office/powerpoint/2015/10/main">
   <p1510:revLst>
-    <p1510:client id="{2EB72A00-7F79-4813-B4C2-C6564860F3F6}" v="2869" dt="2025-11-24T15:49:49.333"/>
+    <p1510:client id="{2EB72A00-7F79-4813-B4C2-C6564860F3F6}" v="2871" dt="2025-11-25T08:16:16.131"/>
   </p1510:revLst>
 </p1510:revInfo>
 </file>
@@ -303,7 +303,7 @@
   <pc:docChgLst>
     <pc:chgData name="Jean-Yves Vuillequez" userId="e7fac481abea6bd0" providerId="LiveId" clId="{79E365E8-22BC-4EC2-9606-9A9AC6CD1D22}"/>
     <pc:docChg chg="undo custSel addSld delSld modSld sldOrd">
-      <pc:chgData name="Jean-Yves Vuillequez" userId="e7fac481abea6bd0" providerId="LiveId" clId="{79E365E8-22BC-4EC2-9606-9A9AC6CD1D22}" dt="2025-11-24T15:49:49.330" v="9475" actId="113"/>
+      <pc:chgData name="Jean-Yves Vuillequez" userId="e7fac481abea6bd0" providerId="LiveId" clId="{79E365E8-22BC-4EC2-9606-9A9AC6CD1D22}" dt="2025-11-25T08:11:49.893" v="9528" actId="1076"/>
       <pc:docMkLst>
         <pc:docMk/>
       </pc:docMkLst>
@@ -599,12 +599,44 @@
           </ac:cxnSpMkLst>
         </pc:cxnChg>
       </pc:sldChg>
-      <pc:sldChg chg="ord">
-        <pc:chgData name="Jean-Yves Vuillequez" userId="e7fac481abea6bd0" providerId="LiveId" clId="{79E365E8-22BC-4EC2-9606-9A9AC6CD1D22}" dt="2025-11-21T15:39:23.675" v="7162"/>
+      <pc:sldChg chg="addSp delSp modSp mod ord">
+        <pc:chgData name="Jean-Yves Vuillequez" userId="e7fac481abea6bd0" providerId="LiveId" clId="{79E365E8-22BC-4EC2-9606-9A9AC6CD1D22}" dt="2025-11-25T08:11:49.893" v="9528" actId="1076"/>
         <pc:sldMkLst>
           <pc:docMk/>
           <pc:sldMk cId="0" sldId="271"/>
         </pc:sldMkLst>
+        <pc:spChg chg="add mod">
+          <ac:chgData name="Jean-Yves Vuillequez" userId="e7fac481abea6bd0" providerId="LiveId" clId="{79E365E8-22BC-4EC2-9606-9A9AC6CD1D22}" dt="2025-11-25T08:11:49.893" v="9528" actId="1076"/>
+          <ac:spMkLst>
+            <pc:docMk/>
+            <pc:sldMk cId="0" sldId="271"/>
+            <ac:spMk id="2" creationId="{85EE54CA-1CA7-BBB2-C3CA-7AD11745D0CB}"/>
+          </ac:spMkLst>
+        </pc:spChg>
+        <pc:spChg chg="add mod">
+          <ac:chgData name="Jean-Yves Vuillequez" userId="e7fac481abea6bd0" providerId="LiveId" clId="{79E365E8-22BC-4EC2-9606-9A9AC6CD1D22}" dt="2025-11-25T08:11:49.893" v="9528" actId="1076"/>
+          <ac:spMkLst>
+            <pc:docMk/>
+            <pc:sldMk cId="0" sldId="271"/>
+            <ac:spMk id="3" creationId="{3A33F078-F242-EE97-2251-526C53A316B8}"/>
+          </ac:spMkLst>
+        </pc:spChg>
+        <pc:picChg chg="add del">
+          <ac:chgData name="Jean-Yves Vuillequez" userId="e7fac481abea6bd0" providerId="LiveId" clId="{79E365E8-22BC-4EC2-9606-9A9AC6CD1D22}" dt="2025-11-25T08:11:41.798" v="9527" actId="478"/>
+          <ac:picMkLst>
+            <pc:docMk/>
+            <pc:sldMk cId="0" sldId="271"/>
+            <ac:picMk id="188" creationId="{00000000-0000-0000-0000-000000000000}"/>
+          </ac:picMkLst>
+        </pc:picChg>
+        <pc:cxnChg chg="add mod">
+          <ac:chgData name="Jean-Yves Vuillequez" userId="e7fac481abea6bd0" providerId="LiveId" clId="{79E365E8-22BC-4EC2-9606-9A9AC6CD1D22}" dt="2025-11-25T08:11:49.893" v="9528" actId="1076"/>
+          <ac:cxnSpMkLst>
+            <pc:docMk/>
+            <pc:sldMk cId="0" sldId="271"/>
+            <ac:cxnSpMk id="4" creationId="{E56D7E92-4368-94BE-9AB2-02EC3C191FD2}"/>
+          </ac:cxnSpMkLst>
+        </pc:cxnChg>
       </pc:sldChg>
       <pc:sldChg chg="modSp add del mod">
         <pc:chgData name="Jean-Yves Vuillequez" userId="e7fac481abea6bd0" providerId="LiveId" clId="{79E365E8-22BC-4EC2-9606-9A9AC6CD1D22}" dt="2025-11-19T14:03:57.617" v="139" actId="20577"/>
@@ -21447,6 +21479,143 @@
           </a:ln>
         </p:spPr>
       </p:pic>
+      <p:sp>
+        <p:nvSpPr>
+          <p:cNvPr id="2" name="Rectangle : coins arrondis 1">
+            <a:extLst>
+              <a:ext uri="{FF2B5EF4-FFF2-40B4-BE49-F238E27FC236}">
+                <a16:creationId xmlns:a16="http://schemas.microsoft.com/office/drawing/2014/main" id="{85EE54CA-1CA7-BBB2-C3CA-7AD11745D0CB}"/>
+              </a:ext>
+            </a:extLst>
+          </p:cNvPr>
+          <p:cNvSpPr/>
+          <p:nvPr/>
+        </p:nvSpPr>
+        <p:spPr>
+          <a:xfrm>
+            <a:off x="1799442" y="3006625"/>
+            <a:ext cx="1485799" cy="545226"/>
+          </a:xfrm>
+          <a:prstGeom prst="roundRect">
+            <a:avLst/>
+          </a:prstGeom>
+          <a:solidFill>
+            <a:schemeClr val="bg1">
+              <a:lumMod val="95000"/>
+            </a:schemeClr>
+          </a:solidFill>
+          <a:ln>
+            <a:noFill/>
+          </a:ln>
+        </p:spPr>
+        <p:style>
+          <a:lnRef idx="2">
+            <a:schemeClr val="accent1">
+              <a:shade val="15000"/>
+            </a:schemeClr>
+          </a:lnRef>
+          <a:fillRef idx="1">
+            <a:schemeClr val="accent1"/>
+          </a:fillRef>
+          <a:effectRef idx="0">
+            <a:schemeClr val="accent1"/>
+          </a:effectRef>
+          <a:fontRef idx="minor">
+            <a:schemeClr val="lt1"/>
+          </a:fontRef>
+        </p:style>
+        <p:txBody>
+          <a:bodyPr rtlCol="0" anchor="ctr"/>
+          <a:lstStyle/>
+          <a:p>
+            <a:pPr algn="ctr"/>
+            <a:endParaRPr lang="fr-FR"/>
+          </a:p>
+        </p:txBody>
+      </p:sp>
+      <p:sp>
+        <p:nvSpPr>
+          <p:cNvPr id="3" name="ZoneTexte 2">
+            <a:extLst>
+              <a:ext uri="{FF2B5EF4-FFF2-40B4-BE49-F238E27FC236}">
+                <a16:creationId xmlns:a16="http://schemas.microsoft.com/office/drawing/2014/main" id="{3A33F078-F242-EE97-2251-526C53A316B8}"/>
+              </a:ext>
+            </a:extLst>
+          </p:cNvPr>
+          <p:cNvSpPr txBox="1"/>
+          <p:nvPr/>
+        </p:nvSpPr>
+        <p:spPr>
+          <a:xfrm>
+            <a:off x="1799442" y="3079183"/>
+            <a:ext cx="1485799" cy="400110"/>
+          </a:xfrm>
+          <a:prstGeom prst="rect">
+            <a:avLst/>
+          </a:prstGeom>
+          <a:noFill/>
+        </p:spPr>
+        <p:txBody>
+          <a:bodyPr wrap="square" rtlCol="0">
+            <a:spAutoFit/>
+          </a:bodyPr>
+          <a:lstStyle/>
+          <a:p>
+            <a:pPr algn="ctr"/>
+            <a:r>
+              <a:rPr lang="fr-FR" sz="1000" dirty="0">
+                <a:hlinkClick r:id="rId5" action="ppaction://hlinksldjump"/>
+              </a:rPr>
+              <a:t>Ressources projet en annexes</a:t>
+            </a:r>
+            <a:endParaRPr lang="fr-FR" sz="800" dirty="0"/>
+          </a:p>
+        </p:txBody>
+      </p:sp>
+      <p:cxnSp>
+        <p:nvCxnSpPr>
+          <p:cNvPr id="4" name="Connecteur droit avec flèche 3">
+            <a:extLst>
+              <a:ext uri="{FF2B5EF4-FFF2-40B4-BE49-F238E27FC236}">
+                <a16:creationId xmlns:a16="http://schemas.microsoft.com/office/drawing/2014/main" id="{E56D7E92-4368-94BE-9AB2-02EC3C191FD2}"/>
+              </a:ext>
+            </a:extLst>
+          </p:cNvPr>
+          <p:cNvCxnSpPr>
+            <a:cxnSpLocks/>
+          </p:cNvCxnSpPr>
+          <p:nvPr/>
+        </p:nvCxnSpPr>
+        <p:spPr>
+          <a:xfrm>
+            <a:off x="1200757" y="3279238"/>
+            <a:ext cx="569861" cy="0"/>
+          </a:xfrm>
+          <a:prstGeom prst="straightConnector1">
+            <a:avLst/>
+          </a:prstGeom>
+          <a:ln w="76200">
+            <a:solidFill>
+              <a:srgbClr val="FFC000"/>
+            </a:solidFill>
+            <a:tailEnd type="triangle"/>
+          </a:ln>
+        </p:spPr>
+        <p:style>
+          <a:lnRef idx="1">
+            <a:schemeClr val="accent1"/>
+          </a:lnRef>
+          <a:fillRef idx="0">
+            <a:schemeClr val="accent1"/>
+          </a:fillRef>
+          <a:effectRef idx="0">
+            <a:schemeClr val="accent1"/>
+          </a:effectRef>
+          <a:fontRef idx="minor">
+            <a:schemeClr val="tx1"/>
+          </a:fontRef>
+        </p:style>
+      </p:cxnSp>
     </p:spTree>
   </p:cSld>
   <p:clrMapOvr>

</xml_diff>

<commit_message>
maj présentation - intégration modèle
</commit_message>
<xml_diff>
--- a/presentation/dsfs_ft_36_Projet_REnergies_efficiency_prediction.pptx
+++ b/presentation/dsfs_ft_36_Projet_REnergies_efficiency_prediction.pptx
@@ -23,10 +23,10 @@
     <p:sldId id="292" r:id="rId14"/>
     <p:sldId id="271" r:id="rId15"/>
     <p:sldId id="273" r:id="rId16"/>
-    <p:sldId id="275" r:id="rId17"/>
-    <p:sldId id="294" r:id="rId18"/>
-    <p:sldId id="295" r:id="rId19"/>
-    <p:sldId id="296" r:id="rId20"/>
+    <p:sldId id="295" r:id="rId17"/>
+    <p:sldId id="296" r:id="rId18"/>
+    <p:sldId id="275" r:id="rId19"/>
+    <p:sldId id="294" r:id="rId20"/>
   </p:sldIdLst>
   <p:sldSz cx="9144000" cy="5143500" type="screen16x9"/>
   <p:notesSz cx="6858000" cy="9144000"/>
@@ -293,7 +293,7 @@
 <file path=ppt/revisionInfo.xml><?xml version="1.0" encoding="utf-8"?>
 <p1510:revInfo xmlns:a="http://schemas.openxmlformats.org/drawingml/2006/main" xmlns:r="http://schemas.openxmlformats.org/officeDocument/2006/relationships" xmlns:p1510="http://schemas.microsoft.com/office/powerpoint/2015/10/main">
   <p1510:revLst>
-    <p1510:client id="{2EB72A00-7F79-4813-B4C2-C6564860F3F6}" v="2871" dt="2025-11-25T08:16:16.131"/>
+    <p1510:client id="{2EB72A00-7F79-4813-B4C2-C6564860F3F6}" v="2872" dt="2025-11-25T08:53:15.397"/>
   </p1510:revLst>
 </p1510:revInfo>
 </file>
@@ -303,7 +303,7 @@
   <pc:docChgLst>
     <pc:chgData name="Jean-Yves Vuillequez" userId="e7fac481abea6bd0" providerId="LiveId" clId="{79E365E8-22BC-4EC2-9606-9A9AC6CD1D22}"/>
     <pc:docChg chg="undo custSel addSld delSld modSld sldOrd">
-      <pc:chgData name="Jean-Yves Vuillequez" userId="e7fac481abea6bd0" providerId="LiveId" clId="{79E365E8-22BC-4EC2-9606-9A9AC6CD1D22}" dt="2025-11-25T08:11:49.893" v="9528" actId="1076"/>
+      <pc:chgData name="Jean-Yves Vuillequez" userId="e7fac481abea6bd0" providerId="LiveId" clId="{79E365E8-22BC-4EC2-9606-9A9AC6CD1D22}" dt="2025-11-25T08:54:23.746" v="9534"/>
       <pc:docMkLst>
         <pc:docMk/>
       </pc:docMkLst>
@@ -600,13 +600,13 @@
         </pc:cxnChg>
       </pc:sldChg>
       <pc:sldChg chg="addSp delSp modSp mod ord">
-        <pc:chgData name="Jean-Yves Vuillequez" userId="e7fac481abea6bd0" providerId="LiveId" clId="{79E365E8-22BC-4EC2-9606-9A9AC6CD1D22}" dt="2025-11-25T08:11:49.893" v="9528" actId="1076"/>
+        <pc:chgData name="Jean-Yves Vuillequez" userId="e7fac481abea6bd0" providerId="LiveId" clId="{79E365E8-22BC-4EC2-9606-9A9AC6CD1D22}" dt="2025-11-25T08:54:11.101" v="9532" actId="208"/>
         <pc:sldMkLst>
           <pc:docMk/>
           <pc:sldMk cId="0" sldId="271"/>
         </pc:sldMkLst>
         <pc:spChg chg="add mod">
-          <ac:chgData name="Jean-Yves Vuillequez" userId="e7fac481abea6bd0" providerId="LiveId" clId="{79E365E8-22BC-4EC2-9606-9A9AC6CD1D22}" dt="2025-11-25T08:11:49.893" v="9528" actId="1076"/>
+          <ac:chgData name="Jean-Yves Vuillequez" userId="e7fac481abea6bd0" providerId="LiveId" clId="{79E365E8-22BC-4EC2-9606-9A9AC6CD1D22}" dt="2025-11-25T08:54:04.024" v="9531" actId="1076"/>
           <ac:spMkLst>
             <pc:docMk/>
             <pc:sldMk cId="0" sldId="271"/>
@@ -614,7 +614,7 @@
           </ac:spMkLst>
         </pc:spChg>
         <pc:spChg chg="add mod">
-          <ac:chgData name="Jean-Yves Vuillequez" userId="e7fac481abea6bd0" providerId="LiveId" clId="{79E365E8-22BC-4EC2-9606-9A9AC6CD1D22}" dt="2025-11-25T08:11:49.893" v="9528" actId="1076"/>
+          <ac:chgData name="Jean-Yves Vuillequez" userId="e7fac481abea6bd0" providerId="LiveId" clId="{79E365E8-22BC-4EC2-9606-9A9AC6CD1D22}" dt="2025-11-25T08:54:04.024" v="9531" actId="1076"/>
           <ac:spMkLst>
             <pc:docMk/>
             <pc:sldMk cId="0" sldId="271"/>
@@ -630,7 +630,7 @@
           </ac:picMkLst>
         </pc:picChg>
         <pc:cxnChg chg="add mod">
-          <ac:chgData name="Jean-Yves Vuillequez" userId="e7fac481abea6bd0" providerId="LiveId" clId="{79E365E8-22BC-4EC2-9606-9A9AC6CD1D22}" dt="2025-11-25T08:11:49.893" v="9528" actId="1076"/>
+          <ac:chgData name="Jean-Yves Vuillequez" userId="e7fac481abea6bd0" providerId="LiveId" clId="{79E365E8-22BC-4EC2-9606-9A9AC6CD1D22}" dt="2025-11-25T08:54:11.101" v="9532" actId="208"/>
           <ac:cxnSpMkLst>
             <pc:docMk/>
             <pc:sldMk cId="0" sldId="271"/>
@@ -1873,7 +1873,7 @@
         </pc:picChg>
       </pc:sldChg>
       <pc:sldChg chg="addSp delSp modSp add mod modNotesTx">
-        <pc:chgData name="Jean-Yves Vuillequez" userId="e7fac481abea6bd0" providerId="LiveId" clId="{79E365E8-22BC-4EC2-9606-9A9AC6CD1D22}" dt="2025-11-24T14:57:45.264" v="9201" actId="113"/>
+        <pc:chgData name="Jean-Yves Vuillequez" userId="e7fac481abea6bd0" providerId="LiveId" clId="{79E365E8-22BC-4EC2-9606-9A9AC6CD1D22}" dt="2025-11-25T08:53:15.397" v="9530"/>
         <pc:sldMkLst>
           <pc:docMk/>
           <pc:sldMk cId="3332770" sldId="291"/>
@@ -1958,6 +1958,22 @@
             <ac:spMk id="178" creationId="{1DE246AA-5B17-33A5-5EF2-125E8EA81EFC}"/>
           </ac:spMkLst>
         </pc:spChg>
+        <pc:picChg chg="add mod">
+          <ac:chgData name="Jean-Yves Vuillequez" userId="e7fac481abea6bd0" providerId="LiveId" clId="{79E365E8-22BC-4EC2-9606-9A9AC6CD1D22}" dt="2025-11-25T08:53:15.397" v="9530"/>
+          <ac:picMkLst>
+            <pc:docMk/>
+            <pc:sldMk cId="3332770" sldId="291"/>
+            <ac:picMk id="2" creationId="{BFC65734-9253-849D-5A6F-F7D5EA9D0712}"/>
+          </ac:picMkLst>
+        </pc:picChg>
+        <pc:picChg chg="add mod">
+          <ac:chgData name="Jean-Yves Vuillequez" userId="e7fac481abea6bd0" providerId="LiveId" clId="{79E365E8-22BC-4EC2-9606-9A9AC6CD1D22}" dt="2025-11-25T08:53:15.397" v="9530"/>
+          <ac:picMkLst>
+            <pc:docMk/>
+            <pc:sldMk cId="3332770" sldId="291"/>
+            <ac:picMk id="3" creationId="{F42D4AB1-28C7-BB89-AEEE-DABEB2514D1E}"/>
+          </ac:picMkLst>
+        </pc:picChg>
         <pc:picChg chg="add del mod">
           <ac:chgData name="Jean-Yves Vuillequez" userId="e7fac481abea6bd0" providerId="LiveId" clId="{79E365E8-22BC-4EC2-9606-9A9AC6CD1D22}" dt="2025-11-24T13:08:48.053" v="8345" actId="21"/>
           <ac:picMkLst>
@@ -2006,8 +2022,8 @@
             <ac:picMk id="11" creationId="{6B0F1A83-2432-176C-4AA5-8DD51C43E45F}"/>
           </ac:picMkLst>
         </pc:picChg>
-        <pc:picChg chg="add mod">
-          <ac:chgData name="Jean-Yves Vuillequez" userId="e7fac481abea6bd0" providerId="LiveId" clId="{79E365E8-22BC-4EC2-9606-9A9AC6CD1D22}" dt="2025-11-24T14:25:33.099" v="9096" actId="1076"/>
+        <pc:picChg chg="add del mod">
+          <ac:chgData name="Jean-Yves Vuillequez" userId="e7fac481abea6bd0" providerId="LiveId" clId="{79E365E8-22BC-4EC2-9606-9A9AC6CD1D22}" dt="2025-11-25T08:53:14.980" v="9529" actId="478"/>
           <ac:picMkLst>
             <pc:docMk/>
             <pc:sldMk cId="3332770" sldId="291"/>
@@ -2022,8 +2038,8 @@
             <ac:picMk id="19" creationId="{251AEA8F-A473-62AD-0FE9-02E7F916FB2E}"/>
           </ac:picMkLst>
         </pc:picChg>
-        <pc:picChg chg="add mod modCrop">
-          <ac:chgData name="Jean-Yves Vuillequez" userId="e7fac481abea6bd0" providerId="LiveId" clId="{79E365E8-22BC-4EC2-9606-9A9AC6CD1D22}" dt="2025-11-24T14:25:55.763" v="9101" actId="14100"/>
+        <pc:picChg chg="add del mod modCrop">
+          <ac:chgData name="Jean-Yves Vuillequez" userId="e7fac481abea6bd0" providerId="LiveId" clId="{79E365E8-22BC-4EC2-9606-9A9AC6CD1D22}" dt="2025-11-25T08:53:14.980" v="9529" actId="478"/>
           <ac:picMkLst>
             <pc:docMk/>
             <pc:sldMk cId="3332770" sldId="291"/>
@@ -2220,8 +2236,8 @@
           </ac:graphicFrameMkLst>
         </pc:graphicFrameChg>
       </pc:sldChg>
-      <pc:sldChg chg="addSp delSp modSp add mod">
-        <pc:chgData name="Jean-Yves Vuillequez" userId="e7fac481abea6bd0" providerId="LiveId" clId="{79E365E8-22BC-4EC2-9606-9A9AC6CD1D22}" dt="2025-11-24T15:29:09.327" v="9309" actId="20577"/>
+      <pc:sldChg chg="addSp delSp modSp add mod ord">
+        <pc:chgData name="Jean-Yves Vuillequez" userId="e7fac481abea6bd0" providerId="LiveId" clId="{79E365E8-22BC-4EC2-9606-9A9AC6CD1D22}" dt="2025-11-25T08:54:23.746" v="9534"/>
         <pc:sldMkLst>
           <pc:docMk/>
           <pc:sldMk cId="2817282669" sldId="295"/>
@@ -2251,8 +2267,8 @@
           </ac:graphicFrameMkLst>
         </pc:graphicFrameChg>
       </pc:sldChg>
-      <pc:sldChg chg="addSp delSp modSp add mod">
-        <pc:chgData name="Jean-Yves Vuillequez" userId="e7fac481abea6bd0" providerId="LiveId" clId="{79E365E8-22BC-4EC2-9606-9A9AC6CD1D22}" dt="2025-11-24T15:44:59.685" v="9438" actId="20577"/>
+      <pc:sldChg chg="addSp delSp modSp add mod ord">
+        <pc:chgData name="Jean-Yves Vuillequez" userId="e7fac481abea6bd0" providerId="LiveId" clId="{79E365E8-22BC-4EC2-9606-9A9AC6CD1D22}" dt="2025-11-25T08:54:23.746" v="9534"/>
         <pc:sldMkLst>
           <pc:docMk/>
           <pc:sldMk cId="2552402859" sldId="296"/>
@@ -3756,6 +3772,296 @@
         <p:cNvPr id="1" name="Shape 92">
           <a:extLst>
             <a:ext uri="{FF2B5EF4-FFF2-40B4-BE49-F238E27FC236}">
+              <a16:creationId xmlns:a16="http://schemas.microsoft.com/office/drawing/2014/main" id="{87D078D1-2A3F-0DA7-5A85-C8E1BAE85CC6}"/>
+            </a:ext>
+          </a:extLst>
+        </p:cNvPr>
+        <p:cNvGrpSpPr/>
+        <p:nvPr/>
+      </p:nvGrpSpPr>
+      <p:grpSpPr>
+        <a:xfrm>
+          <a:off x="0" y="0"/>
+          <a:ext cx="0" cy="0"/>
+          <a:chOff x="0" y="0"/>
+          <a:chExt cx="0" cy="0"/>
+        </a:xfrm>
+      </p:grpSpPr>
+      <p:sp>
+        <p:nvSpPr>
+          <p:cNvPr id="93" name="Google Shape;93;p5:notes">
+            <a:extLst>
+              <a:ext uri="{FF2B5EF4-FFF2-40B4-BE49-F238E27FC236}">
+                <a16:creationId xmlns:a16="http://schemas.microsoft.com/office/drawing/2014/main" id="{6C127E2B-7A52-00DD-B688-335EB1E07C31}"/>
+              </a:ext>
+            </a:extLst>
+          </p:cNvPr>
+          <p:cNvSpPr>
+            <a:spLocks noGrp="1" noRot="1" noChangeAspect="1"/>
+          </p:cNvSpPr>
+          <p:nvPr>
+            <p:ph type="sldImg" idx="2"/>
+          </p:nvPr>
+        </p:nvSpPr>
+        <p:spPr>
+          <a:xfrm>
+            <a:off x="381000" y="685800"/>
+            <a:ext cx="6096000" cy="3429000"/>
+          </a:xfrm>
+          <a:custGeom>
+            <a:avLst/>
+            <a:gdLst/>
+            <a:ahLst/>
+            <a:cxnLst/>
+            <a:rect l="l" t="t" r="r" b="b"/>
+            <a:pathLst>
+              <a:path w="120000" h="120000" extrusionOk="0">
+                <a:moveTo>
+                  <a:pt x="0" y="0"/>
+                </a:moveTo>
+                <a:lnTo>
+                  <a:pt x="120000" y="0"/>
+                </a:lnTo>
+                <a:lnTo>
+                  <a:pt x="120000" y="120000"/>
+                </a:lnTo>
+                <a:lnTo>
+                  <a:pt x="0" y="120000"/>
+                </a:lnTo>
+                <a:close/>
+              </a:path>
+            </a:pathLst>
+          </a:custGeom>
+          <a:noFill/>
+          <a:ln w="9525" cap="flat" cmpd="sng">
+            <a:solidFill>
+              <a:srgbClr val="000000"/>
+            </a:solidFill>
+            <a:prstDash val="solid"/>
+            <a:round/>
+            <a:headEnd type="none" w="sm" len="sm"/>
+            <a:tailEnd type="none" w="sm" len="sm"/>
+          </a:ln>
+        </p:spPr>
+      </p:sp>
+      <p:sp>
+        <p:nvSpPr>
+          <p:cNvPr id="94" name="Google Shape;94;p5:notes">
+            <a:extLst>
+              <a:ext uri="{FF2B5EF4-FFF2-40B4-BE49-F238E27FC236}">
+                <a16:creationId xmlns:a16="http://schemas.microsoft.com/office/drawing/2014/main" id="{DF3A9133-13B1-F98B-09D0-39C018095629}"/>
+              </a:ext>
+            </a:extLst>
+          </p:cNvPr>
+          <p:cNvSpPr txBox="1">
+            <a:spLocks noGrp="1"/>
+          </p:cNvSpPr>
+          <p:nvPr>
+            <p:ph type="body" idx="1"/>
+          </p:nvPr>
+        </p:nvSpPr>
+        <p:spPr>
+          <a:xfrm>
+            <a:off x="685800" y="4343400"/>
+            <a:ext cx="5486400" cy="4114800"/>
+          </a:xfrm>
+          <a:prstGeom prst="rect">
+            <a:avLst/>
+          </a:prstGeom>
+          <a:noFill/>
+          <a:ln>
+            <a:noFill/>
+          </a:ln>
+        </p:spPr>
+        <p:txBody>
+          <a:bodyPr spcFirstLastPara="1" wrap="square" lIns="91425" tIns="91425" rIns="91425" bIns="91425" anchor="t" anchorCtr="0">
+            <a:noAutofit/>
+          </a:bodyPr>
+          <a:lstStyle/>
+          <a:p>
+            <a:pPr marL="0" lvl="0" indent="0" algn="l" rtl="0">
+              <a:lnSpc>
+                <a:spcPct val="100000"/>
+              </a:lnSpc>
+              <a:spcBef>
+                <a:spcPts val="0"/>
+              </a:spcBef>
+              <a:spcAft>
+                <a:spcPts val="0"/>
+              </a:spcAft>
+              <a:buSzPts val="1100"/>
+              <a:buNone/>
+            </a:pPr>
+            <a:endParaRPr/>
+          </a:p>
+        </p:txBody>
+      </p:sp>
+    </p:spTree>
+    <p:extLst>
+      <p:ext uri="{BB962C8B-B14F-4D97-AF65-F5344CB8AC3E}">
+        <p14:creationId xmlns:p14="http://schemas.microsoft.com/office/powerpoint/2010/main" val="2688779081"/>
+      </p:ext>
+    </p:extLst>
+  </p:cSld>
+  <p:clrMapOvr>
+    <a:masterClrMapping/>
+  </p:clrMapOvr>
+</p:notes>
+</file>
+
+<file path=ppt/notesSlides/notesSlide16.xml><?xml version="1.0" encoding="utf-8"?>
+<p:notes xmlns:a="http://schemas.openxmlformats.org/drawingml/2006/main" xmlns:r="http://schemas.openxmlformats.org/officeDocument/2006/relationships" xmlns:p="http://schemas.openxmlformats.org/presentationml/2006/main" showMasterSp="0" showMasterPhAnim="0">
+  <p:cSld>
+    <p:spTree>
+      <p:nvGrpSpPr>
+        <p:cNvPr id="1" name="Shape 92">
+          <a:extLst>
+            <a:ext uri="{FF2B5EF4-FFF2-40B4-BE49-F238E27FC236}">
+              <a16:creationId xmlns:a16="http://schemas.microsoft.com/office/drawing/2014/main" id="{583FB797-51ED-429D-BC0E-259203E92814}"/>
+            </a:ext>
+          </a:extLst>
+        </p:cNvPr>
+        <p:cNvGrpSpPr/>
+        <p:nvPr/>
+      </p:nvGrpSpPr>
+      <p:grpSpPr>
+        <a:xfrm>
+          <a:off x="0" y="0"/>
+          <a:ext cx="0" cy="0"/>
+          <a:chOff x="0" y="0"/>
+          <a:chExt cx="0" cy="0"/>
+        </a:xfrm>
+      </p:grpSpPr>
+      <p:sp>
+        <p:nvSpPr>
+          <p:cNvPr id="93" name="Google Shape;93;p5:notes">
+            <a:extLst>
+              <a:ext uri="{FF2B5EF4-FFF2-40B4-BE49-F238E27FC236}">
+                <a16:creationId xmlns:a16="http://schemas.microsoft.com/office/drawing/2014/main" id="{991DF715-0CB1-F533-20EE-5958E34FAF3F}"/>
+              </a:ext>
+            </a:extLst>
+          </p:cNvPr>
+          <p:cNvSpPr>
+            <a:spLocks noGrp="1" noRot="1" noChangeAspect="1"/>
+          </p:cNvSpPr>
+          <p:nvPr>
+            <p:ph type="sldImg" idx="2"/>
+          </p:nvPr>
+        </p:nvSpPr>
+        <p:spPr>
+          <a:xfrm>
+            <a:off x="381000" y="685800"/>
+            <a:ext cx="6096000" cy="3429000"/>
+          </a:xfrm>
+          <a:custGeom>
+            <a:avLst/>
+            <a:gdLst/>
+            <a:ahLst/>
+            <a:cxnLst/>
+            <a:rect l="l" t="t" r="r" b="b"/>
+            <a:pathLst>
+              <a:path w="120000" h="120000" extrusionOk="0">
+                <a:moveTo>
+                  <a:pt x="0" y="0"/>
+                </a:moveTo>
+                <a:lnTo>
+                  <a:pt x="120000" y="0"/>
+                </a:lnTo>
+                <a:lnTo>
+                  <a:pt x="120000" y="120000"/>
+                </a:lnTo>
+                <a:lnTo>
+                  <a:pt x="0" y="120000"/>
+                </a:lnTo>
+                <a:close/>
+              </a:path>
+            </a:pathLst>
+          </a:custGeom>
+          <a:noFill/>
+          <a:ln w="9525" cap="flat" cmpd="sng">
+            <a:solidFill>
+              <a:srgbClr val="000000"/>
+            </a:solidFill>
+            <a:prstDash val="solid"/>
+            <a:round/>
+            <a:headEnd type="none" w="sm" len="sm"/>
+            <a:tailEnd type="none" w="sm" len="sm"/>
+          </a:ln>
+        </p:spPr>
+      </p:sp>
+      <p:sp>
+        <p:nvSpPr>
+          <p:cNvPr id="94" name="Google Shape;94;p5:notes">
+            <a:extLst>
+              <a:ext uri="{FF2B5EF4-FFF2-40B4-BE49-F238E27FC236}">
+                <a16:creationId xmlns:a16="http://schemas.microsoft.com/office/drawing/2014/main" id="{EFEEF117-B5DF-FDDE-96F9-176F90EBCF01}"/>
+              </a:ext>
+            </a:extLst>
+          </p:cNvPr>
+          <p:cNvSpPr txBox="1">
+            <a:spLocks noGrp="1"/>
+          </p:cNvSpPr>
+          <p:nvPr>
+            <p:ph type="body" idx="1"/>
+          </p:nvPr>
+        </p:nvSpPr>
+        <p:spPr>
+          <a:xfrm>
+            <a:off x="685800" y="4343400"/>
+            <a:ext cx="5486400" cy="4114800"/>
+          </a:xfrm>
+          <a:prstGeom prst="rect">
+            <a:avLst/>
+          </a:prstGeom>
+          <a:noFill/>
+          <a:ln>
+            <a:noFill/>
+          </a:ln>
+        </p:spPr>
+        <p:txBody>
+          <a:bodyPr spcFirstLastPara="1" wrap="square" lIns="91425" tIns="91425" rIns="91425" bIns="91425" anchor="t" anchorCtr="0">
+            <a:noAutofit/>
+          </a:bodyPr>
+          <a:lstStyle/>
+          <a:p>
+            <a:pPr marL="0" lvl="0" indent="0" algn="l" rtl="0">
+              <a:lnSpc>
+                <a:spcPct val="100000"/>
+              </a:lnSpc>
+              <a:spcBef>
+                <a:spcPts val="0"/>
+              </a:spcBef>
+              <a:spcAft>
+                <a:spcPts val="0"/>
+              </a:spcAft>
+              <a:buSzPts val="1100"/>
+              <a:buNone/>
+            </a:pPr>
+            <a:endParaRPr/>
+          </a:p>
+        </p:txBody>
+      </p:sp>
+    </p:spTree>
+    <p:extLst>
+      <p:ext uri="{BB962C8B-B14F-4D97-AF65-F5344CB8AC3E}">
+        <p14:creationId xmlns:p14="http://schemas.microsoft.com/office/powerpoint/2010/main" val="1915157264"/>
+      </p:ext>
+    </p:extLst>
+  </p:cSld>
+  <p:clrMapOvr>
+    <a:masterClrMapping/>
+  </p:clrMapOvr>
+</p:notes>
+</file>
+
+<file path=ppt/notesSlides/notesSlide17.xml><?xml version="1.0" encoding="utf-8"?>
+<p:notes xmlns:a="http://schemas.openxmlformats.org/drawingml/2006/main" xmlns:r="http://schemas.openxmlformats.org/officeDocument/2006/relationships" xmlns:p="http://schemas.openxmlformats.org/presentationml/2006/main" showMasterSp="0" showMasterPhAnim="0">
+  <p:cSld>
+    <p:spTree>
+      <p:nvGrpSpPr>
+        <p:cNvPr id="1" name="Shape 92">
+          <a:extLst>
+            <a:ext uri="{FF2B5EF4-FFF2-40B4-BE49-F238E27FC236}">
               <a16:creationId xmlns:a16="http://schemas.microsoft.com/office/drawing/2014/main" id="{F7CC36C7-11D0-8ADD-0BBF-ADF4FC60E857}"/>
             </a:ext>
           </a:extLst>
@@ -3893,7 +4199,7 @@
 </p:notes>
 </file>
 
-<file path=ppt/notesSlides/notesSlide16.xml><?xml version="1.0" encoding="utf-8"?>
+<file path=ppt/notesSlides/notesSlide18.xml><?xml version="1.0" encoding="utf-8"?>
 <p:notes xmlns:a="http://schemas.openxmlformats.org/drawingml/2006/main" xmlns:r="http://schemas.openxmlformats.org/officeDocument/2006/relationships" xmlns:p="http://schemas.openxmlformats.org/presentationml/2006/main" showMasterSp="0" showMasterPhAnim="0">
   <p:cSld>
     <p:spTree>
@@ -4029,296 +4335,6 @@
     <p:extLst>
       <p:ext uri="{BB962C8B-B14F-4D97-AF65-F5344CB8AC3E}">
         <p14:creationId xmlns:p14="http://schemas.microsoft.com/office/powerpoint/2010/main" val="4242962007"/>
-      </p:ext>
-    </p:extLst>
-  </p:cSld>
-  <p:clrMapOvr>
-    <a:masterClrMapping/>
-  </p:clrMapOvr>
-</p:notes>
-</file>
-
-<file path=ppt/notesSlides/notesSlide17.xml><?xml version="1.0" encoding="utf-8"?>
-<p:notes xmlns:a="http://schemas.openxmlformats.org/drawingml/2006/main" xmlns:r="http://schemas.openxmlformats.org/officeDocument/2006/relationships" xmlns:p="http://schemas.openxmlformats.org/presentationml/2006/main" showMasterSp="0" showMasterPhAnim="0">
-  <p:cSld>
-    <p:spTree>
-      <p:nvGrpSpPr>
-        <p:cNvPr id="1" name="Shape 92">
-          <a:extLst>
-            <a:ext uri="{FF2B5EF4-FFF2-40B4-BE49-F238E27FC236}">
-              <a16:creationId xmlns:a16="http://schemas.microsoft.com/office/drawing/2014/main" id="{87D078D1-2A3F-0DA7-5A85-C8E1BAE85CC6}"/>
-            </a:ext>
-          </a:extLst>
-        </p:cNvPr>
-        <p:cNvGrpSpPr/>
-        <p:nvPr/>
-      </p:nvGrpSpPr>
-      <p:grpSpPr>
-        <a:xfrm>
-          <a:off x="0" y="0"/>
-          <a:ext cx="0" cy="0"/>
-          <a:chOff x="0" y="0"/>
-          <a:chExt cx="0" cy="0"/>
-        </a:xfrm>
-      </p:grpSpPr>
-      <p:sp>
-        <p:nvSpPr>
-          <p:cNvPr id="93" name="Google Shape;93;p5:notes">
-            <a:extLst>
-              <a:ext uri="{FF2B5EF4-FFF2-40B4-BE49-F238E27FC236}">
-                <a16:creationId xmlns:a16="http://schemas.microsoft.com/office/drawing/2014/main" id="{6C127E2B-7A52-00DD-B688-335EB1E07C31}"/>
-              </a:ext>
-            </a:extLst>
-          </p:cNvPr>
-          <p:cNvSpPr>
-            <a:spLocks noGrp="1" noRot="1" noChangeAspect="1"/>
-          </p:cNvSpPr>
-          <p:nvPr>
-            <p:ph type="sldImg" idx="2"/>
-          </p:nvPr>
-        </p:nvSpPr>
-        <p:spPr>
-          <a:xfrm>
-            <a:off x="381000" y="685800"/>
-            <a:ext cx="6096000" cy="3429000"/>
-          </a:xfrm>
-          <a:custGeom>
-            <a:avLst/>
-            <a:gdLst/>
-            <a:ahLst/>
-            <a:cxnLst/>
-            <a:rect l="l" t="t" r="r" b="b"/>
-            <a:pathLst>
-              <a:path w="120000" h="120000" extrusionOk="0">
-                <a:moveTo>
-                  <a:pt x="0" y="0"/>
-                </a:moveTo>
-                <a:lnTo>
-                  <a:pt x="120000" y="0"/>
-                </a:lnTo>
-                <a:lnTo>
-                  <a:pt x="120000" y="120000"/>
-                </a:lnTo>
-                <a:lnTo>
-                  <a:pt x="0" y="120000"/>
-                </a:lnTo>
-                <a:close/>
-              </a:path>
-            </a:pathLst>
-          </a:custGeom>
-          <a:noFill/>
-          <a:ln w="9525" cap="flat" cmpd="sng">
-            <a:solidFill>
-              <a:srgbClr val="000000"/>
-            </a:solidFill>
-            <a:prstDash val="solid"/>
-            <a:round/>
-            <a:headEnd type="none" w="sm" len="sm"/>
-            <a:tailEnd type="none" w="sm" len="sm"/>
-          </a:ln>
-        </p:spPr>
-      </p:sp>
-      <p:sp>
-        <p:nvSpPr>
-          <p:cNvPr id="94" name="Google Shape;94;p5:notes">
-            <a:extLst>
-              <a:ext uri="{FF2B5EF4-FFF2-40B4-BE49-F238E27FC236}">
-                <a16:creationId xmlns:a16="http://schemas.microsoft.com/office/drawing/2014/main" id="{DF3A9133-13B1-F98B-09D0-39C018095629}"/>
-              </a:ext>
-            </a:extLst>
-          </p:cNvPr>
-          <p:cNvSpPr txBox="1">
-            <a:spLocks noGrp="1"/>
-          </p:cNvSpPr>
-          <p:nvPr>
-            <p:ph type="body" idx="1"/>
-          </p:nvPr>
-        </p:nvSpPr>
-        <p:spPr>
-          <a:xfrm>
-            <a:off x="685800" y="4343400"/>
-            <a:ext cx="5486400" cy="4114800"/>
-          </a:xfrm>
-          <a:prstGeom prst="rect">
-            <a:avLst/>
-          </a:prstGeom>
-          <a:noFill/>
-          <a:ln>
-            <a:noFill/>
-          </a:ln>
-        </p:spPr>
-        <p:txBody>
-          <a:bodyPr spcFirstLastPara="1" wrap="square" lIns="91425" tIns="91425" rIns="91425" bIns="91425" anchor="t" anchorCtr="0">
-            <a:noAutofit/>
-          </a:bodyPr>
-          <a:lstStyle/>
-          <a:p>
-            <a:pPr marL="0" lvl="0" indent="0" algn="l" rtl="0">
-              <a:lnSpc>
-                <a:spcPct val="100000"/>
-              </a:lnSpc>
-              <a:spcBef>
-                <a:spcPts val="0"/>
-              </a:spcBef>
-              <a:spcAft>
-                <a:spcPts val="0"/>
-              </a:spcAft>
-              <a:buSzPts val="1100"/>
-              <a:buNone/>
-            </a:pPr>
-            <a:endParaRPr/>
-          </a:p>
-        </p:txBody>
-      </p:sp>
-    </p:spTree>
-    <p:extLst>
-      <p:ext uri="{BB962C8B-B14F-4D97-AF65-F5344CB8AC3E}">
-        <p14:creationId xmlns:p14="http://schemas.microsoft.com/office/powerpoint/2010/main" val="2688779081"/>
-      </p:ext>
-    </p:extLst>
-  </p:cSld>
-  <p:clrMapOvr>
-    <a:masterClrMapping/>
-  </p:clrMapOvr>
-</p:notes>
-</file>
-
-<file path=ppt/notesSlides/notesSlide18.xml><?xml version="1.0" encoding="utf-8"?>
-<p:notes xmlns:a="http://schemas.openxmlformats.org/drawingml/2006/main" xmlns:r="http://schemas.openxmlformats.org/officeDocument/2006/relationships" xmlns:p="http://schemas.openxmlformats.org/presentationml/2006/main" showMasterSp="0" showMasterPhAnim="0">
-  <p:cSld>
-    <p:spTree>
-      <p:nvGrpSpPr>
-        <p:cNvPr id="1" name="Shape 92">
-          <a:extLst>
-            <a:ext uri="{FF2B5EF4-FFF2-40B4-BE49-F238E27FC236}">
-              <a16:creationId xmlns:a16="http://schemas.microsoft.com/office/drawing/2014/main" id="{583FB797-51ED-429D-BC0E-259203E92814}"/>
-            </a:ext>
-          </a:extLst>
-        </p:cNvPr>
-        <p:cNvGrpSpPr/>
-        <p:nvPr/>
-      </p:nvGrpSpPr>
-      <p:grpSpPr>
-        <a:xfrm>
-          <a:off x="0" y="0"/>
-          <a:ext cx="0" cy="0"/>
-          <a:chOff x="0" y="0"/>
-          <a:chExt cx="0" cy="0"/>
-        </a:xfrm>
-      </p:grpSpPr>
-      <p:sp>
-        <p:nvSpPr>
-          <p:cNvPr id="93" name="Google Shape;93;p5:notes">
-            <a:extLst>
-              <a:ext uri="{FF2B5EF4-FFF2-40B4-BE49-F238E27FC236}">
-                <a16:creationId xmlns:a16="http://schemas.microsoft.com/office/drawing/2014/main" id="{991DF715-0CB1-F533-20EE-5958E34FAF3F}"/>
-              </a:ext>
-            </a:extLst>
-          </p:cNvPr>
-          <p:cNvSpPr>
-            <a:spLocks noGrp="1" noRot="1" noChangeAspect="1"/>
-          </p:cNvSpPr>
-          <p:nvPr>
-            <p:ph type="sldImg" idx="2"/>
-          </p:nvPr>
-        </p:nvSpPr>
-        <p:spPr>
-          <a:xfrm>
-            <a:off x="381000" y="685800"/>
-            <a:ext cx="6096000" cy="3429000"/>
-          </a:xfrm>
-          <a:custGeom>
-            <a:avLst/>
-            <a:gdLst/>
-            <a:ahLst/>
-            <a:cxnLst/>
-            <a:rect l="l" t="t" r="r" b="b"/>
-            <a:pathLst>
-              <a:path w="120000" h="120000" extrusionOk="0">
-                <a:moveTo>
-                  <a:pt x="0" y="0"/>
-                </a:moveTo>
-                <a:lnTo>
-                  <a:pt x="120000" y="0"/>
-                </a:lnTo>
-                <a:lnTo>
-                  <a:pt x="120000" y="120000"/>
-                </a:lnTo>
-                <a:lnTo>
-                  <a:pt x="0" y="120000"/>
-                </a:lnTo>
-                <a:close/>
-              </a:path>
-            </a:pathLst>
-          </a:custGeom>
-          <a:noFill/>
-          <a:ln w="9525" cap="flat" cmpd="sng">
-            <a:solidFill>
-              <a:srgbClr val="000000"/>
-            </a:solidFill>
-            <a:prstDash val="solid"/>
-            <a:round/>
-            <a:headEnd type="none" w="sm" len="sm"/>
-            <a:tailEnd type="none" w="sm" len="sm"/>
-          </a:ln>
-        </p:spPr>
-      </p:sp>
-      <p:sp>
-        <p:nvSpPr>
-          <p:cNvPr id="94" name="Google Shape;94;p5:notes">
-            <a:extLst>
-              <a:ext uri="{FF2B5EF4-FFF2-40B4-BE49-F238E27FC236}">
-                <a16:creationId xmlns:a16="http://schemas.microsoft.com/office/drawing/2014/main" id="{EFEEF117-B5DF-FDDE-96F9-176F90EBCF01}"/>
-              </a:ext>
-            </a:extLst>
-          </p:cNvPr>
-          <p:cNvSpPr txBox="1">
-            <a:spLocks noGrp="1"/>
-          </p:cNvSpPr>
-          <p:nvPr>
-            <p:ph type="body" idx="1"/>
-          </p:nvPr>
-        </p:nvSpPr>
-        <p:spPr>
-          <a:xfrm>
-            <a:off x="685800" y="4343400"/>
-            <a:ext cx="5486400" cy="4114800"/>
-          </a:xfrm>
-          <a:prstGeom prst="rect">
-            <a:avLst/>
-          </a:prstGeom>
-          <a:noFill/>
-          <a:ln>
-            <a:noFill/>
-          </a:ln>
-        </p:spPr>
-        <p:txBody>
-          <a:bodyPr spcFirstLastPara="1" wrap="square" lIns="91425" tIns="91425" rIns="91425" bIns="91425" anchor="t" anchorCtr="0">
-            <a:noAutofit/>
-          </a:bodyPr>
-          <a:lstStyle/>
-          <a:p>
-            <a:pPr marL="0" lvl="0" indent="0" algn="l" rtl="0">
-              <a:lnSpc>
-                <a:spcPct val="100000"/>
-              </a:lnSpc>
-              <a:spcBef>
-                <a:spcPts val="0"/>
-              </a:spcBef>
-              <a:spcAft>
-                <a:spcPts val="0"/>
-              </a:spcAft>
-              <a:buSzPts val="1100"/>
-              <a:buNone/>
-            </a:pPr>
-            <a:endParaRPr/>
-          </a:p>
-        </p:txBody>
-      </p:sp>
-    </p:spTree>
-    <p:extLst>
-      <p:ext uri="{BB962C8B-B14F-4D97-AF65-F5344CB8AC3E}">
-        <p14:creationId xmlns:p14="http://schemas.microsoft.com/office/powerpoint/2010/main" val="1915157264"/>
       </p:ext>
     </p:extLst>
   </p:cSld>
@@ -18976,43 +18992,6 @@
           </a:p>
         </p:txBody>
       </p:sp>
-      <p:pic>
-        <p:nvPicPr>
-          <p:cNvPr id="13" name="Image 12">
-            <a:extLst>
-              <a:ext uri="{FF2B5EF4-FFF2-40B4-BE49-F238E27FC236}">
-                <a16:creationId xmlns:a16="http://schemas.microsoft.com/office/drawing/2014/main" id="{42BBF9A1-C47F-62DF-F307-88D7E8C42892}"/>
-              </a:ext>
-            </a:extLst>
-          </p:cNvPr>
-          <p:cNvPicPr>
-            <a:picLocks noChangeAspect="1"/>
-          </p:cNvPicPr>
-          <p:nvPr/>
-        </p:nvPicPr>
-        <p:blipFill>
-          <a:blip r:embed="rId4"/>
-          <a:stretch>
-            <a:fillRect/>
-          </a:stretch>
-        </p:blipFill>
-        <p:spPr>
-          <a:xfrm>
-            <a:off x="463375" y="1335349"/>
-            <a:ext cx="4139602" cy="2563231"/>
-          </a:xfrm>
-          <a:prstGeom prst="rect">
-            <a:avLst/>
-          </a:prstGeom>
-          <a:ln>
-            <a:solidFill>
-              <a:schemeClr val="bg1">
-                <a:lumMod val="75000"/>
-              </a:schemeClr>
-            </a:solidFill>
-          </a:ln>
-        </p:spPr>
-      </p:pic>
       <p:sp>
         <p:nvSpPr>
           <p:cNvPr id="15" name="Google Shape;69;p3">
@@ -19579,10 +19558,48 @@
       </p:sp>
       <p:pic>
         <p:nvPicPr>
-          <p:cNvPr id="21" name="Image 20" descr="Une image contenant capture d’écran, diagramme, Tracé, conception">
+          <p:cNvPr id="2" name="Image 1" descr="Une image contenant capture d’écran, diagramme, Tracé, conception">
             <a:extLst>
               <a:ext uri="{FF2B5EF4-FFF2-40B4-BE49-F238E27FC236}">
-                <a16:creationId xmlns:a16="http://schemas.microsoft.com/office/drawing/2014/main" id="{A65574E9-E5BD-6A21-1763-F42B66A783B7}"/>
+                <a16:creationId xmlns:a16="http://schemas.microsoft.com/office/drawing/2014/main" id="{BFC65734-9253-849D-5A6F-F7D5EA9D0712}"/>
+              </a:ext>
+            </a:extLst>
+          </p:cNvPr>
+          <p:cNvPicPr>
+            <a:picLocks noChangeAspect="1"/>
+          </p:cNvPicPr>
+          <p:nvPr/>
+        </p:nvPicPr>
+        <p:blipFill>
+          <a:blip r:embed="rId4"/>
+          <a:srcRect t="5437" b="3975"/>
+          <a:stretch>
+            <a:fillRect/>
+          </a:stretch>
+        </p:blipFill>
+        <p:spPr>
+          <a:xfrm>
+            <a:off x="5131783" y="1335349"/>
+            <a:ext cx="3709114" cy="2520000"/>
+          </a:xfrm>
+          <a:prstGeom prst="rect">
+            <a:avLst/>
+          </a:prstGeom>
+          <a:ln>
+            <a:solidFill>
+              <a:schemeClr val="bg1">
+                <a:lumMod val="75000"/>
+              </a:schemeClr>
+            </a:solidFill>
+          </a:ln>
+        </p:spPr>
+      </p:pic>
+      <p:pic>
+        <p:nvPicPr>
+          <p:cNvPr id="3" name="Image 2">
+            <a:extLst>
+              <a:ext uri="{FF2B5EF4-FFF2-40B4-BE49-F238E27FC236}">
+                <a16:creationId xmlns:a16="http://schemas.microsoft.com/office/drawing/2014/main" id="{F42D4AB1-28C7-BB89-AEEE-DABEB2514D1E}"/>
               </a:ext>
             </a:extLst>
           </p:cNvPr>
@@ -19593,15 +19610,14 @@
         </p:nvPicPr>
         <p:blipFill>
           <a:blip r:embed="rId5"/>
-          <a:srcRect t="5437" b="3975"/>
           <a:stretch>
             <a:fillRect/>
           </a:stretch>
         </p:blipFill>
         <p:spPr>
           <a:xfrm>
-            <a:off x="5016923" y="1335350"/>
-            <a:ext cx="3770637" cy="2561800"/>
+            <a:off x="690620" y="1335349"/>
+            <a:ext cx="4199999" cy="2520000"/>
           </a:xfrm>
           <a:prstGeom prst="rect">
             <a:avLst/>
@@ -21493,7 +21509,7 @@
         </p:nvSpPr>
         <p:spPr>
           <a:xfrm>
-            <a:off x="1799442" y="3006625"/>
+            <a:off x="1799442" y="3228155"/>
             <a:ext cx="1485799" cy="545226"/>
           </a:xfrm>
           <a:prstGeom prst="roundRect">
@@ -21547,7 +21563,7 @@
         </p:nvSpPr>
         <p:spPr>
           <a:xfrm>
-            <a:off x="1799442" y="3079183"/>
+            <a:off x="1799442" y="3300713"/>
             <a:ext cx="1485799" cy="400110"/>
           </a:xfrm>
           <a:prstGeom prst="rect">
@@ -21588,7 +21604,7 @@
         </p:nvCxnSpPr>
         <p:spPr>
           <a:xfrm>
-            <a:off x="1200757" y="3279238"/>
+            <a:off x="1200757" y="3500768"/>
             <a:ext cx="569861" cy="0"/>
           </a:xfrm>
           <a:prstGeom prst="straightConnector1">
@@ -21596,7 +21612,7 @@
           </a:prstGeom>
           <a:ln w="76200">
             <a:solidFill>
-              <a:srgbClr val="FFC000"/>
+              <a:srgbClr val="FF0000"/>
             </a:solidFill>
             <a:tailEnd type="triangle"/>
           </a:ln>
@@ -21759,1056 +21775,6 @@
 </file>
 
 <file path=ppt/slides/slide15.xml><?xml version="1.0" encoding="utf-8"?>
-<p:sld xmlns:a="http://schemas.openxmlformats.org/drawingml/2006/main" xmlns:r="http://schemas.openxmlformats.org/officeDocument/2006/relationships" xmlns:p="http://schemas.openxmlformats.org/presentationml/2006/main">
-  <p:cSld>
-    <p:spTree>
-      <p:nvGrpSpPr>
-        <p:cNvPr id="1" name="Shape 95">
-          <a:extLst>
-            <a:ext uri="{FF2B5EF4-FFF2-40B4-BE49-F238E27FC236}">
-              <a16:creationId xmlns:a16="http://schemas.microsoft.com/office/drawing/2014/main" id="{06EDD131-5809-747C-6E95-185A073DB048}"/>
-            </a:ext>
-          </a:extLst>
-        </p:cNvPr>
-        <p:cNvGrpSpPr/>
-        <p:nvPr/>
-      </p:nvGrpSpPr>
-      <p:grpSpPr>
-        <a:xfrm>
-          <a:off x="0" y="0"/>
-          <a:ext cx="0" cy="0"/>
-          <a:chOff x="0" y="0"/>
-          <a:chExt cx="0" cy="0"/>
-        </a:xfrm>
-      </p:grpSpPr>
-      <p:sp>
-        <p:nvSpPr>
-          <p:cNvPr id="96" name="Google Shape;96;p5">
-            <a:extLst>
-              <a:ext uri="{FF2B5EF4-FFF2-40B4-BE49-F238E27FC236}">
-                <a16:creationId xmlns:a16="http://schemas.microsoft.com/office/drawing/2014/main" id="{CFE260F2-EC75-DDF8-CE55-329FB5D8E4C4}"/>
-              </a:ext>
-            </a:extLst>
-          </p:cNvPr>
-          <p:cNvSpPr txBox="1">
-            <a:spLocks noGrp="1"/>
-          </p:cNvSpPr>
-          <p:nvPr>
-            <p:ph type="ctrTitle" idx="4294967295"/>
-          </p:nvPr>
-        </p:nvSpPr>
-        <p:spPr>
-          <a:xfrm>
-            <a:off x="1192664" y="403309"/>
-            <a:ext cx="5315100" cy="533100"/>
-          </a:xfrm>
-          <a:prstGeom prst="rect">
-            <a:avLst/>
-          </a:prstGeom>
-          <a:noFill/>
-          <a:ln>
-            <a:noFill/>
-          </a:ln>
-        </p:spPr>
-        <p:txBody>
-          <a:bodyPr spcFirstLastPara="1" wrap="square" lIns="91425" tIns="91425" rIns="91425" bIns="91425" anchor="t" anchorCtr="0">
-            <a:noAutofit/>
-          </a:bodyPr>
-          <a:lstStyle/>
-          <a:p>
-            <a:pPr marL="0" marR="0" lvl="0" indent="0" algn="l" rtl="0">
-              <a:lnSpc>
-                <a:spcPct val="100000"/>
-              </a:lnSpc>
-              <a:spcBef>
-                <a:spcPts val="0"/>
-              </a:spcBef>
-              <a:spcAft>
-                <a:spcPts val="0"/>
-              </a:spcAft>
-              <a:buClr>
-                <a:schemeClr val="dk1"/>
-              </a:buClr>
-              <a:buSzPts val="2800"/>
-              <a:buFont typeface="Arial"/>
-              <a:buNone/>
-            </a:pPr>
-            <a:r>
-              <a:rPr lang="it-IT" sz="2500" i="0" u="none" strike="noStrike" cap="none" dirty="0">
-                <a:solidFill>
-                  <a:srgbClr val="0E3449"/>
-                </a:solidFill>
-                <a:latin typeface="Inter SemiBold"/>
-                <a:ea typeface="Inter SemiBold"/>
-                <a:cs typeface="Inter SemiBold"/>
-                <a:sym typeface="Inter SemiBold"/>
-              </a:rPr>
-              <a:t>Ressourses projet</a:t>
-            </a:r>
-          </a:p>
-        </p:txBody>
-      </p:sp>
-      <p:pic>
-        <p:nvPicPr>
-          <p:cNvPr id="97" name="Google Shape;97;p5">
-            <a:extLst>
-              <a:ext uri="{FF2B5EF4-FFF2-40B4-BE49-F238E27FC236}">
-                <a16:creationId xmlns:a16="http://schemas.microsoft.com/office/drawing/2014/main" id="{66739ED7-F6B1-16FF-21A5-52FBD2C06D52}"/>
-              </a:ext>
-            </a:extLst>
-          </p:cNvPr>
-          <p:cNvPicPr preferRelativeResize="0"/>
-          <p:nvPr/>
-        </p:nvPicPr>
-        <p:blipFill rotWithShape="1">
-          <a:blip r:embed="rId3">
-            <a:alphaModFix/>
-          </a:blip>
-          <a:srcRect/>
-          <a:stretch/>
-        </p:blipFill>
-        <p:spPr>
-          <a:xfrm>
-            <a:off x="463375" y="482852"/>
-            <a:ext cx="576900" cy="385904"/>
-          </a:xfrm>
-          <a:prstGeom prst="rect">
-            <a:avLst/>
-          </a:prstGeom>
-          <a:noFill/>
-          <a:ln>
-            <a:noFill/>
-          </a:ln>
-        </p:spPr>
-      </p:pic>
-      <p:sp>
-        <p:nvSpPr>
-          <p:cNvPr id="98" name="Google Shape;98;p5">
-            <a:extLst>
-              <a:ext uri="{FF2B5EF4-FFF2-40B4-BE49-F238E27FC236}">
-                <a16:creationId xmlns:a16="http://schemas.microsoft.com/office/drawing/2014/main" id="{CF1380DA-0568-3714-99DF-1C8C31BCE89D}"/>
-              </a:ext>
-            </a:extLst>
-          </p:cNvPr>
-          <p:cNvSpPr/>
-          <p:nvPr/>
-        </p:nvSpPr>
-        <p:spPr>
-          <a:xfrm>
-            <a:off x="10225" y="4892025"/>
-            <a:ext cx="9144000" cy="251400"/>
-          </a:xfrm>
-          <a:prstGeom prst="rect">
-            <a:avLst/>
-          </a:prstGeom>
-          <a:solidFill>
-            <a:srgbClr val="C3FFFC"/>
-          </a:solidFill>
-          <a:ln>
-            <a:noFill/>
-          </a:ln>
-        </p:spPr>
-        <p:txBody>
-          <a:bodyPr spcFirstLastPara="1" wrap="square" lIns="91425" tIns="91425" rIns="91425" bIns="91425" anchor="ctr" anchorCtr="0">
-            <a:noAutofit/>
-          </a:bodyPr>
-          <a:lstStyle/>
-          <a:p>
-            <a:pPr marL="0" marR="0" lvl="0" indent="0" algn="l" rtl="0">
-              <a:lnSpc>
-                <a:spcPct val="100000"/>
-              </a:lnSpc>
-              <a:spcBef>
-                <a:spcPts val="0"/>
-              </a:spcBef>
-              <a:spcAft>
-                <a:spcPts val="0"/>
-              </a:spcAft>
-              <a:buClr>
-                <a:srgbClr val="000000"/>
-              </a:buClr>
-              <a:buSzPts val="1400"/>
-              <a:buFont typeface="Arial"/>
-              <a:buNone/>
-            </a:pPr>
-            <a:endParaRPr sz="1400" b="0" i="0" u="none" strike="noStrike" cap="none">
-              <a:solidFill>
-                <a:srgbClr val="000000"/>
-              </a:solidFill>
-              <a:latin typeface="Arial"/>
-              <a:ea typeface="Arial"/>
-              <a:cs typeface="Arial"/>
-              <a:sym typeface="Arial"/>
-            </a:endParaRPr>
-          </a:p>
-        </p:txBody>
-      </p:sp>
-      <p:sp>
-        <p:nvSpPr>
-          <p:cNvPr id="4" name="Google Shape;181;p8">
-            <a:extLst>
-              <a:ext uri="{FF2B5EF4-FFF2-40B4-BE49-F238E27FC236}">
-                <a16:creationId xmlns:a16="http://schemas.microsoft.com/office/drawing/2014/main" id="{9EF8D937-D220-A74B-8191-12E681FE1A08}"/>
-              </a:ext>
-            </a:extLst>
-          </p:cNvPr>
-          <p:cNvSpPr txBox="1">
-            <a:spLocks noGrp="1"/>
-          </p:cNvSpPr>
-          <p:nvPr>
-            <p:ph type="body" idx="1"/>
-          </p:nvPr>
-        </p:nvSpPr>
-        <p:spPr>
-          <a:xfrm>
-            <a:off x="311700" y="1155049"/>
-            <a:ext cx="8520600" cy="3585142"/>
-          </a:xfrm>
-          <a:prstGeom prst="rect">
-            <a:avLst/>
-          </a:prstGeom>
-          <a:noFill/>
-          <a:ln>
-            <a:noFill/>
-          </a:ln>
-        </p:spPr>
-        <p:txBody>
-          <a:bodyPr spcFirstLastPara="1" wrap="square" lIns="91425" tIns="91425" rIns="91425" bIns="91425" anchor="t" anchorCtr="0">
-            <a:noAutofit/>
-          </a:bodyPr>
-          <a:lstStyle/>
-          <a:p>
-            <a:pPr marL="114300" lvl="0" indent="0">
-              <a:spcBef>
-                <a:spcPts val="1200"/>
-              </a:spcBef>
-              <a:buNone/>
-            </a:pPr>
-            <a:r>
-              <a:rPr lang="fr-FR" sz="1400" b="1" dirty="0"/>
-              <a:t>Lien </a:t>
-            </a:r>
-            <a:r>
-              <a:rPr lang="fr-FR" sz="1400" b="1" dirty="0" err="1"/>
-              <a:t>Github</a:t>
-            </a:r>
-            <a:r>
-              <a:rPr lang="fr-FR" sz="1400" b="1" dirty="0"/>
-              <a:t> : </a:t>
-            </a:r>
-            <a:r>
-              <a:rPr lang="fr-FR" sz="1400" dirty="0">
-                <a:hlinkClick r:id="rId4"/>
-              </a:rPr>
-              <a:t>https://github.com/Sheikoh/REnergies_efficiency_prediction.git</a:t>
-            </a:r>
-            <a:endParaRPr lang="fr-FR" sz="1400" dirty="0"/>
-          </a:p>
-          <a:p>
-            <a:pPr marL="114300" lvl="0" indent="0">
-              <a:spcBef>
-                <a:spcPts val="1200"/>
-              </a:spcBef>
-              <a:buNone/>
-            </a:pPr>
-            <a:r>
-              <a:rPr lang="fr-FR" sz="1400" b="1" dirty="0"/>
-              <a:t>Lien Dashboard : </a:t>
-            </a:r>
-            <a:r>
-              <a:rPr lang="fr-FR" sz="1400" dirty="0">
-                <a:hlinkClick r:id="rId5"/>
-              </a:rPr>
-              <a:t>https://renergies99-dashboard.hf.space/</a:t>
-            </a:r>
-            <a:endParaRPr lang="fr-FR" sz="1400" dirty="0"/>
-          </a:p>
-          <a:p>
-            <a:pPr marL="114300" lvl="0" indent="0">
-              <a:spcBef>
-                <a:spcPts val="1200"/>
-              </a:spcBef>
-              <a:buNone/>
-            </a:pPr>
-            <a:r>
-              <a:rPr lang="fr-FR" sz="1400" b="1" dirty="0"/>
-              <a:t>Lien </a:t>
-            </a:r>
-            <a:r>
-              <a:rPr lang="fr-FR" sz="1400" b="1" dirty="0" err="1"/>
-              <a:t>Mlflow</a:t>
-            </a:r>
-            <a:r>
-              <a:rPr lang="fr-FR" sz="1400" b="1" dirty="0"/>
-              <a:t> : </a:t>
-            </a:r>
-            <a:r>
-              <a:rPr lang="fr-FR" sz="1400" dirty="0">
-                <a:hlinkClick r:id="rId6"/>
-              </a:rPr>
-              <a:t>https://renergies99-mlflow.hf.space/</a:t>
-            </a:r>
-            <a:endParaRPr lang="fr-FR" sz="1400" dirty="0"/>
-          </a:p>
-          <a:p>
-            <a:pPr marL="114300" lvl="0" indent="0">
-              <a:spcBef>
-                <a:spcPts val="1200"/>
-              </a:spcBef>
-              <a:buNone/>
-            </a:pPr>
-            <a:r>
-              <a:rPr lang="fr-FR" sz="1400" b="1" dirty="0"/>
-              <a:t>Lien API : </a:t>
-            </a:r>
-            <a:r>
-              <a:rPr lang="fr-FR" sz="1400" dirty="0">
-                <a:hlinkClick r:id="rId7"/>
-              </a:rPr>
-              <a:t>https://renergies99-api-renergy.hf.space/</a:t>
-            </a:r>
-            <a:endParaRPr lang="fr-FR" sz="1400" dirty="0"/>
-          </a:p>
-          <a:p>
-            <a:pPr marL="114300" lvl="0" indent="0">
-              <a:buNone/>
-            </a:pPr>
-            <a:endParaRPr lang="fr-FR" sz="1400" dirty="0"/>
-          </a:p>
-          <a:p>
-            <a:pPr marL="114300" lvl="0" indent="0">
-              <a:buNone/>
-            </a:pPr>
-            <a:endParaRPr sz="1400" dirty="0"/>
-          </a:p>
-        </p:txBody>
-      </p:sp>
-    </p:spTree>
-    <p:extLst>
-      <p:ext uri="{BB962C8B-B14F-4D97-AF65-F5344CB8AC3E}">
-        <p14:creationId xmlns:p14="http://schemas.microsoft.com/office/powerpoint/2010/main" val="4088050223"/>
-      </p:ext>
-    </p:extLst>
-  </p:cSld>
-  <p:clrMapOvr>
-    <a:masterClrMapping/>
-  </p:clrMapOvr>
-</p:sld>
-</file>
-
-<file path=ppt/slides/slide16.xml><?xml version="1.0" encoding="utf-8"?>
-<p:sld xmlns:a="http://schemas.openxmlformats.org/drawingml/2006/main" xmlns:r="http://schemas.openxmlformats.org/officeDocument/2006/relationships" xmlns:p="http://schemas.openxmlformats.org/presentationml/2006/main">
-  <p:cSld>
-    <p:spTree>
-      <p:nvGrpSpPr>
-        <p:cNvPr id="1" name="Shape 95">
-          <a:extLst>
-            <a:ext uri="{FF2B5EF4-FFF2-40B4-BE49-F238E27FC236}">
-              <a16:creationId xmlns:a16="http://schemas.microsoft.com/office/drawing/2014/main" id="{54B39E8E-2AB4-298D-C3FD-3B563ED89E4A}"/>
-            </a:ext>
-          </a:extLst>
-        </p:cNvPr>
-        <p:cNvGrpSpPr/>
-        <p:nvPr/>
-      </p:nvGrpSpPr>
-      <p:grpSpPr>
-        <a:xfrm>
-          <a:off x="0" y="0"/>
-          <a:ext cx="0" cy="0"/>
-          <a:chOff x="0" y="0"/>
-          <a:chExt cx="0" cy="0"/>
-        </a:xfrm>
-      </p:grpSpPr>
-      <p:sp>
-        <p:nvSpPr>
-          <p:cNvPr id="96" name="Google Shape;96;p5">
-            <a:extLst>
-              <a:ext uri="{FF2B5EF4-FFF2-40B4-BE49-F238E27FC236}">
-                <a16:creationId xmlns:a16="http://schemas.microsoft.com/office/drawing/2014/main" id="{A01AE6FF-5294-F6EC-FB0D-D63D7D63D71C}"/>
-              </a:ext>
-            </a:extLst>
-          </p:cNvPr>
-          <p:cNvSpPr txBox="1">
-            <a:spLocks noGrp="1"/>
-          </p:cNvSpPr>
-          <p:nvPr>
-            <p:ph type="ctrTitle" idx="4294967295"/>
-          </p:nvPr>
-        </p:nvSpPr>
-        <p:spPr>
-          <a:xfrm>
-            <a:off x="1192664" y="403309"/>
-            <a:ext cx="5315100" cy="533100"/>
-          </a:xfrm>
-          <a:prstGeom prst="rect">
-            <a:avLst/>
-          </a:prstGeom>
-          <a:noFill/>
-          <a:ln>
-            <a:noFill/>
-          </a:ln>
-        </p:spPr>
-        <p:txBody>
-          <a:bodyPr spcFirstLastPara="1" wrap="square" lIns="91425" tIns="91425" rIns="91425" bIns="91425" anchor="t" anchorCtr="0">
-            <a:noAutofit/>
-          </a:bodyPr>
-          <a:lstStyle/>
-          <a:p>
-            <a:pPr marL="0" marR="0" lvl="0" indent="0" algn="l" rtl="0">
-              <a:lnSpc>
-                <a:spcPct val="100000"/>
-              </a:lnSpc>
-              <a:spcBef>
-                <a:spcPts val="0"/>
-              </a:spcBef>
-              <a:spcAft>
-                <a:spcPts val="0"/>
-              </a:spcAft>
-              <a:buClr>
-                <a:schemeClr val="dk1"/>
-              </a:buClr>
-              <a:buSzPts val="2800"/>
-              <a:buFont typeface="Arial"/>
-              <a:buNone/>
-            </a:pPr>
-            <a:r>
-              <a:rPr lang="it-IT" sz="2500" i="0" u="none" strike="noStrike" cap="none" dirty="0">
-                <a:solidFill>
-                  <a:srgbClr val="0E3449"/>
-                </a:solidFill>
-                <a:latin typeface="Inter SemiBold"/>
-                <a:ea typeface="Inter SemiBold"/>
-                <a:cs typeface="Inter SemiBold"/>
-                <a:sym typeface="Inter SemiBold"/>
-              </a:rPr>
-              <a:t>Sources de données</a:t>
-            </a:r>
-          </a:p>
-        </p:txBody>
-      </p:sp>
-      <p:pic>
-        <p:nvPicPr>
-          <p:cNvPr id="97" name="Google Shape;97;p5">
-            <a:extLst>
-              <a:ext uri="{FF2B5EF4-FFF2-40B4-BE49-F238E27FC236}">
-                <a16:creationId xmlns:a16="http://schemas.microsoft.com/office/drawing/2014/main" id="{7FFB1AFA-ABA9-029D-77BD-FB2682A2296B}"/>
-              </a:ext>
-            </a:extLst>
-          </p:cNvPr>
-          <p:cNvPicPr preferRelativeResize="0"/>
-          <p:nvPr/>
-        </p:nvPicPr>
-        <p:blipFill rotWithShape="1">
-          <a:blip r:embed="rId3">
-            <a:alphaModFix/>
-          </a:blip>
-          <a:srcRect/>
-          <a:stretch/>
-        </p:blipFill>
-        <p:spPr>
-          <a:xfrm>
-            <a:off x="463375" y="482852"/>
-            <a:ext cx="576900" cy="385904"/>
-          </a:xfrm>
-          <a:prstGeom prst="rect">
-            <a:avLst/>
-          </a:prstGeom>
-          <a:noFill/>
-          <a:ln>
-            <a:noFill/>
-          </a:ln>
-        </p:spPr>
-      </p:pic>
-      <p:sp>
-        <p:nvSpPr>
-          <p:cNvPr id="98" name="Google Shape;98;p5">
-            <a:extLst>
-              <a:ext uri="{FF2B5EF4-FFF2-40B4-BE49-F238E27FC236}">
-                <a16:creationId xmlns:a16="http://schemas.microsoft.com/office/drawing/2014/main" id="{33F93AD1-3891-482A-2CFB-204DAC688B8B}"/>
-              </a:ext>
-            </a:extLst>
-          </p:cNvPr>
-          <p:cNvSpPr/>
-          <p:nvPr/>
-        </p:nvSpPr>
-        <p:spPr>
-          <a:xfrm>
-            <a:off x="10225" y="4892025"/>
-            <a:ext cx="9144000" cy="251400"/>
-          </a:xfrm>
-          <a:prstGeom prst="rect">
-            <a:avLst/>
-          </a:prstGeom>
-          <a:solidFill>
-            <a:srgbClr val="C3FFFC"/>
-          </a:solidFill>
-          <a:ln>
-            <a:noFill/>
-          </a:ln>
-        </p:spPr>
-        <p:txBody>
-          <a:bodyPr spcFirstLastPara="1" wrap="square" lIns="91425" tIns="91425" rIns="91425" bIns="91425" anchor="ctr" anchorCtr="0">
-            <a:noAutofit/>
-          </a:bodyPr>
-          <a:lstStyle/>
-          <a:p>
-            <a:pPr marL="0" marR="0" lvl="0" indent="0" algn="l" rtl="0">
-              <a:lnSpc>
-                <a:spcPct val="100000"/>
-              </a:lnSpc>
-              <a:spcBef>
-                <a:spcPts val="0"/>
-              </a:spcBef>
-              <a:spcAft>
-                <a:spcPts val="0"/>
-              </a:spcAft>
-              <a:buClr>
-                <a:srgbClr val="000000"/>
-              </a:buClr>
-              <a:buSzPts val="1400"/>
-              <a:buFont typeface="Arial"/>
-              <a:buNone/>
-            </a:pPr>
-            <a:endParaRPr sz="1400" b="0" i="0" u="none" strike="noStrike" cap="none">
-              <a:solidFill>
-                <a:srgbClr val="000000"/>
-              </a:solidFill>
-              <a:latin typeface="Arial"/>
-              <a:ea typeface="Arial"/>
-              <a:cs typeface="Arial"/>
-              <a:sym typeface="Arial"/>
-            </a:endParaRPr>
-          </a:p>
-        </p:txBody>
-      </p:sp>
-      <p:graphicFrame>
-        <p:nvGraphicFramePr>
-          <p:cNvPr id="2" name="Tableau 1">
-            <a:extLst>
-              <a:ext uri="{FF2B5EF4-FFF2-40B4-BE49-F238E27FC236}">
-                <a16:creationId xmlns:a16="http://schemas.microsoft.com/office/drawing/2014/main" id="{1F110593-1E38-6872-65AA-F9F3DBB52889}"/>
-              </a:ext>
-            </a:extLst>
-          </p:cNvPr>
-          <p:cNvGraphicFramePr>
-            <a:graphicFrameLocks noGrp="1"/>
-          </p:cNvGraphicFramePr>
-          <p:nvPr>
-            <p:extLst>
-              <p:ext uri="{D42A27DB-BD31-4B8C-83A1-F6EECF244321}">
-                <p14:modId xmlns:p14="http://schemas.microsoft.com/office/powerpoint/2010/main" val="2643252541"/>
-              </p:ext>
-            </p:extLst>
-          </p:nvPr>
-        </p:nvGraphicFramePr>
-        <p:xfrm>
-          <a:off x="463375" y="1160010"/>
-          <a:ext cx="8283386" cy="2486560"/>
-        </p:xfrm>
-        <a:graphic>
-          <a:graphicData uri="http://schemas.openxmlformats.org/drawingml/2006/table">
-            <a:tbl>
-              <a:tblPr firstRow="1" bandRow="1">
-                <a:tableStyleId>{5C22544A-7EE6-4342-B048-85BDC9FD1C3A}</a:tableStyleId>
-              </a:tblPr>
-              <a:tblGrid>
-                <a:gridCol w="908225">
-                  <a:extLst>
-                    <a:ext uri="{9D8B030D-6E8A-4147-A177-3AD203B41FA5}">
-                      <a16:colId xmlns:a16="http://schemas.microsoft.com/office/drawing/2014/main" val="2306203329"/>
-                    </a:ext>
-                  </a:extLst>
-                </a:gridCol>
-                <a:gridCol w="3031958">
-                  <a:extLst>
-                    <a:ext uri="{9D8B030D-6E8A-4147-A177-3AD203B41FA5}">
-                      <a16:colId xmlns:a16="http://schemas.microsoft.com/office/drawing/2014/main" val="2541688145"/>
-                    </a:ext>
-                  </a:extLst>
-                </a:gridCol>
-                <a:gridCol w="2033256">
-                  <a:extLst>
-                    <a:ext uri="{9D8B030D-6E8A-4147-A177-3AD203B41FA5}">
-                      <a16:colId xmlns:a16="http://schemas.microsoft.com/office/drawing/2014/main" val="3557785877"/>
-                    </a:ext>
-                  </a:extLst>
-                </a:gridCol>
-                <a:gridCol w="2309947">
-                  <a:extLst>
-                    <a:ext uri="{9D8B030D-6E8A-4147-A177-3AD203B41FA5}">
-                      <a16:colId xmlns:a16="http://schemas.microsoft.com/office/drawing/2014/main" val="3224508020"/>
-                    </a:ext>
-                  </a:extLst>
-                </a:gridCol>
-              </a:tblGrid>
-              <a:tr h="226137">
-                <a:tc>
-                  <a:txBody>
-                    <a:bodyPr/>
-                    <a:lstStyle/>
-                    <a:p>
-                      <a:r>
-                        <a:rPr lang="fr-FR" sz="1000"/>
-                        <a:t>Type</a:t>
-                      </a:r>
-                    </a:p>
-                  </a:txBody>
-                  <a:tcPr/>
-                </a:tc>
-                <a:tc>
-                  <a:txBody>
-                    <a:bodyPr/>
-                    <a:lstStyle/>
-                    <a:p>
-                      <a:r>
-                        <a:rPr lang="fr-FR" sz="1000"/>
-                        <a:t>Description</a:t>
-                      </a:r>
-                    </a:p>
-                  </a:txBody>
-                  <a:tcPr/>
-                </a:tc>
-                <a:tc>
-                  <a:txBody>
-                    <a:bodyPr/>
-                    <a:lstStyle/>
-                    <a:p>
-                      <a:r>
-                        <a:rPr lang="fr-FR" sz="1000" dirty="0"/>
-                        <a:t>Commentaires</a:t>
-                      </a:r>
-                    </a:p>
-                  </a:txBody>
-                  <a:tcPr/>
-                </a:tc>
-                <a:tc>
-                  <a:txBody>
-                    <a:bodyPr/>
-                    <a:lstStyle/>
-                    <a:p>
-                      <a:r>
-                        <a:rPr lang="fr-FR" sz="1000"/>
-                        <a:t>Lien</a:t>
-                      </a:r>
-                    </a:p>
-                  </a:txBody>
-                  <a:tcPr/>
-                </a:tc>
-                <a:extLst>
-                  <a:ext uri="{0D108BD9-81ED-4DB2-BD59-A6C34878D82A}">
-                    <a16:rowId xmlns:a16="http://schemas.microsoft.com/office/drawing/2014/main" val="1404536746"/>
-                  </a:ext>
-                </a:extLst>
-              </a:tr>
-              <a:tr h="476255">
-                <a:tc>
-                  <a:txBody>
-                    <a:bodyPr/>
-                    <a:lstStyle/>
-                    <a:p>
-                      <a:r>
-                        <a:rPr lang="fr-FR" sz="800" dirty="0" err="1"/>
-                        <a:t>Dataset</a:t>
-                      </a:r>
-                      <a:endParaRPr lang="fr-FR" sz="800" dirty="0"/>
-                    </a:p>
-                  </a:txBody>
-                  <a:tcPr anchor="ctr"/>
-                </a:tc>
-                <a:tc>
-                  <a:txBody>
-                    <a:bodyPr/>
-                    <a:lstStyle/>
-                    <a:p>
-                      <a:r>
-                        <a:rPr lang="fr-FR" sz="900" b="1" dirty="0"/>
-                        <a:t>Données de production RTE</a:t>
-                      </a:r>
-                    </a:p>
-                  </a:txBody>
-                  <a:tcPr anchor="ctr"/>
-                </a:tc>
-                <a:tc>
-                  <a:txBody>
-                    <a:bodyPr/>
-                    <a:lstStyle/>
-                    <a:p>
-                      <a:r>
-                        <a:rPr lang="fr-FR" sz="900" dirty="0"/>
-                        <a:t>National : historique sur 14 ans</a:t>
-                      </a:r>
-                    </a:p>
-                    <a:p>
-                      <a:r>
-                        <a:rPr lang="fr-FR" sz="900" dirty="0"/>
-                        <a:t>Régional : historique sur 5 ans</a:t>
-                      </a:r>
-                    </a:p>
-                  </a:txBody>
-                  <a:tcPr anchor="ctr"/>
-                </a:tc>
-                <a:tc>
-                  <a:txBody>
-                    <a:bodyPr/>
-                    <a:lstStyle/>
-                    <a:p>
-                      <a:r>
-                        <a:rPr lang="fr-FR" sz="700" dirty="0">
-                          <a:hlinkClick r:id="rId4"/>
-                        </a:rPr>
-                        <a:t>https://www.rte-france.com/donnees-publications/eco2mix-donnees-temps-reel/telecharger-indicateurs</a:t>
-                      </a:r>
-                      <a:endParaRPr lang="fr-FR" sz="700" dirty="0"/>
-                    </a:p>
-                  </a:txBody>
-                  <a:tcPr anchor="ctr"/>
-                </a:tc>
-                <a:extLst>
-                  <a:ext uri="{0D108BD9-81ED-4DB2-BD59-A6C34878D82A}">
-                    <a16:rowId xmlns:a16="http://schemas.microsoft.com/office/drawing/2014/main" val="594868334"/>
-                  </a:ext>
-                </a:extLst>
-              </a:tr>
-              <a:tr h="476255">
-                <a:tc>
-                  <a:txBody>
-                    <a:bodyPr/>
-                    <a:lstStyle/>
-                    <a:p>
-                      <a:pPr marL="0" marR="0" lvl="0" indent="0" algn="l" defTabSz="914400" rtl="0" eaLnBrk="1" fontAlgn="auto" latinLnBrk="0" hangingPunct="1">
-                        <a:lnSpc>
-                          <a:spcPct val="100000"/>
-                        </a:lnSpc>
-                        <a:spcBef>
-                          <a:spcPts val="0"/>
-                        </a:spcBef>
-                        <a:spcAft>
-                          <a:spcPts val="0"/>
-                        </a:spcAft>
-                        <a:buClr>
-                          <a:srgbClr val="000000"/>
-                        </a:buClr>
-                        <a:buSzTx/>
-                        <a:buFont typeface="Arial"/>
-                        <a:buNone/>
-                        <a:tabLst/>
-                        <a:defRPr/>
-                      </a:pPr>
-                      <a:r>
-                        <a:rPr lang="fr-FR" sz="800" dirty="0" err="1"/>
-                        <a:t>Dataset</a:t>
-                      </a:r>
-                      <a:endParaRPr lang="fr-FR" sz="800" dirty="0"/>
-                    </a:p>
-                  </a:txBody>
-                  <a:tcPr anchor="ctr"/>
-                </a:tc>
-                <a:tc>
-                  <a:txBody>
-                    <a:bodyPr/>
-                    <a:lstStyle/>
-                    <a:p>
-                      <a:r>
-                        <a:rPr lang="fr-FR" sz="900" b="1" i="0" u="none" strike="noStrike" cap="none" dirty="0">
-                          <a:solidFill>
-                            <a:schemeClr val="dk1"/>
-                          </a:solidFill>
-                          <a:latin typeface="+mn-lt"/>
-                          <a:ea typeface="+mn-ea"/>
-                          <a:cs typeface="+mn-cs"/>
-                          <a:sym typeface="Arial"/>
-                        </a:rPr>
-                        <a:t>Imagerie satellite Landsat</a:t>
-                      </a:r>
-                    </a:p>
-                  </a:txBody>
-                  <a:tcPr anchor="ctr"/>
-                </a:tc>
-                <a:tc>
-                  <a:txBody>
-                    <a:bodyPr/>
-                    <a:lstStyle/>
-                    <a:p>
-                      <a:r>
-                        <a:rPr lang="fr-FR" sz="900" dirty="0"/>
-                        <a:t>Images satellites et métadonnées </a:t>
-                      </a:r>
-                    </a:p>
-                  </a:txBody>
-                  <a:tcPr anchor="ctr"/>
-                </a:tc>
-                <a:tc>
-                  <a:txBody>
-                    <a:bodyPr/>
-                    <a:lstStyle/>
-                    <a:p>
-                      <a:r>
-                        <a:rPr lang="fr-FR" sz="700" dirty="0">
-                          <a:hlinkClick r:id="rId5"/>
-                        </a:rPr>
-                        <a:t>https://code.usgs.gov/eros-user-services/accessing_landsat_data</a:t>
-                      </a:r>
-                      <a:endParaRPr lang="fr-FR" sz="700" dirty="0"/>
-                    </a:p>
-                  </a:txBody>
-                  <a:tcPr anchor="ctr"/>
-                </a:tc>
-                <a:extLst>
-                  <a:ext uri="{0D108BD9-81ED-4DB2-BD59-A6C34878D82A}">
-                    <a16:rowId xmlns:a16="http://schemas.microsoft.com/office/drawing/2014/main" val="506933637"/>
-                  </a:ext>
-                </a:extLst>
-              </a:tr>
-              <a:tr h="558690">
-                <a:tc>
-                  <a:txBody>
-                    <a:bodyPr/>
-                    <a:lstStyle/>
-                    <a:p>
-                      <a:pPr marL="0" marR="0" lvl="0" indent="0" algn="l" defTabSz="914400" rtl="0" eaLnBrk="1" fontAlgn="auto" latinLnBrk="0" hangingPunct="1">
-                        <a:lnSpc>
-                          <a:spcPct val="100000"/>
-                        </a:lnSpc>
-                        <a:spcBef>
-                          <a:spcPts val="0"/>
-                        </a:spcBef>
-                        <a:spcAft>
-                          <a:spcPts val="0"/>
-                        </a:spcAft>
-                        <a:buClr>
-                          <a:srgbClr val="000000"/>
-                        </a:buClr>
-                        <a:buSzTx/>
-                        <a:buFont typeface="Arial"/>
-                        <a:buNone/>
-                        <a:tabLst/>
-                        <a:defRPr/>
-                      </a:pPr>
-                      <a:r>
-                        <a:rPr lang="fr-FR" sz="800" dirty="0"/>
-                        <a:t>API</a:t>
-                      </a:r>
-                    </a:p>
-                  </a:txBody>
-                  <a:tcPr anchor="ctr"/>
-                </a:tc>
-                <a:tc>
-                  <a:txBody>
-                    <a:bodyPr/>
-                    <a:lstStyle/>
-                    <a:p>
-                      <a:pPr marL="0" marR="0" lvl="0" indent="0" algn="l" defTabSz="914400" rtl="0" eaLnBrk="1" fontAlgn="auto" latinLnBrk="0" hangingPunct="1">
-                        <a:lnSpc>
-                          <a:spcPct val="100000"/>
-                        </a:lnSpc>
-                        <a:spcBef>
-                          <a:spcPts val="0"/>
-                        </a:spcBef>
-                        <a:spcAft>
-                          <a:spcPts val="0"/>
-                        </a:spcAft>
-                        <a:buClr>
-                          <a:srgbClr val="000000"/>
-                        </a:buClr>
-                        <a:buSzTx/>
-                        <a:buFont typeface="Arial"/>
-                        <a:buNone/>
-                        <a:tabLst/>
-                        <a:defRPr/>
-                      </a:pPr>
-                      <a:r>
-                        <a:rPr lang="fr-FR" sz="900" b="1" dirty="0"/>
-                        <a:t>Données météo</a:t>
-                      </a:r>
-                    </a:p>
-                  </a:txBody>
-                  <a:tcPr anchor="ctr"/>
-                </a:tc>
-                <a:tc>
-                  <a:txBody>
-                    <a:bodyPr/>
-                    <a:lstStyle/>
-                    <a:p>
-                      <a:r>
-                        <a:rPr lang="fr-FR" sz="900" dirty="0"/>
-                        <a:t>Données historiques et données prédictives</a:t>
-                      </a:r>
-                    </a:p>
-                  </a:txBody>
-                  <a:tcPr anchor="ctr"/>
-                </a:tc>
-                <a:tc>
-                  <a:txBody>
-                    <a:bodyPr/>
-                    <a:lstStyle/>
-                    <a:p>
-                      <a:r>
-                        <a:rPr lang="fr-FR" sz="700" dirty="0">
-                          <a:hlinkClick r:id="rId6"/>
-                        </a:rPr>
-                        <a:t>https://openweathermap.org/api/one-call-3</a:t>
-                      </a:r>
-                      <a:endParaRPr lang="fr-FR" sz="700" dirty="0"/>
-                    </a:p>
-                  </a:txBody>
-                  <a:tcPr anchor="ctr"/>
-                </a:tc>
-                <a:extLst>
-                  <a:ext uri="{0D108BD9-81ED-4DB2-BD59-A6C34878D82A}">
-                    <a16:rowId xmlns:a16="http://schemas.microsoft.com/office/drawing/2014/main" val="2477866597"/>
-                  </a:ext>
-                </a:extLst>
-              </a:tr>
-              <a:tr h="558690">
-                <a:tc>
-                  <a:txBody>
-                    <a:bodyPr/>
-                    <a:lstStyle/>
-                    <a:p>
-                      <a:pPr marL="0" marR="0" lvl="0" indent="0" algn="l" defTabSz="914400" rtl="0" eaLnBrk="1" fontAlgn="auto" latinLnBrk="0" hangingPunct="1">
-                        <a:lnSpc>
-                          <a:spcPct val="100000"/>
-                        </a:lnSpc>
-                        <a:spcBef>
-                          <a:spcPts val="0"/>
-                        </a:spcBef>
-                        <a:spcAft>
-                          <a:spcPts val="0"/>
-                        </a:spcAft>
-                        <a:buClr>
-                          <a:srgbClr val="000000"/>
-                        </a:buClr>
-                        <a:buSzTx/>
-                        <a:buFont typeface="Arial"/>
-                        <a:buNone/>
-                        <a:tabLst/>
-                        <a:defRPr/>
-                      </a:pPr>
-                      <a:r>
-                        <a:rPr lang="fr-FR" sz="800" dirty="0" err="1"/>
-                        <a:t>Dataset</a:t>
-                      </a:r>
-                      <a:endParaRPr lang="fr-FR" sz="800" dirty="0"/>
-                    </a:p>
-                  </a:txBody>
-                  <a:tcPr anchor="ctr"/>
-                </a:tc>
-                <a:tc>
-                  <a:txBody>
-                    <a:bodyPr/>
-                    <a:lstStyle/>
-                    <a:p>
-                      <a:pPr marL="0" marR="0" lvl="0" indent="0" algn="l" defTabSz="914400" rtl="0" eaLnBrk="1" fontAlgn="auto" latinLnBrk="0" hangingPunct="1">
-                        <a:lnSpc>
-                          <a:spcPct val="100000"/>
-                        </a:lnSpc>
-                        <a:spcBef>
-                          <a:spcPts val="0"/>
-                        </a:spcBef>
-                        <a:spcAft>
-                          <a:spcPts val="0"/>
-                        </a:spcAft>
-                        <a:buClr>
-                          <a:srgbClr val="000000"/>
-                        </a:buClr>
-                        <a:buSzTx/>
-                        <a:buFont typeface="Arial"/>
-                        <a:buNone/>
-                        <a:tabLst/>
-                        <a:defRPr/>
-                      </a:pPr>
-                      <a:r>
-                        <a:rPr lang="fr-FR" sz="900" b="1" dirty="0"/>
-                        <a:t>Données activité solaire </a:t>
-                      </a:r>
-                    </a:p>
-                  </a:txBody>
-                  <a:tcPr anchor="ctr"/>
-                </a:tc>
-                <a:tc>
-                  <a:txBody>
-                    <a:bodyPr/>
-                    <a:lstStyle/>
-                    <a:p>
-                      <a:pPr marL="0" marR="0" lvl="0" indent="0" algn="l" defTabSz="914400" rtl="0" eaLnBrk="1" fontAlgn="auto" latinLnBrk="0" hangingPunct="1">
-                        <a:lnSpc>
-                          <a:spcPct val="100000"/>
-                        </a:lnSpc>
-                        <a:spcBef>
-                          <a:spcPts val="0"/>
-                        </a:spcBef>
-                        <a:spcAft>
-                          <a:spcPts val="0"/>
-                        </a:spcAft>
-                        <a:buClr>
-                          <a:srgbClr val="000000"/>
-                        </a:buClr>
-                        <a:buSzTx/>
-                        <a:buFont typeface="Arial"/>
-                        <a:buNone/>
-                        <a:tabLst/>
-                        <a:defRPr/>
-                      </a:pPr>
-                      <a:r>
-                        <a:rPr lang="fr-FR" sz="900" dirty="0"/>
-                        <a:t>Données historiques et données prédictives</a:t>
-                      </a:r>
-                    </a:p>
-                  </a:txBody>
-                  <a:tcPr anchor="ctr"/>
-                </a:tc>
-                <a:tc>
-                  <a:txBody>
-                    <a:bodyPr/>
-                    <a:lstStyle/>
-                    <a:p>
-                      <a:r>
-                        <a:rPr lang="fr-FR" sz="700" dirty="0">
-                          <a:hlinkClick r:id="rId7"/>
-                        </a:rPr>
-                        <a:t>https://www.ngdc.noaa.gov/stp/space-weather/swpc-products/daily_reports/solar_geophysical_activity_summaries/</a:t>
-                      </a:r>
-                      <a:endParaRPr lang="fr-FR" sz="700" dirty="0"/>
-                    </a:p>
-                    <a:p>
-                      <a:endParaRPr lang="fr-FR" sz="700" dirty="0"/>
-                    </a:p>
-                    <a:p>
-                      <a:r>
-                        <a:rPr lang="fr-FR" sz="700" dirty="0">
-                          <a:hlinkClick r:id="rId8"/>
-                        </a:rPr>
-                        <a:t>https://www.ngdc.noaa.gov/stp/space-weather/swpc-products/daily_reports/daypre/</a:t>
-                      </a:r>
-                      <a:endParaRPr lang="fr-FR" sz="700" dirty="0"/>
-                    </a:p>
-                  </a:txBody>
-                  <a:tcPr anchor="ctr"/>
-                </a:tc>
-                <a:extLst>
-                  <a:ext uri="{0D108BD9-81ED-4DB2-BD59-A6C34878D82A}">
-                    <a16:rowId xmlns:a16="http://schemas.microsoft.com/office/drawing/2014/main" val="2084688575"/>
-                  </a:ext>
-                </a:extLst>
-              </a:tr>
-            </a:tbl>
-          </a:graphicData>
-        </a:graphic>
-      </p:graphicFrame>
-    </p:spTree>
-    <p:extLst>
-      <p:ext uri="{BB962C8B-B14F-4D97-AF65-F5344CB8AC3E}">
-        <p14:creationId xmlns:p14="http://schemas.microsoft.com/office/powerpoint/2010/main" val="4010613788"/>
-      </p:ext>
-    </p:extLst>
-  </p:cSld>
-  <p:clrMapOvr>
-    <a:masterClrMapping/>
-  </p:clrMapOvr>
-</p:sld>
-</file>
-
-<file path=ppt/slides/slide17.xml><?xml version="1.0" encoding="utf-8"?>
 <p:sld xmlns:a="http://schemas.openxmlformats.org/drawingml/2006/main" xmlns:r="http://schemas.openxmlformats.org/officeDocument/2006/relationships" xmlns:p="http://schemas.openxmlformats.org/presentationml/2006/main">
   <p:cSld>
     <p:spTree>
@@ -24508,7 +23474,7 @@
 </p:sld>
 </file>
 
-<file path=ppt/slides/slide18.xml><?xml version="1.0" encoding="utf-8"?>
+<file path=ppt/slides/slide16.xml><?xml version="1.0" encoding="utf-8"?>
 <p:sld xmlns:a="http://schemas.openxmlformats.org/drawingml/2006/main" xmlns:r="http://schemas.openxmlformats.org/officeDocument/2006/relationships" xmlns:p="http://schemas.openxmlformats.org/presentationml/2006/main">
   <p:cSld>
     <p:spTree>
@@ -25913,6 +24879,1056 @@
     <p:extLst>
       <p:ext uri="{BB962C8B-B14F-4D97-AF65-F5344CB8AC3E}">
         <p14:creationId xmlns:p14="http://schemas.microsoft.com/office/powerpoint/2010/main" val="2552402859"/>
+      </p:ext>
+    </p:extLst>
+  </p:cSld>
+  <p:clrMapOvr>
+    <a:masterClrMapping/>
+  </p:clrMapOvr>
+</p:sld>
+</file>
+
+<file path=ppt/slides/slide17.xml><?xml version="1.0" encoding="utf-8"?>
+<p:sld xmlns:a="http://schemas.openxmlformats.org/drawingml/2006/main" xmlns:r="http://schemas.openxmlformats.org/officeDocument/2006/relationships" xmlns:p="http://schemas.openxmlformats.org/presentationml/2006/main">
+  <p:cSld>
+    <p:spTree>
+      <p:nvGrpSpPr>
+        <p:cNvPr id="1" name="Shape 95">
+          <a:extLst>
+            <a:ext uri="{FF2B5EF4-FFF2-40B4-BE49-F238E27FC236}">
+              <a16:creationId xmlns:a16="http://schemas.microsoft.com/office/drawing/2014/main" id="{06EDD131-5809-747C-6E95-185A073DB048}"/>
+            </a:ext>
+          </a:extLst>
+        </p:cNvPr>
+        <p:cNvGrpSpPr/>
+        <p:nvPr/>
+      </p:nvGrpSpPr>
+      <p:grpSpPr>
+        <a:xfrm>
+          <a:off x="0" y="0"/>
+          <a:ext cx="0" cy="0"/>
+          <a:chOff x="0" y="0"/>
+          <a:chExt cx="0" cy="0"/>
+        </a:xfrm>
+      </p:grpSpPr>
+      <p:sp>
+        <p:nvSpPr>
+          <p:cNvPr id="96" name="Google Shape;96;p5">
+            <a:extLst>
+              <a:ext uri="{FF2B5EF4-FFF2-40B4-BE49-F238E27FC236}">
+                <a16:creationId xmlns:a16="http://schemas.microsoft.com/office/drawing/2014/main" id="{CFE260F2-EC75-DDF8-CE55-329FB5D8E4C4}"/>
+              </a:ext>
+            </a:extLst>
+          </p:cNvPr>
+          <p:cNvSpPr txBox="1">
+            <a:spLocks noGrp="1"/>
+          </p:cNvSpPr>
+          <p:nvPr>
+            <p:ph type="ctrTitle" idx="4294967295"/>
+          </p:nvPr>
+        </p:nvSpPr>
+        <p:spPr>
+          <a:xfrm>
+            <a:off x="1192664" y="403309"/>
+            <a:ext cx="5315100" cy="533100"/>
+          </a:xfrm>
+          <a:prstGeom prst="rect">
+            <a:avLst/>
+          </a:prstGeom>
+          <a:noFill/>
+          <a:ln>
+            <a:noFill/>
+          </a:ln>
+        </p:spPr>
+        <p:txBody>
+          <a:bodyPr spcFirstLastPara="1" wrap="square" lIns="91425" tIns="91425" rIns="91425" bIns="91425" anchor="t" anchorCtr="0">
+            <a:noAutofit/>
+          </a:bodyPr>
+          <a:lstStyle/>
+          <a:p>
+            <a:pPr marL="0" marR="0" lvl="0" indent="0" algn="l" rtl="0">
+              <a:lnSpc>
+                <a:spcPct val="100000"/>
+              </a:lnSpc>
+              <a:spcBef>
+                <a:spcPts val="0"/>
+              </a:spcBef>
+              <a:spcAft>
+                <a:spcPts val="0"/>
+              </a:spcAft>
+              <a:buClr>
+                <a:schemeClr val="dk1"/>
+              </a:buClr>
+              <a:buSzPts val="2800"/>
+              <a:buFont typeface="Arial"/>
+              <a:buNone/>
+            </a:pPr>
+            <a:r>
+              <a:rPr lang="it-IT" sz="2500" i="0" u="none" strike="noStrike" cap="none" dirty="0">
+                <a:solidFill>
+                  <a:srgbClr val="0E3449"/>
+                </a:solidFill>
+                <a:latin typeface="Inter SemiBold"/>
+                <a:ea typeface="Inter SemiBold"/>
+                <a:cs typeface="Inter SemiBold"/>
+                <a:sym typeface="Inter SemiBold"/>
+              </a:rPr>
+              <a:t>Ressourses projet</a:t>
+            </a:r>
+          </a:p>
+        </p:txBody>
+      </p:sp>
+      <p:pic>
+        <p:nvPicPr>
+          <p:cNvPr id="97" name="Google Shape;97;p5">
+            <a:extLst>
+              <a:ext uri="{FF2B5EF4-FFF2-40B4-BE49-F238E27FC236}">
+                <a16:creationId xmlns:a16="http://schemas.microsoft.com/office/drawing/2014/main" id="{66739ED7-F6B1-16FF-21A5-52FBD2C06D52}"/>
+              </a:ext>
+            </a:extLst>
+          </p:cNvPr>
+          <p:cNvPicPr preferRelativeResize="0"/>
+          <p:nvPr/>
+        </p:nvPicPr>
+        <p:blipFill rotWithShape="1">
+          <a:blip r:embed="rId3">
+            <a:alphaModFix/>
+          </a:blip>
+          <a:srcRect/>
+          <a:stretch/>
+        </p:blipFill>
+        <p:spPr>
+          <a:xfrm>
+            <a:off x="463375" y="482852"/>
+            <a:ext cx="576900" cy="385904"/>
+          </a:xfrm>
+          <a:prstGeom prst="rect">
+            <a:avLst/>
+          </a:prstGeom>
+          <a:noFill/>
+          <a:ln>
+            <a:noFill/>
+          </a:ln>
+        </p:spPr>
+      </p:pic>
+      <p:sp>
+        <p:nvSpPr>
+          <p:cNvPr id="98" name="Google Shape;98;p5">
+            <a:extLst>
+              <a:ext uri="{FF2B5EF4-FFF2-40B4-BE49-F238E27FC236}">
+                <a16:creationId xmlns:a16="http://schemas.microsoft.com/office/drawing/2014/main" id="{CF1380DA-0568-3714-99DF-1C8C31BCE89D}"/>
+              </a:ext>
+            </a:extLst>
+          </p:cNvPr>
+          <p:cNvSpPr/>
+          <p:nvPr/>
+        </p:nvSpPr>
+        <p:spPr>
+          <a:xfrm>
+            <a:off x="10225" y="4892025"/>
+            <a:ext cx="9144000" cy="251400"/>
+          </a:xfrm>
+          <a:prstGeom prst="rect">
+            <a:avLst/>
+          </a:prstGeom>
+          <a:solidFill>
+            <a:srgbClr val="C3FFFC"/>
+          </a:solidFill>
+          <a:ln>
+            <a:noFill/>
+          </a:ln>
+        </p:spPr>
+        <p:txBody>
+          <a:bodyPr spcFirstLastPara="1" wrap="square" lIns="91425" tIns="91425" rIns="91425" bIns="91425" anchor="ctr" anchorCtr="0">
+            <a:noAutofit/>
+          </a:bodyPr>
+          <a:lstStyle/>
+          <a:p>
+            <a:pPr marL="0" marR="0" lvl="0" indent="0" algn="l" rtl="0">
+              <a:lnSpc>
+                <a:spcPct val="100000"/>
+              </a:lnSpc>
+              <a:spcBef>
+                <a:spcPts val="0"/>
+              </a:spcBef>
+              <a:spcAft>
+                <a:spcPts val="0"/>
+              </a:spcAft>
+              <a:buClr>
+                <a:srgbClr val="000000"/>
+              </a:buClr>
+              <a:buSzPts val="1400"/>
+              <a:buFont typeface="Arial"/>
+              <a:buNone/>
+            </a:pPr>
+            <a:endParaRPr sz="1400" b="0" i="0" u="none" strike="noStrike" cap="none">
+              <a:solidFill>
+                <a:srgbClr val="000000"/>
+              </a:solidFill>
+              <a:latin typeface="Arial"/>
+              <a:ea typeface="Arial"/>
+              <a:cs typeface="Arial"/>
+              <a:sym typeface="Arial"/>
+            </a:endParaRPr>
+          </a:p>
+        </p:txBody>
+      </p:sp>
+      <p:sp>
+        <p:nvSpPr>
+          <p:cNvPr id="4" name="Google Shape;181;p8">
+            <a:extLst>
+              <a:ext uri="{FF2B5EF4-FFF2-40B4-BE49-F238E27FC236}">
+                <a16:creationId xmlns:a16="http://schemas.microsoft.com/office/drawing/2014/main" id="{9EF8D937-D220-A74B-8191-12E681FE1A08}"/>
+              </a:ext>
+            </a:extLst>
+          </p:cNvPr>
+          <p:cNvSpPr txBox="1">
+            <a:spLocks noGrp="1"/>
+          </p:cNvSpPr>
+          <p:nvPr>
+            <p:ph type="body" idx="1"/>
+          </p:nvPr>
+        </p:nvSpPr>
+        <p:spPr>
+          <a:xfrm>
+            <a:off x="311700" y="1155049"/>
+            <a:ext cx="8520600" cy="3585142"/>
+          </a:xfrm>
+          <a:prstGeom prst="rect">
+            <a:avLst/>
+          </a:prstGeom>
+          <a:noFill/>
+          <a:ln>
+            <a:noFill/>
+          </a:ln>
+        </p:spPr>
+        <p:txBody>
+          <a:bodyPr spcFirstLastPara="1" wrap="square" lIns="91425" tIns="91425" rIns="91425" bIns="91425" anchor="t" anchorCtr="0">
+            <a:noAutofit/>
+          </a:bodyPr>
+          <a:lstStyle/>
+          <a:p>
+            <a:pPr marL="114300" lvl="0" indent="0">
+              <a:spcBef>
+                <a:spcPts val="1200"/>
+              </a:spcBef>
+              <a:buNone/>
+            </a:pPr>
+            <a:r>
+              <a:rPr lang="fr-FR" sz="1400" b="1" dirty="0"/>
+              <a:t>Lien </a:t>
+            </a:r>
+            <a:r>
+              <a:rPr lang="fr-FR" sz="1400" b="1" dirty="0" err="1"/>
+              <a:t>Github</a:t>
+            </a:r>
+            <a:r>
+              <a:rPr lang="fr-FR" sz="1400" b="1" dirty="0"/>
+              <a:t> : </a:t>
+            </a:r>
+            <a:r>
+              <a:rPr lang="fr-FR" sz="1400" dirty="0">
+                <a:hlinkClick r:id="rId4"/>
+              </a:rPr>
+              <a:t>https://github.com/Sheikoh/REnergies_efficiency_prediction.git</a:t>
+            </a:r>
+            <a:endParaRPr lang="fr-FR" sz="1400" dirty="0"/>
+          </a:p>
+          <a:p>
+            <a:pPr marL="114300" lvl="0" indent="0">
+              <a:spcBef>
+                <a:spcPts val="1200"/>
+              </a:spcBef>
+              <a:buNone/>
+            </a:pPr>
+            <a:r>
+              <a:rPr lang="fr-FR" sz="1400" b="1" dirty="0"/>
+              <a:t>Lien Dashboard : </a:t>
+            </a:r>
+            <a:r>
+              <a:rPr lang="fr-FR" sz="1400" dirty="0">
+                <a:hlinkClick r:id="rId5"/>
+              </a:rPr>
+              <a:t>https://renergies99-dashboard.hf.space/</a:t>
+            </a:r>
+            <a:endParaRPr lang="fr-FR" sz="1400" dirty="0"/>
+          </a:p>
+          <a:p>
+            <a:pPr marL="114300" lvl="0" indent="0">
+              <a:spcBef>
+                <a:spcPts val="1200"/>
+              </a:spcBef>
+              <a:buNone/>
+            </a:pPr>
+            <a:r>
+              <a:rPr lang="fr-FR" sz="1400" b="1" dirty="0"/>
+              <a:t>Lien </a:t>
+            </a:r>
+            <a:r>
+              <a:rPr lang="fr-FR" sz="1400" b="1" dirty="0" err="1"/>
+              <a:t>Mlflow</a:t>
+            </a:r>
+            <a:r>
+              <a:rPr lang="fr-FR" sz="1400" b="1" dirty="0"/>
+              <a:t> : </a:t>
+            </a:r>
+            <a:r>
+              <a:rPr lang="fr-FR" sz="1400" dirty="0">
+                <a:hlinkClick r:id="rId6"/>
+              </a:rPr>
+              <a:t>https://renergies99-mlflow.hf.space/</a:t>
+            </a:r>
+            <a:endParaRPr lang="fr-FR" sz="1400" dirty="0"/>
+          </a:p>
+          <a:p>
+            <a:pPr marL="114300" lvl="0" indent="0">
+              <a:spcBef>
+                <a:spcPts val="1200"/>
+              </a:spcBef>
+              <a:buNone/>
+            </a:pPr>
+            <a:r>
+              <a:rPr lang="fr-FR" sz="1400" b="1" dirty="0"/>
+              <a:t>Lien API : </a:t>
+            </a:r>
+            <a:r>
+              <a:rPr lang="fr-FR" sz="1400" dirty="0">
+                <a:hlinkClick r:id="rId7"/>
+              </a:rPr>
+              <a:t>https://renergies99-api-renergy.hf.space/</a:t>
+            </a:r>
+            <a:endParaRPr lang="fr-FR" sz="1400" dirty="0"/>
+          </a:p>
+          <a:p>
+            <a:pPr marL="114300" lvl="0" indent="0">
+              <a:buNone/>
+            </a:pPr>
+            <a:endParaRPr lang="fr-FR" sz="1400" dirty="0"/>
+          </a:p>
+          <a:p>
+            <a:pPr marL="114300" lvl="0" indent="0">
+              <a:buNone/>
+            </a:pPr>
+            <a:endParaRPr sz="1400" dirty="0"/>
+          </a:p>
+        </p:txBody>
+      </p:sp>
+    </p:spTree>
+    <p:extLst>
+      <p:ext uri="{BB962C8B-B14F-4D97-AF65-F5344CB8AC3E}">
+        <p14:creationId xmlns:p14="http://schemas.microsoft.com/office/powerpoint/2010/main" val="4088050223"/>
+      </p:ext>
+    </p:extLst>
+  </p:cSld>
+  <p:clrMapOvr>
+    <a:masterClrMapping/>
+  </p:clrMapOvr>
+</p:sld>
+</file>
+
+<file path=ppt/slides/slide18.xml><?xml version="1.0" encoding="utf-8"?>
+<p:sld xmlns:a="http://schemas.openxmlformats.org/drawingml/2006/main" xmlns:r="http://schemas.openxmlformats.org/officeDocument/2006/relationships" xmlns:p="http://schemas.openxmlformats.org/presentationml/2006/main">
+  <p:cSld>
+    <p:spTree>
+      <p:nvGrpSpPr>
+        <p:cNvPr id="1" name="Shape 95">
+          <a:extLst>
+            <a:ext uri="{FF2B5EF4-FFF2-40B4-BE49-F238E27FC236}">
+              <a16:creationId xmlns:a16="http://schemas.microsoft.com/office/drawing/2014/main" id="{54B39E8E-2AB4-298D-C3FD-3B563ED89E4A}"/>
+            </a:ext>
+          </a:extLst>
+        </p:cNvPr>
+        <p:cNvGrpSpPr/>
+        <p:nvPr/>
+      </p:nvGrpSpPr>
+      <p:grpSpPr>
+        <a:xfrm>
+          <a:off x="0" y="0"/>
+          <a:ext cx="0" cy="0"/>
+          <a:chOff x="0" y="0"/>
+          <a:chExt cx="0" cy="0"/>
+        </a:xfrm>
+      </p:grpSpPr>
+      <p:sp>
+        <p:nvSpPr>
+          <p:cNvPr id="96" name="Google Shape;96;p5">
+            <a:extLst>
+              <a:ext uri="{FF2B5EF4-FFF2-40B4-BE49-F238E27FC236}">
+                <a16:creationId xmlns:a16="http://schemas.microsoft.com/office/drawing/2014/main" id="{A01AE6FF-5294-F6EC-FB0D-D63D7D63D71C}"/>
+              </a:ext>
+            </a:extLst>
+          </p:cNvPr>
+          <p:cNvSpPr txBox="1">
+            <a:spLocks noGrp="1"/>
+          </p:cNvSpPr>
+          <p:nvPr>
+            <p:ph type="ctrTitle" idx="4294967295"/>
+          </p:nvPr>
+        </p:nvSpPr>
+        <p:spPr>
+          <a:xfrm>
+            <a:off x="1192664" y="403309"/>
+            <a:ext cx="5315100" cy="533100"/>
+          </a:xfrm>
+          <a:prstGeom prst="rect">
+            <a:avLst/>
+          </a:prstGeom>
+          <a:noFill/>
+          <a:ln>
+            <a:noFill/>
+          </a:ln>
+        </p:spPr>
+        <p:txBody>
+          <a:bodyPr spcFirstLastPara="1" wrap="square" lIns="91425" tIns="91425" rIns="91425" bIns="91425" anchor="t" anchorCtr="0">
+            <a:noAutofit/>
+          </a:bodyPr>
+          <a:lstStyle/>
+          <a:p>
+            <a:pPr marL="0" marR="0" lvl="0" indent="0" algn="l" rtl="0">
+              <a:lnSpc>
+                <a:spcPct val="100000"/>
+              </a:lnSpc>
+              <a:spcBef>
+                <a:spcPts val="0"/>
+              </a:spcBef>
+              <a:spcAft>
+                <a:spcPts val="0"/>
+              </a:spcAft>
+              <a:buClr>
+                <a:schemeClr val="dk1"/>
+              </a:buClr>
+              <a:buSzPts val="2800"/>
+              <a:buFont typeface="Arial"/>
+              <a:buNone/>
+            </a:pPr>
+            <a:r>
+              <a:rPr lang="it-IT" sz="2500" i="0" u="none" strike="noStrike" cap="none" dirty="0">
+                <a:solidFill>
+                  <a:srgbClr val="0E3449"/>
+                </a:solidFill>
+                <a:latin typeface="Inter SemiBold"/>
+                <a:ea typeface="Inter SemiBold"/>
+                <a:cs typeface="Inter SemiBold"/>
+                <a:sym typeface="Inter SemiBold"/>
+              </a:rPr>
+              <a:t>Sources de données</a:t>
+            </a:r>
+          </a:p>
+        </p:txBody>
+      </p:sp>
+      <p:pic>
+        <p:nvPicPr>
+          <p:cNvPr id="97" name="Google Shape;97;p5">
+            <a:extLst>
+              <a:ext uri="{FF2B5EF4-FFF2-40B4-BE49-F238E27FC236}">
+                <a16:creationId xmlns:a16="http://schemas.microsoft.com/office/drawing/2014/main" id="{7FFB1AFA-ABA9-029D-77BD-FB2682A2296B}"/>
+              </a:ext>
+            </a:extLst>
+          </p:cNvPr>
+          <p:cNvPicPr preferRelativeResize="0"/>
+          <p:nvPr/>
+        </p:nvPicPr>
+        <p:blipFill rotWithShape="1">
+          <a:blip r:embed="rId3">
+            <a:alphaModFix/>
+          </a:blip>
+          <a:srcRect/>
+          <a:stretch/>
+        </p:blipFill>
+        <p:spPr>
+          <a:xfrm>
+            <a:off x="463375" y="482852"/>
+            <a:ext cx="576900" cy="385904"/>
+          </a:xfrm>
+          <a:prstGeom prst="rect">
+            <a:avLst/>
+          </a:prstGeom>
+          <a:noFill/>
+          <a:ln>
+            <a:noFill/>
+          </a:ln>
+        </p:spPr>
+      </p:pic>
+      <p:sp>
+        <p:nvSpPr>
+          <p:cNvPr id="98" name="Google Shape;98;p5">
+            <a:extLst>
+              <a:ext uri="{FF2B5EF4-FFF2-40B4-BE49-F238E27FC236}">
+                <a16:creationId xmlns:a16="http://schemas.microsoft.com/office/drawing/2014/main" id="{33F93AD1-3891-482A-2CFB-204DAC688B8B}"/>
+              </a:ext>
+            </a:extLst>
+          </p:cNvPr>
+          <p:cNvSpPr/>
+          <p:nvPr/>
+        </p:nvSpPr>
+        <p:spPr>
+          <a:xfrm>
+            <a:off x="10225" y="4892025"/>
+            <a:ext cx="9144000" cy="251400"/>
+          </a:xfrm>
+          <a:prstGeom prst="rect">
+            <a:avLst/>
+          </a:prstGeom>
+          <a:solidFill>
+            <a:srgbClr val="C3FFFC"/>
+          </a:solidFill>
+          <a:ln>
+            <a:noFill/>
+          </a:ln>
+        </p:spPr>
+        <p:txBody>
+          <a:bodyPr spcFirstLastPara="1" wrap="square" lIns="91425" tIns="91425" rIns="91425" bIns="91425" anchor="ctr" anchorCtr="0">
+            <a:noAutofit/>
+          </a:bodyPr>
+          <a:lstStyle/>
+          <a:p>
+            <a:pPr marL="0" marR="0" lvl="0" indent="0" algn="l" rtl="0">
+              <a:lnSpc>
+                <a:spcPct val="100000"/>
+              </a:lnSpc>
+              <a:spcBef>
+                <a:spcPts val="0"/>
+              </a:spcBef>
+              <a:spcAft>
+                <a:spcPts val="0"/>
+              </a:spcAft>
+              <a:buClr>
+                <a:srgbClr val="000000"/>
+              </a:buClr>
+              <a:buSzPts val="1400"/>
+              <a:buFont typeface="Arial"/>
+              <a:buNone/>
+            </a:pPr>
+            <a:endParaRPr sz="1400" b="0" i="0" u="none" strike="noStrike" cap="none">
+              <a:solidFill>
+                <a:srgbClr val="000000"/>
+              </a:solidFill>
+              <a:latin typeface="Arial"/>
+              <a:ea typeface="Arial"/>
+              <a:cs typeface="Arial"/>
+              <a:sym typeface="Arial"/>
+            </a:endParaRPr>
+          </a:p>
+        </p:txBody>
+      </p:sp>
+      <p:graphicFrame>
+        <p:nvGraphicFramePr>
+          <p:cNvPr id="2" name="Tableau 1">
+            <a:extLst>
+              <a:ext uri="{FF2B5EF4-FFF2-40B4-BE49-F238E27FC236}">
+                <a16:creationId xmlns:a16="http://schemas.microsoft.com/office/drawing/2014/main" id="{1F110593-1E38-6872-65AA-F9F3DBB52889}"/>
+              </a:ext>
+            </a:extLst>
+          </p:cNvPr>
+          <p:cNvGraphicFramePr>
+            <a:graphicFrameLocks noGrp="1"/>
+          </p:cNvGraphicFramePr>
+          <p:nvPr>
+            <p:extLst>
+              <p:ext uri="{D42A27DB-BD31-4B8C-83A1-F6EECF244321}">
+                <p14:modId xmlns:p14="http://schemas.microsoft.com/office/powerpoint/2010/main" val="2643252541"/>
+              </p:ext>
+            </p:extLst>
+          </p:nvPr>
+        </p:nvGraphicFramePr>
+        <p:xfrm>
+          <a:off x="463375" y="1160010"/>
+          <a:ext cx="8283386" cy="2486560"/>
+        </p:xfrm>
+        <a:graphic>
+          <a:graphicData uri="http://schemas.openxmlformats.org/drawingml/2006/table">
+            <a:tbl>
+              <a:tblPr firstRow="1" bandRow="1">
+                <a:tableStyleId>{5C22544A-7EE6-4342-B048-85BDC9FD1C3A}</a:tableStyleId>
+              </a:tblPr>
+              <a:tblGrid>
+                <a:gridCol w="908225">
+                  <a:extLst>
+                    <a:ext uri="{9D8B030D-6E8A-4147-A177-3AD203B41FA5}">
+                      <a16:colId xmlns:a16="http://schemas.microsoft.com/office/drawing/2014/main" val="2306203329"/>
+                    </a:ext>
+                  </a:extLst>
+                </a:gridCol>
+                <a:gridCol w="3031958">
+                  <a:extLst>
+                    <a:ext uri="{9D8B030D-6E8A-4147-A177-3AD203B41FA5}">
+                      <a16:colId xmlns:a16="http://schemas.microsoft.com/office/drawing/2014/main" val="2541688145"/>
+                    </a:ext>
+                  </a:extLst>
+                </a:gridCol>
+                <a:gridCol w="2033256">
+                  <a:extLst>
+                    <a:ext uri="{9D8B030D-6E8A-4147-A177-3AD203B41FA5}">
+                      <a16:colId xmlns:a16="http://schemas.microsoft.com/office/drawing/2014/main" val="3557785877"/>
+                    </a:ext>
+                  </a:extLst>
+                </a:gridCol>
+                <a:gridCol w="2309947">
+                  <a:extLst>
+                    <a:ext uri="{9D8B030D-6E8A-4147-A177-3AD203B41FA5}">
+                      <a16:colId xmlns:a16="http://schemas.microsoft.com/office/drawing/2014/main" val="3224508020"/>
+                    </a:ext>
+                  </a:extLst>
+                </a:gridCol>
+              </a:tblGrid>
+              <a:tr h="226137">
+                <a:tc>
+                  <a:txBody>
+                    <a:bodyPr/>
+                    <a:lstStyle/>
+                    <a:p>
+                      <a:r>
+                        <a:rPr lang="fr-FR" sz="1000"/>
+                        <a:t>Type</a:t>
+                      </a:r>
+                    </a:p>
+                  </a:txBody>
+                  <a:tcPr/>
+                </a:tc>
+                <a:tc>
+                  <a:txBody>
+                    <a:bodyPr/>
+                    <a:lstStyle/>
+                    <a:p>
+                      <a:r>
+                        <a:rPr lang="fr-FR" sz="1000"/>
+                        <a:t>Description</a:t>
+                      </a:r>
+                    </a:p>
+                  </a:txBody>
+                  <a:tcPr/>
+                </a:tc>
+                <a:tc>
+                  <a:txBody>
+                    <a:bodyPr/>
+                    <a:lstStyle/>
+                    <a:p>
+                      <a:r>
+                        <a:rPr lang="fr-FR" sz="1000" dirty="0"/>
+                        <a:t>Commentaires</a:t>
+                      </a:r>
+                    </a:p>
+                  </a:txBody>
+                  <a:tcPr/>
+                </a:tc>
+                <a:tc>
+                  <a:txBody>
+                    <a:bodyPr/>
+                    <a:lstStyle/>
+                    <a:p>
+                      <a:r>
+                        <a:rPr lang="fr-FR" sz="1000"/>
+                        <a:t>Lien</a:t>
+                      </a:r>
+                    </a:p>
+                  </a:txBody>
+                  <a:tcPr/>
+                </a:tc>
+                <a:extLst>
+                  <a:ext uri="{0D108BD9-81ED-4DB2-BD59-A6C34878D82A}">
+                    <a16:rowId xmlns:a16="http://schemas.microsoft.com/office/drawing/2014/main" val="1404536746"/>
+                  </a:ext>
+                </a:extLst>
+              </a:tr>
+              <a:tr h="476255">
+                <a:tc>
+                  <a:txBody>
+                    <a:bodyPr/>
+                    <a:lstStyle/>
+                    <a:p>
+                      <a:r>
+                        <a:rPr lang="fr-FR" sz="800" dirty="0" err="1"/>
+                        <a:t>Dataset</a:t>
+                      </a:r>
+                      <a:endParaRPr lang="fr-FR" sz="800" dirty="0"/>
+                    </a:p>
+                  </a:txBody>
+                  <a:tcPr anchor="ctr"/>
+                </a:tc>
+                <a:tc>
+                  <a:txBody>
+                    <a:bodyPr/>
+                    <a:lstStyle/>
+                    <a:p>
+                      <a:r>
+                        <a:rPr lang="fr-FR" sz="900" b="1" dirty="0"/>
+                        <a:t>Données de production RTE</a:t>
+                      </a:r>
+                    </a:p>
+                  </a:txBody>
+                  <a:tcPr anchor="ctr"/>
+                </a:tc>
+                <a:tc>
+                  <a:txBody>
+                    <a:bodyPr/>
+                    <a:lstStyle/>
+                    <a:p>
+                      <a:r>
+                        <a:rPr lang="fr-FR" sz="900" dirty="0"/>
+                        <a:t>National : historique sur 14 ans</a:t>
+                      </a:r>
+                    </a:p>
+                    <a:p>
+                      <a:r>
+                        <a:rPr lang="fr-FR" sz="900" dirty="0"/>
+                        <a:t>Régional : historique sur 5 ans</a:t>
+                      </a:r>
+                    </a:p>
+                  </a:txBody>
+                  <a:tcPr anchor="ctr"/>
+                </a:tc>
+                <a:tc>
+                  <a:txBody>
+                    <a:bodyPr/>
+                    <a:lstStyle/>
+                    <a:p>
+                      <a:r>
+                        <a:rPr lang="fr-FR" sz="700" dirty="0">
+                          <a:hlinkClick r:id="rId4"/>
+                        </a:rPr>
+                        <a:t>https://www.rte-france.com/donnees-publications/eco2mix-donnees-temps-reel/telecharger-indicateurs</a:t>
+                      </a:r>
+                      <a:endParaRPr lang="fr-FR" sz="700" dirty="0"/>
+                    </a:p>
+                  </a:txBody>
+                  <a:tcPr anchor="ctr"/>
+                </a:tc>
+                <a:extLst>
+                  <a:ext uri="{0D108BD9-81ED-4DB2-BD59-A6C34878D82A}">
+                    <a16:rowId xmlns:a16="http://schemas.microsoft.com/office/drawing/2014/main" val="594868334"/>
+                  </a:ext>
+                </a:extLst>
+              </a:tr>
+              <a:tr h="476255">
+                <a:tc>
+                  <a:txBody>
+                    <a:bodyPr/>
+                    <a:lstStyle/>
+                    <a:p>
+                      <a:pPr marL="0" marR="0" lvl="0" indent="0" algn="l" defTabSz="914400" rtl="0" eaLnBrk="1" fontAlgn="auto" latinLnBrk="0" hangingPunct="1">
+                        <a:lnSpc>
+                          <a:spcPct val="100000"/>
+                        </a:lnSpc>
+                        <a:spcBef>
+                          <a:spcPts val="0"/>
+                        </a:spcBef>
+                        <a:spcAft>
+                          <a:spcPts val="0"/>
+                        </a:spcAft>
+                        <a:buClr>
+                          <a:srgbClr val="000000"/>
+                        </a:buClr>
+                        <a:buSzTx/>
+                        <a:buFont typeface="Arial"/>
+                        <a:buNone/>
+                        <a:tabLst/>
+                        <a:defRPr/>
+                      </a:pPr>
+                      <a:r>
+                        <a:rPr lang="fr-FR" sz="800" dirty="0" err="1"/>
+                        <a:t>Dataset</a:t>
+                      </a:r>
+                      <a:endParaRPr lang="fr-FR" sz="800" dirty="0"/>
+                    </a:p>
+                  </a:txBody>
+                  <a:tcPr anchor="ctr"/>
+                </a:tc>
+                <a:tc>
+                  <a:txBody>
+                    <a:bodyPr/>
+                    <a:lstStyle/>
+                    <a:p>
+                      <a:r>
+                        <a:rPr lang="fr-FR" sz="900" b="1" i="0" u="none" strike="noStrike" cap="none" dirty="0">
+                          <a:solidFill>
+                            <a:schemeClr val="dk1"/>
+                          </a:solidFill>
+                          <a:latin typeface="+mn-lt"/>
+                          <a:ea typeface="+mn-ea"/>
+                          <a:cs typeface="+mn-cs"/>
+                          <a:sym typeface="Arial"/>
+                        </a:rPr>
+                        <a:t>Imagerie satellite Landsat</a:t>
+                      </a:r>
+                    </a:p>
+                  </a:txBody>
+                  <a:tcPr anchor="ctr"/>
+                </a:tc>
+                <a:tc>
+                  <a:txBody>
+                    <a:bodyPr/>
+                    <a:lstStyle/>
+                    <a:p>
+                      <a:r>
+                        <a:rPr lang="fr-FR" sz="900" dirty="0"/>
+                        <a:t>Images satellites et métadonnées </a:t>
+                      </a:r>
+                    </a:p>
+                  </a:txBody>
+                  <a:tcPr anchor="ctr"/>
+                </a:tc>
+                <a:tc>
+                  <a:txBody>
+                    <a:bodyPr/>
+                    <a:lstStyle/>
+                    <a:p>
+                      <a:r>
+                        <a:rPr lang="fr-FR" sz="700" dirty="0">
+                          <a:hlinkClick r:id="rId5"/>
+                        </a:rPr>
+                        <a:t>https://code.usgs.gov/eros-user-services/accessing_landsat_data</a:t>
+                      </a:r>
+                      <a:endParaRPr lang="fr-FR" sz="700" dirty="0"/>
+                    </a:p>
+                  </a:txBody>
+                  <a:tcPr anchor="ctr"/>
+                </a:tc>
+                <a:extLst>
+                  <a:ext uri="{0D108BD9-81ED-4DB2-BD59-A6C34878D82A}">
+                    <a16:rowId xmlns:a16="http://schemas.microsoft.com/office/drawing/2014/main" val="506933637"/>
+                  </a:ext>
+                </a:extLst>
+              </a:tr>
+              <a:tr h="558690">
+                <a:tc>
+                  <a:txBody>
+                    <a:bodyPr/>
+                    <a:lstStyle/>
+                    <a:p>
+                      <a:pPr marL="0" marR="0" lvl="0" indent="0" algn="l" defTabSz="914400" rtl="0" eaLnBrk="1" fontAlgn="auto" latinLnBrk="0" hangingPunct="1">
+                        <a:lnSpc>
+                          <a:spcPct val="100000"/>
+                        </a:lnSpc>
+                        <a:spcBef>
+                          <a:spcPts val="0"/>
+                        </a:spcBef>
+                        <a:spcAft>
+                          <a:spcPts val="0"/>
+                        </a:spcAft>
+                        <a:buClr>
+                          <a:srgbClr val="000000"/>
+                        </a:buClr>
+                        <a:buSzTx/>
+                        <a:buFont typeface="Arial"/>
+                        <a:buNone/>
+                        <a:tabLst/>
+                        <a:defRPr/>
+                      </a:pPr>
+                      <a:r>
+                        <a:rPr lang="fr-FR" sz="800" dirty="0"/>
+                        <a:t>API</a:t>
+                      </a:r>
+                    </a:p>
+                  </a:txBody>
+                  <a:tcPr anchor="ctr"/>
+                </a:tc>
+                <a:tc>
+                  <a:txBody>
+                    <a:bodyPr/>
+                    <a:lstStyle/>
+                    <a:p>
+                      <a:pPr marL="0" marR="0" lvl="0" indent="0" algn="l" defTabSz="914400" rtl="0" eaLnBrk="1" fontAlgn="auto" latinLnBrk="0" hangingPunct="1">
+                        <a:lnSpc>
+                          <a:spcPct val="100000"/>
+                        </a:lnSpc>
+                        <a:spcBef>
+                          <a:spcPts val="0"/>
+                        </a:spcBef>
+                        <a:spcAft>
+                          <a:spcPts val="0"/>
+                        </a:spcAft>
+                        <a:buClr>
+                          <a:srgbClr val="000000"/>
+                        </a:buClr>
+                        <a:buSzTx/>
+                        <a:buFont typeface="Arial"/>
+                        <a:buNone/>
+                        <a:tabLst/>
+                        <a:defRPr/>
+                      </a:pPr>
+                      <a:r>
+                        <a:rPr lang="fr-FR" sz="900" b="1" dirty="0"/>
+                        <a:t>Données météo</a:t>
+                      </a:r>
+                    </a:p>
+                  </a:txBody>
+                  <a:tcPr anchor="ctr"/>
+                </a:tc>
+                <a:tc>
+                  <a:txBody>
+                    <a:bodyPr/>
+                    <a:lstStyle/>
+                    <a:p>
+                      <a:r>
+                        <a:rPr lang="fr-FR" sz="900" dirty="0"/>
+                        <a:t>Données historiques et données prédictives</a:t>
+                      </a:r>
+                    </a:p>
+                  </a:txBody>
+                  <a:tcPr anchor="ctr"/>
+                </a:tc>
+                <a:tc>
+                  <a:txBody>
+                    <a:bodyPr/>
+                    <a:lstStyle/>
+                    <a:p>
+                      <a:r>
+                        <a:rPr lang="fr-FR" sz="700" dirty="0">
+                          <a:hlinkClick r:id="rId6"/>
+                        </a:rPr>
+                        <a:t>https://openweathermap.org/api/one-call-3</a:t>
+                      </a:r>
+                      <a:endParaRPr lang="fr-FR" sz="700" dirty="0"/>
+                    </a:p>
+                  </a:txBody>
+                  <a:tcPr anchor="ctr"/>
+                </a:tc>
+                <a:extLst>
+                  <a:ext uri="{0D108BD9-81ED-4DB2-BD59-A6C34878D82A}">
+                    <a16:rowId xmlns:a16="http://schemas.microsoft.com/office/drawing/2014/main" val="2477866597"/>
+                  </a:ext>
+                </a:extLst>
+              </a:tr>
+              <a:tr h="558690">
+                <a:tc>
+                  <a:txBody>
+                    <a:bodyPr/>
+                    <a:lstStyle/>
+                    <a:p>
+                      <a:pPr marL="0" marR="0" lvl="0" indent="0" algn="l" defTabSz="914400" rtl="0" eaLnBrk="1" fontAlgn="auto" latinLnBrk="0" hangingPunct="1">
+                        <a:lnSpc>
+                          <a:spcPct val="100000"/>
+                        </a:lnSpc>
+                        <a:spcBef>
+                          <a:spcPts val="0"/>
+                        </a:spcBef>
+                        <a:spcAft>
+                          <a:spcPts val="0"/>
+                        </a:spcAft>
+                        <a:buClr>
+                          <a:srgbClr val="000000"/>
+                        </a:buClr>
+                        <a:buSzTx/>
+                        <a:buFont typeface="Arial"/>
+                        <a:buNone/>
+                        <a:tabLst/>
+                        <a:defRPr/>
+                      </a:pPr>
+                      <a:r>
+                        <a:rPr lang="fr-FR" sz="800" dirty="0" err="1"/>
+                        <a:t>Dataset</a:t>
+                      </a:r>
+                      <a:endParaRPr lang="fr-FR" sz="800" dirty="0"/>
+                    </a:p>
+                  </a:txBody>
+                  <a:tcPr anchor="ctr"/>
+                </a:tc>
+                <a:tc>
+                  <a:txBody>
+                    <a:bodyPr/>
+                    <a:lstStyle/>
+                    <a:p>
+                      <a:pPr marL="0" marR="0" lvl="0" indent="0" algn="l" defTabSz="914400" rtl="0" eaLnBrk="1" fontAlgn="auto" latinLnBrk="0" hangingPunct="1">
+                        <a:lnSpc>
+                          <a:spcPct val="100000"/>
+                        </a:lnSpc>
+                        <a:spcBef>
+                          <a:spcPts val="0"/>
+                        </a:spcBef>
+                        <a:spcAft>
+                          <a:spcPts val="0"/>
+                        </a:spcAft>
+                        <a:buClr>
+                          <a:srgbClr val="000000"/>
+                        </a:buClr>
+                        <a:buSzTx/>
+                        <a:buFont typeface="Arial"/>
+                        <a:buNone/>
+                        <a:tabLst/>
+                        <a:defRPr/>
+                      </a:pPr>
+                      <a:r>
+                        <a:rPr lang="fr-FR" sz="900" b="1" dirty="0"/>
+                        <a:t>Données activité solaire </a:t>
+                      </a:r>
+                    </a:p>
+                  </a:txBody>
+                  <a:tcPr anchor="ctr"/>
+                </a:tc>
+                <a:tc>
+                  <a:txBody>
+                    <a:bodyPr/>
+                    <a:lstStyle/>
+                    <a:p>
+                      <a:pPr marL="0" marR="0" lvl="0" indent="0" algn="l" defTabSz="914400" rtl="0" eaLnBrk="1" fontAlgn="auto" latinLnBrk="0" hangingPunct="1">
+                        <a:lnSpc>
+                          <a:spcPct val="100000"/>
+                        </a:lnSpc>
+                        <a:spcBef>
+                          <a:spcPts val="0"/>
+                        </a:spcBef>
+                        <a:spcAft>
+                          <a:spcPts val="0"/>
+                        </a:spcAft>
+                        <a:buClr>
+                          <a:srgbClr val="000000"/>
+                        </a:buClr>
+                        <a:buSzTx/>
+                        <a:buFont typeface="Arial"/>
+                        <a:buNone/>
+                        <a:tabLst/>
+                        <a:defRPr/>
+                      </a:pPr>
+                      <a:r>
+                        <a:rPr lang="fr-FR" sz="900" dirty="0"/>
+                        <a:t>Données historiques et données prédictives</a:t>
+                      </a:r>
+                    </a:p>
+                  </a:txBody>
+                  <a:tcPr anchor="ctr"/>
+                </a:tc>
+                <a:tc>
+                  <a:txBody>
+                    <a:bodyPr/>
+                    <a:lstStyle/>
+                    <a:p>
+                      <a:r>
+                        <a:rPr lang="fr-FR" sz="700" dirty="0">
+                          <a:hlinkClick r:id="rId7"/>
+                        </a:rPr>
+                        <a:t>https://www.ngdc.noaa.gov/stp/space-weather/swpc-products/daily_reports/solar_geophysical_activity_summaries/</a:t>
+                      </a:r>
+                      <a:endParaRPr lang="fr-FR" sz="700" dirty="0"/>
+                    </a:p>
+                    <a:p>
+                      <a:endParaRPr lang="fr-FR" sz="700" dirty="0"/>
+                    </a:p>
+                    <a:p>
+                      <a:r>
+                        <a:rPr lang="fr-FR" sz="700" dirty="0">
+                          <a:hlinkClick r:id="rId8"/>
+                        </a:rPr>
+                        <a:t>https://www.ngdc.noaa.gov/stp/space-weather/swpc-products/daily_reports/daypre/</a:t>
+                      </a:r>
+                      <a:endParaRPr lang="fr-FR" sz="700" dirty="0"/>
+                    </a:p>
+                  </a:txBody>
+                  <a:tcPr anchor="ctr"/>
+                </a:tc>
+                <a:extLst>
+                  <a:ext uri="{0D108BD9-81ED-4DB2-BD59-A6C34878D82A}">
+                    <a16:rowId xmlns:a16="http://schemas.microsoft.com/office/drawing/2014/main" val="2084688575"/>
+                  </a:ext>
+                </a:extLst>
+              </a:tr>
+            </a:tbl>
+          </a:graphicData>
+        </a:graphic>
+      </p:graphicFrame>
+    </p:spTree>
+    <p:extLst>
+      <p:ext uri="{BB962C8B-B14F-4D97-AF65-F5344CB8AC3E}">
+        <p14:creationId xmlns:p14="http://schemas.microsoft.com/office/powerpoint/2010/main" val="4010613788"/>
       </p:ext>
     </p:extLst>
   </p:cSld>

</xml_diff>

<commit_message>
maj présentation et graphiques modèles
</commit_message>
<xml_diff>
--- a/presentation/dsfs_ft_36_Projet_REnergies_efficiency_prediction.pptx
+++ b/presentation/dsfs_ft_36_Projet_REnergies_efficiency_prediction.pptx
@@ -6,7 +6,7 @@
     <p:sldMasterId id="2147483660" r:id="rId2"/>
   </p:sldMasterIdLst>
   <p:notesMasterIdLst>
-    <p:notesMasterId r:id="rId21"/>
+    <p:notesMasterId r:id="rId22"/>
   </p:notesMasterIdLst>
   <p:sldIdLst>
     <p:sldId id="256" r:id="rId3"/>
@@ -21,36 +21,37 @@
     <p:sldId id="291" r:id="rId12"/>
     <p:sldId id="297" r:id="rId13"/>
     <p:sldId id="292" r:id="rId14"/>
-    <p:sldId id="271" r:id="rId15"/>
-    <p:sldId id="273" r:id="rId16"/>
-    <p:sldId id="295" r:id="rId17"/>
-    <p:sldId id="296" r:id="rId18"/>
-    <p:sldId id="275" r:id="rId19"/>
-    <p:sldId id="294" r:id="rId20"/>
+    <p:sldId id="298" r:id="rId15"/>
+    <p:sldId id="271" r:id="rId16"/>
+    <p:sldId id="273" r:id="rId17"/>
+    <p:sldId id="295" r:id="rId18"/>
+    <p:sldId id="296" r:id="rId19"/>
+    <p:sldId id="275" r:id="rId20"/>
+    <p:sldId id="294" r:id="rId21"/>
   </p:sldIdLst>
   <p:sldSz cx="9144000" cy="5143500" type="screen16x9"/>
   <p:notesSz cx="6858000" cy="9144000"/>
   <p:embeddedFontLst>
     <p:embeddedFont>
       <p:font typeface="Inter" panose="020B0604020202020204" charset="0"/>
-      <p:regular r:id="rId22"/>
-      <p:bold r:id="rId23"/>
-      <p:italic r:id="rId24"/>
-      <p:boldItalic r:id="rId25"/>
+      <p:regular r:id="rId23"/>
+      <p:bold r:id="rId24"/>
+      <p:italic r:id="rId25"/>
+      <p:boldItalic r:id="rId26"/>
     </p:embeddedFont>
     <p:embeddedFont>
       <p:font typeface="Inter Medium" panose="020B0604020202020204" charset="0"/>
-      <p:regular r:id="rId26"/>
-      <p:bold r:id="rId27"/>
-      <p:italic r:id="rId28"/>
-      <p:boldItalic r:id="rId29"/>
+      <p:regular r:id="rId27"/>
+      <p:bold r:id="rId28"/>
+      <p:italic r:id="rId29"/>
+      <p:boldItalic r:id="rId30"/>
     </p:embeddedFont>
     <p:embeddedFont>
       <p:font typeface="Inter SemiBold" panose="020B0604020202020204" charset="0"/>
-      <p:regular r:id="rId30"/>
-      <p:bold r:id="rId31"/>
-      <p:italic r:id="rId32"/>
-      <p:boldItalic r:id="rId33"/>
+      <p:regular r:id="rId31"/>
+      <p:bold r:id="rId32"/>
+      <p:italic r:id="rId33"/>
+      <p:boldItalic r:id="rId34"/>
     </p:embeddedFont>
   </p:embeddedFontLst>
   <p:defaultTextStyle>
@@ -293,7 +294,7 @@
 <file path=ppt/revisionInfo.xml><?xml version="1.0" encoding="utf-8"?>
 <p1510:revInfo xmlns:a="http://schemas.openxmlformats.org/drawingml/2006/main" xmlns:r="http://schemas.openxmlformats.org/officeDocument/2006/relationships" xmlns:p1510="http://schemas.microsoft.com/office/powerpoint/2015/10/main">
   <p1510:revLst>
-    <p1510:client id="{2EB72A00-7F79-4813-B4C2-C6564860F3F6}" v="2872" dt="2025-11-25T08:53:15.397"/>
+    <p1510:client id="{2EB72A00-7F79-4813-B4C2-C6564860F3F6}" v="2919" dt="2025-11-25T09:56:49.003"/>
   </p1510:revLst>
 </p1510:revInfo>
 </file>
@@ -302,8 +303,8 @@
 <pc:chgInfo xmlns:a="http://schemas.openxmlformats.org/drawingml/2006/main" xmlns:r="http://schemas.openxmlformats.org/officeDocument/2006/relationships" xmlns:ac="http://schemas.microsoft.com/office/drawing/2013/main/command" xmlns:pc="http://schemas.microsoft.com/office/powerpoint/2013/main/command">
   <pc:docChgLst>
     <pc:chgData name="Jean-Yves Vuillequez" userId="e7fac481abea6bd0" providerId="LiveId" clId="{79E365E8-22BC-4EC2-9606-9A9AC6CD1D22}"/>
-    <pc:docChg chg="undo custSel addSld delSld modSld sldOrd">
-      <pc:chgData name="Jean-Yves Vuillequez" userId="e7fac481abea6bd0" providerId="LiveId" clId="{79E365E8-22BC-4EC2-9606-9A9AC6CD1D22}" dt="2025-11-25T08:54:23.746" v="9534"/>
+    <pc:docChg chg="undo redo custSel addSld delSld modSld sldOrd">
+      <pc:chgData name="Jean-Yves Vuillequez" userId="e7fac481abea6bd0" providerId="LiveId" clId="{79E365E8-22BC-4EC2-9606-9A9AC6CD1D22}" dt="2025-11-25T09:56:49.003" v="9726"/>
       <pc:docMkLst>
         <pc:docMk/>
       </pc:docMkLst>
@@ -1627,7 +1628,7 @@
         </pc:picChg>
       </pc:sldChg>
       <pc:sldChg chg="addSp delSp modSp add mod ord modAnim">
-        <pc:chgData name="Jean-Yves Vuillequez" userId="e7fac481abea6bd0" providerId="LiveId" clId="{79E365E8-22BC-4EC2-9606-9A9AC6CD1D22}" dt="2025-11-24T15:42:47.576" v="9435" actId="1076"/>
+        <pc:chgData name="Jean-Yves Vuillequez" userId="e7fac481abea6bd0" providerId="LiveId" clId="{79E365E8-22BC-4EC2-9606-9A9AC6CD1D22}" dt="2025-11-25T09:33:18.885" v="9545"/>
         <pc:sldMkLst>
           <pc:docMk/>
           <pc:sldMk cId="3647836335" sldId="287"/>
@@ -1746,7 +1747,7 @@
         </pc:picChg>
       </pc:sldChg>
       <pc:sldChg chg="addSp delSp modSp add mod modAnim modNotesTx">
-        <pc:chgData name="Jean-Yves Vuillequez" userId="e7fac481abea6bd0" providerId="LiveId" clId="{79E365E8-22BC-4EC2-9606-9A9AC6CD1D22}" dt="2025-11-24T15:49:49.330" v="9475" actId="113"/>
+        <pc:chgData name="Jean-Yves Vuillequez" userId="e7fac481abea6bd0" providerId="LiveId" clId="{79E365E8-22BC-4EC2-9606-9A9AC6CD1D22}" dt="2025-11-25T09:56:49.003" v="9726"/>
         <pc:sldMkLst>
           <pc:docMk/>
           <pc:sldMk cId="2290935718" sldId="289"/>
@@ -1792,7 +1793,7 @@
           </ac:spMkLst>
         </pc:spChg>
         <pc:spChg chg="add mod">
-          <ac:chgData name="Jean-Yves Vuillequez" userId="e7fac481abea6bd0" providerId="LiveId" clId="{79E365E8-22BC-4EC2-9606-9A9AC6CD1D22}" dt="2025-11-24T15:49:49.330" v="9475" actId="113"/>
+          <ac:chgData name="Jean-Yves Vuillequez" userId="e7fac481abea6bd0" providerId="LiveId" clId="{79E365E8-22BC-4EC2-9606-9A9AC6CD1D22}" dt="2025-11-25T09:55:44.740" v="9709" actId="20577"/>
           <ac:spMkLst>
             <pc:docMk/>
             <pc:sldMk cId="2290935718" sldId="289"/>
@@ -1815,6 +1816,22 @@
             <ac:spMk id="178" creationId="{834EF362-0DAC-26BA-DE49-3126B33E851C}"/>
           </ac:spMkLst>
         </pc:spChg>
+        <pc:picChg chg="add del mod">
+          <ac:chgData name="Jean-Yves Vuillequez" userId="e7fac481abea6bd0" providerId="LiveId" clId="{79E365E8-22BC-4EC2-9606-9A9AC6CD1D22}" dt="2025-11-25T09:55:33.394" v="9706" actId="21"/>
+          <ac:picMkLst>
+            <pc:docMk/>
+            <pc:sldMk cId="2290935718" sldId="289"/>
+            <ac:picMk id="4" creationId="{000A3F10-64A4-99A8-2113-EEBBDD6801ED}"/>
+          </ac:picMkLst>
+        </pc:picChg>
+        <pc:picChg chg="add mod">
+          <ac:chgData name="Jean-Yves Vuillequez" userId="e7fac481abea6bd0" providerId="LiveId" clId="{79E365E8-22BC-4EC2-9606-9A9AC6CD1D22}" dt="2025-11-25T09:55:35.312" v="9708"/>
+          <ac:picMkLst>
+            <pc:docMk/>
+            <pc:sldMk cId="2290935718" sldId="289"/>
+            <ac:picMk id="5" creationId="{000A3F10-64A4-99A8-2113-EEBBDD6801ED}"/>
+          </ac:picMkLst>
+        </pc:picChg>
         <pc:picChg chg="add del mod">
           <ac:chgData name="Jean-Yves Vuillequez" userId="e7fac481abea6bd0" providerId="LiveId" clId="{79E365E8-22BC-4EC2-9606-9A9AC6CD1D22}" dt="2025-11-24T09:17:46.771" v="7796" actId="478"/>
           <ac:picMkLst>
@@ -1839,12 +1856,20 @@
             <ac:picMk id="7" creationId="{5FE561E2-56B0-D6A0-F0B7-7F202EE51386}"/>
           </ac:picMkLst>
         </pc:picChg>
-        <pc:picChg chg="add mod">
-          <ac:chgData name="Jean-Yves Vuillequez" userId="e7fac481abea6bd0" providerId="LiveId" clId="{79E365E8-22BC-4EC2-9606-9A9AC6CD1D22}" dt="2025-11-24T14:15:26.350" v="8996" actId="1076"/>
+        <pc:picChg chg="add del mod">
+          <ac:chgData name="Jean-Yves Vuillequez" userId="e7fac481abea6bd0" providerId="LiveId" clId="{79E365E8-22BC-4EC2-9606-9A9AC6CD1D22}" dt="2025-11-25T09:56:47.735" v="9725" actId="478"/>
           <ac:picMkLst>
             <pc:docMk/>
             <pc:sldMk cId="2290935718" sldId="289"/>
             <ac:picMk id="7" creationId="{D843FCAE-84D8-B3E1-4B7A-0383F76C878B}"/>
+          </ac:picMkLst>
+        </pc:picChg>
+        <pc:picChg chg="add del mod">
+          <ac:chgData name="Jean-Yves Vuillequez" userId="e7fac481abea6bd0" providerId="LiveId" clId="{79E365E8-22BC-4EC2-9606-9A9AC6CD1D22}" dt="2025-11-25T09:56:28.999" v="9717" actId="478"/>
+          <ac:picMkLst>
+            <pc:docMk/>
+            <pc:sldMk cId="2290935718" sldId="289"/>
+            <ac:picMk id="8" creationId="{75BB14DA-0E1D-6252-77D5-F3B18DB8E908}"/>
           </ac:picMkLst>
         </pc:picChg>
         <pc:picChg chg="add del mod">
@@ -1855,8 +1880,8 @@
             <ac:picMk id="12" creationId="{7D6B0B43-8628-A21E-C82B-D058DBA5452A}"/>
           </ac:picMkLst>
         </pc:picChg>
-        <pc:picChg chg="add mod">
-          <ac:chgData name="Jean-Yves Vuillequez" userId="e7fac481abea6bd0" providerId="LiveId" clId="{79E365E8-22BC-4EC2-9606-9A9AC6CD1D22}" dt="2025-11-24T14:48:29.277" v="9172" actId="14100"/>
+        <pc:picChg chg="add del mod">
+          <ac:chgData name="Jean-Yves Vuillequez" userId="e7fac481abea6bd0" providerId="LiveId" clId="{79E365E8-22BC-4EC2-9606-9A9AC6CD1D22}" dt="2025-11-25T09:55:34.360" v="9707" actId="478"/>
           <ac:picMkLst>
             <pc:docMk/>
             <pc:sldMk cId="2290935718" sldId="289"/>
@@ -1869,6 +1894,22 @@
             <pc:docMk/>
             <pc:sldMk cId="2290935718" sldId="289"/>
             <ac:picMk id="14" creationId="{291A7323-DA08-B6B0-D55B-6BCFB1C0351B}"/>
+          </ac:picMkLst>
+        </pc:picChg>
+        <pc:picChg chg="add del mod">
+          <ac:chgData name="Jean-Yves Vuillequez" userId="e7fac481abea6bd0" providerId="LiveId" clId="{79E365E8-22BC-4EC2-9606-9A9AC6CD1D22}" dt="2025-11-25T09:56:46.881" v="9724" actId="21"/>
+          <ac:picMkLst>
+            <pc:docMk/>
+            <pc:sldMk cId="2290935718" sldId="289"/>
+            <ac:picMk id="14" creationId="{BC10BE04-1AA9-616C-9AB5-9507462BB970}"/>
+          </ac:picMkLst>
+        </pc:picChg>
+        <pc:picChg chg="add mod">
+          <ac:chgData name="Jean-Yves Vuillequez" userId="e7fac481abea6bd0" providerId="LiveId" clId="{79E365E8-22BC-4EC2-9606-9A9AC6CD1D22}" dt="2025-11-25T09:56:49.003" v="9726"/>
+          <ac:picMkLst>
+            <pc:docMk/>
+            <pc:sldMk cId="2290935718" sldId="289"/>
+            <ac:picMk id="15" creationId="{BC10BE04-1AA9-616C-9AB5-9507462BB970}"/>
           </ac:picMkLst>
         </pc:picChg>
       </pc:sldChg>
@@ -2056,13 +2097,13 @@
         </pc:cxnChg>
       </pc:sldChg>
       <pc:sldChg chg="addSp delSp modSp add mod ord delAnim modAnim modNotesTx">
-        <pc:chgData name="Jean-Yves Vuillequez" userId="e7fac481abea6bd0" providerId="LiveId" clId="{79E365E8-22BC-4EC2-9606-9A9AC6CD1D22}" dt="2025-11-24T15:04:25.227" v="9205" actId="113"/>
+        <pc:chgData name="Jean-Yves Vuillequez" userId="e7fac481abea6bd0" providerId="LiveId" clId="{79E365E8-22BC-4EC2-9606-9A9AC6CD1D22}" dt="2025-11-25T09:41:19.311" v="9574" actId="14100"/>
         <pc:sldMkLst>
           <pc:docMk/>
           <pc:sldMk cId="3315518580" sldId="292"/>
         </pc:sldMkLst>
         <pc:spChg chg="add mod">
-          <ac:chgData name="Jean-Yves Vuillequez" userId="e7fac481abea6bd0" providerId="LiveId" clId="{79E365E8-22BC-4EC2-9606-9A9AC6CD1D22}" dt="2025-11-21T14:03:47.959" v="6805" actId="14100"/>
+          <ac:chgData name="Jean-Yves Vuillequez" userId="e7fac481abea6bd0" providerId="LiveId" clId="{79E365E8-22BC-4EC2-9606-9A9AC6CD1D22}" dt="2025-11-25T09:41:19.311" v="9574" actId="14100"/>
           <ac:spMkLst>
             <pc:docMk/>
             <pc:sldMk cId="3315518580" sldId="292"/>
@@ -2070,7 +2111,7 @@
           </ac:spMkLst>
         </pc:spChg>
         <pc:spChg chg="add mod">
-          <ac:chgData name="Jean-Yves Vuillequez" userId="e7fac481abea6bd0" providerId="LiveId" clId="{79E365E8-22BC-4EC2-9606-9A9AC6CD1D22}" dt="2025-11-21T14:04:10.873" v="6846" actId="113"/>
+          <ac:chgData name="Jean-Yves Vuillequez" userId="e7fac481abea6bd0" providerId="LiveId" clId="{79E365E8-22BC-4EC2-9606-9A9AC6CD1D22}" dt="2025-11-25T09:41:18.557" v="9573" actId="1076"/>
           <ac:spMkLst>
             <pc:docMk/>
             <pc:sldMk cId="3315518580" sldId="292"/>
@@ -2078,7 +2119,7 @@
           </ac:spMkLst>
         </pc:spChg>
         <pc:spChg chg="add mod">
-          <ac:chgData name="Jean-Yves Vuillequez" userId="e7fac481abea6bd0" providerId="LiveId" clId="{79E365E8-22BC-4EC2-9606-9A9AC6CD1D22}" dt="2025-11-24T15:04:25.227" v="9205" actId="113"/>
+          <ac:chgData name="Jean-Yves Vuillequez" userId="e7fac481abea6bd0" providerId="LiveId" clId="{79E365E8-22BC-4EC2-9606-9A9AC6CD1D22}" dt="2025-11-25T09:41:19.311" v="9574" actId="14100"/>
           <ac:spMkLst>
             <pc:docMk/>
             <pc:sldMk cId="3315518580" sldId="292"/>
@@ -2094,7 +2135,7 @@
           </ac:spMkLst>
         </pc:spChg>
         <pc:spChg chg="mod topLvl">
-          <ac:chgData name="Jean-Yves Vuillequez" userId="e7fac481abea6bd0" providerId="LiveId" clId="{79E365E8-22BC-4EC2-9606-9A9AC6CD1D22}" dt="2025-11-20T15:12:24.584" v="3988" actId="478"/>
+          <ac:chgData name="Jean-Yves Vuillequez" userId="e7fac481abea6bd0" providerId="LiveId" clId="{79E365E8-22BC-4EC2-9606-9A9AC6CD1D22}" dt="2025-11-25T09:41:17.970" v="9572" actId="1076"/>
           <ac:spMkLst>
             <pc:docMk/>
             <pc:sldMk cId="3315518580" sldId="292"/>
@@ -2118,15 +2159,23 @@
           </ac:spMkLst>
         </pc:spChg>
         <pc:grpChg chg="add mod">
-          <ac:chgData name="Jean-Yves Vuillequez" userId="e7fac481abea6bd0" providerId="LiveId" clId="{79E365E8-22BC-4EC2-9606-9A9AC6CD1D22}" dt="2025-11-21T15:24:06.980" v="7159" actId="164"/>
+          <ac:chgData name="Jean-Yves Vuillequez" userId="e7fac481abea6bd0" providerId="LiveId" clId="{79E365E8-22BC-4EC2-9606-9A9AC6CD1D22}" dt="2025-11-25T09:41:17.970" v="9572" actId="1076"/>
           <ac:grpSpMkLst>
             <pc:docMk/>
             <pc:sldMk cId="3315518580" sldId="292"/>
             <ac:grpSpMk id="5" creationId="{F4E17C80-100B-9769-D624-90E0C0132394}"/>
           </ac:grpSpMkLst>
         </pc:grpChg>
+        <pc:picChg chg="add del mod">
+          <ac:chgData name="Jean-Yves Vuillequez" userId="e7fac481abea6bd0" providerId="LiveId" clId="{79E365E8-22BC-4EC2-9606-9A9AC6CD1D22}" dt="2025-11-25T09:41:16.373" v="9568"/>
+          <ac:picMkLst>
+            <pc:docMk/>
+            <pc:sldMk cId="3315518580" sldId="292"/>
+            <ac:picMk id="7" creationId="{E33D8126-FD17-736C-5FBC-B9AF511D26AF}"/>
+          </ac:picMkLst>
+        </pc:picChg>
         <pc:picChg chg="add mod">
-          <ac:chgData name="Jean-Yves Vuillequez" userId="e7fac481abea6bd0" providerId="LiveId" clId="{79E365E8-22BC-4EC2-9606-9A9AC6CD1D22}" dt="2025-11-20T15:12:42.291" v="3996" actId="1076"/>
+          <ac:chgData name="Jean-Yves Vuillequez" userId="e7fac481abea6bd0" providerId="LiveId" clId="{79E365E8-22BC-4EC2-9606-9A9AC6CD1D22}" dt="2025-11-25T09:41:17.970" v="9572" actId="1076"/>
           <ac:picMkLst>
             <pc:docMk/>
             <pc:sldMk cId="3315518580" sldId="292"/>
@@ -2135,7 +2184,7 @@
         </pc:picChg>
       </pc:sldChg>
       <pc:sldChg chg="addSp delSp modSp add mod modAnim">
-        <pc:chgData name="Jean-Yves Vuillequez" userId="e7fac481abea6bd0" providerId="LiveId" clId="{79E365E8-22BC-4EC2-9606-9A9AC6CD1D22}" dt="2025-11-20T20:39:03.631" v="5241"/>
+        <pc:chgData name="Jean-Yves Vuillequez" userId="e7fac481abea6bd0" providerId="LiveId" clId="{79E365E8-22BC-4EC2-9606-9A9AC6CD1D22}" dt="2025-11-25T09:47:24.190" v="9695" actId="1076"/>
         <pc:sldMkLst>
           <pc:docMk/>
           <pc:sldMk cId="1155304805" sldId="293"/>
@@ -2146,6 +2195,22 @@
             <pc:docMk/>
             <pc:sldMk cId="1155304805" sldId="293"/>
             <ac:spMk id="2" creationId="{1563EBE9-16C3-6238-4969-9E03C7CCE61D}"/>
+          </ac:spMkLst>
+        </pc:spChg>
+        <pc:spChg chg="add mod">
+          <ac:chgData name="Jean-Yves Vuillequez" userId="e7fac481abea6bd0" providerId="LiveId" clId="{79E365E8-22BC-4EC2-9606-9A9AC6CD1D22}" dt="2025-11-25T09:45:21.036" v="9692" actId="1076"/>
+          <ac:spMkLst>
+            <pc:docMk/>
+            <pc:sldMk cId="1155304805" sldId="293"/>
+            <ac:spMk id="3" creationId="{DEBF304F-77EB-BA94-CD84-BF91A9CC35D2}"/>
+          </ac:spMkLst>
+        </pc:spChg>
+        <pc:spChg chg="add mod">
+          <ac:chgData name="Jean-Yves Vuillequez" userId="e7fac481abea6bd0" providerId="LiveId" clId="{79E365E8-22BC-4EC2-9606-9A9AC6CD1D22}" dt="2025-11-25T09:44:58.571" v="9687"/>
+          <ac:spMkLst>
+            <pc:docMk/>
+            <pc:sldMk cId="1155304805" sldId="293"/>
+            <ac:spMk id="4" creationId="{1A25B44F-3D72-A752-04D6-8C3086471959}"/>
           </ac:spMkLst>
         </pc:spChg>
         <pc:spChg chg="mod">
@@ -2197,7 +2262,7 @@
           </ac:picMkLst>
         </pc:picChg>
         <pc:picChg chg="add mod">
-          <ac:chgData name="Jean-Yves Vuillequez" userId="e7fac481abea6bd0" providerId="LiveId" clId="{79E365E8-22BC-4EC2-9606-9A9AC6CD1D22}" dt="2025-11-20T13:23:14.504" v="3231" actId="1076"/>
+          <ac:chgData name="Jean-Yves Vuillequez" userId="e7fac481abea6bd0" providerId="LiveId" clId="{79E365E8-22BC-4EC2-9606-9A9AC6CD1D22}" dt="2025-11-25T09:47:17.251" v="9693" actId="14100"/>
           <ac:picMkLst>
             <pc:docMk/>
             <pc:sldMk cId="1155304805" sldId="293"/>
@@ -2205,7 +2270,7 @@
           </ac:picMkLst>
         </pc:picChg>
         <pc:picChg chg="add mod">
-          <ac:chgData name="Jean-Yves Vuillequez" userId="e7fac481abea6bd0" providerId="LiveId" clId="{79E365E8-22BC-4EC2-9606-9A9AC6CD1D22}" dt="2025-11-20T13:25:16.756" v="3238" actId="1076"/>
+          <ac:chgData name="Jean-Yves Vuillequez" userId="e7fac481abea6bd0" providerId="LiveId" clId="{79E365E8-22BC-4EC2-9606-9A9AC6CD1D22}" dt="2025-11-25T09:47:24.190" v="9695" actId="1076"/>
           <ac:picMkLst>
             <pc:docMk/>
             <pc:sldMk cId="1155304805" sldId="293"/>
@@ -2391,6 +2456,109 @@
           <pc:docMk/>
           <pc:sldMk cId="1637271805" sldId="297"/>
         </pc:sldMkLst>
+      </pc:sldChg>
+      <pc:sldChg chg="addSp delSp modSp add mod delAnim modAnim">
+        <pc:chgData name="Jean-Yves Vuillequez" userId="e7fac481abea6bd0" providerId="LiveId" clId="{79E365E8-22BC-4EC2-9606-9A9AC6CD1D22}" dt="2025-11-25T09:51:50.968" v="9700"/>
+        <pc:sldMkLst>
+          <pc:docMk/>
+          <pc:sldMk cId="1528976140" sldId="298"/>
+        </pc:sldMkLst>
+        <pc:spChg chg="del">
+          <ac:chgData name="Jean-Yves Vuillequez" userId="e7fac481abea6bd0" providerId="LiveId" clId="{79E365E8-22BC-4EC2-9606-9A9AC6CD1D22}" dt="2025-11-25T09:41:27.680" v="9576" actId="478"/>
+          <ac:spMkLst>
+            <pc:docMk/>
+            <pc:sldMk cId="1528976140" sldId="298"/>
+            <ac:spMk id="2" creationId="{533C9DFD-6E8E-88F1-7225-5C3975042C24}"/>
+          </ac:spMkLst>
+        </pc:spChg>
+        <pc:spChg chg="del">
+          <ac:chgData name="Jean-Yves Vuillequez" userId="e7fac481abea6bd0" providerId="LiveId" clId="{79E365E8-22BC-4EC2-9606-9A9AC6CD1D22}" dt="2025-11-25T09:41:27.680" v="9576" actId="478"/>
+          <ac:spMkLst>
+            <pc:docMk/>
+            <pc:sldMk cId="1528976140" sldId="298"/>
+            <ac:spMk id="3" creationId="{8785E37A-885C-D1C2-87DF-533478F56CB4}"/>
+          </ac:spMkLst>
+        </pc:spChg>
+        <pc:spChg chg="add mod">
+          <ac:chgData name="Jean-Yves Vuillequez" userId="e7fac481abea6bd0" providerId="LiveId" clId="{79E365E8-22BC-4EC2-9606-9A9AC6CD1D22}" dt="2025-11-25T09:41:48.200" v="9618" actId="20577"/>
+          <ac:spMkLst>
+            <pc:docMk/>
+            <pc:sldMk cId="1528976140" sldId="298"/>
+            <ac:spMk id="4" creationId="{B4652961-82E1-E9F1-B367-5278489897BB}"/>
+          </ac:spMkLst>
+        </pc:spChg>
+        <pc:spChg chg="del">
+          <ac:chgData name="Jean-Yves Vuillequez" userId="e7fac481abea6bd0" providerId="LiveId" clId="{79E365E8-22BC-4EC2-9606-9A9AC6CD1D22}" dt="2025-11-25T09:41:27.680" v="9576" actId="478"/>
+          <ac:spMkLst>
+            <pc:docMk/>
+            <pc:sldMk cId="1528976140" sldId="298"/>
+            <ac:spMk id="6" creationId="{8794308E-6A49-D3F2-09A4-7DDEF1CE7AE5}"/>
+          </ac:spMkLst>
+        </pc:spChg>
+        <pc:spChg chg="del">
+          <ac:chgData name="Jean-Yves Vuillequez" userId="e7fac481abea6bd0" providerId="LiveId" clId="{79E365E8-22BC-4EC2-9606-9A9AC6CD1D22}" dt="2025-11-25T09:41:27.680" v="9576" actId="478"/>
+          <ac:spMkLst>
+            <pc:docMk/>
+            <pc:sldMk cId="1528976140" sldId="298"/>
+            <ac:spMk id="11" creationId="{4EA49E74-8FBD-25AE-94C8-C376AB937BEF}"/>
+          </ac:spMkLst>
+        </pc:spChg>
+        <pc:spChg chg="add mod">
+          <ac:chgData name="Jean-Yves Vuillequez" userId="e7fac481abea6bd0" providerId="LiveId" clId="{79E365E8-22BC-4EC2-9606-9A9AC6CD1D22}" dt="2025-11-25T09:43:46.651" v="9667" actId="1076"/>
+          <ac:spMkLst>
+            <pc:docMk/>
+            <pc:sldMk cId="1528976140" sldId="298"/>
+            <ac:spMk id="13" creationId="{A0C660C5-C6B4-4D60-632C-38AA341D4E42}"/>
+          </ac:spMkLst>
+        </pc:spChg>
+        <pc:spChg chg="add mod">
+          <ac:chgData name="Jean-Yves Vuillequez" userId="e7fac481abea6bd0" providerId="LiveId" clId="{79E365E8-22BC-4EC2-9606-9A9AC6CD1D22}" dt="2025-11-25T09:44:01.713" v="9686" actId="14100"/>
+          <ac:spMkLst>
+            <pc:docMk/>
+            <pc:sldMk cId="1528976140" sldId="298"/>
+            <ac:spMk id="15" creationId="{7B02442F-1F39-3A7F-A132-603CFB285A80}"/>
+          </ac:spMkLst>
+        </pc:spChg>
+        <pc:spChg chg="mod">
+          <ac:chgData name="Jean-Yves Vuillequez" userId="e7fac481abea6bd0" providerId="LiveId" clId="{79E365E8-22BC-4EC2-9606-9A9AC6CD1D22}" dt="2025-11-25T09:42:21.129" v="9640" actId="1076"/>
+          <ac:spMkLst>
+            <pc:docMk/>
+            <pc:sldMk cId="1528976140" sldId="298"/>
+            <ac:spMk id="71" creationId="{B282795F-CC32-9B21-2C73-46BD6A694971}"/>
+          </ac:spMkLst>
+        </pc:spChg>
+        <pc:grpChg chg="del">
+          <ac:chgData name="Jean-Yves Vuillequez" userId="e7fac481abea6bd0" providerId="LiveId" clId="{79E365E8-22BC-4EC2-9606-9A9AC6CD1D22}" dt="2025-11-25T09:41:27.680" v="9576" actId="478"/>
+          <ac:grpSpMkLst>
+            <pc:docMk/>
+            <pc:sldMk cId="1528976140" sldId="298"/>
+            <ac:grpSpMk id="5" creationId="{716D0D9E-884E-53FC-BF93-5F07B985ACC1}"/>
+          </ac:grpSpMkLst>
+        </pc:grpChg>
+        <pc:picChg chg="add mod ord">
+          <ac:chgData name="Jean-Yves Vuillequez" userId="e7fac481abea6bd0" providerId="LiveId" clId="{79E365E8-22BC-4EC2-9606-9A9AC6CD1D22}" dt="2025-11-25T09:51:43.823" v="9698" actId="1076"/>
+          <ac:picMkLst>
+            <pc:docMk/>
+            <pc:sldMk cId="1528976140" sldId="298"/>
+            <ac:picMk id="8" creationId="{36374721-DBF6-6DC3-7F02-E2A019B585B7}"/>
+          </ac:picMkLst>
+        </pc:picChg>
+        <pc:picChg chg="add mod">
+          <ac:chgData name="Jean-Yves Vuillequez" userId="e7fac481abea6bd0" providerId="LiveId" clId="{79E365E8-22BC-4EC2-9606-9A9AC6CD1D22}" dt="2025-11-25T09:43:08.174" v="9659" actId="1076"/>
+          <ac:picMkLst>
+            <pc:docMk/>
+            <pc:sldMk cId="1528976140" sldId="298"/>
+            <ac:picMk id="12" creationId="{D61A617B-D6B7-1A94-495F-DC4E854385A5}"/>
+          </ac:picMkLst>
+        </pc:picChg>
+        <pc:picChg chg="del">
+          <ac:chgData name="Jean-Yves Vuillequez" userId="e7fac481abea6bd0" providerId="LiveId" clId="{79E365E8-22BC-4EC2-9606-9A9AC6CD1D22}" dt="2025-11-25T09:41:27.680" v="9576" actId="478"/>
+          <ac:picMkLst>
+            <pc:docMk/>
+            <pc:sldMk cId="1528976140" sldId="298"/>
+            <ac:picMk id="14" creationId="{00FAD22A-9740-C05B-F72B-F96EA58B04F4}"/>
+          </ac:picMkLst>
+        </pc:picChg>
       </pc:sldChg>
     </pc:docChg>
   </pc:docChgLst>
@@ -3520,6 +3688,249 @@
   <p:cSld>
     <p:spTree>
       <p:nvGrpSpPr>
+        <p:cNvPr id="1" name="Shape 65">
+          <a:extLst>
+            <a:ext uri="{FF2B5EF4-FFF2-40B4-BE49-F238E27FC236}">
+              <a16:creationId xmlns:a16="http://schemas.microsoft.com/office/drawing/2014/main" id="{46888412-051D-A3DD-D553-7665D0C04847}"/>
+            </a:ext>
+          </a:extLst>
+        </p:cNvPr>
+        <p:cNvGrpSpPr/>
+        <p:nvPr/>
+      </p:nvGrpSpPr>
+      <p:grpSpPr>
+        <a:xfrm>
+          <a:off x="0" y="0"/>
+          <a:ext cx="0" cy="0"/>
+          <a:chOff x="0" y="0"/>
+          <a:chExt cx="0" cy="0"/>
+        </a:xfrm>
+      </p:grpSpPr>
+      <p:sp>
+        <p:nvSpPr>
+          <p:cNvPr id="66" name="Google Shape;66;p3:notes">
+            <a:extLst>
+              <a:ext uri="{FF2B5EF4-FFF2-40B4-BE49-F238E27FC236}">
+                <a16:creationId xmlns:a16="http://schemas.microsoft.com/office/drawing/2014/main" id="{26D0A05E-F9D6-869F-CEEA-413C0CB68668}"/>
+              </a:ext>
+            </a:extLst>
+          </p:cNvPr>
+          <p:cNvSpPr>
+            <a:spLocks noGrp="1" noRot="1" noChangeAspect="1"/>
+          </p:cNvSpPr>
+          <p:nvPr>
+            <p:ph type="sldImg" idx="2"/>
+          </p:nvPr>
+        </p:nvSpPr>
+        <p:spPr>
+          <a:xfrm>
+            <a:off x="381000" y="685800"/>
+            <a:ext cx="6096000" cy="3429000"/>
+          </a:xfrm>
+          <a:custGeom>
+            <a:avLst/>
+            <a:gdLst/>
+            <a:ahLst/>
+            <a:cxnLst/>
+            <a:rect l="l" t="t" r="r" b="b"/>
+            <a:pathLst>
+              <a:path w="120000" h="120000" extrusionOk="0">
+                <a:moveTo>
+                  <a:pt x="0" y="0"/>
+                </a:moveTo>
+                <a:lnTo>
+                  <a:pt x="120000" y="0"/>
+                </a:lnTo>
+                <a:lnTo>
+                  <a:pt x="120000" y="120000"/>
+                </a:lnTo>
+                <a:lnTo>
+                  <a:pt x="0" y="120000"/>
+                </a:lnTo>
+                <a:close/>
+              </a:path>
+            </a:pathLst>
+          </a:custGeom>
+          <a:noFill/>
+          <a:ln w="9525" cap="flat" cmpd="sng">
+            <a:solidFill>
+              <a:srgbClr val="000000"/>
+            </a:solidFill>
+            <a:prstDash val="solid"/>
+            <a:round/>
+            <a:headEnd type="none" w="sm" len="sm"/>
+            <a:tailEnd type="none" w="sm" len="sm"/>
+          </a:ln>
+        </p:spPr>
+      </p:sp>
+      <p:sp>
+        <p:nvSpPr>
+          <p:cNvPr id="67" name="Google Shape;67;p3:notes">
+            <a:extLst>
+              <a:ext uri="{FF2B5EF4-FFF2-40B4-BE49-F238E27FC236}">
+                <a16:creationId xmlns:a16="http://schemas.microsoft.com/office/drawing/2014/main" id="{8EF31D09-A55E-2754-61F7-B234B4AD781A}"/>
+              </a:ext>
+            </a:extLst>
+          </p:cNvPr>
+          <p:cNvSpPr txBox="1">
+            <a:spLocks noGrp="1"/>
+          </p:cNvSpPr>
+          <p:nvPr>
+            <p:ph type="body" idx="1"/>
+          </p:nvPr>
+        </p:nvSpPr>
+        <p:spPr>
+          <a:xfrm>
+            <a:off x="685800" y="4343400"/>
+            <a:ext cx="5486400" cy="4114800"/>
+          </a:xfrm>
+          <a:prstGeom prst="rect">
+            <a:avLst/>
+          </a:prstGeom>
+          <a:noFill/>
+          <a:ln>
+            <a:noFill/>
+          </a:ln>
+        </p:spPr>
+        <p:txBody>
+          <a:bodyPr spcFirstLastPara="1" wrap="square" lIns="91425" tIns="91425" rIns="91425" bIns="91425" anchor="t" anchorCtr="0">
+            <a:noAutofit/>
+          </a:bodyPr>
+          <a:lstStyle/>
+          <a:p>
+            <a:pPr marL="114300" indent="0">
+              <a:buNone/>
+            </a:pPr>
+            <a:r>
+              <a:rPr lang="fr-FR" sz="1100" b="1" dirty="0"/>
+              <a:t>Valeur immédiate :</a:t>
+            </a:r>
+          </a:p>
+          <a:p>
+            <a:pPr marL="114300" indent="0">
+              <a:buNone/>
+            </a:pPr>
+            <a:r>
+              <a:rPr lang="fr-FR" sz="1100" dirty="0"/>
+              <a:t>Visibilité sur 3 jours → meilleure planification.</a:t>
+            </a:r>
+          </a:p>
+          <a:p>
+            <a:pPr marL="114300" indent="0">
+              <a:buNone/>
+            </a:pPr>
+            <a:r>
+              <a:rPr lang="fr-FR" sz="1100" dirty="0"/>
+              <a:t>Anticipation des pics et baisses → réseau plus stable, délestage de l’hydro électrique au profit du solaire</a:t>
+            </a:r>
+          </a:p>
+          <a:p>
+            <a:pPr marL="114300" indent="0">
+              <a:buNone/>
+            </a:pPr>
+            <a:r>
+              <a:rPr lang="fr-FR" sz="1100" dirty="0"/>
+              <a:t>Lecture régionale fine → priorisation des investissements ??</a:t>
+            </a:r>
+          </a:p>
+          <a:p>
+            <a:pPr marL="114300" indent="0">
+              <a:buNone/>
+            </a:pPr>
+            <a:r>
+              <a:rPr lang="fr-FR" sz="1100" dirty="0"/>
+              <a:t>Outil d’aide à la décision clair et exploitable</a:t>
+            </a:r>
+          </a:p>
+          <a:p>
+            <a:endParaRPr lang="fr-FR" sz="1100" b="1" dirty="0"/>
+          </a:p>
+          <a:p>
+            <a:pPr marL="114300" indent="0">
+              <a:buNone/>
+            </a:pPr>
+            <a:r>
+              <a:rPr lang="fr-FR" sz="1100" b="1" dirty="0"/>
+              <a:t>Perspectives :</a:t>
+            </a:r>
+          </a:p>
+          <a:p>
+            <a:pPr marL="114300" indent="0">
+              <a:buNone/>
+            </a:pPr>
+            <a:r>
+              <a:rPr lang="fr-FR" sz="1100" dirty="0"/>
+              <a:t>Passage en temps réel</a:t>
+            </a:r>
+          </a:p>
+          <a:p>
+            <a:pPr marL="114300" indent="0">
+              <a:buNone/>
+            </a:pPr>
+            <a:r>
+              <a:rPr lang="fr-FR" sz="1100" dirty="0"/>
+              <a:t>Ajout de la prévision intra </a:t>
+            </a:r>
+            <a:r>
+              <a:rPr lang="fr-FR" sz="1100" dirty="0" err="1"/>
+              <a:t>day</a:t>
+            </a:r>
+            <a:r>
+              <a:rPr lang="fr-FR" sz="1100" dirty="0"/>
+              <a:t> (données de prod RTE disponibles à la demi heure)</a:t>
+            </a:r>
+          </a:p>
+          <a:p>
+            <a:pPr marL="114300" indent="0">
+              <a:buNone/>
+            </a:pPr>
+            <a:r>
+              <a:rPr lang="fr-FR" sz="1100" dirty="0"/>
+              <a:t>Enrichissement par données satellitaires</a:t>
+            </a:r>
+          </a:p>
+          <a:p>
+            <a:pPr marL="158750" indent="0">
+              <a:buNone/>
+            </a:pPr>
+            <a:endParaRPr lang="fr-FR" dirty="0"/>
+          </a:p>
+          <a:p>
+            <a:pPr marL="0" lvl="0" indent="0" algn="l" rtl="0">
+              <a:lnSpc>
+                <a:spcPct val="100000"/>
+              </a:lnSpc>
+              <a:spcBef>
+                <a:spcPts val="0"/>
+              </a:spcBef>
+              <a:spcAft>
+                <a:spcPts val="0"/>
+              </a:spcAft>
+              <a:buSzPts val="1100"/>
+              <a:buNone/>
+            </a:pPr>
+            <a:endParaRPr dirty="0"/>
+          </a:p>
+        </p:txBody>
+      </p:sp>
+    </p:spTree>
+    <p:extLst>
+      <p:ext uri="{BB962C8B-B14F-4D97-AF65-F5344CB8AC3E}">
+        <p14:creationId xmlns:p14="http://schemas.microsoft.com/office/powerpoint/2010/main" val="3763191641"/>
+      </p:ext>
+    </p:extLst>
+  </p:cSld>
+  <p:clrMapOvr>
+    <a:masterClrMapping/>
+  </p:clrMapOvr>
+</p:notes>
+</file>
+
+<file path=ppt/notesSlides/notesSlide14.xml><?xml version="1.0" encoding="utf-8"?>
+<p:notes xmlns:a="http://schemas.openxmlformats.org/drawingml/2006/main" xmlns:r="http://schemas.openxmlformats.org/officeDocument/2006/relationships" xmlns:p="http://schemas.openxmlformats.org/presentationml/2006/main" showMasterSp="0" showMasterPhAnim="0">
+  <p:cSld>
+    <p:spTree>
+      <p:nvGrpSpPr>
         <p:cNvPr id="1" name="Shape 183"/>
         <p:cNvGrpSpPr/>
         <p:nvPr/>
@@ -3637,7 +4048,7 @@
 </p:notes>
 </file>
 
-<file path=ppt/notesSlides/notesSlide14.xml><?xml version="1.0" encoding="utf-8"?>
+<file path=ppt/notesSlides/notesSlide15.xml><?xml version="1.0" encoding="utf-8"?>
 <p:notes xmlns:a="http://schemas.openxmlformats.org/drawingml/2006/main" xmlns:r="http://schemas.openxmlformats.org/officeDocument/2006/relationships" xmlns:p="http://schemas.openxmlformats.org/presentationml/2006/main" showMasterSp="0" showMasterPhAnim="0">
   <p:cSld>
     <p:spTree>
@@ -3764,7 +4175,7 @@
 </p:notes>
 </file>
 
-<file path=ppt/notesSlides/notesSlide15.xml><?xml version="1.0" encoding="utf-8"?>
+<file path=ppt/notesSlides/notesSlide16.xml><?xml version="1.0" encoding="utf-8"?>
 <p:notes xmlns:a="http://schemas.openxmlformats.org/drawingml/2006/main" xmlns:r="http://schemas.openxmlformats.org/officeDocument/2006/relationships" xmlns:p="http://schemas.openxmlformats.org/presentationml/2006/main" showMasterSp="0" showMasterPhAnim="0">
   <p:cSld>
     <p:spTree>
@@ -3909,7 +4320,7 @@
 </p:notes>
 </file>
 
-<file path=ppt/notesSlides/notesSlide16.xml><?xml version="1.0" encoding="utf-8"?>
+<file path=ppt/notesSlides/notesSlide17.xml><?xml version="1.0" encoding="utf-8"?>
 <p:notes xmlns:a="http://schemas.openxmlformats.org/drawingml/2006/main" xmlns:r="http://schemas.openxmlformats.org/officeDocument/2006/relationships" xmlns:p="http://schemas.openxmlformats.org/presentationml/2006/main" showMasterSp="0" showMasterPhAnim="0">
   <p:cSld>
     <p:spTree>
@@ -4054,7 +4465,7 @@
 </p:notes>
 </file>
 
-<file path=ppt/notesSlides/notesSlide17.xml><?xml version="1.0" encoding="utf-8"?>
+<file path=ppt/notesSlides/notesSlide18.xml><?xml version="1.0" encoding="utf-8"?>
 <p:notes xmlns:a="http://schemas.openxmlformats.org/drawingml/2006/main" xmlns:r="http://schemas.openxmlformats.org/officeDocument/2006/relationships" xmlns:p="http://schemas.openxmlformats.org/presentationml/2006/main" showMasterSp="0" showMasterPhAnim="0">
   <p:cSld>
     <p:spTree>
@@ -4199,7 +4610,7 @@
 </p:notes>
 </file>
 
-<file path=ppt/notesSlides/notesSlide18.xml><?xml version="1.0" encoding="utf-8"?>
+<file path=ppt/notesSlides/notesSlide19.xml><?xml version="1.0" encoding="utf-8"?>
 <p:notes xmlns:a="http://schemas.openxmlformats.org/drawingml/2006/main" xmlns:r="http://schemas.openxmlformats.org/officeDocument/2006/relationships" xmlns:p="http://schemas.openxmlformats.org/presentationml/2006/main" showMasterSp="0" showMasterPhAnim="0">
   <p:cSld>
     <p:spTree>
@@ -21337,6 +21748,854 @@
 <file path=ppt/slides/slide13.xml><?xml version="1.0" encoding="utf-8"?>
 <p:sld xmlns:a="http://schemas.openxmlformats.org/drawingml/2006/main" xmlns:r="http://schemas.openxmlformats.org/officeDocument/2006/relationships" xmlns:p="http://schemas.openxmlformats.org/presentationml/2006/main">
   <p:cSld>
+    <p:spTree>
+      <p:nvGrpSpPr>
+        <p:cNvPr id="1" name="Shape 68">
+          <a:extLst>
+            <a:ext uri="{FF2B5EF4-FFF2-40B4-BE49-F238E27FC236}">
+              <a16:creationId xmlns:a16="http://schemas.microsoft.com/office/drawing/2014/main" id="{FE12E16B-A392-6E24-A2D3-8948C24A757B}"/>
+            </a:ext>
+          </a:extLst>
+        </p:cNvPr>
+        <p:cNvGrpSpPr/>
+        <p:nvPr/>
+      </p:nvGrpSpPr>
+      <p:grpSpPr>
+        <a:xfrm>
+          <a:off x="0" y="0"/>
+          <a:ext cx="0" cy="0"/>
+          <a:chOff x="0" y="0"/>
+          <a:chExt cx="0" cy="0"/>
+        </a:xfrm>
+      </p:grpSpPr>
+      <p:pic>
+        <p:nvPicPr>
+          <p:cNvPr id="8" name="Image 7" descr="Une image contenant texte, capture d’écran, ligne, Tracé&#10;&#10;Le contenu généré par l’IA peut être incorrect.">
+            <a:extLst>
+              <a:ext uri="{FF2B5EF4-FFF2-40B4-BE49-F238E27FC236}">
+                <a16:creationId xmlns:a16="http://schemas.microsoft.com/office/drawing/2014/main" id="{36374721-DBF6-6DC3-7F02-E2A019B585B7}"/>
+              </a:ext>
+            </a:extLst>
+          </p:cNvPr>
+          <p:cNvPicPr>
+            <a:picLocks noChangeAspect="1"/>
+          </p:cNvPicPr>
+          <p:nvPr/>
+        </p:nvPicPr>
+        <p:blipFill>
+          <a:blip r:embed="rId3"/>
+          <a:stretch>
+            <a:fillRect/>
+          </a:stretch>
+        </p:blipFill>
+        <p:spPr>
+          <a:xfrm>
+            <a:off x="56562" y="1058637"/>
+            <a:ext cx="5976983" cy="2111572"/>
+          </a:xfrm>
+          <a:prstGeom prst="rect">
+            <a:avLst/>
+          </a:prstGeom>
+        </p:spPr>
+      </p:pic>
+      <p:sp>
+        <p:nvSpPr>
+          <p:cNvPr id="70" name="Google Shape;70;p3">
+            <a:extLst>
+              <a:ext uri="{FF2B5EF4-FFF2-40B4-BE49-F238E27FC236}">
+                <a16:creationId xmlns:a16="http://schemas.microsoft.com/office/drawing/2014/main" id="{9F6F2A3B-E718-0677-1AF3-47945BA37F79}"/>
+              </a:ext>
+            </a:extLst>
+          </p:cNvPr>
+          <p:cNvSpPr txBox="1">
+            <a:spLocks noGrp="1"/>
+          </p:cNvSpPr>
+          <p:nvPr>
+            <p:ph type="ctrTitle" idx="4294967295"/>
+          </p:nvPr>
+        </p:nvSpPr>
+        <p:spPr>
+          <a:xfrm>
+            <a:off x="1192664" y="403309"/>
+            <a:ext cx="5315100" cy="533100"/>
+          </a:xfrm>
+          <a:prstGeom prst="rect">
+            <a:avLst/>
+          </a:prstGeom>
+          <a:noFill/>
+          <a:ln>
+            <a:noFill/>
+          </a:ln>
+        </p:spPr>
+        <p:txBody>
+          <a:bodyPr spcFirstLastPara="1" wrap="square" lIns="91425" tIns="91425" rIns="91425" bIns="91425" anchor="t" anchorCtr="0">
+            <a:noAutofit/>
+          </a:bodyPr>
+          <a:lstStyle/>
+          <a:p>
+            <a:pPr marL="0" marR="0" lvl="0" indent="0" algn="l" rtl="0">
+              <a:lnSpc>
+                <a:spcPct val="100000"/>
+              </a:lnSpc>
+              <a:spcBef>
+                <a:spcPts val="0"/>
+              </a:spcBef>
+              <a:spcAft>
+                <a:spcPts val="0"/>
+              </a:spcAft>
+              <a:buClr>
+                <a:schemeClr val="dk1"/>
+              </a:buClr>
+              <a:buSzPts val="2800"/>
+              <a:buFont typeface="Arial"/>
+              <a:buNone/>
+            </a:pPr>
+            <a:r>
+              <a:rPr lang="fr-FR" sz="2500" i="0" u="none" strike="noStrike" cap="none" dirty="0">
+                <a:solidFill>
+                  <a:srgbClr val="0E3449"/>
+                </a:solidFill>
+                <a:latin typeface="Inter SemiBold"/>
+                <a:ea typeface="Inter SemiBold"/>
+                <a:cs typeface="Inter SemiBold"/>
+                <a:sym typeface="Inter SemiBold"/>
+              </a:rPr>
+              <a:t>Valeur ajoutée et perspectives</a:t>
+            </a:r>
+            <a:endParaRPr sz="2500" i="0" u="none" strike="noStrike" cap="none" dirty="0">
+              <a:solidFill>
+                <a:srgbClr val="0E3449"/>
+              </a:solidFill>
+              <a:latin typeface="Inter SemiBold"/>
+              <a:ea typeface="Inter SemiBold"/>
+              <a:cs typeface="Inter SemiBold"/>
+              <a:sym typeface="Inter SemiBold"/>
+            </a:endParaRPr>
+          </a:p>
+        </p:txBody>
+      </p:sp>
+      <p:sp>
+        <p:nvSpPr>
+          <p:cNvPr id="71" name="Google Shape;71;p3">
+            <a:extLst>
+              <a:ext uri="{FF2B5EF4-FFF2-40B4-BE49-F238E27FC236}">
+                <a16:creationId xmlns:a16="http://schemas.microsoft.com/office/drawing/2014/main" id="{B282795F-CC32-9B21-2C73-46BD6A694971}"/>
+              </a:ext>
+            </a:extLst>
+          </p:cNvPr>
+          <p:cNvSpPr/>
+          <p:nvPr/>
+        </p:nvSpPr>
+        <p:spPr>
+          <a:xfrm>
+            <a:off x="10225" y="4892025"/>
+            <a:ext cx="9144000" cy="251400"/>
+          </a:xfrm>
+          <a:prstGeom prst="rect">
+            <a:avLst/>
+          </a:prstGeom>
+          <a:solidFill>
+            <a:srgbClr val="C3FFFC"/>
+          </a:solidFill>
+          <a:ln>
+            <a:noFill/>
+          </a:ln>
+        </p:spPr>
+        <p:txBody>
+          <a:bodyPr spcFirstLastPara="1" wrap="square" lIns="91425" tIns="91425" rIns="91425" bIns="91425" anchor="ctr" anchorCtr="0">
+            <a:noAutofit/>
+          </a:bodyPr>
+          <a:lstStyle/>
+          <a:p>
+            <a:pPr marL="0" marR="0" lvl="0" indent="0" algn="l" rtl="0">
+              <a:lnSpc>
+                <a:spcPct val="100000"/>
+              </a:lnSpc>
+              <a:spcBef>
+                <a:spcPts val="0"/>
+              </a:spcBef>
+              <a:spcAft>
+                <a:spcPts val="0"/>
+              </a:spcAft>
+              <a:buClr>
+                <a:srgbClr val="000000"/>
+              </a:buClr>
+              <a:buSzPts val="1400"/>
+              <a:buFont typeface="Arial"/>
+              <a:buNone/>
+            </a:pPr>
+            <a:endParaRPr sz="1400" b="0" i="0" u="none" strike="noStrike" cap="none" dirty="0">
+              <a:solidFill>
+                <a:srgbClr val="000000"/>
+              </a:solidFill>
+              <a:latin typeface="Arial"/>
+              <a:ea typeface="Arial"/>
+              <a:cs typeface="Arial"/>
+              <a:sym typeface="Arial"/>
+            </a:endParaRPr>
+          </a:p>
+        </p:txBody>
+      </p:sp>
+      <p:pic>
+        <p:nvPicPr>
+          <p:cNvPr id="72" name="Google Shape;72;p3">
+            <a:extLst>
+              <a:ext uri="{FF2B5EF4-FFF2-40B4-BE49-F238E27FC236}">
+                <a16:creationId xmlns:a16="http://schemas.microsoft.com/office/drawing/2014/main" id="{D133BC4D-117A-A7BD-E1C1-78AEAF7CE4AC}"/>
+              </a:ext>
+            </a:extLst>
+          </p:cNvPr>
+          <p:cNvPicPr preferRelativeResize="0"/>
+          <p:nvPr/>
+        </p:nvPicPr>
+        <p:blipFill rotWithShape="1">
+          <a:blip r:embed="rId4">
+            <a:alphaModFix/>
+          </a:blip>
+          <a:srcRect/>
+          <a:stretch/>
+        </p:blipFill>
+        <p:spPr>
+          <a:xfrm>
+            <a:off x="463375" y="482852"/>
+            <a:ext cx="576900" cy="385904"/>
+          </a:xfrm>
+          <a:prstGeom prst="rect">
+            <a:avLst/>
+          </a:prstGeom>
+          <a:noFill/>
+          <a:ln>
+            <a:noFill/>
+          </a:ln>
+        </p:spPr>
+      </p:pic>
+      <p:sp>
+        <p:nvSpPr>
+          <p:cNvPr id="4" name="Google Shape;178;p8">
+            <a:extLst>
+              <a:ext uri="{FF2B5EF4-FFF2-40B4-BE49-F238E27FC236}">
+                <a16:creationId xmlns:a16="http://schemas.microsoft.com/office/drawing/2014/main" id="{B4652961-82E1-E9F1-B367-5278489897BB}"/>
+              </a:ext>
+            </a:extLst>
+          </p:cNvPr>
+          <p:cNvSpPr txBox="1">
+            <a:spLocks/>
+          </p:cNvSpPr>
+          <p:nvPr/>
+        </p:nvSpPr>
+        <p:spPr>
+          <a:xfrm>
+            <a:off x="1192664" y="779179"/>
+            <a:ext cx="5315100" cy="375870"/>
+          </a:xfrm>
+          <a:prstGeom prst="rect">
+            <a:avLst/>
+          </a:prstGeom>
+          <a:noFill/>
+          <a:ln>
+            <a:noFill/>
+          </a:ln>
+        </p:spPr>
+        <p:txBody>
+          <a:bodyPr spcFirstLastPara="1" wrap="square" lIns="91425" tIns="91425" rIns="91425" bIns="91425" anchor="t" anchorCtr="0">
+            <a:noAutofit/>
+          </a:bodyPr>
+          <a:lstStyle>
+            <a:defPPr marR="0" lvl="0" algn="l" rtl="0">
+              <a:lnSpc>
+                <a:spcPct val="100000"/>
+              </a:lnSpc>
+              <a:spcBef>
+                <a:spcPts val="0"/>
+              </a:spcBef>
+              <a:spcAft>
+                <a:spcPts val="0"/>
+              </a:spcAft>
+            </a:defPPr>
+            <a:lvl1pPr marR="0" lvl="0" algn="l" rtl="0">
+              <a:lnSpc>
+                <a:spcPct val="100000"/>
+              </a:lnSpc>
+              <a:spcBef>
+                <a:spcPts val="0"/>
+              </a:spcBef>
+              <a:spcAft>
+                <a:spcPts val="0"/>
+              </a:spcAft>
+              <a:buClr>
+                <a:schemeClr val="dk1"/>
+              </a:buClr>
+              <a:buSzPts val="2800"/>
+              <a:buFont typeface="Arial"/>
+              <a:buNone/>
+              <a:defRPr sz="2800" b="0" i="0" u="none" strike="noStrike" cap="none">
+                <a:solidFill>
+                  <a:schemeClr val="dk1"/>
+                </a:solidFill>
+                <a:latin typeface="Arial"/>
+                <a:ea typeface="Arial"/>
+                <a:cs typeface="Arial"/>
+                <a:sym typeface="Arial"/>
+              </a:defRPr>
+            </a:lvl1pPr>
+            <a:lvl2pPr marR="0" lvl="1" algn="l" rtl="0">
+              <a:lnSpc>
+                <a:spcPct val="100000"/>
+              </a:lnSpc>
+              <a:spcBef>
+                <a:spcPts val="0"/>
+              </a:spcBef>
+              <a:spcAft>
+                <a:spcPts val="0"/>
+              </a:spcAft>
+              <a:buClr>
+                <a:schemeClr val="dk1"/>
+              </a:buClr>
+              <a:buSzPts val="2800"/>
+              <a:buFont typeface="Arial"/>
+              <a:buNone/>
+              <a:defRPr sz="2800" b="0" i="0" u="none" strike="noStrike" cap="none">
+                <a:solidFill>
+                  <a:schemeClr val="dk1"/>
+                </a:solidFill>
+                <a:latin typeface="Arial"/>
+                <a:ea typeface="Arial"/>
+                <a:cs typeface="Arial"/>
+                <a:sym typeface="Arial"/>
+              </a:defRPr>
+            </a:lvl2pPr>
+            <a:lvl3pPr marR="0" lvl="2" algn="l" rtl="0">
+              <a:lnSpc>
+                <a:spcPct val="100000"/>
+              </a:lnSpc>
+              <a:spcBef>
+                <a:spcPts val="0"/>
+              </a:spcBef>
+              <a:spcAft>
+                <a:spcPts val="0"/>
+              </a:spcAft>
+              <a:buClr>
+                <a:schemeClr val="dk1"/>
+              </a:buClr>
+              <a:buSzPts val="2800"/>
+              <a:buFont typeface="Arial"/>
+              <a:buNone/>
+              <a:defRPr sz="2800" b="0" i="0" u="none" strike="noStrike" cap="none">
+                <a:solidFill>
+                  <a:schemeClr val="dk1"/>
+                </a:solidFill>
+                <a:latin typeface="Arial"/>
+                <a:ea typeface="Arial"/>
+                <a:cs typeface="Arial"/>
+                <a:sym typeface="Arial"/>
+              </a:defRPr>
+            </a:lvl3pPr>
+            <a:lvl4pPr marR="0" lvl="3" algn="l" rtl="0">
+              <a:lnSpc>
+                <a:spcPct val="100000"/>
+              </a:lnSpc>
+              <a:spcBef>
+                <a:spcPts val="0"/>
+              </a:spcBef>
+              <a:spcAft>
+                <a:spcPts val="0"/>
+              </a:spcAft>
+              <a:buClr>
+                <a:schemeClr val="dk1"/>
+              </a:buClr>
+              <a:buSzPts val="2800"/>
+              <a:buFont typeface="Arial"/>
+              <a:buNone/>
+              <a:defRPr sz="2800" b="0" i="0" u="none" strike="noStrike" cap="none">
+                <a:solidFill>
+                  <a:schemeClr val="dk1"/>
+                </a:solidFill>
+                <a:latin typeface="Arial"/>
+                <a:ea typeface="Arial"/>
+                <a:cs typeface="Arial"/>
+                <a:sym typeface="Arial"/>
+              </a:defRPr>
+            </a:lvl4pPr>
+            <a:lvl5pPr marR="0" lvl="4" algn="l" rtl="0">
+              <a:lnSpc>
+                <a:spcPct val="100000"/>
+              </a:lnSpc>
+              <a:spcBef>
+                <a:spcPts val="0"/>
+              </a:spcBef>
+              <a:spcAft>
+                <a:spcPts val="0"/>
+              </a:spcAft>
+              <a:buClr>
+                <a:schemeClr val="dk1"/>
+              </a:buClr>
+              <a:buSzPts val="2800"/>
+              <a:buFont typeface="Arial"/>
+              <a:buNone/>
+              <a:defRPr sz="2800" b="0" i="0" u="none" strike="noStrike" cap="none">
+                <a:solidFill>
+                  <a:schemeClr val="dk1"/>
+                </a:solidFill>
+                <a:latin typeface="Arial"/>
+                <a:ea typeface="Arial"/>
+                <a:cs typeface="Arial"/>
+                <a:sym typeface="Arial"/>
+              </a:defRPr>
+            </a:lvl5pPr>
+            <a:lvl6pPr marR="0" lvl="5" algn="l" rtl="0">
+              <a:lnSpc>
+                <a:spcPct val="100000"/>
+              </a:lnSpc>
+              <a:spcBef>
+                <a:spcPts val="0"/>
+              </a:spcBef>
+              <a:spcAft>
+                <a:spcPts val="0"/>
+              </a:spcAft>
+              <a:buClr>
+                <a:schemeClr val="dk1"/>
+              </a:buClr>
+              <a:buSzPts val="2800"/>
+              <a:buFont typeface="Arial"/>
+              <a:buNone/>
+              <a:defRPr sz="2800" b="0" i="0" u="none" strike="noStrike" cap="none">
+                <a:solidFill>
+                  <a:schemeClr val="dk1"/>
+                </a:solidFill>
+                <a:latin typeface="Arial"/>
+                <a:ea typeface="Arial"/>
+                <a:cs typeface="Arial"/>
+                <a:sym typeface="Arial"/>
+              </a:defRPr>
+            </a:lvl6pPr>
+            <a:lvl7pPr marR="0" lvl="6" algn="l" rtl="0">
+              <a:lnSpc>
+                <a:spcPct val="100000"/>
+              </a:lnSpc>
+              <a:spcBef>
+                <a:spcPts val="0"/>
+              </a:spcBef>
+              <a:spcAft>
+                <a:spcPts val="0"/>
+              </a:spcAft>
+              <a:buClr>
+                <a:schemeClr val="dk1"/>
+              </a:buClr>
+              <a:buSzPts val="2800"/>
+              <a:buFont typeface="Arial"/>
+              <a:buNone/>
+              <a:defRPr sz="2800" b="0" i="0" u="none" strike="noStrike" cap="none">
+                <a:solidFill>
+                  <a:schemeClr val="dk1"/>
+                </a:solidFill>
+                <a:latin typeface="Arial"/>
+                <a:ea typeface="Arial"/>
+                <a:cs typeface="Arial"/>
+                <a:sym typeface="Arial"/>
+              </a:defRPr>
+            </a:lvl7pPr>
+            <a:lvl8pPr marR="0" lvl="7" algn="l" rtl="0">
+              <a:lnSpc>
+                <a:spcPct val="100000"/>
+              </a:lnSpc>
+              <a:spcBef>
+                <a:spcPts val="0"/>
+              </a:spcBef>
+              <a:spcAft>
+                <a:spcPts val="0"/>
+              </a:spcAft>
+              <a:buClr>
+                <a:schemeClr val="dk1"/>
+              </a:buClr>
+              <a:buSzPts val="2800"/>
+              <a:buFont typeface="Arial"/>
+              <a:buNone/>
+              <a:defRPr sz="2800" b="0" i="0" u="none" strike="noStrike" cap="none">
+                <a:solidFill>
+                  <a:schemeClr val="dk1"/>
+                </a:solidFill>
+                <a:latin typeface="Arial"/>
+                <a:ea typeface="Arial"/>
+                <a:cs typeface="Arial"/>
+                <a:sym typeface="Arial"/>
+              </a:defRPr>
+            </a:lvl8pPr>
+            <a:lvl9pPr marR="0" lvl="8" algn="l" rtl="0">
+              <a:lnSpc>
+                <a:spcPct val="100000"/>
+              </a:lnSpc>
+              <a:spcBef>
+                <a:spcPts val="0"/>
+              </a:spcBef>
+              <a:spcAft>
+                <a:spcPts val="0"/>
+              </a:spcAft>
+              <a:buClr>
+                <a:schemeClr val="dk1"/>
+              </a:buClr>
+              <a:buSzPts val="2800"/>
+              <a:buFont typeface="Arial"/>
+              <a:buNone/>
+              <a:defRPr sz="2800" b="0" i="0" u="none" strike="noStrike" cap="none">
+                <a:solidFill>
+                  <a:schemeClr val="dk1"/>
+                </a:solidFill>
+                <a:latin typeface="Arial"/>
+                <a:ea typeface="Arial"/>
+                <a:cs typeface="Arial"/>
+                <a:sym typeface="Arial"/>
+              </a:defRPr>
+            </a:lvl9pPr>
+          </a:lstStyle>
+          <a:p>
+            <a:r>
+              <a:rPr lang="fr-FR" sz="1400" b="1" dirty="0">
+                <a:solidFill>
+                  <a:srgbClr val="0E3449"/>
+                </a:solidFill>
+                <a:latin typeface="Inter SemiBold"/>
+                <a:ea typeface="Inter SemiBold"/>
+                <a:sym typeface="Inter SemiBold"/>
+              </a:rPr>
+              <a:t>En cours : Amélioration du modèle</a:t>
+            </a:r>
+          </a:p>
+        </p:txBody>
+      </p:sp>
+      <p:pic>
+        <p:nvPicPr>
+          <p:cNvPr id="12" name="Image 11" descr="Une image contenant texte, capture d’écran, ligne, Tracé">
+            <a:extLst>
+              <a:ext uri="{FF2B5EF4-FFF2-40B4-BE49-F238E27FC236}">
+                <a16:creationId xmlns:a16="http://schemas.microsoft.com/office/drawing/2014/main" id="{D61A617B-D6B7-1A94-495F-DC4E854385A5}"/>
+              </a:ext>
+            </a:extLst>
+          </p:cNvPr>
+          <p:cNvPicPr>
+            <a:picLocks noChangeAspect="1"/>
+          </p:cNvPicPr>
+          <p:nvPr/>
+        </p:nvPicPr>
+        <p:blipFill>
+          <a:blip r:embed="rId5"/>
+          <a:stretch>
+            <a:fillRect/>
+          </a:stretch>
+        </p:blipFill>
+        <p:spPr>
+          <a:xfrm>
+            <a:off x="3431357" y="2917309"/>
+            <a:ext cx="5561813" cy="1974716"/>
+          </a:xfrm>
+          <a:prstGeom prst="rect">
+            <a:avLst/>
+          </a:prstGeom>
+        </p:spPr>
+      </p:pic>
+      <p:sp>
+        <p:nvSpPr>
+          <p:cNvPr id="13" name="Flèche : droite 12">
+            <a:extLst>
+              <a:ext uri="{FF2B5EF4-FFF2-40B4-BE49-F238E27FC236}">
+                <a16:creationId xmlns:a16="http://schemas.microsoft.com/office/drawing/2014/main" id="{A0C660C5-C6B4-4D60-632C-38AA341D4E42}"/>
+              </a:ext>
+            </a:extLst>
+          </p:cNvPr>
+          <p:cNvSpPr/>
+          <p:nvPr/>
+        </p:nvSpPr>
+        <p:spPr>
+          <a:xfrm flipH="1">
+            <a:off x="5962454" y="1835009"/>
+            <a:ext cx="1202174" cy="596535"/>
+          </a:xfrm>
+          <a:prstGeom prst="rightArrow">
+            <a:avLst/>
+          </a:prstGeom>
+          <a:solidFill>
+            <a:srgbClr val="FF0000"/>
+          </a:solidFill>
+          <a:ln>
+            <a:noFill/>
+          </a:ln>
+        </p:spPr>
+        <p:style>
+          <a:lnRef idx="2">
+            <a:schemeClr val="accent1">
+              <a:shade val="15000"/>
+            </a:schemeClr>
+          </a:lnRef>
+          <a:fillRef idx="1">
+            <a:schemeClr val="accent1"/>
+          </a:fillRef>
+          <a:effectRef idx="0">
+            <a:schemeClr val="accent1"/>
+          </a:effectRef>
+          <a:fontRef idx="minor">
+            <a:schemeClr val="lt1"/>
+          </a:fontRef>
+        </p:style>
+        <p:txBody>
+          <a:bodyPr rtlCol="0" anchor="ctr"/>
+          <a:lstStyle/>
+          <a:p>
+            <a:pPr algn="ctr"/>
+            <a:r>
+              <a:rPr lang="fr-FR" sz="1000" b="1" dirty="0"/>
+              <a:t>Amélioration du modèle</a:t>
+            </a:r>
+          </a:p>
+        </p:txBody>
+      </p:sp>
+      <p:sp>
+        <p:nvSpPr>
+          <p:cNvPr id="15" name="Flèche : droite 14">
+            <a:extLst>
+              <a:ext uri="{FF2B5EF4-FFF2-40B4-BE49-F238E27FC236}">
+                <a16:creationId xmlns:a16="http://schemas.microsoft.com/office/drawing/2014/main" id="{7B02442F-1F39-3A7F-A132-603CFB285A80}"/>
+              </a:ext>
+            </a:extLst>
+          </p:cNvPr>
+          <p:cNvSpPr/>
+          <p:nvPr/>
+        </p:nvSpPr>
+        <p:spPr>
+          <a:xfrm>
+            <a:off x="1956062" y="3539452"/>
+            <a:ext cx="1314240" cy="596535"/>
+          </a:xfrm>
+          <a:prstGeom prst="rightArrow">
+            <a:avLst/>
+          </a:prstGeom>
+          <a:solidFill>
+            <a:srgbClr val="FF0000"/>
+          </a:solidFill>
+          <a:ln>
+            <a:noFill/>
+          </a:ln>
+        </p:spPr>
+        <p:style>
+          <a:lnRef idx="2">
+            <a:schemeClr val="accent1">
+              <a:shade val="15000"/>
+            </a:schemeClr>
+          </a:lnRef>
+          <a:fillRef idx="1">
+            <a:schemeClr val="accent1"/>
+          </a:fillRef>
+          <a:effectRef idx="0">
+            <a:schemeClr val="accent1"/>
+          </a:effectRef>
+          <a:fontRef idx="minor">
+            <a:schemeClr val="lt1"/>
+          </a:fontRef>
+        </p:style>
+        <p:txBody>
+          <a:bodyPr rtlCol="0" anchor="ctr"/>
+          <a:lstStyle/>
+          <a:p>
+            <a:pPr algn="ctr"/>
+            <a:r>
+              <a:rPr lang="fr-FR" sz="1000" b="1" dirty="0"/>
+              <a:t>Généralisation</a:t>
+            </a:r>
+          </a:p>
+        </p:txBody>
+      </p:sp>
+    </p:spTree>
+    <p:extLst>
+      <p:ext uri="{BB962C8B-B14F-4D97-AF65-F5344CB8AC3E}">
+        <p14:creationId xmlns:p14="http://schemas.microsoft.com/office/powerpoint/2010/main" val="1528976140"/>
+      </p:ext>
+    </p:extLst>
+  </p:cSld>
+  <p:clrMapOvr>
+    <a:masterClrMapping/>
+  </p:clrMapOvr>
+  <p:timing>
+    <p:tnLst>
+      <p:par>
+        <p:cTn id="1" dur="indefinite" restart="never" nodeType="tmRoot">
+          <p:childTnLst>
+            <p:seq concurrent="1" nextAc="seek">
+              <p:cTn id="2" dur="indefinite" nodeType="mainSeq">
+                <p:childTnLst>
+                  <p:par>
+                    <p:cTn id="3" fill="hold">
+                      <p:stCondLst>
+                        <p:cond delay="indefinite"/>
+                      </p:stCondLst>
+                      <p:childTnLst>
+                        <p:par>
+                          <p:cTn id="4" fill="hold">
+                            <p:stCondLst>
+                              <p:cond delay="0"/>
+                            </p:stCondLst>
+                            <p:childTnLst>
+                              <p:par>
+                                <p:cTn id="5" presetID="1" presetClass="entr" presetSubtype="0" fill="hold" nodeType="clickEffect">
+                                  <p:stCondLst>
+                                    <p:cond delay="0"/>
+                                  </p:stCondLst>
+                                  <p:childTnLst>
+                                    <p:set>
+                                      <p:cBhvr>
+                                        <p:cTn id="6" dur="1" fill="hold">
+                                          <p:stCondLst>
+                                            <p:cond delay="0"/>
+                                          </p:stCondLst>
+                                        </p:cTn>
+                                        <p:tgtEl>
+                                          <p:spTgt spid="8"/>
+                                        </p:tgtEl>
+                                        <p:attrNameLst>
+                                          <p:attrName>style.visibility</p:attrName>
+                                        </p:attrNameLst>
+                                      </p:cBhvr>
+                                      <p:to>
+                                        <p:strVal val="visible"/>
+                                      </p:to>
+                                    </p:set>
+                                  </p:childTnLst>
+                                </p:cTn>
+                              </p:par>
+                              <p:par>
+                                <p:cTn id="7" presetID="1" presetClass="entr" presetSubtype="0" fill="hold" grpId="0" nodeType="withEffect">
+                                  <p:stCondLst>
+                                    <p:cond delay="0"/>
+                                  </p:stCondLst>
+                                  <p:childTnLst>
+                                    <p:set>
+                                      <p:cBhvr>
+                                        <p:cTn id="8" dur="1" fill="hold">
+                                          <p:stCondLst>
+                                            <p:cond delay="0"/>
+                                          </p:stCondLst>
+                                        </p:cTn>
+                                        <p:tgtEl>
+                                          <p:spTgt spid="13"/>
+                                        </p:tgtEl>
+                                        <p:attrNameLst>
+                                          <p:attrName>style.visibility</p:attrName>
+                                        </p:attrNameLst>
+                                      </p:cBhvr>
+                                      <p:to>
+                                        <p:strVal val="visible"/>
+                                      </p:to>
+                                    </p:set>
+                                  </p:childTnLst>
+                                </p:cTn>
+                              </p:par>
+                            </p:childTnLst>
+                          </p:cTn>
+                        </p:par>
+                      </p:childTnLst>
+                    </p:cTn>
+                  </p:par>
+                  <p:par>
+                    <p:cTn id="9" fill="hold">
+                      <p:stCondLst>
+                        <p:cond delay="indefinite"/>
+                      </p:stCondLst>
+                      <p:childTnLst>
+                        <p:par>
+                          <p:cTn id="10" fill="hold">
+                            <p:stCondLst>
+                              <p:cond delay="0"/>
+                            </p:stCondLst>
+                            <p:childTnLst>
+                              <p:par>
+                                <p:cTn id="11" presetID="1" presetClass="entr" presetSubtype="0" fill="hold" grpId="0" nodeType="clickEffect">
+                                  <p:stCondLst>
+                                    <p:cond delay="0"/>
+                                  </p:stCondLst>
+                                  <p:childTnLst>
+                                    <p:set>
+                                      <p:cBhvr>
+                                        <p:cTn id="12" dur="1" fill="hold">
+                                          <p:stCondLst>
+                                            <p:cond delay="0"/>
+                                          </p:stCondLst>
+                                        </p:cTn>
+                                        <p:tgtEl>
+                                          <p:spTgt spid="15"/>
+                                        </p:tgtEl>
+                                        <p:attrNameLst>
+                                          <p:attrName>style.visibility</p:attrName>
+                                        </p:attrNameLst>
+                                      </p:cBhvr>
+                                      <p:to>
+                                        <p:strVal val="visible"/>
+                                      </p:to>
+                                    </p:set>
+                                  </p:childTnLst>
+                                </p:cTn>
+                              </p:par>
+                              <p:par>
+                                <p:cTn id="13" presetID="1" presetClass="entr" presetSubtype="0" fill="hold" nodeType="withEffect">
+                                  <p:stCondLst>
+                                    <p:cond delay="0"/>
+                                  </p:stCondLst>
+                                  <p:childTnLst>
+                                    <p:set>
+                                      <p:cBhvr>
+                                        <p:cTn id="14" dur="1" fill="hold">
+                                          <p:stCondLst>
+                                            <p:cond delay="0"/>
+                                          </p:stCondLst>
+                                        </p:cTn>
+                                        <p:tgtEl>
+                                          <p:spTgt spid="12"/>
+                                        </p:tgtEl>
+                                        <p:attrNameLst>
+                                          <p:attrName>style.visibility</p:attrName>
+                                        </p:attrNameLst>
+                                      </p:cBhvr>
+                                      <p:to>
+                                        <p:strVal val="visible"/>
+                                      </p:to>
+                                    </p:set>
+                                  </p:childTnLst>
+                                </p:cTn>
+                              </p:par>
+                            </p:childTnLst>
+                          </p:cTn>
+                        </p:par>
+                      </p:childTnLst>
+                    </p:cTn>
+                  </p:par>
+                </p:childTnLst>
+              </p:cTn>
+              <p:prevCondLst>
+                <p:cond evt="onPrev" delay="0">
+                  <p:tgtEl>
+                    <p:sldTgt/>
+                  </p:tgtEl>
+                </p:cond>
+              </p:prevCondLst>
+              <p:nextCondLst>
+                <p:cond evt="onNext" delay="0">
+                  <p:tgtEl>
+                    <p:sldTgt/>
+                  </p:tgtEl>
+                </p:cond>
+              </p:nextCondLst>
+            </p:seq>
+          </p:childTnLst>
+        </p:cTn>
+      </p:par>
+    </p:tnLst>
+    <p:bldLst>
+      <p:bldP spid="13" grpId="0" animBg="1"/>
+      <p:bldP spid="15" grpId="0" animBg="1"/>
+    </p:bldLst>
+  </p:timing>
+</p:sld>
+</file>
+
+<file path=ppt/slides/slide14.xml><?xml version="1.0" encoding="utf-8"?>
+<p:sld xmlns:a="http://schemas.openxmlformats.org/drawingml/2006/main" xmlns:r="http://schemas.openxmlformats.org/officeDocument/2006/relationships" xmlns:p="http://schemas.openxmlformats.org/presentationml/2006/main">
+  <p:cSld>
     <p:bg>
       <p:bgPr>
         <a:solidFill>
@@ -21640,7 +22899,7 @@
 </p:sld>
 </file>
 
-<file path=ppt/slides/slide14.xml><?xml version="1.0" encoding="utf-8"?>
+<file path=ppt/slides/slide15.xml><?xml version="1.0" encoding="utf-8"?>
 <p:sld xmlns:a="http://schemas.openxmlformats.org/drawingml/2006/main" xmlns:r="http://schemas.openxmlformats.org/officeDocument/2006/relationships" xmlns:p="http://schemas.openxmlformats.org/presentationml/2006/main">
   <p:cSld>
     <p:spTree>
@@ -21774,7 +23033,7 @@
 </p:sld>
 </file>
 
-<file path=ppt/slides/slide15.xml><?xml version="1.0" encoding="utf-8"?>
+<file path=ppt/slides/slide16.xml><?xml version="1.0" encoding="utf-8"?>
 <p:sld xmlns:a="http://schemas.openxmlformats.org/drawingml/2006/main" xmlns:r="http://schemas.openxmlformats.org/officeDocument/2006/relationships" xmlns:p="http://schemas.openxmlformats.org/presentationml/2006/main">
   <p:cSld>
     <p:spTree>
@@ -23474,7 +24733,7 @@
 </p:sld>
 </file>
 
-<file path=ppt/slides/slide16.xml><?xml version="1.0" encoding="utf-8"?>
+<file path=ppt/slides/slide17.xml><?xml version="1.0" encoding="utf-8"?>
 <p:sld xmlns:a="http://schemas.openxmlformats.org/drawingml/2006/main" xmlns:r="http://schemas.openxmlformats.org/officeDocument/2006/relationships" xmlns:p="http://schemas.openxmlformats.org/presentationml/2006/main">
   <p:cSld>
     <p:spTree>
@@ -24888,7 +26147,7 @@
 </p:sld>
 </file>
 
-<file path=ppt/slides/slide17.xml><?xml version="1.0" encoding="utf-8"?>
+<file path=ppt/slides/slide18.xml><?xml version="1.0" encoding="utf-8"?>
 <p:sld xmlns:a="http://schemas.openxmlformats.org/drawingml/2006/main" xmlns:r="http://schemas.openxmlformats.org/officeDocument/2006/relationships" xmlns:p="http://schemas.openxmlformats.org/presentationml/2006/main">
   <p:cSld>
     <p:spTree>
@@ -25226,7 +26485,7 @@
 </p:sld>
 </file>
 
-<file path=ppt/slides/slide18.xml><?xml version="1.0" encoding="utf-8"?>
+<file path=ppt/slides/slide19.xml><?xml version="1.0" encoding="utf-8"?>
 <p:sld xmlns:a="http://schemas.openxmlformats.org/drawingml/2006/main" xmlns:r="http://schemas.openxmlformats.org/officeDocument/2006/relationships" xmlns:p="http://schemas.openxmlformats.org/presentationml/2006/main">
   <p:cSld>
     <p:spTree>
@@ -29211,7 +30470,7 @@
                                           </p:stCondLst>
                                         </p:cTn>
                                         <p:tgtEl>
-                                          <p:spTgt spid="6"/>
+                                          <p:spTgt spid="12"/>
                                         </p:tgtEl>
                                         <p:attrNameLst>
                                           <p:attrName>style.visibility</p:attrName>
@@ -29238,34 +30497,7 @@
                                           </p:stCondLst>
                                         </p:cTn>
                                         <p:tgtEl>
-                                          <p:spTgt spid="7"/>
-                                        </p:tgtEl>
-                                        <p:attrNameLst>
-                                          <p:attrName>style.visibility</p:attrName>
-                                        </p:attrNameLst>
-                                      </p:cBhvr>
-                                      <p:to>
-                                        <p:strVal val="visible"/>
-                                      </p:to>
-                                    </p:set>
-                                  </p:childTnLst>
-                                </p:cTn>
-                              </p:par>
-                              <p:par>
-                                <p:cTn id="13" presetID="1" presetClass="entr" presetSubtype="0" fill="hold" nodeType="withEffect">
-                                  <p:stCondLst>
-                                    <p:cond delay="0"/>
-                                  </p:stCondLst>
-                                  <p:childTnLst>
-                                    <p:set>
-                                      <p:cBhvr>
-                                        <p:cTn id="14" dur="1" fill="hold">
-                                          <p:stCondLst>
-                                            <p:cond delay="0"/>
-                                          </p:stCondLst>
-                                        </p:cTn>
-                                        <p:tgtEl>
-                                          <p:spTgt spid="11"/>
+                                          <p:spTgt spid="5"/>
                                         </p:tgtEl>
                                         <p:attrNameLst>
                                           <p:attrName>style.visibility</p:attrName>
@@ -29285,19 +30517,46 @@
                     </p:cTn>
                   </p:par>
                   <p:par>
-                    <p:cTn id="15" fill="hold">
+                    <p:cTn id="13" fill="hold">
                       <p:stCondLst>
                         <p:cond delay="indefinite"/>
                       </p:stCondLst>
                       <p:childTnLst>
                         <p:par>
-                          <p:cTn id="16" fill="hold">
+                          <p:cTn id="14" fill="hold">
                             <p:stCondLst>
                               <p:cond delay="0"/>
                             </p:stCondLst>
                             <p:childTnLst>
                               <p:par>
-                                <p:cTn id="17" presetID="1" presetClass="entr" presetSubtype="0" fill="hold" grpId="0" nodeType="clickEffect">
+                                <p:cTn id="15" presetID="1" presetClass="entr" presetSubtype="0" fill="hold" nodeType="clickEffect">
+                                  <p:stCondLst>
+                                    <p:cond delay="0"/>
+                                  </p:stCondLst>
+                                  <p:childTnLst>
+                                    <p:set>
+                                      <p:cBhvr>
+                                        <p:cTn id="16" dur="1" fill="hold">
+                                          <p:stCondLst>
+                                            <p:cond delay="0"/>
+                                          </p:stCondLst>
+                                        </p:cTn>
+                                        <p:tgtEl>
+                                          <p:spTgt spid="11"/>
+                                        </p:tgtEl>
+                                        <p:attrNameLst>
+                                          <p:attrName>style.visibility</p:attrName>
+                                        </p:attrNameLst>
+                                      </p:cBhvr>
+                                      <p:to>
+                                        <p:strVal val="visible"/>
+                                      </p:to>
+                                    </p:set>
+                                  </p:childTnLst>
+                                </p:cTn>
+                              </p:par>
+                              <p:par>
+                                <p:cTn id="17" presetID="1" presetClass="entr" presetSubtype="0" fill="hold" grpId="0" nodeType="withEffect">
                                   <p:stCondLst>
                                     <p:cond delay="0"/>
                                   </p:stCondLst>
@@ -29310,7 +30569,7 @@
                                           </p:stCondLst>
                                         </p:cTn>
                                         <p:tgtEl>
-                                          <p:spTgt spid="8"/>
+                                          <p:spTgt spid="6"/>
                                         </p:tgtEl>
                                         <p:attrNameLst>
                                           <p:attrName>style.visibility</p:attrName>
@@ -29337,7 +30596,52 @@
                                           </p:stCondLst>
                                         </p:cTn>
                                         <p:tgtEl>
-                                          <p:spTgt spid="9"/>
+                                          <p:spTgt spid="7"/>
+                                        </p:tgtEl>
+                                        <p:attrNameLst>
+                                          <p:attrName>style.visibility</p:attrName>
+                                        </p:attrNameLst>
+                                      </p:cBhvr>
+                                      <p:to>
+                                        <p:strVal val="visible"/>
+                                      </p:to>
+                                    </p:set>
+                                  </p:childTnLst>
+                                </p:cTn>
+                              </p:par>
+                            </p:childTnLst>
+                          </p:cTn>
+                        </p:par>
+                      </p:childTnLst>
+                    </p:cTn>
+                  </p:par>
+                  <p:par>
+                    <p:cTn id="21" fill="hold">
+                      <p:stCondLst>
+                        <p:cond delay="indefinite"/>
+                      </p:stCondLst>
+                      <p:childTnLst>
+                        <p:par>
+                          <p:cTn id="22" fill="hold">
+                            <p:stCondLst>
+                              <p:cond delay="0"/>
+                            </p:stCondLst>
+                            <p:childTnLst>
+                              <p:par>
+                                <p:cTn id="23" presetID="1" presetClass="entr" presetSubtype="0" fill="hold" grpId="0" nodeType="clickEffect">
+                                  <p:stCondLst>
+                                    <p:cond delay="0"/>
+                                  </p:stCondLst>
+                                  <p:childTnLst>
+                                    <p:set>
+                                      <p:cBhvr>
+                                        <p:cTn id="24" dur="1" fill="hold">
+                                          <p:stCondLst>
+                                            <p:cond delay="0"/>
+                                          </p:stCondLst>
+                                        </p:cTn>
+                                        <p:tgtEl>
+                                          <p:spTgt spid="13"/>
                                         </p:tgtEl>
                                         <p:attrNameLst>
                                           <p:attrName>style.visibility</p:attrName>
@@ -29351,20 +30655,47 @@
                                 </p:cTn>
                               </p:par>
                               <p:par>
-                                <p:cTn id="21" presetID="1" presetClass="entr" presetSubtype="0" fill="hold" grpId="0" nodeType="withEffect">
+                                <p:cTn id="25" presetID="1" presetClass="entr" presetSubtype="0" fill="hold" grpId="0" nodeType="withEffect">
                                   <p:stCondLst>
                                     <p:cond delay="0"/>
                                   </p:stCondLst>
                                   <p:childTnLst>
                                     <p:set>
                                       <p:cBhvr>
-                                        <p:cTn id="22" dur="1" fill="hold">
+                                        <p:cTn id="26" dur="1" fill="hold">
                                           <p:stCondLst>
                                             <p:cond delay="0"/>
                                           </p:stCondLst>
                                         </p:cTn>
                                         <p:tgtEl>
-                                          <p:spTgt spid="13"/>
+                                          <p:spTgt spid="8"/>
+                                        </p:tgtEl>
+                                        <p:attrNameLst>
+                                          <p:attrName>style.visibility</p:attrName>
+                                        </p:attrNameLst>
+                                      </p:cBhvr>
+                                      <p:to>
+                                        <p:strVal val="visible"/>
+                                      </p:to>
+                                    </p:set>
+                                  </p:childTnLst>
+                                </p:cTn>
+                              </p:par>
+                              <p:par>
+                                <p:cTn id="27" presetID="1" presetClass="entr" presetSubtype="0" fill="hold" grpId="0" nodeType="withEffect">
+                                  <p:stCondLst>
+                                    <p:cond delay="0"/>
+                                  </p:stCondLst>
+                                  <p:childTnLst>
+                                    <p:set>
+                                      <p:cBhvr>
+                                        <p:cTn id="28" dur="1" fill="hold">
+                                          <p:stCondLst>
+                                            <p:cond delay="0"/>
+                                          </p:stCondLst>
+                                        </p:cTn>
+                                        <p:tgtEl>
+                                          <p:spTgt spid="9"/>
                                         </p:tgtEl>
                                         <p:attrNameLst>
                                           <p:attrName>style.visibility</p:attrName>
@@ -29411,6 +30742,8 @@
       <p:bldP spid="8" grpId="0" animBg="1"/>
       <p:bldP spid="9" grpId="0" animBg="1"/>
       <p:bldP spid="13" grpId="0" animBg="1"/>
+      <p:bldP spid="5" grpId="0" animBg="1"/>
+      <p:bldP spid="12" grpId="0" animBg="1"/>
     </p:bldLst>
   </p:timing>
 </p:sld>
@@ -41032,8 +42365,8 @@
         </p:blipFill>
         <p:spPr>
           <a:xfrm>
-            <a:off x="4976649" y="3166441"/>
-            <a:ext cx="3357640" cy="1698504"/>
+            <a:off x="4963214" y="3159645"/>
+            <a:ext cx="3371075" cy="1705300"/>
           </a:xfrm>
           <a:prstGeom prst="rect">
             <a:avLst/>
@@ -41062,14 +42395,348 @@
         </p:blipFill>
         <p:spPr>
           <a:xfrm>
-            <a:off x="311699" y="3180270"/>
-            <a:ext cx="3466770" cy="1711699"/>
+            <a:off x="311699" y="3159645"/>
+            <a:ext cx="3430740" cy="1693909"/>
           </a:xfrm>
           <a:prstGeom prst="rect">
             <a:avLst/>
           </a:prstGeom>
         </p:spPr>
       </p:pic>
+      <p:sp>
+        <p:nvSpPr>
+          <p:cNvPr id="3" name="Google Shape;178;p8">
+            <a:extLst>
+              <a:ext uri="{FF2B5EF4-FFF2-40B4-BE49-F238E27FC236}">
+                <a16:creationId xmlns:a16="http://schemas.microsoft.com/office/drawing/2014/main" id="{DEBF304F-77EB-BA94-CD84-BF91A9CC35D2}"/>
+              </a:ext>
+            </a:extLst>
+          </p:cNvPr>
+          <p:cNvSpPr txBox="1">
+            <a:spLocks/>
+          </p:cNvSpPr>
+          <p:nvPr/>
+        </p:nvSpPr>
+        <p:spPr>
+          <a:xfrm>
+            <a:off x="258304" y="4717038"/>
+            <a:ext cx="3233278" cy="125564"/>
+          </a:xfrm>
+          <a:prstGeom prst="rect">
+            <a:avLst/>
+          </a:prstGeom>
+          <a:noFill/>
+          <a:ln>
+            <a:noFill/>
+          </a:ln>
+        </p:spPr>
+        <p:txBody>
+          <a:bodyPr spcFirstLastPara="1" wrap="square" lIns="91425" tIns="91425" rIns="91425" bIns="91425" anchor="t" anchorCtr="0">
+            <a:noAutofit/>
+          </a:bodyPr>
+          <a:lstStyle>
+            <a:defPPr marR="0" lvl="0" algn="l" rtl="0">
+              <a:lnSpc>
+                <a:spcPct val="100000"/>
+              </a:lnSpc>
+              <a:spcBef>
+                <a:spcPts val="0"/>
+              </a:spcBef>
+              <a:spcAft>
+                <a:spcPts val="0"/>
+              </a:spcAft>
+              <a:defRPr/>
+            </a:defPPr>
+            <a:lvl1pPr>
+              <a:buClr>
+                <a:schemeClr val="dk1"/>
+              </a:buClr>
+              <a:buSzPts val="2800"/>
+              <a:buNone/>
+              <a:defRPr sz="800" b="1">
+                <a:solidFill>
+                  <a:srgbClr val="0E3449"/>
+                </a:solidFill>
+                <a:latin typeface="Inter SemiBold"/>
+                <a:ea typeface="Inter SemiBold"/>
+              </a:defRPr>
+            </a:lvl1pPr>
+            <a:lvl2pPr>
+              <a:buClr>
+                <a:schemeClr val="dk1"/>
+              </a:buClr>
+              <a:buSzPts val="2800"/>
+              <a:buNone/>
+              <a:defRPr sz="2800">
+                <a:solidFill>
+                  <a:schemeClr val="dk1"/>
+                </a:solidFill>
+              </a:defRPr>
+            </a:lvl2pPr>
+            <a:lvl3pPr>
+              <a:buClr>
+                <a:schemeClr val="dk1"/>
+              </a:buClr>
+              <a:buSzPts val="2800"/>
+              <a:buNone/>
+              <a:defRPr sz="2800">
+                <a:solidFill>
+                  <a:schemeClr val="dk1"/>
+                </a:solidFill>
+              </a:defRPr>
+            </a:lvl3pPr>
+            <a:lvl4pPr>
+              <a:buClr>
+                <a:schemeClr val="dk1"/>
+              </a:buClr>
+              <a:buSzPts val="2800"/>
+              <a:buNone/>
+              <a:defRPr sz="2800">
+                <a:solidFill>
+                  <a:schemeClr val="dk1"/>
+                </a:solidFill>
+              </a:defRPr>
+            </a:lvl4pPr>
+            <a:lvl5pPr>
+              <a:buClr>
+                <a:schemeClr val="dk1"/>
+              </a:buClr>
+              <a:buSzPts val="2800"/>
+              <a:buNone/>
+              <a:defRPr sz="2800">
+                <a:solidFill>
+                  <a:schemeClr val="dk1"/>
+                </a:solidFill>
+              </a:defRPr>
+            </a:lvl5pPr>
+            <a:lvl6pPr>
+              <a:buClr>
+                <a:schemeClr val="dk1"/>
+              </a:buClr>
+              <a:buSzPts val="2800"/>
+              <a:buNone/>
+              <a:defRPr sz="2800">
+                <a:solidFill>
+                  <a:schemeClr val="dk1"/>
+                </a:solidFill>
+              </a:defRPr>
+            </a:lvl6pPr>
+            <a:lvl7pPr>
+              <a:buClr>
+                <a:schemeClr val="dk1"/>
+              </a:buClr>
+              <a:buSzPts val="2800"/>
+              <a:buNone/>
+              <a:defRPr sz="2800">
+                <a:solidFill>
+                  <a:schemeClr val="dk1"/>
+                </a:solidFill>
+              </a:defRPr>
+            </a:lvl7pPr>
+            <a:lvl8pPr>
+              <a:buClr>
+                <a:schemeClr val="dk1"/>
+              </a:buClr>
+              <a:buSzPts val="2800"/>
+              <a:buNone/>
+              <a:defRPr sz="2800">
+                <a:solidFill>
+                  <a:schemeClr val="dk1"/>
+                </a:solidFill>
+              </a:defRPr>
+            </a:lvl8pPr>
+            <a:lvl9pPr>
+              <a:buClr>
+                <a:schemeClr val="dk1"/>
+              </a:buClr>
+              <a:buSzPts val="2800"/>
+              <a:buNone/>
+              <a:defRPr sz="2800">
+                <a:solidFill>
+                  <a:schemeClr val="dk1"/>
+                </a:solidFill>
+              </a:defRPr>
+            </a:lvl9pPr>
+          </a:lstStyle>
+          <a:p>
+            <a:pPr algn="ctr"/>
+            <a:r>
+              <a:rPr lang="fr-FR" sz="500" b="0" dirty="0"/>
+              <a:t>heure</a:t>
+            </a:r>
+            <a:endParaRPr lang="fr-FR" sz="500" b="0" dirty="0">
+              <a:sym typeface="Inter SemiBold"/>
+            </a:endParaRPr>
+          </a:p>
+        </p:txBody>
+      </p:sp>
+      <p:sp>
+        <p:nvSpPr>
+          <p:cNvPr id="4" name="Google Shape;178;p8">
+            <a:extLst>
+              <a:ext uri="{FF2B5EF4-FFF2-40B4-BE49-F238E27FC236}">
+                <a16:creationId xmlns:a16="http://schemas.microsoft.com/office/drawing/2014/main" id="{1A25B44F-3D72-A752-04D6-8C3086471959}"/>
+              </a:ext>
+            </a:extLst>
+          </p:cNvPr>
+          <p:cNvSpPr txBox="1">
+            <a:spLocks/>
+          </p:cNvSpPr>
+          <p:nvPr/>
+        </p:nvSpPr>
+        <p:spPr>
+          <a:xfrm>
+            <a:off x="4891125" y="4717038"/>
+            <a:ext cx="3233278" cy="125564"/>
+          </a:xfrm>
+          <a:prstGeom prst="rect">
+            <a:avLst/>
+          </a:prstGeom>
+          <a:noFill/>
+          <a:ln>
+            <a:noFill/>
+          </a:ln>
+        </p:spPr>
+        <p:txBody>
+          <a:bodyPr spcFirstLastPara="1" wrap="square" lIns="91425" tIns="91425" rIns="91425" bIns="91425" anchor="t" anchorCtr="0">
+            <a:noAutofit/>
+          </a:bodyPr>
+          <a:lstStyle>
+            <a:defPPr marR="0" lvl="0" algn="l" rtl="0">
+              <a:lnSpc>
+                <a:spcPct val="100000"/>
+              </a:lnSpc>
+              <a:spcBef>
+                <a:spcPts val="0"/>
+              </a:spcBef>
+              <a:spcAft>
+                <a:spcPts val="0"/>
+              </a:spcAft>
+              <a:defRPr/>
+            </a:defPPr>
+            <a:lvl1pPr>
+              <a:buClr>
+                <a:schemeClr val="dk1"/>
+              </a:buClr>
+              <a:buSzPts val="2800"/>
+              <a:buNone/>
+              <a:defRPr sz="800" b="1">
+                <a:solidFill>
+                  <a:srgbClr val="0E3449"/>
+                </a:solidFill>
+                <a:latin typeface="Inter SemiBold"/>
+                <a:ea typeface="Inter SemiBold"/>
+              </a:defRPr>
+            </a:lvl1pPr>
+            <a:lvl2pPr>
+              <a:buClr>
+                <a:schemeClr val="dk1"/>
+              </a:buClr>
+              <a:buSzPts val="2800"/>
+              <a:buNone/>
+              <a:defRPr sz="2800">
+                <a:solidFill>
+                  <a:schemeClr val="dk1"/>
+                </a:solidFill>
+              </a:defRPr>
+            </a:lvl2pPr>
+            <a:lvl3pPr>
+              <a:buClr>
+                <a:schemeClr val="dk1"/>
+              </a:buClr>
+              <a:buSzPts val="2800"/>
+              <a:buNone/>
+              <a:defRPr sz="2800">
+                <a:solidFill>
+                  <a:schemeClr val="dk1"/>
+                </a:solidFill>
+              </a:defRPr>
+            </a:lvl3pPr>
+            <a:lvl4pPr>
+              <a:buClr>
+                <a:schemeClr val="dk1"/>
+              </a:buClr>
+              <a:buSzPts val="2800"/>
+              <a:buNone/>
+              <a:defRPr sz="2800">
+                <a:solidFill>
+                  <a:schemeClr val="dk1"/>
+                </a:solidFill>
+              </a:defRPr>
+            </a:lvl4pPr>
+            <a:lvl5pPr>
+              <a:buClr>
+                <a:schemeClr val="dk1"/>
+              </a:buClr>
+              <a:buSzPts val="2800"/>
+              <a:buNone/>
+              <a:defRPr sz="2800">
+                <a:solidFill>
+                  <a:schemeClr val="dk1"/>
+                </a:solidFill>
+              </a:defRPr>
+            </a:lvl5pPr>
+            <a:lvl6pPr>
+              <a:buClr>
+                <a:schemeClr val="dk1"/>
+              </a:buClr>
+              <a:buSzPts val="2800"/>
+              <a:buNone/>
+              <a:defRPr sz="2800">
+                <a:solidFill>
+                  <a:schemeClr val="dk1"/>
+                </a:solidFill>
+              </a:defRPr>
+            </a:lvl6pPr>
+            <a:lvl7pPr>
+              <a:buClr>
+                <a:schemeClr val="dk1"/>
+              </a:buClr>
+              <a:buSzPts val="2800"/>
+              <a:buNone/>
+              <a:defRPr sz="2800">
+                <a:solidFill>
+                  <a:schemeClr val="dk1"/>
+                </a:solidFill>
+              </a:defRPr>
+            </a:lvl7pPr>
+            <a:lvl8pPr>
+              <a:buClr>
+                <a:schemeClr val="dk1"/>
+              </a:buClr>
+              <a:buSzPts val="2800"/>
+              <a:buNone/>
+              <a:defRPr sz="2800">
+                <a:solidFill>
+                  <a:schemeClr val="dk1"/>
+                </a:solidFill>
+              </a:defRPr>
+            </a:lvl8pPr>
+            <a:lvl9pPr>
+              <a:buClr>
+                <a:schemeClr val="dk1"/>
+              </a:buClr>
+              <a:buSzPts val="2800"/>
+              <a:buNone/>
+              <a:defRPr sz="2800">
+                <a:solidFill>
+                  <a:schemeClr val="dk1"/>
+                </a:solidFill>
+              </a:defRPr>
+            </a:lvl9pPr>
+          </a:lstStyle>
+          <a:p>
+            <a:pPr algn="ctr"/>
+            <a:r>
+              <a:rPr lang="fr-FR" sz="500" b="0" dirty="0"/>
+              <a:t>heure</a:t>
+            </a:r>
+            <a:endParaRPr lang="fr-FR" sz="500" b="0" dirty="0">
+              <a:sym typeface="Inter SemiBold"/>
+            </a:endParaRPr>
+          </a:p>
+        </p:txBody>
+      </p:sp>
     </p:spTree>
     <p:extLst>
       <p:ext uri="{BB962C8B-B14F-4D97-AF65-F5344CB8AC3E}">
@@ -41334,6 +43001,60 @@
                                   </p:childTnLst>
                                 </p:cTn>
                               </p:par>
+                              <p:par>
+                                <p:cTn id="23" presetID="1" presetClass="entr" presetSubtype="0" fill="hold" grpId="0" nodeType="withEffect">
+                                  <p:stCondLst>
+                                    <p:cond delay="0"/>
+                                  </p:stCondLst>
+                                  <p:childTnLst>
+                                    <p:set>
+                                      <p:cBhvr>
+                                        <p:cTn id="24" dur="1" fill="hold">
+                                          <p:stCondLst>
+                                            <p:cond delay="0"/>
+                                          </p:stCondLst>
+                                        </p:cTn>
+                                        <p:tgtEl>
+                                          <p:spTgt spid="3"/>
+                                        </p:tgtEl>
+                                        <p:attrNameLst>
+                                          <p:attrName>style.visibility</p:attrName>
+                                        </p:attrNameLst>
+                                      </p:cBhvr>
+                                      <p:to>
+                                        <p:strVal val="visible"/>
+                                      </p:to>
+                                    </p:set>
+                                  </p:childTnLst>
+                                </p:cTn>
+                              </p:par>
+                              <p:par>
+                                <p:cTn id="25" presetID="1" presetClass="entr" presetSubtype="0" fill="hold" grpId="0" nodeType="withEffect">
+                                  <p:stCondLst>
+                                    <p:cond delay="0"/>
+                                  </p:stCondLst>
+                                  <p:childTnLst>
+                                    <p:set>
+                                      <p:cBhvr>
+                                        <p:cTn id="26" dur="1" fill="hold">
+                                          <p:stCondLst>
+                                            <p:cond delay="0"/>
+                                          </p:stCondLst>
+                                        </p:cTn>
+                                        <p:tgtEl>
+                                          <p:spTgt spid="4"/>
+                                        </p:tgtEl>
+                                        <p:attrNameLst>
+                                          <p:attrName>style.visibility</p:attrName>
+                                        </p:attrNameLst>
+                                      </p:cBhvr>
+                                      <p:to>
+                                        <p:strVal val="visible"/>
+                                      </p:to>
+                                    </p:set>
+                                  </p:childTnLst>
+                                </p:cTn>
+                              </p:par>
                             </p:childTnLst>
                           </p:cTn>
                         </p:par>
@@ -41366,6 +43087,8 @@
       <p:bldP spid="27" grpId="0"/>
       <p:bldP spid="29" grpId="0"/>
       <p:bldP spid="32" grpId="0"/>
+      <p:bldP spid="3" grpId="0"/>
+      <p:bldP spid="4" grpId="0"/>
     </p:bldLst>
   </p:timing>
 </p:sld>
@@ -42225,15 +43948,7 @@
             </a:r>
             <a:r>
               <a:rPr lang="fr-FR" sz="900" dirty="0"/>
-              <a:t>(cf. 10cm dans le </a:t>
-            </a:r>
-            <a:r>
-              <a:rPr lang="fr-FR" sz="900" dirty="0" err="1"/>
-              <a:t>Dataset</a:t>
-            </a:r>
-            <a:r>
-              <a:rPr lang="fr-FR" sz="900" dirty="0"/>
-              <a:t>) est </a:t>
+              <a:t>est </a:t>
             </a:r>
             <a:r>
               <a:rPr lang="fr-FR" sz="900" b="1" dirty="0"/>
@@ -42325,10 +44040,10 @@
       </p:sp>
       <p:pic>
         <p:nvPicPr>
-          <p:cNvPr id="13" name="Image 12" descr="Une image contenant texte, capture d’écran, affichage, nombre&#10;&#10;Le contenu généré par l’IA peut être incorrect.">
+          <p:cNvPr id="5" name="Image 4">
             <a:extLst>
               <a:ext uri="{FF2B5EF4-FFF2-40B4-BE49-F238E27FC236}">
-                <a16:creationId xmlns:a16="http://schemas.microsoft.com/office/drawing/2014/main" id="{7D6B0B43-8628-A21E-C82B-D058DBA5452A}"/>
+                <a16:creationId xmlns:a16="http://schemas.microsoft.com/office/drawing/2014/main" id="{000A3F10-64A4-99A8-2113-EEBBDD6801ED}"/>
               </a:ext>
             </a:extLst>
           </p:cNvPr>
@@ -42362,10 +44077,10 @@
       </p:pic>
       <p:pic>
         <p:nvPicPr>
-          <p:cNvPr id="7" name="Image 6" descr="Une image contenant texte, diagramme, Tracé, capture d’écran">
+          <p:cNvPr id="15" name="Image 14">
             <a:extLst>
               <a:ext uri="{FF2B5EF4-FFF2-40B4-BE49-F238E27FC236}">
-                <a16:creationId xmlns:a16="http://schemas.microsoft.com/office/drawing/2014/main" id="{D843FCAE-84D8-B3E1-4B7A-0383F76C878B}"/>
+                <a16:creationId xmlns:a16="http://schemas.microsoft.com/office/drawing/2014/main" id="{BC10BE04-1AA9-616C-9AB5-9507462BB970}"/>
               </a:ext>
             </a:extLst>
           </p:cNvPr>
@@ -42382,8 +44097,8 @@
         </p:blipFill>
         <p:spPr>
           <a:xfrm>
-            <a:off x="4922672" y="1155049"/>
-            <a:ext cx="3595361" cy="2862681"/>
+            <a:off x="4919646" y="1156260"/>
+            <a:ext cx="3595360" cy="2862681"/>
           </a:xfrm>
           <a:prstGeom prst="rect">
             <a:avLst/>

</xml_diff>